<commit_message>
Algoritmo distanze tra liste
</commit_message>
<xml_diff>
--- a/SEGRETI_MODULI_PYTHON_FINALSLIDE.pptx
+++ b/SEGRETI_MODULI_PYTHON_FINALSLIDE.pptx
@@ -5,7 +5,7 @@
     <p:sldMasterId id="2147483648" r:id="rId1"/>
   </p:sldMasterIdLst>
   <p:notesMasterIdLst>
-    <p:notesMasterId r:id="rId21"/>
+    <p:notesMasterId r:id="rId26"/>
   </p:notesMasterIdLst>
   <p:sldIdLst>
     <p:sldId id="256" r:id="rId2"/>
@@ -26,7 +26,12 @@
     <p:sldId id="271" r:id="rId17"/>
     <p:sldId id="272" r:id="rId18"/>
     <p:sldId id="273" r:id="rId19"/>
-    <p:sldId id="274" r:id="rId20"/>
+    <p:sldId id="275" r:id="rId20"/>
+    <p:sldId id="276" r:id="rId21"/>
+    <p:sldId id="277" r:id="rId22"/>
+    <p:sldId id="278" r:id="rId23"/>
+    <p:sldId id="279" r:id="rId24"/>
+    <p:sldId id="274" r:id="rId25"/>
   </p:sldIdLst>
   <p:sldSz cx="9144000" cy="5143500" type="screen16x9"/>
   <p:notesSz cx="6858000" cy="9144000"/>
@@ -275,7 +280,7 @@
       </p15:sldGuideLst>
     </p:ext>
     <p:ext uri="GoogleSlidesCustomDataVersion2">
-      <go:slidesCustomData xmlns:go="http://customooxmlschemas.google.com/" xmlns:ahyp="http://schemas.microsoft.com/office/drawing/2018/hyperlinkcolor" xmlns:p15="http://schemas.microsoft.com/office/powerpoint/2012/main" xmlns:p14="http://schemas.microsoft.com/office/powerpoint/2010/main" xmlns:com="http://schemas.openxmlformats.org/drawingml/2006/compatibility" xmlns:pvml="urn:schemas-microsoft-com:office:powerpoint" xmlns:v="urn:schemas-microsoft-com:vml" xmlns:o="urn:schemas-microsoft-com:office:office" xmlns:dgm="http://schemas.openxmlformats.org/drawingml/2006/diagram" xmlns:c="http://schemas.openxmlformats.org/drawingml/2006/chart" xmlns:mv="urn:schemas-microsoft-com:mac:vml" xmlns:mc="http://schemas.openxmlformats.org/markup-compatibility/2006" xmlns="" r:id="rId26" roundtripDataSignature="AMtx7mgegO3OfnUNPhh+E85DmcvDystYkw=="/>
+      <go:slidesCustomData xmlns="" xmlns:mc="http://schemas.openxmlformats.org/markup-compatibility/2006" xmlns:mv="urn:schemas-microsoft-com:mac:vml" xmlns:c="http://schemas.openxmlformats.org/drawingml/2006/chart" xmlns:dgm="http://schemas.openxmlformats.org/drawingml/2006/diagram" xmlns:o="urn:schemas-microsoft-com:office:office" xmlns:v="urn:schemas-microsoft-com:vml" xmlns:pvml="urn:schemas-microsoft-com:office:powerpoint" xmlns:com="http://schemas.openxmlformats.org/drawingml/2006/compatibility" xmlns:p14="http://schemas.microsoft.com/office/powerpoint/2010/main" xmlns:p15="http://schemas.microsoft.com/office/powerpoint/2012/main" xmlns:ahyp="http://schemas.microsoft.com/office/drawing/2018/hyperlinkcolor" xmlns:go="http://customooxmlschemas.google.com/" r:id="rId27" roundtripDataSignature="AMtx7mgegO3OfnUNPhh+E85DmcvDystYkw=="/>
     </p:ext>
   </p:extLst>
 </p:presentation>
@@ -298,7 +303,7 @@
         <p15:threadingInfo xmlns:p15="http://schemas.microsoft.com/office/powerpoint/2012/main" timeZoneBias="0"/>
       </p:ext>
       <p:ext uri="http://customooxmlschemas.google.com/">
-        <go:slidesCustomData xmlns:go="http://customooxmlschemas.google.com/" xmlns:ahyp="http://schemas.microsoft.com/office/drawing/2018/hyperlinkcolor" xmlns:p15="http://schemas.microsoft.com/office/powerpoint/2012/main" xmlns:p14="http://schemas.microsoft.com/office/powerpoint/2010/main" xmlns:com="http://schemas.openxmlformats.org/drawingml/2006/compatibility" xmlns:pvml="urn:schemas-microsoft-com:office:powerpoint" xmlns:v="urn:schemas-microsoft-com:vml" xmlns:o="urn:schemas-microsoft-com:office:office" xmlns:dgm="http://schemas.openxmlformats.org/drawingml/2006/diagram" xmlns:c="http://schemas.openxmlformats.org/drawingml/2006/chart" xmlns:mv="urn:schemas-microsoft-com:mac:vml" xmlns:mc="http://schemas.openxmlformats.org/markup-compatibility/2006" xmlns="" commentPostId="AAABwuaQn2s"/>
+        <go:slidesCustomData xmlns="" xmlns:mc="http://schemas.openxmlformats.org/markup-compatibility/2006" xmlns:mv="urn:schemas-microsoft-com:mac:vml" xmlns:c="http://schemas.openxmlformats.org/drawingml/2006/chart" xmlns:dgm="http://schemas.openxmlformats.org/drawingml/2006/diagram" xmlns:o="urn:schemas-microsoft-com:office:office" xmlns:v="urn:schemas-microsoft-com:vml" xmlns:pvml="urn:schemas-microsoft-com:office:powerpoint" xmlns:com="http://schemas.openxmlformats.org/drawingml/2006/compatibility" xmlns:p14="http://schemas.microsoft.com/office/powerpoint/2010/main" xmlns:p15="http://schemas.microsoft.com/office/powerpoint/2012/main" xmlns:ahyp="http://schemas.microsoft.com/office/drawing/2018/hyperlinkcolor" xmlns:go="http://customooxmlschemas.google.com/" commentPostId="AAABwuaQn2s"/>
       </p:ext>
     </p:extLst>
   </p:cm>
@@ -313,7 +318,7 @@
         </p15:threadingInfo>
       </p:ext>
       <p:ext uri="http://customooxmlschemas.google.com/">
-        <go:slidesCustomData xmlns:go="http://customooxmlschemas.google.com/" xmlns:ahyp="http://schemas.microsoft.com/office/drawing/2018/hyperlinkcolor" xmlns:p15="http://schemas.microsoft.com/office/powerpoint/2012/main" xmlns:p14="http://schemas.microsoft.com/office/powerpoint/2010/main" xmlns:com="http://schemas.openxmlformats.org/drawingml/2006/compatibility" xmlns:pvml="urn:schemas-microsoft-com:office:powerpoint" xmlns:v="urn:schemas-microsoft-com:vml" xmlns:o="urn:schemas-microsoft-com:office:office" xmlns:dgm="http://schemas.openxmlformats.org/drawingml/2006/diagram" xmlns:c="http://schemas.openxmlformats.org/drawingml/2006/chart" xmlns:mv="urn:schemas-microsoft-com:mac:vml" xmlns:mc="http://schemas.openxmlformats.org/markup-compatibility/2006" xmlns="" commentPostId="AAABwuaQn2w"/>
+        <go:slidesCustomData xmlns="" xmlns:mc="http://schemas.openxmlformats.org/markup-compatibility/2006" xmlns:mv="urn:schemas-microsoft-com:mac:vml" xmlns:c="http://schemas.openxmlformats.org/drawingml/2006/chart" xmlns:dgm="http://schemas.openxmlformats.org/drawingml/2006/diagram" xmlns:o="urn:schemas-microsoft-com:office:office" xmlns:v="urn:schemas-microsoft-com:vml" xmlns:pvml="urn:schemas-microsoft-com:office:powerpoint" xmlns:com="http://schemas.openxmlformats.org/drawingml/2006/compatibility" xmlns:p14="http://schemas.microsoft.com/office/powerpoint/2010/main" xmlns:p15="http://schemas.microsoft.com/office/powerpoint/2012/main" xmlns:ahyp="http://schemas.microsoft.com/office/drawing/2018/hyperlinkcolor" xmlns:go="http://customooxmlschemas.google.com/" commentPostId="AAABwuaQn2w"/>
       </p:ext>
     </p:extLst>
   </p:cm>
@@ -15634,6 +15639,1833 @@
   <p:cSld>
     <p:spTree>
       <p:nvGrpSpPr>
+        <p:cNvPr id="1" name=""/>
+        <p:cNvGrpSpPr/>
+        <p:nvPr/>
+      </p:nvGrpSpPr>
+      <p:grpSpPr>
+        <a:xfrm>
+          <a:off x="0" y="0"/>
+          <a:ext cx="0" cy="0"/>
+          <a:chOff x="0" y="0"/>
+          <a:chExt cx="0" cy="0"/>
+        </a:xfrm>
+      </p:grpSpPr>
+      <p:sp>
+        <p:nvSpPr>
+          <p:cNvPr id="6" name="Google Shape;234;g3a9b731e4a8_0_59">
+            <a:extLst>
+              <a:ext uri="{FF2B5EF4-FFF2-40B4-BE49-F238E27FC236}">
+                <a16:creationId xmlns:a16="http://schemas.microsoft.com/office/drawing/2014/main" id="{9AFC9425-5DE0-9EAF-F0D0-F74516F6CC85}"/>
+              </a:ext>
+            </a:extLst>
+          </p:cNvPr>
+          <p:cNvSpPr txBox="1"/>
+          <p:nvPr/>
+        </p:nvSpPr>
+        <p:spPr>
+          <a:xfrm>
+            <a:off x="1873040" y="319065"/>
+            <a:ext cx="6567600" cy="400800"/>
+          </a:xfrm>
+          <a:prstGeom prst="rect">
+            <a:avLst/>
+          </a:prstGeom>
+          <a:noFill/>
+          <a:ln>
+            <a:noFill/>
+          </a:ln>
+        </p:spPr>
+        <p:txBody>
+          <a:bodyPr spcFirstLastPara="1" wrap="square" lIns="91425" tIns="45700" rIns="91425" bIns="45700" anchor="t" anchorCtr="0">
+            <a:spAutoFit/>
+          </a:bodyPr>
+          <a:lstStyle/>
+          <a:p>
+            <a:pPr marL="0" marR="0" lvl="0" indent="0" algn="l" rtl="0">
+              <a:spcBef>
+                <a:spcPts val="0"/>
+              </a:spcBef>
+              <a:spcAft>
+                <a:spcPts val="0"/>
+              </a:spcAft>
+              <a:buNone/>
+            </a:pPr>
+            <a:r>
+              <a:rPr lang="it-IT" sz="2004" b="1">
+                <a:solidFill>
+                  <a:srgbClr val="0F4761"/>
+                </a:solidFill>
+                <a:latin typeface="Arial"/>
+                <a:ea typeface="Arial"/>
+                <a:cs typeface="Arial"/>
+                <a:sym typeface="Arial"/>
+              </a:rPr>
+              <a:t>04 Dicembre 2025 – Segreti sui moduli Python</a:t>
+            </a:r>
+            <a:endParaRPr/>
+          </a:p>
+        </p:txBody>
+      </p:sp>
+      <p:pic>
+        <p:nvPicPr>
+          <p:cNvPr id="7" name="Google Shape;235;g3a9b731e4a8_0_59">
+            <a:extLst>
+              <a:ext uri="{FF2B5EF4-FFF2-40B4-BE49-F238E27FC236}">
+                <a16:creationId xmlns:a16="http://schemas.microsoft.com/office/drawing/2014/main" id="{9C2331DC-E4E6-928E-AF1C-3DF0D7813D9B}"/>
+              </a:ext>
+            </a:extLst>
+          </p:cNvPr>
+          <p:cNvPicPr preferRelativeResize="0"/>
+          <p:nvPr/>
+        </p:nvPicPr>
+        <p:blipFill rotWithShape="1">
+          <a:blip r:embed="rId2">
+            <a:alphaModFix/>
+          </a:blip>
+          <a:srcRect/>
+          <a:stretch/>
+        </p:blipFill>
+        <p:spPr>
+          <a:xfrm>
+            <a:off x="551323" y="114848"/>
+            <a:ext cx="1268025" cy="809225"/>
+          </a:xfrm>
+          <a:prstGeom prst="rect">
+            <a:avLst/>
+          </a:prstGeom>
+          <a:noFill/>
+          <a:ln>
+            <a:noFill/>
+          </a:ln>
+        </p:spPr>
+      </p:pic>
+      <p:sp>
+        <p:nvSpPr>
+          <p:cNvPr id="9" name="CasellaDiTesto 8">
+            <a:extLst>
+              <a:ext uri="{FF2B5EF4-FFF2-40B4-BE49-F238E27FC236}">
+                <a16:creationId xmlns:a16="http://schemas.microsoft.com/office/drawing/2014/main" id="{D7A426B3-3918-F230-7647-30C22685D936}"/>
+              </a:ext>
+            </a:extLst>
+          </p:cNvPr>
+          <p:cNvSpPr txBox="1"/>
+          <p:nvPr/>
+        </p:nvSpPr>
+        <p:spPr>
+          <a:xfrm>
+            <a:off x="1452066" y="996979"/>
+            <a:ext cx="6239868" cy="307777"/>
+          </a:xfrm>
+          <a:prstGeom prst="rect">
+            <a:avLst/>
+          </a:prstGeom>
+          <a:noFill/>
+        </p:spPr>
+        <p:txBody>
+          <a:bodyPr wrap="square">
+            <a:spAutoFit/>
+          </a:bodyPr>
+          <a:lstStyle/>
+          <a:p>
+            <a:r>
+              <a:rPr lang="it-IT" dirty="0"/>
+              <a:t>Algoritmo generalizzato per calcolare la distanza totale tra due liste</a:t>
+            </a:r>
+          </a:p>
+        </p:txBody>
+      </p:sp>
+      <p:sp>
+        <p:nvSpPr>
+          <p:cNvPr id="11" name="Rectangle 2">
+            <a:extLst>
+              <a:ext uri="{FF2B5EF4-FFF2-40B4-BE49-F238E27FC236}">
+                <a16:creationId xmlns:a16="http://schemas.microsoft.com/office/drawing/2014/main" id="{B05FFD96-C354-CC02-67B7-812AF94CA094}"/>
+              </a:ext>
+            </a:extLst>
+          </p:cNvPr>
+          <p:cNvSpPr>
+            <a:spLocks noChangeArrowheads="1"/>
+          </p:cNvSpPr>
+          <p:nvPr/>
+        </p:nvSpPr>
+        <p:spPr bwMode="auto">
+          <a:xfrm>
+            <a:off x="1452066" y="1377662"/>
+            <a:ext cx="5849384" cy="1661993"/>
+          </a:xfrm>
+          <a:prstGeom prst="rect">
+            <a:avLst/>
+          </a:prstGeom>
+          <a:noFill/>
+          <a:ln>
+            <a:noFill/>
+          </a:ln>
+          <a:effectLst/>
+          <a:extLst>
+            <a:ext uri="{909E8E84-426E-40DD-AFC4-6F175D3DCCD1}">
+              <a14:hiddenFill xmlns:a14="http://schemas.microsoft.com/office/drawing/2010/main">
+                <a:solidFill>
+                  <a:schemeClr val="accent1"/>
+                </a:solidFill>
+              </a14:hiddenFill>
+            </a:ext>
+            <a:ext uri="{91240B29-F687-4F45-9708-019B960494DF}">
+              <a14:hiddenLine xmlns:a14="http://schemas.microsoft.com/office/drawing/2010/main" w="9525">
+                <a:solidFill>
+                  <a:schemeClr val="tx1"/>
+                </a:solidFill>
+                <a:miter lim="800000"/>
+                <a:headEnd/>
+                <a:tailEnd/>
+              </a14:hiddenLine>
+            </a:ext>
+            <a:ext uri="{AF507438-7753-43E0-B8FC-AC1667EBCBE1}">
+              <a14:hiddenEffects xmlns:a14="http://schemas.microsoft.com/office/drawing/2010/main">
+                <a:effectLst>
+                  <a:outerShdw dist="35921" dir="2700000" algn="ctr" rotWithShape="0">
+                    <a:schemeClr val="bg2"/>
+                  </a:outerShdw>
+                </a:effectLst>
+              </a14:hiddenEffects>
+            </a:ext>
+          </a:extLst>
+        </p:spPr>
+        <p:txBody>
+          <a:bodyPr vert="horz" wrap="square" lIns="91440" tIns="45720" rIns="91440" bIns="45720" numCol="1" anchor="ctr" anchorCtr="0" compatLnSpc="1">
+            <a:prstTxWarp prst="textNoShape">
+              <a:avLst/>
+            </a:prstTxWarp>
+            <a:spAutoFit/>
+          </a:bodyPr>
+          <a:lstStyle/>
+          <a:p>
+            <a:pPr marL="0" marR="0" lvl="0" indent="0" algn="l" defTabSz="914400" rtl="0" eaLnBrk="0" fontAlgn="base" latinLnBrk="0" hangingPunct="0">
+              <a:lnSpc>
+                <a:spcPct val="100000"/>
+              </a:lnSpc>
+              <a:spcBef>
+                <a:spcPct val="0"/>
+              </a:spcBef>
+              <a:spcAft>
+                <a:spcPct val="0"/>
+              </a:spcAft>
+              <a:buClrTx/>
+              <a:buSzTx/>
+              <a:buFontTx/>
+              <a:buNone/>
+              <a:tabLst/>
+            </a:pPr>
+            <a:r>
+              <a:rPr lang="it-IT" altLang="it-IT" sz="2800" dirty="0"/>
+              <a:t>Hai</a:t>
+            </a:r>
+            <a:r>
+              <a:rPr kumimoji="0" lang="it-IT" altLang="it-IT" sz="2800" b="0" i="0" u="none" strike="noStrike" cap="none" normalizeH="0" baseline="0" dirty="0">
+                <a:ln>
+                  <a:noFill/>
+                </a:ln>
+                <a:solidFill>
+                  <a:schemeClr val="tx1"/>
+                </a:solidFill>
+                <a:effectLst/>
+                <a:latin typeface="Arial" panose="020B0604020202020204" pitchFamily="34" charset="0"/>
+              </a:rPr>
+              <a:t> due liste di numeri:</a:t>
+            </a:r>
+          </a:p>
+          <a:p>
+            <a:pPr marL="0" marR="0" lvl="0" indent="0" algn="l" defTabSz="914400" rtl="0" eaLnBrk="0" fontAlgn="base" latinLnBrk="0" hangingPunct="0">
+              <a:lnSpc>
+                <a:spcPct val="100000"/>
+              </a:lnSpc>
+              <a:spcBef>
+                <a:spcPct val="0"/>
+              </a:spcBef>
+              <a:spcAft>
+                <a:spcPct val="0"/>
+              </a:spcAft>
+              <a:buClrTx/>
+              <a:buSzTx/>
+              <a:buFontTx/>
+              <a:buChar char="•"/>
+              <a:tabLst/>
+            </a:pPr>
+            <a:r>
+              <a:rPr kumimoji="0" lang="it-IT" altLang="it-IT" sz="2800" b="0" i="0" u="none" strike="noStrike" cap="none" normalizeH="0" baseline="0" dirty="0">
+                <a:ln>
+                  <a:noFill/>
+                </a:ln>
+                <a:solidFill>
+                  <a:schemeClr val="tx1"/>
+                </a:solidFill>
+                <a:effectLst/>
+                <a:latin typeface="Arial Unicode MS"/>
+              </a:rPr>
+              <a:t>L = [l₁, l₂, …, lₙ]</a:t>
+            </a:r>
+            <a:endParaRPr kumimoji="0" lang="it-IT" altLang="it-IT" sz="2800" b="0" i="0" u="none" strike="noStrike" cap="none" normalizeH="0" baseline="0" dirty="0">
+              <a:ln>
+                <a:noFill/>
+              </a:ln>
+              <a:solidFill>
+                <a:schemeClr val="tx1"/>
+              </a:solidFill>
+              <a:effectLst/>
+            </a:endParaRPr>
+          </a:p>
+          <a:p>
+            <a:pPr marL="0" marR="0" lvl="0" indent="0" algn="l" defTabSz="914400" rtl="0" eaLnBrk="0" fontAlgn="base" latinLnBrk="0" hangingPunct="0">
+              <a:lnSpc>
+                <a:spcPct val="100000"/>
+              </a:lnSpc>
+              <a:spcBef>
+                <a:spcPct val="0"/>
+              </a:spcBef>
+              <a:spcAft>
+                <a:spcPct val="0"/>
+              </a:spcAft>
+              <a:buClrTx/>
+              <a:buSzTx/>
+              <a:buFontTx/>
+              <a:buChar char="•"/>
+              <a:tabLst/>
+            </a:pPr>
+            <a:r>
+              <a:rPr kumimoji="0" lang="it-IT" altLang="it-IT" sz="2800" b="0" i="0" u="none" strike="noStrike" cap="none" normalizeH="0" baseline="0" dirty="0">
+                <a:ln>
+                  <a:noFill/>
+                </a:ln>
+                <a:solidFill>
+                  <a:schemeClr val="tx1"/>
+                </a:solidFill>
+                <a:effectLst/>
+                <a:latin typeface="Arial Unicode MS"/>
+              </a:rPr>
+              <a:t>R = [r₁, r₂, …, rₙ]</a:t>
+            </a:r>
+            <a:endParaRPr kumimoji="0" lang="it-IT" altLang="it-IT" sz="2800" b="0" i="0" u="none" strike="noStrike" cap="none" normalizeH="0" baseline="0" dirty="0">
+              <a:ln>
+                <a:noFill/>
+              </a:ln>
+              <a:solidFill>
+                <a:schemeClr val="tx1"/>
+              </a:solidFill>
+              <a:effectLst/>
+            </a:endParaRPr>
+          </a:p>
+          <a:p>
+            <a:pPr marL="0" marR="0" lvl="0" indent="0" algn="l" defTabSz="914400" rtl="0" eaLnBrk="0" fontAlgn="base" latinLnBrk="0" hangingPunct="0">
+              <a:lnSpc>
+                <a:spcPct val="100000"/>
+              </a:lnSpc>
+              <a:spcBef>
+                <a:spcPct val="0"/>
+              </a:spcBef>
+              <a:spcAft>
+                <a:spcPct val="0"/>
+              </a:spcAft>
+              <a:buClrTx/>
+              <a:buSzTx/>
+              <a:buFontTx/>
+              <a:buNone/>
+              <a:tabLst/>
+            </a:pPr>
+            <a:endParaRPr kumimoji="0" lang="it-IT" altLang="it-IT" sz="1800" b="0" i="0" u="none" strike="noStrike" cap="none" normalizeH="0" baseline="0" dirty="0">
+              <a:ln>
+                <a:noFill/>
+              </a:ln>
+              <a:solidFill>
+                <a:schemeClr val="tx1"/>
+              </a:solidFill>
+              <a:effectLst/>
+              <a:latin typeface="Arial" panose="020B0604020202020204" pitchFamily="34" charset="0"/>
+            </a:endParaRPr>
+          </a:p>
+        </p:txBody>
+      </p:sp>
+      <p:sp>
+        <p:nvSpPr>
+          <p:cNvPr id="13" name="CasellaDiTesto 12">
+            <a:extLst>
+              <a:ext uri="{FF2B5EF4-FFF2-40B4-BE49-F238E27FC236}">
+                <a16:creationId xmlns:a16="http://schemas.microsoft.com/office/drawing/2014/main" id="{42A9ECD1-6865-4F7C-77B3-14390A7386D5}"/>
+              </a:ext>
+            </a:extLst>
+          </p:cNvPr>
+          <p:cNvSpPr txBox="1"/>
+          <p:nvPr/>
+        </p:nvSpPr>
+        <p:spPr>
+          <a:xfrm>
+            <a:off x="1452066" y="2978885"/>
+            <a:ext cx="4572000" cy="738664"/>
+          </a:xfrm>
+          <a:prstGeom prst="rect">
+            <a:avLst/>
+          </a:prstGeom>
+          <a:noFill/>
+        </p:spPr>
+        <p:txBody>
+          <a:bodyPr wrap="square">
+            <a:spAutoFit/>
+          </a:bodyPr>
+          <a:lstStyle/>
+          <a:p>
+            <a:r>
+              <a:rPr lang="it-IT" b="1" dirty="0"/>
+              <a:t>Obiettivo:</a:t>
+            </a:r>
+          </a:p>
+          <a:p>
+            <a:r>
+              <a:rPr lang="it-IT" dirty="0"/>
+              <a:t>Ordinare entrambe le liste e sommare le distanze assolute degli elementi in posizione corrispondente.</a:t>
+            </a:r>
+          </a:p>
+        </p:txBody>
+      </p:sp>
+    </p:spTree>
+    <p:extLst>
+      <p:ext uri="{BB962C8B-B14F-4D97-AF65-F5344CB8AC3E}">
+        <p14:creationId xmlns:p14="http://schemas.microsoft.com/office/powerpoint/2010/main" val="2126477125"/>
+      </p:ext>
+    </p:extLst>
+  </p:cSld>
+  <p:clrMapOvr>
+    <a:masterClrMapping/>
+  </p:clrMapOvr>
+</p:sld>
+</file>
+
+<file path=ppt/slides/slide2.xml><?xml version="1.0" encoding="utf-8"?>
+<p:sld xmlns:a="http://schemas.openxmlformats.org/drawingml/2006/main" xmlns:r="http://schemas.openxmlformats.org/officeDocument/2006/relationships" xmlns:p="http://schemas.openxmlformats.org/presentationml/2006/main">
+  <p:cSld>
+    <p:spTree>
+      <p:nvGrpSpPr>
+        <p:cNvPr id="1" name="Shape 95"/>
+        <p:cNvGrpSpPr/>
+        <p:nvPr/>
+      </p:nvGrpSpPr>
+      <p:grpSpPr>
+        <a:xfrm>
+          <a:off x="0" y="0"/>
+          <a:ext cx="0" cy="0"/>
+          <a:chOff x="0" y="0"/>
+          <a:chExt cx="0" cy="0"/>
+        </a:xfrm>
+      </p:grpSpPr>
+      <p:sp>
+        <p:nvSpPr>
+          <p:cNvPr id="96" name="Google Shape;96;p2"/>
+          <p:cNvSpPr/>
+          <p:nvPr/>
+        </p:nvSpPr>
+        <p:spPr>
+          <a:xfrm>
+            <a:off x="238200" y="2345447"/>
+            <a:ext cx="8991523" cy="2312184"/>
+          </a:xfrm>
+          <a:custGeom>
+            <a:avLst/>
+            <a:gdLst/>
+            <a:ahLst/>
+            <a:cxnLst/>
+            <a:rect l="l" t="t" r="r" b="b"/>
+            <a:pathLst>
+              <a:path w="5619702" h="1758315" extrusionOk="0">
+                <a:moveTo>
+                  <a:pt x="0" y="0"/>
+                </a:moveTo>
+                <a:lnTo>
+                  <a:pt x="5619702" y="0"/>
+                </a:lnTo>
+                <a:lnTo>
+                  <a:pt x="5619702" y="1758315"/>
+                </a:lnTo>
+                <a:lnTo>
+                  <a:pt x="0" y="1758315"/>
+                </a:lnTo>
+                <a:lnTo>
+                  <a:pt x="0" y="0"/>
+                </a:lnTo>
+                <a:close/>
+              </a:path>
+            </a:pathLst>
+          </a:custGeom>
+          <a:blipFill rotWithShape="1">
+            <a:blip r:embed="rId3">
+              <a:alphaModFix/>
+            </a:blip>
+            <a:stretch>
+              <a:fillRect/>
+            </a:stretch>
+          </a:blipFill>
+          <a:ln>
+            <a:noFill/>
+          </a:ln>
+        </p:spPr>
+      </p:sp>
+      <p:sp>
+        <p:nvSpPr>
+          <p:cNvPr id="97" name="Google Shape;97;p2"/>
+          <p:cNvSpPr txBox="1"/>
+          <p:nvPr/>
+        </p:nvSpPr>
+        <p:spPr>
+          <a:xfrm>
+            <a:off x="551329" y="1651572"/>
+            <a:ext cx="3216600" cy="431700"/>
+          </a:xfrm>
+          <a:prstGeom prst="rect">
+            <a:avLst/>
+          </a:prstGeom>
+          <a:noFill/>
+          <a:ln>
+            <a:noFill/>
+          </a:ln>
+        </p:spPr>
+        <p:txBody>
+          <a:bodyPr spcFirstLastPara="1" wrap="square" lIns="0" tIns="0" rIns="0" bIns="0" anchor="t" anchorCtr="0">
+            <a:spAutoFit/>
+          </a:bodyPr>
+          <a:lstStyle/>
+          <a:p>
+            <a:pPr marL="0" marR="0" lvl="0" indent="0" algn="l" rtl="0">
+              <a:lnSpc>
+                <a:spcPct val="58437"/>
+              </a:lnSpc>
+              <a:spcBef>
+                <a:spcPts val="0"/>
+              </a:spcBef>
+              <a:spcAft>
+                <a:spcPts val="0"/>
+              </a:spcAft>
+              <a:buNone/>
+            </a:pPr>
+            <a:r>
+              <a:rPr lang="it-IT" sz="4800">
+                <a:solidFill>
+                  <a:srgbClr val="0F4761"/>
+                </a:solidFill>
+                <a:latin typeface="Arial"/>
+                <a:ea typeface="Arial"/>
+                <a:cs typeface="Arial"/>
+                <a:sym typeface="Arial"/>
+              </a:rPr>
+              <a:t>Profilo </a:t>
+            </a:r>
+            <a:endParaRPr/>
+          </a:p>
+        </p:txBody>
+      </p:sp>
+      <p:sp>
+        <p:nvSpPr>
+          <p:cNvPr id="98" name="Google Shape;98;p2"/>
+          <p:cNvSpPr txBox="1"/>
+          <p:nvPr/>
+        </p:nvSpPr>
+        <p:spPr>
+          <a:xfrm>
+            <a:off x="1799190" y="341028"/>
+            <a:ext cx="6567600" cy="400800"/>
+          </a:xfrm>
+          <a:prstGeom prst="rect">
+            <a:avLst/>
+          </a:prstGeom>
+          <a:noFill/>
+          <a:ln>
+            <a:noFill/>
+          </a:ln>
+        </p:spPr>
+        <p:txBody>
+          <a:bodyPr spcFirstLastPara="1" wrap="square" lIns="91425" tIns="45700" rIns="91425" bIns="45700" anchor="t" anchorCtr="0">
+            <a:spAutoFit/>
+          </a:bodyPr>
+          <a:lstStyle/>
+          <a:p>
+            <a:pPr marL="0" marR="0" lvl="0" indent="0" algn="l" rtl="0">
+              <a:spcBef>
+                <a:spcPts val="0"/>
+              </a:spcBef>
+              <a:spcAft>
+                <a:spcPts val="0"/>
+              </a:spcAft>
+              <a:buNone/>
+            </a:pPr>
+            <a:r>
+              <a:rPr lang="it-IT" sz="2004" b="1">
+                <a:solidFill>
+                  <a:srgbClr val="0F4761"/>
+                </a:solidFill>
+                <a:latin typeface="Arial"/>
+                <a:ea typeface="Arial"/>
+                <a:cs typeface="Arial"/>
+                <a:sym typeface="Arial"/>
+              </a:rPr>
+              <a:t>04 Dicembre 2025 – Segreti sui moduli Python</a:t>
+            </a:r>
+            <a:endParaRPr/>
+          </a:p>
+        </p:txBody>
+      </p:sp>
+      <p:pic>
+        <p:nvPicPr>
+          <p:cNvPr id="99" name="Google Shape;99;p2"/>
+          <p:cNvPicPr preferRelativeResize="0"/>
+          <p:nvPr/>
+        </p:nvPicPr>
+        <p:blipFill rotWithShape="1">
+          <a:blip r:embed="rId4">
+            <a:alphaModFix/>
+          </a:blip>
+          <a:srcRect/>
+          <a:stretch/>
+        </p:blipFill>
+        <p:spPr>
+          <a:xfrm>
+            <a:off x="551323" y="114848"/>
+            <a:ext cx="1268025" cy="809225"/>
+          </a:xfrm>
+          <a:prstGeom prst="rect">
+            <a:avLst/>
+          </a:prstGeom>
+          <a:noFill/>
+          <a:ln>
+            <a:noFill/>
+          </a:ln>
+        </p:spPr>
+      </p:pic>
+    </p:spTree>
+  </p:cSld>
+  <p:clrMapOvr>
+    <a:masterClrMapping/>
+  </p:clrMapOvr>
+</p:sld>
+</file>
+
+<file path=ppt/slides/slide20.xml><?xml version="1.0" encoding="utf-8"?>
+<p:sld xmlns:a="http://schemas.openxmlformats.org/drawingml/2006/main" xmlns:r="http://schemas.openxmlformats.org/officeDocument/2006/relationships" xmlns:p="http://schemas.openxmlformats.org/presentationml/2006/main">
+  <p:cSld>
+    <p:spTree>
+      <p:nvGrpSpPr>
+        <p:cNvPr id="1" name=""/>
+        <p:cNvGrpSpPr/>
+        <p:nvPr/>
+      </p:nvGrpSpPr>
+      <p:grpSpPr>
+        <a:xfrm>
+          <a:off x="0" y="0"/>
+          <a:ext cx="0" cy="0"/>
+          <a:chOff x="0" y="0"/>
+          <a:chExt cx="0" cy="0"/>
+        </a:xfrm>
+      </p:grpSpPr>
+      <p:sp>
+        <p:nvSpPr>
+          <p:cNvPr id="4" name="Google Shape;234;g3a9b731e4a8_0_59">
+            <a:extLst>
+              <a:ext uri="{FF2B5EF4-FFF2-40B4-BE49-F238E27FC236}">
+                <a16:creationId xmlns:a16="http://schemas.microsoft.com/office/drawing/2014/main" id="{C4A75FF6-9B54-38E2-AEA5-E987DF2A1D2E}"/>
+              </a:ext>
+            </a:extLst>
+          </p:cNvPr>
+          <p:cNvSpPr txBox="1"/>
+          <p:nvPr/>
+        </p:nvSpPr>
+        <p:spPr>
+          <a:xfrm>
+            <a:off x="1873040" y="319065"/>
+            <a:ext cx="6567600" cy="400800"/>
+          </a:xfrm>
+          <a:prstGeom prst="rect">
+            <a:avLst/>
+          </a:prstGeom>
+          <a:noFill/>
+          <a:ln>
+            <a:noFill/>
+          </a:ln>
+        </p:spPr>
+        <p:txBody>
+          <a:bodyPr spcFirstLastPara="1" wrap="square" lIns="91425" tIns="45700" rIns="91425" bIns="45700" anchor="t" anchorCtr="0">
+            <a:spAutoFit/>
+          </a:bodyPr>
+          <a:lstStyle/>
+          <a:p>
+            <a:pPr marL="0" marR="0" lvl="0" indent="0" algn="l" rtl="0">
+              <a:spcBef>
+                <a:spcPts val="0"/>
+              </a:spcBef>
+              <a:spcAft>
+                <a:spcPts val="0"/>
+              </a:spcAft>
+              <a:buNone/>
+            </a:pPr>
+            <a:r>
+              <a:rPr lang="it-IT" sz="2004" b="1" dirty="0">
+                <a:solidFill>
+                  <a:srgbClr val="0F4761"/>
+                </a:solidFill>
+                <a:latin typeface="Arial"/>
+                <a:ea typeface="Arial"/>
+                <a:cs typeface="Arial"/>
+                <a:sym typeface="Arial"/>
+              </a:rPr>
+              <a:t>04 Dicembre 2025 – Segreti sui moduli Python</a:t>
+            </a:r>
+            <a:endParaRPr dirty="0"/>
+          </a:p>
+        </p:txBody>
+      </p:sp>
+      <p:pic>
+        <p:nvPicPr>
+          <p:cNvPr id="5" name="Google Shape;235;g3a9b731e4a8_0_59">
+            <a:extLst>
+              <a:ext uri="{FF2B5EF4-FFF2-40B4-BE49-F238E27FC236}">
+                <a16:creationId xmlns:a16="http://schemas.microsoft.com/office/drawing/2014/main" id="{1BCDF16E-F7FF-D3D7-4683-E5964CDAAB48}"/>
+              </a:ext>
+            </a:extLst>
+          </p:cNvPr>
+          <p:cNvPicPr preferRelativeResize="0"/>
+          <p:nvPr/>
+        </p:nvPicPr>
+        <p:blipFill rotWithShape="1">
+          <a:blip r:embed="rId2">
+            <a:alphaModFix/>
+          </a:blip>
+          <a:srcRect/>
+          <a:stretch/>
+        </p:blipFill>
+        <p:spPr>
+          <a:xfrm>
+            <a:off x="551323" y="114848"/>
+            <a:ext cx="1268025" cy="809225"/>
+          </a:xfrm>
+          <a:prstGeom prst="rect">
+            <a:avLst/>
+          </a:prstGeom>
+          <a:noFill/>
+          <a:ln>
+            <a:noFill/>
+          </a:ln>
+        </p:spPr>
+      </p:pic>
+      <p:sp>
+        <p:nvSpPr>
+          <p:cNvPr id="6" name="Rectangle 1">
+            <a:extLst>
+              <a:ext uri="{FF2B5EF4-FFF2-40B4-BE49-F238E27FC236}">
+                <a16:creationId xmlns:a16="http://schemas.microsoft.com/office/drawing/2014/main" id="{B734183E-4B9A-1740-0DEB-A4D4A82CAB8A}"/>
+              </a:ext>
+            </a:extLst>
+          </p:cNvPr>
+          <p:cNvSpPr>
+            <a:spLocks noChangeArrowheads="1"/>
+          </p:cNvSpPr>
+          <p:nvPr/>
+        </p:nvSpPr>
+        <p:spPr bwMode="auto">
+          <a:xfrm>
+            <a:off x="1873040" y="1063645"/>
+            <a:ext cx="4816704" cy="3016210"/>
+          </a:xfrm>
+          <a:prstGeom prst="rect">
+            <a:avLst/>
+          </a:prstGeom>
+          <a:noFill/>
+          <a:ln>
+            <a:noFill/>
+          </a:ln>
+          <a:effectLst/>
+          <a:extLst>
+            <a:ext uri="{909E8E84-426E-40DD-AFC4-6F175D3DCCD1}">
+              <a14:hiddenFill xmlns:a14="http://schemas.microsoft.com/office/drawing/2010/main">
+                <a:solidFill>
+                  <a:schemeClr val="accent1"/>
+                </a:solidFill>
+              </a14:hiddenFill>
+            </a:ext>
+            <a:ext uri="{91240B29-F687-4F45-9708-019B960494DF}">
+              <a14:hiddenLine xmlns:a14="http://schemas.microsoft.com/office/drawing/2010/main" w="9525">
+                <a:solidFill>
+                  <a:schemeClr val="tx1"/>
+                </a:solidFill>
+                <a:miter lim="800000"/>
+                <a:headEnd/>
+                <a:tailEnd/>
+              </a14:hiddenLine>
+            </a:ext>
+            <a:ext uri="{AF507438-7753-43E0-B8FC-AC1667EBCBE1}">
+              <a14:hiddenEffects xmlns:a14="http://schemas.microsoft.com/office/drawing/2010/main">
+                <a:effectLst>
+                  <a:outerShdw dist="35921" dir="2700000" algn="ctr" rotWithShape="0">
+                    <a:schemeClr val="bg2"/>
+                  </a:outerShdw>
+                </a:effectLst>
+              </a14:hiddenEffects>
+            </a:ext>
+          </a:extLst>
+        </p:spPr>
+        <p:txBody>
+          <a:bodyPr vert="horz" wrap="square" lIns="91440" tIns="45720" rIns="91440" bIns="45720" numCol="1" anchor="ctr" anchorCtr="0" compatLnSpc="1">
+            <a:prstTxWarp prst="textNoShape">
+              <a:avLst/>
+            </a:prstTxWarp>
+            <a:spAutoFit/>
+          </a:bodyPr>
+          <a:lstStyle/>
+          <a:p>
+            <a:pPr marL="0" marR="0" lvl="0" indent="0" algn="l" defTabSz="914400" rtl="0" eaLnBrk="0" fontAlgn="base" latinLnBrk="0" hangingPunct="0">
+              <a:lnSpc>
+                <a:spcPct val="100000"/>
+              </a:lnSpc>
+              <a:spcBef>
+                <a:spcPct val="0"/>
+              </a:spcBef>
+              <a:spcAft>
+                <a:spcPct val="0"/>
+              </a:spcAft>
+              <a:buClrTx/>
+              <a:buSzTx/>
+              <a:buFontTx/>
+              <a:buNone/>
+              <a:tabLst/>
+            </a:pPr>
+            <a:r>
+              <a:rPr kumimoji="0" lang="it-IT" altLang="it-IT" b="1" i="0" u="none" strike="noStrike" cap="none" normalizeH="0" baseline="0" dirty="0">
+                <a:ln>
+                  <a:noFill/>
+                </a:ln>
+                <a:solidFill>
+                  <a:schemeClr val="tx1"/>
+                </a:solidFill>
+                <a:effectLst/>
+                <a:latin typeface="Arial" panose="020B0604020202020204" pitchFamily="34" charset="0"/>
+              </a:rPr>
+              <a:t>Passi dell’algoritmo</a:t>
+            </a:r>
+          </a:p>
+          <a:p>
+            <a:pPr marL="0" marR="0" lvl="0" indent="0" algn="l" defTabSz="914400" rtl="0" eaLnBrk="0" fontAlgn="base" latinLnBrk="0" hangingPunct="0">
+              <a:lnSpc>
+                <a:spcPct val="100000"/>
+              </a:lnSpc>
+              <a:spcBef>
+                <a:spcPct val="0"/>
+              </a:spcBef>
+              <a:spcAft>
+                <a:spcPct val="0"/>
+              </a:spcAft>
+              <a:buClrTx/>
+              <a:buSzTx/>
+              <a:buFontTx/>
+              <a:buNone/>
+              <a:tabLst/>
+            </a:pPr>
+            <a:endParaRPr kumimoji="0" lang="it-IT" altLang="it-IT" b="1" i="0" u="none" strike="noStrike" cap="none" normalizeH="0" baseline="0" dirty="0">
+              <a:ln>
+                <a:noFill/>
+              </a:ln>
+              <a:solidFill>
+                <a:schemeClr val="tx1"/>
+              </a:solidFill>
+              <a:effectLst/>
+              <a:latin typeface="Arial" panose="020B0604020202020204" pitchFamily="34" charset="0"/>
+            </a:endParaRPr>
+          </a:p>
+          <a:p>
+            <a:pPr marL="0" marR="0" lvl="0" indent="0" algn="l" defTabSz="914400" rtl="0" eaLnBrk="0" fontAlgn="base" latinLnBrk="0" hangingPunct="0">
+              <a:lnSpc>
+                <a:spcPct val="100000"/>
+              </a:lnSpc>
+              <a:spcBef>
+                <a:spcPct val="0"/>
+              </a:spcBef>
+              <a:spcAft>
+                <a:spcPct val="0"/>
+              </a:spcAft>
+              <a:buClrTx/>
+              <a:buSzTx/>
+              <a:buFontTx/>
+              <a:buNone/>
+              <a:tabLst/>
+            </a:pPr>
+            <a:r>
+              <a:rPr kumimoji="0" lang="it-IT" altLang="it-IT" b="1" i="0" u="none" strike="noStrike" cap="none" normalizeH="0" baseline="0" dirty="0">
+                <a:ln>
+                  <a:noFill/>
+                </a:ln>
+                <a:solidFill>
+                  <a:schemeClr val="tx1"/>
+                </a:solidFill>
+                <a:effectLst/>
+                <a:latin typeface="Arial" panose="020B0604020202020204" pitchFamily="34" charset="0"/>
+              </a:rPr>
+              <a:t>1. Leggi le due liste</a:t>
+            </a:r>
+          </a:p>
+          <a:p>
+            <a:pPr marL="0" marR="0" lvl="0" indent="0" algn="l" defTabSz="914400" rtl="0" eaLnBrk="0" fontAlgn="base" latinLnBrk="0" hangingPunct="0">
+              <a:lnSpc>
+                <a:spcPct val="100000"/>
+              </a:lnSpc>
+              <a:spcBef>
+                <a:spcPct val="0"/>
+              </a:spcBef>
+              <a:spcAft>
+                <a:spcPct val="0"/>
+              </a:spcAft>
+              <a:buClrTx/>
+              <a:buSzTx/>
+              <a:buFontTx/>
+              <a:buNone/>
+              <a:tabLst/>
+            </a:pPr>
+            <a:r>
+              <a:rPr kumimoji="0" lang="it-IT" altLang="it-IT" b="0" i="0" u="none" strike="noStrike" cap="none" normalizeH="0" baseline="0" dirty="0">
+                <a:ln>
+                  <a:noFill/>
+                </a:ln>
+                <a:solidFill>
+                  <a:schemeClr val="tx1"/>
+                </a:solidFill>
+                <a:effectLst/>
+                <a:latin typeface="Arial" panose="020B0604020202020204" pitchFamily="34" charset="0"/>
+              </a:rPr>
+              <a:t>Estrarre i numeri della prima colonna nella lista </a:t>
+            </a:r>
+            <a:r>
+              <a:rPr kumimoji="0" lang="it-IT" altLang="it-IT" b="0" i="0" u="none" strike="noStrike" cap="none" normalizeH="0" baseline="0" dirty="0">
+                <a:ln>
+                  <a:noFill/>
+                </a:ln>
+                <a:solidFill>
+                  <a:schemeClr val="tx1"/>
+                </a:solidFill>
+                <a:effectLst/>
+                <a:latin typeface="Arial Unicode MS"/>
+              </a:rPr>
+              <a:t>L</a:t>
+            </a:r>
+            <a:r>
+              <a:rPr kumimoji="0" lang="it-IT" altLang="it-IT" b="0" i="0" u="none" strike="noStrike" cap="none" normalizeH="0" baseline="0" dirty="0">
+                <a:ln>
+                  <a:noFill/>
+                </a:ln>
+                <a:solidFill>
+                  <a:schemeClr val="tx1"/>
+                </a:solidFill>
+                <a:effectLst/>
+              </a:rPr>
+              <a:t> e quelli della seconda colonna nella lista </a:t>
+            </a:r>
+            <a:r>
+              <a:rPr kumimoji="0" lang="it-IT" altLang="it-IT" b="0" i="0" u="none" strike="noStrike" cap="none" normalizeH="0" baseline="0" dirty="0">
+                <a:ln>
+                  <a:noFill/>
+                </a:ln>
+                <a:solidFill>
+                  <a:schemeClr val="tx1"/>
+                </a:solidFill>
+                <a:effectLst/>
+                <a:latin typeface="Arial Unicode MS"/>
+              </a:rPr>
+              <a:t>R</a:t>
+            </a:r>
+            <a:r>
+              <a:rPr kumimoji="0" lang="it-IT" altLang="it-IT" b="0" i="0" u="none" strike="noStrike" cap="none" normalizeH="0" baseline="0" dirty="0">
+                <a:ln>
+                  <a:noFill/>
+                </a:ln>
+                <a:solidFill>
+                  <a:schemeClr val="tx1"/>
+                </a:solidFill>
+                <a:effectLst/>
+              </a:rPr>
+              <a:t>.</a:t>
+            </a:r>
+          </a:p>
+          <a:p>
+            <a:pPr marL="0" marR="0" lvl="0" indent="0" algn="l" defTabSz="914400" rtl="0" eaLnBrk="0" fontAlgn="base" latinLnBrk="0" hangingPunct="0">
+              <a:lnSpc>
+                <a:spcPct val="100000"/>
+              </a:lnSpc>
+              <a:spcBef>
+                <a:spcPct val="0"/>
+              </a:spcBef>
+              <a:spcAft>
+                <a:spcPct val="0"/>
+              </a:spcAft>
+              <a:buClrTx/>
+              <a:buSzTx/>
+              <a:buFontTx/>
+              <a:buNone/>
+              <a:tabLst/>
+            </a:pPr>
+            <a:r>
+              <a:rPr lang="it-IT" dirty="0"/>
+              <a:t>2. </a:t>
+            </a:r>
+            <a:r>
+              <a:rPr lang="it-IT" b="1" dirty="0">
+                <a:solidFill>
+                  <a:schemeClr val="tx1"/>
+                </a:solidFill>
+                <a:latin typeface="Arial" panose="020B0604020202020204" pitchFamily="34" charset="0"/>
+              </a:rPr>
+              <a:t>Ordina entrambe le liste</a:t>
+            </a:r>
+          </a:p>
+          <a:p>
+            <a:pPr marL="0" marR="0" lvl="0" indent="0" algn="l" defTabSz="914400" rtl="0" eaLnBrk="0" fontAlgn="base" latinLnBrk="0" hangingPunct="0">
+              <a:lnSpc>
+                <a:spcPct val="100000"/>
+              </a:lnSpc>
+              <a:spcBef>
+                <a:spcPct val="0"/>
+              </a:spcBef>
+              <a:spcAft>
+                <a:spcPct val="0"/>
+              </a:spcAft>
+              <a:buClrTx/>
+              <a:buSzTx/>
+              <a:buFontTx/>
+              <a:buNone/>
+              <a:tabLst/>
+            </a:pPr>
+            <a:r>
+              <a:rPr lang="it-IT" altLang="it-IT" b="1" dirty="0">
+                <a:solidFill>
+                  <a:schemeClr val="tx1"/>
+                </a:solidFill>
+                <a:latin typeface="Arial" panose="020B0604020202020204" pitchFamily="34" charset="0"/>
+              </a:rPr>
+              <a:t>sort(L)</a:t>
+            </a:r>
+          </a:p>
+          <a:p>
+            <a:pPr marL="0" marR="0" lvl="0" indent="0" algn="l" defTabSz="914400" rtl="0" eaLnBrk="0" fontAlgn="base" latinLnBrk="0" hangingPunct="0">
+              <a:lnSpc>
+                <a:spcPct val="100000"/>
+              </a:lnSpc>
+              <a:spcBef>
+                <a:spcPct val="0"/>
+              </a:spcBef>
+              <a:spcAft>
+                <a:spcPct val="0"/>
+              </a:spcAft>
+              <a:buClrTx/>
+              <a:buSzTx/>
+              <a:buFontTx/>
+              <a:buNone/>
+              <a:tabLst/>
+            </a:pPr>
+            <a:r>
+              <a:rPr lang="it-IT" altLang="it-IT" b="1" dirty="0">
+                <a:solidFill>
+                  <a:schemeClr val="tx1"/>
+                </a:solidFill>
+                <a:latin typeface="Arial" panose="020B0604020202020204" pitchFamily="34" charset="0"/>
+              </a:rPr>
+              <a:t>sort(R)</a:t>
+            </a:r>
+          </a:p>
+          <a:p>
+            <a:pPr eaLnBrk="0" fontAlgn="base" hangingPunct="0">
+              <a:spcBef>
+                <a:spcPct val="0"/>
+              </a:spcBef>
+              <a:spcAft>
+                <a:spcPct val="0"/>
+              </a:spcAft>
+              <a:buClrTx/>
+            </a:pPr>
+            <a:r>
+              <a:rPr lang="it-IT" dirty="0"/>
+              <a:t>3. </a:t>
+            </a:r>
+            <a:r>
+              <a:rPr lang="it-IT" b="1" dirty="0">
+                <a:solidFill>
+                  <a:schemeClr val="tx1"/>
+                </a:solidFill>
+                <a:latin typeface="Arial" panose="020B0604020202020204" pitchFamily="34" charset="0"/>
+              </a:rPr>
+              <a:t>Calcola la distanza cumulativa </a:t>
+            </a:r>
+            <a:r>
+              <a:rPr kumimoji="0" lang="it-IT" altLang="it-IT" sz="1400" b="0" i="0" u="none" strike="noStrike" cap="none" normalizeH="0" baseline="0" dirty="0">
+                <a:ln>
+                  <a:noFill/>
+                </a:ln>
+                <a:solidFill>
+                  <a:schemeClr val="tx1"/>
+                </a:solidFill>
+                <a:effectLst/>
+                <a:latin typeface="Arial" panose="020B0604020202020204" pitchFamily="34" charset="0"/>
+              </a:rPr>
+              <a:t>Per ogni indice </a:t>
+            </a:r>
+            <a:r>
+              <a:rPr kumimoji="0" lang="it-IT" altLang="it-IT" sz="1800" b="0" i="0" u="none" strike="noStrike" cap="none" normalizeH="0" baseline="0" dirty="0">
+                <a:ln>
+                  <a:noFill/>
+                </a:ln>
+                <a:solidFill>
+                  <a:schemeClr val="tx1"/>
+                </a:solidFill>
+                <a:effectLst/>
+                <a:latin typeface="Arial Unicode MS"/>
+              </a:rPr>
+              <a:t>i</a:t>
+            </a:r>
+            <a:r>
+              <a:rPr kumimoji="0" lang="it-IT" altLang="it-IT" sz="1800" b="0" i="0" u="none" strike="noStrike" cap="none" normalizeH="0" baseline="0" dirty="0">
+                <a:ln>
+                  <a:noFill/>
+                </a:ln>
+                <a:solidFill>
+                  <a:schemeClr val="tx1"/>
+                </a:solidFill>
+                <a:effectLst/>
+              </a:rPr>
+              <a:t> da </a:t>
+            </a:r>
+            <a:r>
+              <a:rPr kumimoji="0" lang="it-IT" altLang="it-IT" sz="1800" b="0" i="0" u="none" strike="noStrike" cap="none" normalizeH="0" baseline="0" dirty="0">
+                <a:ln>
+                  <a:noFill/>
+                </a:ln>
+                <a:solidFill>
+                  <a:schemeClr val="tx1"/>
+                </a:solidFill>
+                <a:effectLst/>
+                <a:latin typeface="Arial Unicode MS"/>
+              </a:rPr>
+              <a:t>0</a:t>
+            </a:r>
+            <a:r>
+              <a:rPr kumimoji="0" lang="it-IT" altLang="it-IT" sz="1800" b="0" i="0" u="none" strike="noStrike" cap="none" normalizeH="0" baseline="0" dirty="0">
+                <a:ln>
+                  <a:noFill/>
+                </a:ln>
+                <a:solidFill>
+                  <a:schemeClr val="tx1"/>
+                </a:solidFill>
+                <a:effectLst/>
+              </a:rPr>
+              <a:t> a </a:t>
+            </a:r>
+            <a:r>
+              <a:rPr kumimoji="0" lang="it-IT" altLang="it-IT" sz="1800" b="0" i="0" u="none" strike="noStrike" cap="none" normalizeH="0" baseline="0" dirty="0">
+                <a:ln>
+                  <a:noFill/>
+                </a:ln>
+                <a:solidFill>
+                  <a:schemeClr val="tx1"/>
+                </a:solidFill>
+                <a:effectLst/>
+                <a:latin typeface="Arial Unicode MS"/>
+              </a:rPr>
+              <a:t>n-1</a:t>
+            </a:r>
+            <a:r>
+              <a:rPr kumimoji="0" lang="it-IT" altLang="it-IT" sz="1800" b="0" i="0" u="none" strike="noStrike" cap="none" normalizeH="0" baseline="0" dirty="0">
+                <a:ln>
+                  <a:noFill/>
+                </a:ln>
+                <a:solidFill>
+                  <a:schemeClr val="tx1"/>
+                </a:solidFill>
+                <a:effectLst/>
+              </a:rPr>
+              <a:t>:</a:t>
+            </a:r>
+            <a:endParaRPr kumimoji="0" lang="it-IT" altLang="it-IT" sz="1800" b="0" i="0" u="none" strike="noStrike" cap="none" normalizeH="0" baseline="0" dirty="0">
+              <a:ln>
+                <a:noFill/>
+              </a:ln>
+              <a:solidFill>
+                <a:schemeClr val="tx1"/>
+              </a:solidFill>
+              <a:effectLst/>
+              <a:latin typeface="Arial Unicode MS"/>
+            </a:endParaRPr>
+          </a:p>
+          <a:p>
+            <a:pPr eaLnBrk="0" fontAlgn="base" hangingPunct="0">
+              <a:spcBef>
+                <a:spcPct val="0"/>
+              </a:spcBef>
+              <a:spcAft>
+                <a:spcPct val="0"/>
+              </a:spcAft>
+              <a:buClrTx/>
+            </a:pPr>
+            <a:r>
+              <a:rPr lang="it-IT" dirty="0"/>
+              <a:t>Somma tutte le distanze </a:t>
+            </a:r>
+            <a:r>
+              <a:rPr lang="it-IT" dirty="0" err="1"/>
+              <a:t>distanza_totale</a:t>
+            </a:r>
+            <a:r>
+              <a:rPr lang="it-IT" dirty="0"/>
+              <a:t> = Σ </a:t>
+            </a:r>
+            <a:r>
+              <a:rPr lang="it-IT" dirty="0" err="1"/>
+              <a:t>abs</a:t>
+            </a:r>
+            <a:r>
+              <a:rPr lang="it-IT" dirty="0"/>
+              <a:t>(L[i] - R[i])</a:t>
+            </a:r>
+            <a:endParaRPr lang="it-IT" altLang="it-IT" b="1" dirty="0">
+              <a:solidFill>
+                <a:schemeClr val="tx1"/>
+              </a:solidFill>
+              <a:latin typeface="Arial" panose="020B0604020202020204" pitchFamily="34" charset="0"/>
+            </a:endParaRPr>
+          </a:p>
+          <a:p>
+            <a:pPr marL="0" marR="0" lvl="0" indent="0" algn="l" defTabSz="914400" rtl="0" eaLnBrk="0" fontAlgn="base" latinLnBrk="0" hangingPunct="0">
+              <a:lnSpc>
+                <a:spcPct val="100000"/>
+              </a:lnSpc>
+              <a:spcBef>
+                <a:spcPct val="0"/>
+              </a:spcBef>
+              <a:spcAft>
+                <a:spcPct val="0"/>
+              </a:spcAft>
+              <a:buClrTx/>
+              <a:buSzTx/>
+              <a:buFontTx/>
+              <a:buNone/>
+              <a:tabLst/>
+            </a:pPr>
+            <a:endParaRPr lang="it-IT" altLang="it-IT" b="1" dirty="0">
+              <a:solidFill>
+                <a:schemeClr val="tx1"/>
+              </a:solidFill>
+              <a:latin typeface="Arial" panose="020B0604020202020204" pitchFamily="34" charset="0"/>
+            </a:endParaRPr>
+          </a:p>
+          <a:p>
+            <a:pPr marL="0" marR="0" lvl="0" indent="0" algn="l" defTabSz="914400" rtl="0" eaLnBrk="0" fontAlgn="base" latinLnBrk="0" hangingPunct="0">
+              <a:lnSpc>
+                <a:spcPct val="100000"/>
+              </a:lnSpc>
+              <a:spcBef>
+                <a:spcPct val="0"/>
+              </a:spcBef>
+              <a:spcAft>
+                <a:spcPct val="0"/>
+              </a:spcAft>
+              <a:buClrTx/>
+              <a:buSzTx/>
+              <a:buFontTx/>
+              <a:buNone/>
+              <a:tabLst/>
+            </a:pPr>
+            <a:endParaRPr lang="it-IT" altLang="it-IT" b="1" dirty="0">
+              <a:solidFill>
+                <a:schemeClr val="tx1"/>
+              </a:solidFill>
+              <a:latin typeface="Arial" panose="020B0604020202020204" pitchFamily="34" charset="0"/>
+            </a:endParaRPr>
+          </a:p>
+        </p:txBody>
+      </p:sp>
+    </p:spTree>
+    <p:extLst>
+      <p:ext uri="{BB962C8B-B14F-4D97-AF65-F5344CB8AC3E}">
+        <p14:creationId xmlns:p14="http://schemas.microsoft.com/office/powerpoint/2010/main" val="1186064759"/>
+      </p:ext>
+    </p:extLst>
+  </p:cSld>
+  <p:clrMapOvr>
+    <a:masterClrMapping/>
+  </p:clrMapOvr>
+</p:sld>
+</file>
+
+<file path=ppt/slides/slide21.xml><?xml version="1.0" encoding="utf-8"?>
+<p:sld xmlns:a="http://schemas.openxmlformats.org/drawingml/2006/main" xmlns:r="http://schemas.openxmlformats.org/officeDocument/2006/relationships" xmlns:p="http://schemas.openxmlformats.org/presentationml/2006/main">
+  <p:cSld>
+    <p:spTree>
+      <p:nvGrpSpPr>
+        <p:cNvPr id="1" name=""/>
+        <p:cNvGrpSpPr/>
+        <p:nvPr/>
+      </p:nvGrpSpPr>
+      <p:grpSpPr>
+        <a:xfrm>
+          <a:off x="0" y="0"/>
+          <a:ext cx="0" cy="0"/>
+          <a:chOff x="0" y="0"/>
+          <a:chExt cx="0" cy="0"/>
+        </a:xfrm>
+      </p:grpSpPr>
+      <p:sp>
+        <p:nvSpPr>
+          <p:cNvPr id="4" name="Google Shape;234;g3a9b731e4a8_0_59">
+            <a:extLst>
+              <a:ext uri="{FF2B5EF4-FFF2-40B4-BE49-F238E27FC236}">
+                <a16:creationId xmlns:a16="http://schemas.microsoft.com/office/drawing/2014/main" id="{879F89FA-4A11-6FD8-16C2-893617E2CD29}"/>
+              </a:ext>
+            </a:extLst>
+          </p:cNvPr>
+          <p:cNvSpPr txBox="1"/>
+          <p:nvPr/>
+        </p:nvSpPr>
+        <p:spPr>
+          <a:xfrm>
+            <a:off x="1873040" y="319065"/>
+            <a:ext cx="6567600" cy="400800"/>
+          </a:xfrm>
+          <a:prstGeom prst="rect">
+            <a:avLst/>
+          </a:prstGeom>
+          <a:noFill/>
+          <a:ln>
+            <a:noFill/>
+          </a:ln>
+        </p:spPr>
+        <p:txBody>
+          <a:bodyPr spcFirstLastPara="1" wrap="square" lIns="91425" tIns="45700" rIns="91425" bIns="45700" anchor="t" anchorCtr="0">
+            <a:spAutoFit/>
+          </a:bodyPr>
+          <a:lstStyle/>
+          <a:p>
+            <a:pPr marL="0" marR="0" lvl="0" indent="0" algn="l" rtl="0">
+              <a:spcBef>
+                <a:spcPts val="0"/>
+              </a:spcBef>
+              <a:spcAft>
+                <a:spcPts val="0"/>
+              </a:spcAft>
+              <a:buNone/>
+            </a:pPr>
+            <a:r>
+              <a:rPr lang="it-IT" sz="2004" b="1" dirty="0">
+                <a:solidFill>
+                  <a:srgbClr val="0F4761"/>
+                </a:solidFill>
+                <a:latin typeface="Arial"/>
+                <a:ea typeface="Arial"/>
+                <a:cs typeface="Arial"/>
+                <a:sym typeface="Arial"/>
+              </a:rPr>
+              <a:t>04 Dicembre 2025 – Segreti sui moduli Python</a:t>
+            </a:r>
+            <a:endParaRPr dirty="0"/>
+          </a:p>
+        </p:txBody>
+      </p:sp>
+      <p:pic>
+        <p:nvPicPr>
+          <p:cNvPr id="5" name="Google Shape;235;g3a9b731e4a8_0_59">
+            <a:extLst>
+              <a:ext uri="{FF2B5EF4-FFF2-40B4-BE49-F238E27FC236}">
+                <a16:creationId xmlns:a16="http://schemas.microsoft.com/office/drawing/2014/main" id="{5577E92C-BD82-138C-CA5C-B7E5701E38DD}"/>
+              </a:ext>
+            </a:extLst>
+          </p:cNvPr>
+          <p:cNvPicPr preferRelativeResize="0"/>
+          <p:nvPr/>
+        </p:nvPicPr>
+        <p:blipFill rotWithShape="1">
+          <a:blip r:embed="rId2">
+            <a:alphaModFix/>
+          </a:blip>
+          <a:srcRect/>
+          <a:stretch/>
+        </p:blipFill>
+        <p:spPr>
+          <a:xfrm>
+            <a:off x="551323" y="114848"/>
+            <a:ext cx="1268025" cy="809225"/>
+          </a:xfrm>
+          <a:prstGeom prst="rect">
+            <a:avLst/>
+          </a:prstGeom>
+          <a:noFill/>
+          <a:ln>
+            <a:noFill/>
+          </a:ln>
+        </p:spPr>
+      </p:pic>
+      <p:pic>
+        <p:nvPicPr>
+          <p:cNvPr id="8" name="Immagine 7">
+            <a:extLst>
+              <a:ext uri="{FF2B5EF4-FFF2-40B4-BE49-F238E27FC236}">
+                <a16:creationId xmlns:a16="http://schemas.microsoft.com/office/drawing/2014/main" id="{546E7B2A-45FA-E1A4-A5C8-1EAF951CDDCD}"/>
+              </a:ext>
+            </a:extLst>
+          </p:cNvPr>
+          <p:cNvPicPr>
+            <a:picLocks noChangeAspect="1"/>
+          </p:cNvPicPr>
+          <p:nvPr/>
+        </p:nvPicPr>
+        <p:blipFill>
+          <a:blip r:embed="rId3"/>
+          <a:stretch>
+            <a:fillRect/>
+          </a:stretch>
+        </p:blipFill>
+        <p:spPr>
+          <a:xfrm>
+            <a:off x="2181096" y="834935"/>
+            <a:ext cx="5010407" cy="3473629"/>
+          </a:xfrm>
+          <a:prstGeom prst="rect">
+            <a:avLst/>
+          </a:prstGeom>
+        </p:spPr>
+      </p:pic>
+      <p:sp>
+        <p:nvSpPr>
+          <p:cNvPr id="9" name="CasellaDiTesto 8">
+            <a:extLst>
+              <a:ext uri="{FF2B5EF4-FFF2-40B4-BE49-F238E27FC236}">
+                <a16:creationId xmlns:a16="http://schemas.microsoft.com/office/drawing/2014/main" id="{216FA822-2432-379A-C79D-A6B8A04B70C1}"/>
+              </a:ext>
+            </a:extLst>
+          </p:cNvPr>
+          <p:cNvSpPr txBox="1"/>
+          <p:nvPr/>
+        </p:nvSpPr>
+        <p:spPr>
+          <a:xfrm>
+            <a:off x="753171" y="4423634"/>
+            <a:ext cx="7866256" cy="523220"/>
+          </a:xfrm>
+          <a:prstGeom prst="rect">
+            <a:avLst/>
+          </a:prstGeom>
+          <a:noFill/>
+        </p:spPr>
+        <p:txBody>
+          <a:bodyPr wrap="none" rtlCol="0">
+            <a:spAutoFit/>
+          </a:bodyPr>
+          <a:lstStyle/>
+          <a:p>
+            <a:r>
+              <a:rPr lang="it-IT" dirty="0"/>
+              <a:t>Si è realizzato un servizio per implementare l’algoritmo utilizzando il package </a:t>
+            </a:r>
+            <a:r>
+              <a:rPr lang="it-IT" dirty="0" err="1"/>
+              <a:t>FastApi</a:t>
+            </a:r>
+            <a:r>
+              <a:rPr lang="it-IT" dirty="0"/>
+              <a:t> che integra</a:t>
+            </a:r>
+          </a:p>
+          <a:p>
+            <a:r>
+              <a:rPr lang="it-IT" dirty="0"/>
+              <a:t>anche </a:t>
+            </a:r>
+            <a:r>
+              <a:rPr lang="it-IT" dirty="0" err="1"/>
+              <a:t>swagger</a:t>
+            </a:r>
+            <a:r>
+              <a:rPr lang="it-IT" dirty="0"/>
+              <a:t> per testare il servizio e il calcolo algoritmo  </a:t>
+            </a:r>
+          </a:p>
+        </p:txBody>
+      </p:sp>
+    </p:spTree>
+    <p:extLst>
+      <p:ext uri="{BB962C8B-B14F-4D97-AF65-F5344CB8AC3E}">
+        <p14:creationId xmlns:p14="http://schemas.microsoft.com/office/powerpoint/2010/main" val="3035426981"/>
+      </p:ext>
+    </p:extLst>
+  </p:cSld>
+  <p:clrMapOvr>
+    <a:masterClrMapping/>
+  </p:clrMapOvr>
+</p:sld>
+</file>
+
+<file path=ppt/slides/slide22.xml><?xml version="1.0" encoding="utf-8"?>
+<p:sld xmlns:a="http://schemas.openxmlformats.org/drawingml/2006/main" xmlns:r="http://schemas.openxmlformats.org/officeDocument/2006/relationships" xmlns:p="http://schemas.openxmlformats.org/presentationml/2006/main">
+  <p:cSld>
+    <p:spTree>
+      <p:nvGrpSpPr>
+        <p:cNvPr id="1" name=""/>
+        <p:cNvGrpSpPr/>
+        <p:nvPr/>
+      </p:nvGrpSpPr>
+      <p:grpSpPr>
+        <a:xfrm>
+          <a:off x="0" y="0"/>
+          <a:ext cx="0" cy="0"/>
+          <a:chOff x="0" y="0"/>
+          <a:chExt cx="0" cy="0"/>
+        </a:xfrm>
+      </p:grpSpPr>
+      <p:sp>
+        <p:nvSpPr>
+          <p:cNvPr id="4" name="Google Shape;234;g3a9b731e4a8_0_59">
+            <a:extLst>
+              <a:ext uri="{FF2B5EF4-FFF2-40B4-BE49-F238E27FC236}">
+                <a16:creationId xmlns:a16="http://schemas.microsoft.com/office/drawing/2014/main" id="{C72B940D-D2AD-30CB-7EA3-1863E85FFE9C}"/>
+              </a:ext>
+            </a:extLst>
+          </p:cNvPr>
+          <p:cNvSpPr txBox="1"/>
+          <p:nvPr/>
+        </p:nvSpPr>
+        <p:spPr>
+          <a:xfrm>
+            <a:off x="1873040" y="319065"/>
+            <a:ext cx="6567600" cy="400800"/>
+          </a:xfrm>
+          <a:prstGeom prst="rect">
+            <a:avLst/>
+          </a:prstGeom>
+          <a:noFill/>
+          <a:ln>
+            <a:noFill/>
+          </a:ln>
+        </p:spPr>
+        <p:txBody>
+          <a:bodyPr spcFirstLastPara="1" wrap="square" lIns="91425" tIns="45700" rIns="91425" bIns="45700" anchor="t" anchorCtr="0">
+            <a:spAutoFit/>
+          </a:bodyPr>
+          <a:lstStyle/>
+          <a:p>
+            <a:pPr marL="0" marR="0" lvl="0" indent="0" algn="l" rtl="0">
+              <a:spcBef>
+                <a:spcPts val="0"/>
+              </a:spcBef>
+              <a:spcAft>
+                <a:spcPts val="0"/>
+              </a:spcAft>
+              <a:buNone/>
+            </a:pPr>
+            <a:r>
+              <a:rPr lang="it-IT" sz="2004" b="1" dirty="0">
+                <a:solidFill>
+                  <a:srgbClr val="0F4761"/>
+                </a:solidFill>
+                <a:latin typeface="Arial"/>
+                <a:ea typeface="Arial"/>
+                <a:cs typeface="Arial"/>
+                <a:sym typeface="Arial"/>
+              </a:rPr>
+              <a:t>04 Dicembre 2025 – Segreti sui moduli Python</a:t>
+            </a:r>
+            <a:endParaRPr dirty="0"/>
+          </a:p>
+        </p:txBody>
+      </p:sp>
+      <p:pic>
+        <p:nvPicPr>
+          <p:cNvPr id="5" name="Google Shape;235;g3a9b731e4a8_0_59">
+            <a:extLst>
+              <a:ext uri="{FF2B5EF4-FFF2-40B4-BE49-F238E27FC236}">
+                <a16:creationId xmlns:a16="http://schemas.microsoft.com/office/drawing/2014/main" id="{D26AC762-CFF4-6BED-6C86-BE4C234815CA}"/>
+              </a:ext>
+            </a:extLst>
+          </p:cNvPr>
+          <p:cNvPicPr preferRelativeResize="0"/>
+          <p:nvPr/>
+        </p:nvPicPr>
+        <p:blipFill rotWithShape="1">
+          <a:blip r:embed="rId2">
+            <a:alphaModFix/>
+          </a:blip>
+          <a:srcRect/>
+          <a:stretch/>
+        </p:blipFill>
+        <p:spPr>
+          <a:xfrm>
+            <a:off x="551323" y="114848"/>
+            <a:ext cx="1268025" cy="809225"/>
+          </a:xfrm>
+          <a:prstGeom prst="rect">
+            <a:avLst/>
+          </a:prstGeom>
+          <a:noFill/>
+          <a:ln>
+            <a:noFill/>
+          </a:ln>
+        </p:spPr>
+      </p:pic>
+      <p:pic>
+        <p:nvPicPr>
+          <p:cNvPr id="7" name="Immagine 6">
+            <a:extLst>
+              <a:ext uri="{FF2B5EF4-FFF2-40B4-BE49-F238E27FC236}">
+                <a16:creationId xmlns:a16="http://schemas.microsoft.com/office/drawing/2014/main" id="{B919CE02-818A-132A-C3E0-0EF9BBAF6D3D}"/>
+              </a:ext>
+            </a:extLst>
+          </p:cNvPr>
+          <p:cNvPicPr>
+            <a:picLocks noChangeAspect="1"/>
+          </p:cNvPicPr>
+          <p:nvPr/>
+        </p:nvPicPr>
+        <p:blipFill>
+          <a:blip r:embed="rId3"/>
+          <a:stretch>
+            <a:fillRect/>
+          </a:stretch>
+        </p:blipFill>
+        <p:spPr>
+          <a:xfrm>
+            <a:off x="1438835" y="1021977"/>
+            <a:ext cx="5916706" cy="2736159"/>
+          </a:xfrm>
+          <a:prstGeom prst="rect">
+            <a:avLst/>
+          </a:prstGeom>
+        </p:spPr>
+      </p:pic>
+      <p:sp>
+        <p:nvSpPr>
+          <p:cNvPr id="8" name="CasellaDiTesto 7">
+            <a:extLst>
+              <a:ext uri="{FF2B5EF4-FFF2-40B4-BE49-F238E27FC236}">
+                <a16:creationId xmlns:a16="http://schemas.microsoft.com/office/drawing/2014/main" id="{C9B8C36C-1AF5-A67E-4527-BFE7E4A08C08}"/>
+              </a:ext>
+            </a:extLst>
+          </p:cNvPr>
+          <p:cNvSpPr txBox="1"/>
+          <p:nvPr/>
+        </p:nvSpPr>
+        <p:spPr>
+          <a:xfrm>
+            <a:off x="2030507" y="3906359"/>
+            <a:ext cx="4891083" cy="307777"/>
+          </a:xfrm>
+          <a:prstGeom prst="rect">
+            <a:avLst/>
+          </a:prstGeom>
+          <a:noFill/>
+        </p:spPr>
+        <p:txBody>
+          <a:bodyPr wrap="none" rtlCol="0">
+            <a:spAutoFit/>
+          </a:bodyPr>
+          <a:lstStyle/>
+          <a:p>
+            <a:r>
+              <a:rPr lang="it-IT" dirty="0"/>
+              <a:t>Testing dell’algoritmo del calcolo delle distanze tra due liste</a:t>
+            </a:r>
+          </a:p>
+        </p:txBody>
+      </p:sp>
+    </p:spTree>
+    <p:extLst>
+      <p:ext uri="{BB962C8B-B14F-4D97-AF65-F5344CB8AC3E}">
+        <p14:creationId xmlns:p14="http://schemas.microsoft.com/office/powerpoint/2010/main" val="657158539"/>
+      </p:ext>
+    </p:extLst>
+  </p:cSld>
+  <p:clrMapOvr>
+    <a:masterClrMapping/>
+  </p:clrMapOvr>
+</p:sld>
+</file>
+
+<file path=ppt/slides/slide23.xml><?xml version="1.0" encoding="utf-8"?>
+<p:sld xmlns:a="http://schemas.openxmlformats.org/drawingml/2006/main" xmlns:r="http://schemas.openxmlformats.org/officeDocument/2006/relationships" xmlns:p="http://schemas.openxmlformats.org/presentationml/2006/main">
+  <p:cSld>
+    <p:spTree>
+      <p:nvGrpSpPr>
+        <p:cNvPr id="1" name=""/>
+        <p:cNvGrpSpPr/>
+        <p:nvPr/>
+      </p:nvGrpSpPr>
+      <p:grpSpPr>
+        <a:xfrm>
+          <a:off x="0" y="0"/>
+          <a:ext cx="0" cy="0"/>
+          <a:chOff x="0" y="0"/>
+          <a:chExt cx="0" cy="0"/>
+        </a:xfrm>
+      </p:grpSpPr>
+      <p:sp>
+        <p:nvSpPr>
+          <p:cNvPr id="4" name="Google Shape;234;g3a9b731e4a8_0_59">
+            <a:extLst>
+              <a:ext uri="{FF2B5EF4-FFF2-40B4-BE49-F238E27FC236}">
+                <a16:creationId xmlns:a16="http://schemas.microsoft.com/office/drawing/2014/main" id="{9A449A1F-5D20-AE91-EB7D-B702C7CE1007}"/>
+              </a:ext>
+            </a:extLst>
+          </p:cNvPr>
+          <p:cNvSpPr txBox="1"/>
+          <p:nvPr/>
+        </p:nvSpPr>
+        <p:spPr>
+          <a:xfrm>
+            <a:off x="1873040" y="319065"/>
+            <a:ext cx="6567600" cy="400800"/>
+          </a:xfrm>
+          <a:prstGeom prst="rect">
+            <a:avLst/>
+          </a:prstGeom>
+          <a:noFill/>
+          <a:ln>
+            <a:noFill/>
+          </a:ln>
+        </p:spPr>
+        <p:txBody>
+          <a:bodyPr spcFirstLastPara="1" wrap="square" lIns="91425" tIns="45700" rIns="91425" bIns="45700" anchor="t" anchorCtr="0">
+            <a:spAutoFit/>
+          </a:bodyPr>
+          <a:lstStyle/>
+          <a:p>
+            <a:pPr marL="0" marR="0" lvl="0" indent="0" algn="l" rtl="0">
+              <a:spcBef>
+                <a:spcPts val="0"/>
+              </a:spcBef>
+              <a:spcAft>
+                <a:spcPts val="0"/>
+              </a:spcAft>
+              <a:buNone/>
+            </a:pPr>
+            <a:r>
+              <a:rPr lang="it-IT" sz="2004" b="1" dirty="0">
+                <a:solidFill>
+                  <a:srgbClr val="0F4761"/>
+                </a:solidFill>
+                <a:latin typeface="Arial"/>
+                <a:ea typeface="Arial"/>
+                <a:cs typeface="Arial"/>
+                <a:sym typeface="Arial"/>
+              </a:rPr>
+              <a:t>04 Dicembre 2025 – Segreti sui moduli Python</a:t>
+            </a:r>
+            <a:endParaRPr dirty="0"/>
+          </a:p>
+        </p:txBody>
+      </p:sp>
+      <p:pic>
+        <p:nvPicPr>
+          <p:cNvPr id="5" name="Google Shape;235;g3a9b731e4a8_0_59">
+            <a:extLst>
+              <a:ext uri="{FF2B5EF4-FFF2-40B4-BE49-F238E27FC236}">
+                <a16:creationId xmlns:a16="http://schemas.microsoft.com/office/drawing/2014/main" id="{448F1734-EE78-7740-BD85-28C136069315}"/>
+              </a:ext>
+            </a:extLst>
+          </p:cNvPr>
+          <p:cNvPicPr preferRelativeResize="0"/>
+          <p:nvPr/>
+        </p:nvPicPr>
+        <p:blipFill rotWithShape="1">
+          <a:blip r:embed="rId2">
+            <a:alphaModFix/>
+          </a:blip>
+          <a:srcRect/>
+          <a:stretch/>
+        </p:blipFill>
+        <p:spPr>
+          <a:xfrm>
+            <a:off x="551323" y="114848"/>
+            <a:ext cx="1268025" cy="809225"/>
+          </a:xfrm>
+          <a:prstGeom prst="rect">
+            <a:avLst/>
+          </a:prstGeom>
+          <a:noFill/>
+          <a:ln>
+            <a:noFill/>
+          </a:ln>
+        </p:spPr>
+      </p:pic>
+      <p:pic>
+        <p:nvPicPr>
+          <p:cNvPr id="7" name="Immagine 6">
+            <a:extLst>
+              <a:ext uri="{FF2B5EF4-FFF2-40B4-BE49-F238E27FC236}">
+                <a16:creationId xmlns:a16="http://schemas.microsoft.com/office/drawing/2014/main" id="{4F2A0C9B-3A84-7104-6E37-C660D1683781}"/>
+              </a:ext>
+            </a:extLst>
+          </p:cNvPr>
+          <p:cNvPicPr>
+            <a:picLocks noChangeAspect="1"/>
+          </p:cNvPicPr>
+          <p:nvPr/>
+        </p:nvPicPr>
+        <p:blipFill>
+          <a:blip r:embed="rId3"/>
+          <a:stretch>
+            <a:fillRect/>
+          </a:stretch>
+        </p:blipFill>
+        <p:spPr>
+          <a:xfrm>
+            <a:off x="390601" y="1015252"/>
+            <a:ext cx="3408193" cy="3467986"/>
+          </a:xfrm>
+          <a:prstGeom prst="rect">
+            <a:avLst/>
+          </a:prstGeom>
+        </p:spPr>
+      </p:pic>
+      <p:pic>
+        <p:nvPicPr>
+          <p:cNvPr id="9" name="Immagine 8">
+            <a:extLst>
+              <a:ext uri="{FF2B5EF4-FFF2-40B4-BE49-F238E27FC236}">
+                <a16:creationId xmlns:a16="http://schemas.microsoft.com/office/drawing/2014/main" id="{5200E1C3-5CDC-A91A-BB3C-1CC79B64F722}"/>
+              </a:ext>
+            </a:extLst>
+          </p:cNvPr>
+          <p:cNvPicPr>
+            <a:picLocks noChangeAspect="1"/>
+          </p:cNvPicPr>
+          <p:nvPr/>
+        </p:nvPicPr>
+        <p:blipFill>
+          <a:blip r:embed="rId4"/>
+          <a:stretch>
+            <a:fillRect/>
+          </a:stretch>
+        </p:blipFill>
+        <p:spPr>
+          <a:xfrm>
+            <a:off x="4019410" y="1015252"/>
+            <a:ext cx="3955022" cy="3143736"/>
+          </a:xfrm>
+          <a:prstGeom prst="rect">
+            <a:avLst/>
+          </a:prstGeom>
+        </p:spPr>
+      </p:pic>
+    </p:spTree>
+    <p:extLst>
+      <p:ext uri="{BB962C8B-B14F-4D97-AF65-F5344CB8AC3E}">
+        <p14:creationId xmlns:p14="http://schemas.microsoft.com/office/powerpoint/2010/main" val="58139383"/>
+      </p:ext>
+    </p:extLst>
+  </p:cSld>
+  <p:clrMapOvr>
+    <a:masterClrMapping/>
+  </p:clrMapOvr>
+</p:sld>
+</file>
+
+<file path=ppt/slides/slide24.xml><?xml version="1.0" encoding="utf-8"?>
+<p:sld xmlns:a="http://schemas.openxmlformats.org/drawingml/2006/main" xmlns:r="http://schemas.openxmlformats.org/officeDocument/2006/relationships" xmlns:p="http://schemas.openxmlformats.org/presentationml/2006/main">
+  <p:cSld>
+    <p:spTree>
+      <p:nvGrpSpPr>
         <p:cNvPr id="1" name="Shape 241"/>
         <p:cNvGrpSpPr/>
         <p:nvPr/>
@@ -15923,212 +17755,6 @@
           </a:p>
         </p:txBody>
       </p:sp>
-    </p:spTree>
-  </p:cSld>
-  <p:clrMapOvr>
-    <a:masterClrMapping/>
-  </p:clrMapOvr>
-</p:sld>
-</file>
-
-<file path=ppt/slides/slide2.xml><?xml version="1.0" encoding="utf-8"?>
-<p:sld xmlns:a="http://schemas.openxmlformats.org/drawingml/2006/main" xmlns:r="http://schemas.openxmlformats.org/officeDocument/2006/relationships" xmlns:p="http://schemas.openxmlformats.org/presentationml/2006/main">
-  <p:cSld>
-    <p:spTree>
-      <p:nvGrpSpPr>
-        <p:cNvPr id="1" name="Shape 95"/>
-        <p:cNvGrpSpPr/>
-        <p:nvPr/>
-      </p:nvGrpSpPr>
-      <p:grpSpPr>
-        <a:xfrm>
-          <a:off x="0" y="0"/>
-          <a:ext cx="0" cy="0"/>
-          <a:chOff x="0" y="0"/>
-          <a:chExt cx="0" cy="0"/>
-        </a:xfrm>
-      </p:grpSpPr>
-      <p:sp>
-        <p:nvSpPr>
-          <p:cNvPr id="96" name="Google Shape;96;p2"/>
-          <p:cNvSpPr/>
-          <p:nvPr/>
-        </p:nvSpPr>
-        <p:spPr>
-          <a:xfrm>
-            <a:off x="238200" y="2345447"/>
-            <a:ext cx="8991523" cy="2312184"/>
-          </a:xfrm>
-          <a:custGeom>
-            <a:avLst/>
-            <a:gdLst/>
-            <a:ahLst/>
-            <a:cxnLst/>
-            <a:rect l="l" t="t" r="r" b="b"/>
-            <a:pathLst>
-              <a:path w="5619702" h="1758315" extrusionOk="0">
-                <a:moveTo>
-                  <a:pt x="0" y="0"/>
-                </a:moveTo>
-                <a:lnTo>
-                  <a:pt x="5619702" y="0"/>
-                </a:lnTo>
-                <a:lnTo>
-                  <a:pt x="5619702" y="1758315"/>
-                </a:lnTo>
-                <a:lnTo>
-                  <a:pt x="0" y="1758315"/>
-                </a:lnTo>
-                <a:lnTo>
-                  <a:pt x="0" y="0"/>
-                </a:lnTo>
-                <a:close/>
-              </a:path>
-            </a:pathLst>
-          </a:custGeom>
-          <a:blipFill rotWithShape="1">
-            <a:blip r:embed="rId3">
-              <a:alphaModFix/>
-            </a:blip>
-            <a:stretch>
-              <a:fillRect/>
-            </a:stretch>
-          </a:blipFill>
-          <a:ln>
-            <a:noFill/>
-          </a:ln>
-        </p:spPr>
-      </p:sp>
-      <p:sp>
-        <p:nvSpPr>
-          <p:cNvPr id="97" name="Google Shape;97;p2"/>
-          <p:cNvSpPr txBox="1"/>
-          <p:nvPr/>
-        </p:nvSpPr>
-        <p:spPr>
-          <a:xfrm>
-            <a:off x="551329" y="1651572"/>
-            <a:ext cx="3216600" cy="431700"/>
-          </a:xfrm>
-          <a:prstGeom prst="rect">
-            <a:avLst/>
-          </a:prstGeom>
-          <a:noFill/>
-          <a:ln>
-            <a:noFill/>
-          </a:ln>
-        </p:spPr>
-        <p:txBody>
-          <a:bodyPr spcFirstLastPara="1" wrap="square" lIns="0" tIns="0" rIns="0" bIns="0" anchor="t" anchorCtr="0">
-            <a:spAutoFit/>
-          </a:bodyPr>
-          <a:lstStyle/>
-          <a:p>
-            <a:pPr marL="0" marR="0" lvl="0" indent="0" algn="l" rtl="0">
-              <a:lnSpc>
-                <a:spcPct val="58437"/>
-              </a:lnSpc>
-              <a:spcBef>
-                <a:spcPts val="0"/>
-              </a:spcBef>
-              <a:spcAft>
-                <a:spcPts val="0"/>
-              </a:spcAft>
-              <a:buNone/>
-            </a:pPr>
-            <a:r>
-              <a:rPr lang="it-IT" sz="4800">
-                <a:solidFill>
-                  <a:srgbClr val="0F4761"/>
-                </a:solidFill>
-                <a:latin typeface="Arial"/>
-                <a:ea typeface="Arial"/>
-                <a:cs typeface="Arial"/>
-                <a:sym typeface="Arial"/>
-              </a:rPr>
-              <a:t>Profilo </a:t>
-            </a:r>
-            <a:endParaRPr/>
-          </a:p>
-        </p:txBody>
-      </p:sp>
-      <p:sp>
-        <p:nvSpPr>
-          <p:cNvPr id="98" name="Google Shape;98;p2"/>
-          <p:cNvSpPr txBox="1"/>
-          <p:nvPr/>
-        </p:nvSpPr>
-        <p:spPr>
-          <a:xfrm>
-            <a:off x="1799190" y="341028"/>
-            <a:ext cx="6567600" cy="400800"/>
-          </a:xfrm>
-          <a:prstGeom prst="rect">
-            <a:avLst/>
-          </a:prstGeom>
-          <a:noFill/>
-          <a:ln>
-            <a:noFill/>
-          </a:ln>
-        </p:spPr>
-        <p:txBody>
-          <a:bodyPr spcFirstLastPara="1" wrap="square" lIns="91425" tIns="45700" rIns="91425" bIns="45700" anchor="t" anchorCtr="0">
-            <a:spAutoFit/>
-          </a:bodyPr>
-          <a:lstStyle/>
-          <a:p>
-            <a:pPr marL="0" marR="0" lvl="0" indent="0" algn="l" rtl="0">
-              <a:spcBef>
-                <a:spcPts val="0"/>
-              </a:spcBef>
-              <a:spcAft>
-                <a:spcPts val="0"/>
-              </a:spcAft>
-              <a:buNone/>
-            </a:pPr>
-            <a:r>
-              <a:rPr lang="it-IT" sz="2004" b="1">
-                <a:solidFill>
-                  <a:srgbClr val="0F4761"/>
-                </a:solidFill>
-                <a:latin typeface="Arial"/>
-                <a:ea typeface="Arial"/>
-                <a:cs typeface="Arial"/>
-                <a:sym typeface="Arial"/>
-              </a:rPr>
-              <a:t>04 Dicembre 2025 – Segreti sui moduli Python</a:t>
-            </a:r>
-            <a:endParaRPr/>
-          </a:p>
-        </p:txBody>
-      </p:sp>
-      <p:pic>
-        <p:nvPicPr>
-          <p:cNvPr id="99" name="Google Shape;99;p2"/>
-          <p:cNvPicPr preferRelativeResize="0"/>
-          <p:nvPr/>
-        </p:nvPicPr>
-        <p:blipFill rotWithShape="1">
-          <a:blip r:embed="rId4">
-            <a:alphaModFix/>
-          </a:blip>
-          <a:srcRect/>
-          <a:stretch/>
-        </p:blipFill>
-        <p:spPr>
-          <a:xfrm>
-            <a:off x="551323" y="114848"/>
-            <a:ext cx="1268025" cy="809225"/>
-          </a:xfrm>
-          <a:prstGeom prst="rect">
-            <a:avLst/>
-          </a:prstGeom>
-          <a:noFill/>
-          <a:ln>
-            <a:noFill/>
-          </a:ln>
-        </p:spPr>
-      </p:pic>
     </p:spTree>
   </p:cSld>
   <p:clrMapOvr>

</xml_diff>

<commit_message>
aggiornata release slide talk'
</commit_message>
<xml_diff>
--- a/SEGRETI_MODULI_PYTHON_FINALSLIDE.pptx
+++ b/SEGRETI_MODULI_PYTHON_FINALSLIDE.pptx
@@ -41,6 +41,7 @@
     <p:sldId id="286" r:id="rId36"/>
     <p:sldId id="287" r:id="rId37"/>
     <p:sldId id="288" r:id="rId38"/>
+    <p:sldId id="289" r:id="rId39"/>
   </p:sldIdLst>
   <p:sldSz cy="5143500" cx="9144000"/>
   <p:notesSz cx="6858000" cy="9144000"/>
@@ -289,7 +290,7 @@
       </p15:sldGuideLst>
     </p:ext>
     <p:ext uri="GoogleSlidesCustomDataVersion2">
-      <go:slidesCustomData xmlns:go="http://customooxmlschemas.google.com/" r:id="rId39" roundtripDataSignature="AMtx7mgAA88vlTMa94FWF6pCP9xJHMfJzA=="/>
+      <go:slidesCustomData xmlns:go="http://customooxmlschemas.google.com/" r:id="rId40" roundtripDataSignature="AMtx7mgQucvfgzgh8zg7dLE8ACzTvMHwSw=="/>
     </p:ext>
   </p:extLst>
 </p:presentation>
@@ -2376,7 +2377,7 @@
       </p:grpSpPr>
       <p:sp>
         <p:nvSpPr>
-          <p:cNvPr id="221" name="Google Shape;221;g3a9b731e4a8_0_31:notes"/>
+          <p:cNvPr id="221" name="Google Shape;221;g3ad6459f57e_0_0:notes"/>
           <p:cNvSpPr/>
           <p:nvPr>
             <p:ph idx="2" type="sldImg"/>
@@ -2411,7 +2412,7 @@
       </p:sp>
       <p:sp>
         <p:nvSpPr>
-          <p:cNvPr id="222" name="Google Shape;222;g3a9b731e4a8_0_31:notes"/>
+          <p:cNvPr id="222" name="Google Shape;222;g3ad6459f57e_0_0:notes"/>
           <p:cNvSpPr txBox="1"/>
           <p:nvPr>
             <p:ph idx="1" type="body"/>
@@ -2450,7 +2451,7 @@
       </p:sp>
       <p:sp>
         <p:nvSpPr>
-          <p:cNvPr id="223" name="Google Shape;223;g3a9b731e4a8_0_31:notes"/>
+          <p:cNvPr id="223" name="Google Shape;223;g3ad6459f57e_0_0:notes"/>
           <p:cNvSpPr txBox="1"/>
           <p:nvPr>
             <p:ph idx="12" type="sldNum"/>
@@ -2505,7 +2506,7 @@
   <p:cSld>
     <p:spTree>
       <p:nvGrpSpPr>
-        <p:cNvPr id="229" name="Shape 229"/>
+        <p:cNvPr id="230" name="Shape 230"/>
         <p:cNvGrpSpPr/>
         <p:nvPr/>
       </p:nvGrpSpPr>
@@ -2519,7 +2520,7 @@
       </p:grpSpPr>
       <p:sp>
         <p:nvSpPr>
-          <p:cNvPr id="230" name="Google Shape;230;g3a9b731e4a8_0_40:notes"/>
+          <p:cNvPr id="231" name="Google Shape;231;g3a9b731e4a8_0_31:notes"/>
           <p:cNvSpPr/>
           <p:nvPr>
             <p:ph idx="2" type="sldImg"/>
@@ -2554,7 +2555,7 @@
       </p:sp>
       <p:sp>
         <p:nvSpPr>
-          <p:cNvPr id="231" name="Google Shape;231;g3a9b731e4a8_0_40:notes"/>
+          <p:cNvPr id="232" name="Google Shape;232;g3a9b731e4a8_0_31:notes"/>
           <p:cNvSpPr txBox="1"/>
           <p:nvPr>
             <p:ph idx="1" type="body"/>
@@ -2593,7 +2594,7 @@
       </p:sp>
       <p:sp>
         <p:nvSpPr>
-          <p:cNvPr id="232" name="Google Shape;232;g3a9b731e4a8_0_40:notes"/>
+          <p:cNvPr id="233" name="Google Shape;233;g3a9b731e4a8_0_31:notes"/>
           <p:cNvSpPr txBox="1"/>
           <p:nvPr>
             <p:ph idx="12" type="sldNum"/>
@@ -2648,7 +2649,7 @@
   <p:cSld>
     <p:spTree>
       <p:nvGrpSpPr>
-        <p:cNvPr id="238" name="Shape 238"/>
+        <p:cNvPr id="239" name="Shape 239"/>
         <p:cNvGrpSpPr/>
         <p:nvPr/>
       </p:nvGrpSpPr>
@@ -2662,7 +2663,7 @@
       </p:grpSpPr>
       <p:sp>
         <p:nvSpPr>
-          <p:cNvPr id="239" name="Google Shape;239;g38660da28e9_0_0:notes"/>
+          <p:cNvPr id="240" name="Google Shape;240;g3a9b731e4a8_0_40:notes"/>
           <p:cNvSpPr/>
           <p:nvPr>
             <p:ph idx="2" type="sldImg"/>
@@ -2697,7 +2698,7 @@
       </p:sp>
       <p:sp>
         <p:nvSpPr>
-          <p:cNvPr id="240" name="Google Shape;240;g38660da28e9_0_0:notes"/>
+          <p:cNvPr id="241" name="Google Shape;241;g3a9b731e4a8_0_40:notes"/>
           <p:cNvSpPr txBox="1"/>
           <p:nvPr>
             <p:ph idx="1" type="body"/>
@@ -2736,7 +2737,7 @@
       </p:sp>
       <p:sp>
         <p:nvSpPr>
-          <p:cNvPr id="241" name="Google Shape;241;g38660da28e9_0_0:notes"/>
+          <p:cNvPr id="242" name="Google Shape;242;g3a9b731e4a8_0_40:notes"/>
           <p:cNvSpPr txBox="1"/>
           <p:nvPr>
             <p:ph idx="12" type="sldNum"/>
@@ -2890,7 +2891,7 @@
   <p:cSld>
     <p:spTree>
       <p:nvGrpSpPr>
-        <p:cNvPr id="247" name="Shape 247"/>
+        <p:cNvPr id="248" name="Shape 248"/>
         <p:cNvGrpSpPr/>
         <p:nvPr/>
       </p:nvGrpSpPr>
@@ -2904,7 +2905,7 @@
       </p:grpSpPr>
       <p:sp>
         <p:nvSpPr>
-          <p:cNvPr id="248" name="Google Shape;248;g39a291deda2_1_0:notes"/>
+          <p:cNvPr id="249" name="Google Shape;249;g38660da28e9_0_0:notes"/>
           <p:cNvSpPr/>
           <p:nvPr>
             <p:ph idx="2" type="sldImg"/>
@@ -2939,7 +2940,7 @@
       </p:sp>
       <p:sp>
         <p:nvSpPr>
-          <p:cNvPr id="249" name="Google Shape;249;g39a291deda2_1_0:notes"/>
+          <p:cNvPr id="250" name="Google Shape;250;g38660da28e9_0_0:notes"/>
           <p:cNvSpPr txBox="1"/>
           <p:nvPr>
             <p:ph idx="1" type="body"/>
@@ -2978,7 +2979,7 @@
       </p:sp>
       <p:sp>
         <p:nvSpPr>
-          <p:cNvPr id="250" name="Google Shape;250;g39a291deda2_1_0:notes"/>
+          <p:cNvPr id="251" name="Google Shape;251;g38660da28e9_0_0:notes"/>
           <p:cNvSpPr txBox="1"/>
           <p:nvPr>
             <p:ph idx="12" type="sldNum"/>
@@ -3033,7 +3034,7 @@
   <p:cSld>
     <p:spTree>
       <p:nvGrpSpPr>
-        <p:cNvPr id="256" name="Shape 256"/>
+        <p:cNvPr id="257" name="Shape 257"/>
         <p:cNvGrpSpPr/>
         <p:nvPr/>
       </p:nvGrpSpPr>
@@ -3047,7 +3048,7 @@
       </p:grpSpPr>
       <p:sp>
         <p:nvSpPr>
-          <p:cNvPr id="257" name="Google Shape;257;g39a291deda2_1_14:notes"/>
+          <p:cNvPr id="258" name="Google Shape;258;g39a291deda2_1_0:notes"/>
           <p:cNvSpPr/>
           <p:nvPr>
             <p:ph idx="2" type="sldImg"/>
@@ -3082,7 +3083,7 @@
       </p:sp>
       <p:sp>
         <p:nvSpPr>
-          <p:cNvPr id="258" name="Google Shape;258;g39a291deda2_1_14:notes"/>
+          <p:cNvPr id="259" name="Google Shape;259;g39a291deda2_1_0:notes"/>
           <p:cNvSpPr txBox="1"/>
           <p:nvPr>
             <p:ph idx="1" type="body"/>
@@ -3121,7 +3122,7 @@
       </p:sp>
       <p:sp>
         <p:nvSpPr>
-          <p:cNvPr id="259" name="Google Shape;259;g39a291deda2_1_14:notes"/>
+          <p:cNvPr id="260" name="Google Shape;260;g39a291deda2_1_0:notes"/>
           <p:cNvSpPr txBox="1"/>
           <p:nvPr>
             <p:ph idx="12" type="sldNum"/>
@@ -3176,7 +3177,7 @@
   <p:cSld>
     <p:spTree>
       <p:nvGrpSpPr>
-        <p:cNvPr id="265" name="Shape 265"/>
+        <p:cNvPr id="266" name="Shape 266"/>
         <p:cNvGrpSpPr/>
         <p:nvPr/>
       </p:nvGrpSpPr>
@@ -3190,7 +3191,7 @@
       </p:grpSpPr>
       <p:sp>
         <p:nvSpPr>
-          <p:cNvPr id="266" name="Google Shape;266;g39a291deda2_1_23:notes"/>
+          <p:cNvPr id="267" name="Google Shape;267;g39a291deda2_1_14:notes"/>
           <p:cNvSpPr/>
           <p:nvPr>
             <p:ph idx="2" type="sldImg"/>
@@ -3225,7 +3226,7 @@
       </p:sp>
       <p:sp>
         <p:nvSpPr>
-          <p:cNvPr id="267" name="Google Shape;267;g39a291deda2_1_23:notes"/>
+          <p:cNvPr id="268" name="Google Shape;268;g39a291deda2_1_14:notes"/>
           <p:cNvSpPr txBox="1"/>
           <p:nvPr>
             <p:ph idx="1" type="body"/>
@@ -3264,7 +3265,7 @@
       </p:sp>
       <p:sp>
         <p:nvSpPr>
-          <p:cNvPr id="268" name="Google Shape;268;g39a291deda2_1_23:notes"/>
+          <p:cNvPr id="269" name="Google Shape;269;g39a291deda2_1_14:notes"/>
           <p:cNvSpPr txBox="1"/>
           <p:nvPr>
             <p:ph idx="12" type="sldNum"/>
@@ -3319,7 +3320,7 @@
   <p:cSld>
     <p:spTree>
       <p:nvGrpSpPr>
-        <p:cNvPr id="276" name="Shape 276"/>
+        <p:cNvPr id="275" name="Shape 275"/>
         <p:cNvGrpSpPr/>
         <p:nvPr/>
       </p:nvGrpSpPr>
@@ -3333,7 +3334,7 @@
       </p:grpSpPr>
       <p:sp>
         <p:nvSpPr>
-          <p:cNvPr id="277" name="Google Shape;277;g39a291deda2_1_39:notes"/>
+          <p:cNvPr id="276" name="Google Shape;276;g39a291deda2_1_23:notes"/>
           <p:cNvSpPr/>
           <p:nvPr>
             <p:ph idx="2" type="sldImg"/>
@@ -3368,7 +3369,7 @@
       </p:sp>
       <p:sp>
         <p:nvSpPr>
-          <p:cNvPr id="278" name="Google Shape;278;g39a291deda2_1_39:notes"/>
+          <p:cNvPr id="277" name="Google Shape;277;g39a291deda2_1_23:notes"/>
           <p:cNvSpPr txBox="1"/>
           <p:nvPr>
             <p:ph idx="1" type="body"/>
@@ -3407,7 +3408,7 @@
       </p:sp>
       <p:sp>
         <p:nvSpPr>
-          <p:cNvPr id="279" name="Google Shape;279;g39a291deda2_1_39:notes"/>
+          <p:cNvPr id="278" name="Google Shape;278;g39a291deda2_1_23:notes"/>
           <p:cNvSpPr txBox="1"/>
           <p:nvPr>
             <p:ph idx="12" type="sldNum"/>
@@ -3476,7 +3477,7 @@
       </p:grpSpPr>
       <p:sp>
         <p:nvSpPr>
-          <p:cNvPr id="287" name="Google Shape;287;g39a291deda2_1_50:notes"/>
+          <p:cNvPr id="287" name="Google Shape;287;g39a291deda2_1_39:notes"/>
           <p:cNvSpPr/>
           <p:nvPr>
             <p:ph idx="2" type="sldImg"/>
@@ -3511,7 +3512,7 @@
       </p:sp>
       <p:sp>
         <p:nvSpPr>
-          <p:cNvPr id="288" name="Google Shape;288;g39a291deda2_1_50:notes"/>
+          <p:cNvPr id="288" name="Google Shape;288;g39a291deda2_1_39:notes"/>
           <p:cNvSpPr txBox="1"/>
           <p:nvPr>
             <p:ph idx="1" type="body"/>
@@ -3550,7 +3551,7 @@
       </p:sp>
       <p:sp>
         <p:nvSpPr>
-          <p:cNvPr id="289" name="Google Shape;289;g39a291deda2_1_50:notes"/>
+          <p:cNvPr id="289" name="Google Shape;289;g39a291deda2_1_39:notes"/>
           <p:cNvSpPr txBox="1"/>
           <p:nvPr>
             <p:ph idx="12" type="sldNum"/>
@@ -3605,7 +3606,7 @@
   <p:cSld>
     <p:spTree>
       <p:nvGrpSpPr>
-        <p:cNvPr id="295" name="Shape 295"/>
+        <p:cNvPr id="296" name="Shape 296"/>
         <p:cNvGrpSpPr/>
         <p:nvPr/>
       </p:nvGrpSpPr>
@@ -3619,7 +3620,7 @@
       </p:grpSpPr>
       <p:sp>
         <p:nvSpPr>
-          <p:cNvPr id="296" name="Google Shape;296;g3aa6201ac61_0_0:notes"/>
+          <p:cNvPr id="297" name="Google Shape;297;g39a291deda2_1_50:notes"/>
           <p:cNvSpPr/>
           <p:nvPr>
             <p:ph idx="2" type="sldImg"/>
@@ -3654,7 +3655,7 @@
       </p:sp>
       <p:sp>
         <p:nvSpPr>
-          <p:cNvPr id="297" name="Google Shape;297;g3aa6201ac61_0_0:notes"/>
+          <p:cNvPr id="298" name="Google Shape;298;g39a291deda2_1_50:notes"/>
           <p:cNvSpPr txBox="1"/>
           <p:nvPr>
             <p:ph idx="1" type="body"/>
@@ -3693,7 +3694,7 @@
       </p:sp>
       <p:sp>
         <p:nvSpPr>
-          <p:cNvPr id="298" name="Google Shape;298;g3aa6201ac61_0_0:notes"/>
+          <p:cNvPr id="299" name="Google Shape;299;g39a291deda2_1_50:notes"/>
           <p:cNvSpPr txBox="1"/>
           <p:nvPr>
             <p:ph idx="12" type="sldNum"/>
@@ -3748,7 +3749,7 @@
   <p:cSld>
     <p:spTree>
       <p:nvGrpSpPr>
-        <p:cNvPr id="304" name="Shape 304"/>
+        <p:cNvPr id="305" name="Shape 305"/>
         <p:cNvGrpSpPr/>
         <p:nvPr/>
       </p:nvGrpSpPr>
@@ -3762,7 +3763,7 @@
       </p:grpSpPr>
       <p:sp>
         <p:nvSpPr>
-          <p:cNvPr id="305" name="Google Shape;305;g3aa6201ac61_0_6:notes"/>
+          <p:cNvPr id="306" name="Google Shape;306;g3aa6201ac61_0_0:notes"/>
           <p:cNvSpPr/>
           <p:nvPr>
             <p:ph idx="2" type="sldImg"/>
@@ -3797,7 +3798,7 @@
       </p:sp>
       <p:sp>
         <p:nvSpPr>
-          <p:cNvPr id="306" name="Google Shape;306;g3aa6201ac61_0_6:notes"/>
+          <p:cNvPr id="307" name="Google Shape;307;g3aa6201ac61_0_0:notes"/>
           <p:cNvSpPr txBox="1"/>
           <p:nvPr>
             <p:ph idx="1" type="body"/>
@@ -3836,7 +3837,7 @@
       </p:sp>
       <p:sp>
         <p:nvSpPr>
-          <p:cNvPr id="307" name="Google Shape;307;g3aa6201ac61_0_6:notes"/>
+          <p:cNvPr id="308" name="Google Shape;308;g3aa6201ac61_0_0:notes"/>
           <p:cNvSpPr txBox="1"/>
           <p:nvPr>
             <p:ph idx="12" type="sldNum"/>
@@ -3891,7 +3892,7 @@
   <p:cSld>
     <p:spTree>
       <p:nvGrpSpPr>
-        <p:cNvPr id="312" name="Shape 312"/>
+        <p:cNvPr id="314" name="Shape 314"/>
         <p:cNvGrpSpPr/>
         <p:nvPr/>
       </p:nvGrpSpPr>
@@ -3905,7 +3906,7 @@
       </p:grpSpPr>
       <p:sp>
         <p:nvSpPr>
-          <p:cNvPr id="313" name="Google Shape;313;g3ac9e9082d3_0_11:notes"/>
+          <p:cNvPr id="315" name="Google Shape;315;g3aa6201ac61_0_6:notes"/>
           <p:cNvSpPr/>
           <p:nvPr>
             <p:ph idx="2" type="sldImg"/>
@@ -3940,7 +3941,7 @@
       </p:sp>
       <p:sp>
         <p:nvSpPr>
-          <p:cNvPr id="314" name="Google Shape;314;g3ac9e9082d3_0_11:notes"/>
+          <p:cNvPr id="316" name="Google Shape;316;g3aa6201ac61_0_6:notes"/>
           <p:cNvSpPr txBox="1"/>
           <p:nvPr>
             <p:ph idx="1" type="body"/>
@@ -3979,7 +3980,7 @@
       </p:sp>
       <p:sp>
         <p:nvSpPr>
-          <p:cNvPr id="315" name="Google Shape;315;g3ac9e9082d3_0_11:notes"/>
+          <p:cNvPr id="317" name="Google Shape;317;g3aa6201ac61_0_6:notes"/>
           <p:cNvSpPr txBox="1"/>
           <p:nvPr>
             <p:ph idx="12" type="sldNum"/>
@@ -4034,7 +4035,7 @@
   <p:cSld>
     <p:spTree>
       <p:nvGrpSpPr>
-        <p:cNvPr id="321" name="Shape 321"/>
+        <p:cNvPr id="322" name="Shape 322"/>
         <p:cNvGrpSpPr/>
         <p:nvPr/>
       </p:nvGrpSpPr>
@@ -4048,7 +4049,7 @@
       </p:grpSpPr>
       <p:sp>
         <p:nvSpPr>
-          <p:cNvPr id="322" name="Google Shape;322;g3ac9e796f79_0_0:notes"/>
+          <p:cNvPr id="323" name="Google Shape;323;g3ac9e9082d3_0_11:notes"/>
           <p:cNvSpPr/>
           <p:nvPr>
             <p:ph idx="2" type="sldImg"/>
@@ -4083,7 +4084,7 @@
       </p:sp>
       <p:sp>
         <p:nvSpPr>
-          <p:cNvPr id="323" name="Google Shape;323;g3ac9e796f79_0_0:notes"/>
+          <p:cNvPr id="324" name="Google Shape;324;g3ac9e9082d3_0_11:notes"/>
           <p:cNvSpPr txBox="1"/>
           <p:nvPr>
             <p:ph idx="1" type="body"/>
@@ -4122,7 +4123,7 @@
       </p:sp>
       <p:sp>
         <p:nvSpPr>
-          <p:cNvPr id="324" name="Google Shape;324;g3ac9e796f79_0_0:notes"/>
+          <p:cNvPr id="325" name="Google Shape;325;g3ac9e9082d3_0_11:notes"/>
           <p:cNvSpPr txBox="1"/>
           <p:nvPr>
             <p:ph idx="12" type="sldNum"/>
@@ -4177,7 +4178,7 @@
   <p:cSld>
     <p:spTree>
       <p:nvGrpSpPr>
-        <p:cNvPr id="328" name="Shape 328"/>
+        <p:cNvPr id="331" name="Shape 331"/>
         <p:cNvGrpSpPr/>
         <p:nvPr/>
       </p:nvGrpSpPr>
@@ -4191,7 +4192,7 @@
       </p:grpSpPr>
       <p:sp>
         <p:nvSpPr>
-          <p:cNvPr id="329" name="Google Shape;329;g3aa6201ac61_0_12:notes"/>
+          <p:cNvPr id="332" name="Google Shape;332;g3ac9e796f79_0_0:notes"/>
           <p:cNvSpPr/>
           <p:nvPr>
             <p:ph idx="2" type="sldImg"/>
@@ -4226,7 +4227,7 @@
       </p:sp>
       <p:sp>
         <p:nvSpPr>
-          <p:cNvPr id="330" name="Google Shape;330;g3aa6201ac61_0_12:notes"/>
+          <p:cNvPr id="333" name="Google Shape;333;g3ac9e796f79_0_0:notes"/>
           <p:cNvSpPr txBox="1"/>
           <p:nvPr>
             <p:ph idx="1" type="body"/>
@@ -4265,7 +4266,7 @@
       </p:sp>
       <p:sp>
         <p:nvSpPr>
-          <p:cNvPr id="331" name="Google Shape;331;g3aa6201ac61_0_12:notes"/>
+          <p:cNvPr id="334" name="Google Shape;334;g3ac9e796f79_0_0:notes"/>
           <p:cNvSpPr txBox="1"/>
           <p:nvPr>
             <p:ph idx="12" type="sldNum"/>
@@ -4419,7 +4420,7 @@
   <p:cSld>
     <p:spTree>
       <p:nvGrpSpPr>
-        <p:cNvPr id="336" name="Shape 336"/>
+        <p:cNvPr id="338" name="Shape 338"/>
         <p:cNvGrpSpPr/>
         <p:nvPr/>
       </p:nvGrpSpPr>
@@ -4433,7 +4434,7 @@
       </p:grpSpPr>
       <p:sp>
         <p:nvSpPr>
-          <p:cNvPr id="337" name="Google Shape;337;g3ac9e796f79_0_6:notes"/>
+          <p:cNvPr id="339" name="Google Shape;339;g3aa6201ac61_0_12:notes"/>
           <p:cNvSpPr/>
           <p:nvPr>
             <p:ph idx="2" type="sldImg"/>
@@ -4468,7 +4469,7 @@
       </p:sp>
       <p:sp>
         <p:nvSpPr>
-          <p:cNvPr id="338" name="Google Shape;338;g3ac9e796f79_0_6:notes"/>
+          <p:cNvPr id="340" name="Google Shape;340;g3aa6201ac61_0_12:notes"/>
           <p:cNvSpPr txBox="1"/>
           <p:nvPr>
             <p:ph idx="1" type="body"/>
@@ -4507,7 +4508,7 @@
       </p:sp>
       <p:sp>
         <p:nvSpPr>
-          <p:cNvPr id="339" name="Google Shape;339;g3ac9e796f79_0_6:notes"/>
+          <p:cNvPr id="341" name="Google Shape;341;g3aa6201ac61_0_12:notes"/>
           <p:cNvSpPr txBox="1"/>
           <p:nvPr>
             <p:ph idx="12" type="sldNum"/>
@@ -4562,7 +4563,7 @@
   <p:cSld>
     <p:spTree>
       <p:nvGrpSpPr>
-        <p:cNvPr id="345" name="Shape 345"/>
+        <p:cNvPr id="346" name="Shape 346"/>
         <p:cNvGrpSpPr/>
         <p:nvPr/>
       </p:nvGrpSpPr>
@@ -4576,7 +4577,7 @@
       </p:grpSpPr>
       <p:sp>
         <p:nvSpPr>
-          <p:cNvPr id="346" name="Google Shape;346;g3aa6201ac61_0_19:notes"/>
+          <p:cNvPr id="347" name="Google Shape;347;g3ac9e796f79_0_6:notes"/>
           <p:cNvSpPr/>
           <p:nvPr>
             <p:ph idx="2" type="sldImg"/>
@@ -4611,7 +4612,7 @@
       </p:sp>
       <p:sp>
         <p:nvSpPr>
-          <p:cNvPr id="347" name="Google Shape;347;g3aa6201ac61_0_19:notes"/>
+          <p:cNvPr id="348" name="Google Shape;348;g3ac9e796f79_0_6:notes"/>
           <p:cNvSpPr txBox="1"/>
           <p:nvPr>
             <p:ph idx="1" type="body"/>
@@ -4650,7 +4651,7 @@
       </p:sp>
       <p:sp>
         <p:nvSpPr>
-          <p:cNvPr id="348" name="Google Shape;348;g3aa6201ac61_0_19:notes"/>
+          <p:cNvPr id="349" name="Google Shape;349;g3ac9e796f79_0_6:notes"/>
           <p:cNvSpPr txBox="1"/>
           <p:nvPr>
             <p:ph idx="12" type="sldNum"/>
@@ -4705,7 +4706,7 @@
   <p:cSld>
     <p:spTree>
       <p:nvGrpSpPr>
-        <p:cNvPr id="353" name="Shape 353"/>
+        <p:cNvPr id="355" name="Shape 355"/>
         <p:cNvGrpSpPr/>
         <p:nvPr/>
       </p:nvGrpSpPr>
@@ -4719,7 +4720,7 @@
       </p:grpSpPr>
       <p:sp>
         <p:nvSpPr>
-          <p:cNvPr id="354" name="Google Shape;354;g3aa6201ac61_0_26:notes"/>
+          <p:cNvPr id="356" name="Google Shape;356;g3aa6201ac61_0_19:notes"/>
           <p:cNvSpPr/>
           <p:nvPr>
             <p:ph idx="2" type="sldImg"/>
@@ -4754,7 +4755,7 @@
       </p:sp>
       <p:sp>
         <p:nvSpPr>
-          <p:cNvPr id="355" name="Google Shape;355;g3aa6201ac61_0_26:notes"/>
+          <p:cNvPr id="357" name="Google Shape;357;g3aa6201ac61_0_19:notes"/>
           <p:cNvSpPr txBox="1"/>
           <p:nvPr>
             <p:ph idx="1" type="body"/>
@@ -4793,7 +4794,7 @@
       </p:sp>
       <p:sp>
         <p:nvSpPr>
-          <p:cNvPr id="356" name="Google Shape;356;g3aa6201ac61_0_26:notes"/>
+          <p:cNvPr id="358" name="Google Shape;358;g3aa6201ac61_0_19:notes"/>
           <p:cNvSpPr txBox="1"/>
           <p:nvPr>
             <p:ph idx="12" type="sldNum"/>
@@ -4848,7 +4849,7 @@
   <p:cSld>
     <p:spTree>
       <p:nvGrpSpPr>
-        <p:cNvPr id="362" name="Shape 362"/>
+        <p:cNvPr id="363" name="Shape 363"/>
         <p:cNvGrpSpPr/>
         <p:nvPr/>
       </p:nvGrpSpPr>
@@ -4862,7 +4863,42 @@
       </p:grpSpPr>
       <p:sp>
         <p:nvSpPr>
-          <p:cNvPr id="363" name="Google Shape;363;p15:notes"/>
+          <p:cNvPr id="364" name="Google Shape;364;g3aa6201ac61_0_26:notes"/>
+          <p:cNvSpPr/>
+          <p:nvPr>
+            <p:ph idx="2" type="sldImg"/>
+          </p:nvPr>
+        </p:nvSpPr>
+        <p:spPr>
+          <a:xfrm>
+            <a:off x="685260" y="1143000"/>
+            <a:ext cx="5487600" cy="3086100"/>
+          </a:xfrm>
+          <a:custGeom>
+            <a:rect b="b" l="l" r="r" t="t"/>
+            <a:pathLst>
+              <a:path extrusionOk="0" h="120000" w="120000">
+                <a:moveTo>
+                  <a:pt x="0" y="0"/>
+                </a:moveTo>
+                <a:lnTo>
+                  <a:pt x="120000" y="0"/>
+                </a:lnTo>
+                <a:lnTo>
+                  <a:pt x="120000" y="120000"/>
+                </a:lnTo>
+                <a:lnTo>
+                  <a:pt x="0" y="120000"/>
+                </a:lnTo>
+                <a:close/>
+              </a:path>
+            </a:pathLst>
+          </a:custGeom>
+        </p:spPr>
+      </p:sp>
+      <p:sp>
+        <p:nvSpPr>
+          <p:cNvPr id="365" name="Google Shape;365;g3aa6201ac61_0_26:notes"/>
           <p:cNvSpPr txBox="1"/>
           <p:nvPr>
             <p:ph idx="1" type="body"/>
@@ -4871,7 +4907,7 @@
         <p:spPr>
           <a:xfrm>
             <a:off x="685800" y="4400550"/>
-            <a:ext cx="5486400" cy="3600450"/>
+            <a:ext cx="5486400" cy="3600600"/>
           </a:xfrm>
           <a:prstGeom prst="rect">
             <a:avLst/>
@@ -4901,7 +4937,115 @@
       </p:sp>
       <p:sp>
         <p:nvSpPr>
-          <p:cNvPr id="364" name="Google Shape;364;p15:notes"/>
+          <p:cNvPr id="366" name="Google Shape;366;g3aa6201ac61_0_26:notes"/>
+          <p:cNvSpPr txBox="1"/>
+          <p:nvPr>
+            <p:ph idx="12" type="sldNum"/>
+          </p:nvPr>
+        </p:nvSpPr>
+        <p:spPr>
+          <a:xfrm>
+            <a:off x="3884613" y="8685213"/>
+            <a:ext cx="2971800" cy="458700"/>
+          </a:xfrm>
+          <a:prstGeom prst="rect">
+            <a:avLst/>
+          </a:prstGeom>
+        </p:spPr>
+        <p:txBody>
+          <a:bodyPr anchorCtr="0" anchor="b" bIns="45700" lIns="91425" spcFirstLastPara="1" rIns="91425" wrap="square" tIns="45700">
+            <a:noAutofit/>
+          </a:bodyPr>
+          <a:lstStyle/>
+          <a:p>
+            <a:pPr indent="0" lvl="0" marL="0" rtl="0" algn="r">
+              <a:spcBef>
+                <a:spcPts val="0"/>
+              </a:spcBef>
+              <a:spcAft>
+                <a:spcPts val="0"/>
+              </a:spcAft>
+              <a:buClr>
+                <a:srgbClr val="000000"/>
+              </a:buClr>
+              <a:buFont typeface="Arial"/>
+              <a:buNone/>
+            </a:pPr>
+            <a:fld id="{00000000-1234-1234-1234-123412341234}" type="slidenum">
+              <a:rPr lang="it-IT"/>
+              <a:t>‹#›</a:t>
+            </a:fld>
+            <a:endParaRPr/>
+          </a:p>
+        </p:txBody>
+      </p:sp>
+    </p:spTree>
+  </p:cSld>
+  <p:clrMapOvr>
+    <a:masterClrMapping/>
+  </p:clrMapOvr>
+</p:notes>
+</file>
+
+<file path=ppt/notesSlides/notesSlide34.xml><?xml version="1.0" encoding="utf-8"?>
+<p:notes xmlns:a="http://schemas.openxmlformats.org/drawingml/2006/main" xmlns:r="http://schemas.openxmlformats.org/officeDocument/2006/relationships" xmlns:mc="http://schemas.openxmlformats.org/markup-compatibility/2006" xmlns:mv="urn:schemas-microsoft-com:mac:vml" xmlns:p="http://schemas.openxmlformats.org/presentationml/2006/main" xmlns:c="http://schemas.openxmlformats.org/drawingml/2006/chart" xmlns:dgm="http://schemas.openxmlformats.org/drawingml/2006/diagram" xmlns:o="urn:schemas-microsoft-com:office:office" xmlns:v="urn:schemas-microsoft-com:vml" xmlns:pvml="urn:schemas-microsoft-com:office:powerpoint" xmlns:com="http://schemas.openxmlformats.org/drawingml/2006/compatibility" xmlns:p14="http://schemas.microsoft.com/office/powerpoint/2010/main" xmlns:p15="http://schemas.microsoft.com/office/powerpoint/2012/main" xmlns:ahyp="http://schemas.microsoft.com/office/drawing/2018/hyperlinkcolor" showMasterPhAnim="0" showMasterSp="0">
+  <p:cSld>
+    <p:spTree>
+      <p:nvGrpSpPr>
+        <p:cNvPr id="372" name="Shape 372"/>
+        <p:cNvGrpSpPr/>
+        <p:nvPr/>
+      </p:nvGrpSpPr>
+      <p:grpSpPr>
+        <a:xfrm>
+          <a:off x="0" y="0"/>
+          <a:ext cx="0" cy="0"/>
+          <a:chOff x="0" y="0"/>
+          <a:chExt cx="0" cy="0"/>
+        </a:xfrm>
+      </p:grpSpPr>
+      <p:sp>
+        <p:nvSpPr>
+          <p:cNvPr id="373" name="Google Shape;373;p15:notes"/>
+          <p:cNvSpPr txBox="1"/>
+          <p:nvPr>
+            <p:ph idx="1" type="body"/>
+          </p:nvPr>
+        </p:nvSpPr>
+        <p:spPr>
+          <a:xfrm>
+            <a:off x="685800" y="4400550"/>
+            <a:ext cx="5486400" cy="3600450"/>
+          </a:xfrm>
+          <a:prstGeom prst="rect">
+            <a:avLst/>
+          </a:prstGeom>
+        </p:spPr>
+        <p:txBody>
+          <a:bodyPr anchorCtr="0" anchor="t" bIns="45700" lIns="91425" spcFirstLastPara="1" rIns="91425" wrap="square" tIns="45700">
+            <a:noAutofit/>
+          </a:bodyPr>
+          <a:lstStyle/>
+          <a:p>
+            <a:pPr indent="0" lvl="0" marL="0" rtl="0" algn="l">
+              <a:spcBef>
+                <a:spcPts val="0"/>
+              </a:spcBef>
+              <a:spcAft>
+                <a:spcPts val="0"/>
+              </a:spcAft>
+              <a:buNone/>
+            </a:pPr>
+            <a:r>
+              <a:t/>
+            </a:r>
+            <a:endParaRPr/>
+          </a:p>
+        </p:txBody>
+      </p:sp>
+      <p:sp>
+        <p:nvSpPr>
+          <p:cNvPr id="374" name="Google Shape;374;p15:notes"/>
           <p:cNvSpPr/>
           <p:nvPr>
             <p:ph idx="2" type="sldImg"/>
@@ -16857,13 +17001,13 @@
       </p:grpSpPr>
       <p:sp>
         <p:nvSpPr>
-          <p:cNvPr id="225" name="Google Shape;225;g3a9b731e4a8_0_31"/>
+          <p:cNvPr id="225" name="Google Shape;225;g3ad6459f57e_0_0"/>
           <p:cNvSpPr txBox="1"/>
           <p:nvPr/>
         </p:nvSpPr>
         <p:spPr>
           <a:xfrm>
-            <a:off x="2057615" y="417515"/>
+            <a:off x="1873040" y="319065"/>
             <a:ext cx="6567600" cy="400800"/>
           </a:xfrm>
           <a:prstGeom prst="rect">
@@ -16907,7 +17051,7 @@
       </p:sp>
       <p:pic>
         <p:nvPicPr>
-          <p:cNvPr id="226" name="Google Shape;226;g3a9b731e4a8_0_31"/>
+          <p:cNvPr id="226" name="Google Shape;226;g3ad6459f57e_0_0"/>
           <p:cNvPicPr preferRelativeResize="0"/>
           <p:nvPr/>
         </p:nvPicPr>
@@ -16920,7 +17064,7 @@
         </p:blipFill>
         <p:spPr>
           <a:xfrm>
-            <a:off x="735898" y="213298"/>
+            <a:off x="551323" y="114848"/>
             <a:ext cx="1268025" cy="809225"/>
           </a:xfrm>
           <a:prstGeom prst="rect">
@@ -16932,9 +17076,67 @@
           </a:ln>
         </p:spPr>
       </p:pic>
+      <p:sp>
+        <p:nvSpPr>
+          <p:cNvPr id="227" name="Google Shape;227;g3ad6459f57e_0_0"/>
+          <p:cNvSpPr txBox="1"/>
+          <p:nvPr/>
+        </p:nvSpPr>
+        <p:spPr>
+          <a:xfrm>
+            <a:off x="1787850" y="953763"/>
+            <a:ext cx="6652800" cy="461700"/>
+          </a:xfrm>
+          <a:prstGeom prst="rect">
+            <a:avLst/>
+          </a:prstGeom>
+          <a:noFill/>
+          <a:ln>
+            <a:noFill/>
+          </a:ln>
+        </p:spPr>
+        <p:txBody>
+          <a:bodyPr anchorCtr="0" anchor="t" bIns="91425" lIns="91425" spcFirstLastPara="1" rIns="91425" wrap="square" tIns="91425">
+            <a:spAutoFit/>
+          </a:bodyPr>
+          <a:lstStyle/>
+          <a:p>
+            <a:pPr indent="0" lvl="0" marL="0" rtl="0" algn="l">
+              <a:spcBef>
+                <a:spcPts val="0"/>
+              </a:spcBef>
+              <a:spcAft>
+                <a:spcPts val="0"/>
+              </a:spcAft>
+              <a:buNone/>
+            </a:pPr>
+            <a:r>
+              <a:rPr lang="it-IT" sz="1800">
+                <a:solidFill>
+                  <a:schemeClr val="dk1"/>
+                </a:solidFill>
+                <a:latin typeface="Calibri"/>
+                <a:ea typeface="Calibri"/>
+                <a:cs typeface="Calibri"/>
+                <a:sym typeface="Calibri"/>
+              </a:rPr>
+              <a:t>Possibili sintassi del comando con python -m unittest ….</a:t>
+            </a:r>
+            <a:endParaRPr sz="1800">
+              <a:solidFill>
+                <a:schemeClr val="dk1"/>
+              </a:solidFill>
+              <a:latin typeface="Calibri"/>
+              <a:ea typeface="Calibri"/>
+              <a:cs typeface="Calibri"/>
+              <a:sym typeface="Calibri"/>
+            </a:endParaRPr>
+          </a:p>
+        </p:txBody>
+      </p:sp>
       <p:pic>
         <p:nvPicPr>
-          <p:cNvPr id="227" name="Google Shape;227;g3a9b731e4a8_0_31"/>
+          <p:cNvPr id="228" name="Google Shape;228;g3ad6459f57e_0_0"/>
           <p:cNvPicPr preferRelativeResize="0"/>
           <p:nvPr/>
         </p:nvPicPr>
@@ -16948,8 +17150,8 @@
         </p:blipFill>
         <p:spPr>
           <a:xfrm>
-            <a:off x="447725" y="2950275"/>
-            <a:ext cx="8839200" cy="581526"/>
+            <a:off x="354025" y="1649361"/>
+            <a:ext cx="8839204" cy="750987"/>
           </a:xfrm>
           <a:prstGeom prst="rect">
             <a:avLst/>
@@ -16960,9 +17162,167 @@
           </a:ln>
         </p:spPr>
       </p:pic>
+      <p:pic>
+        <p:nvPicPr>
+          <p:cNvPr id="229" name="Google Shape;229;g3ad6459f57e_0_0"/>
+          <p:cNvPicPr preferRelativeResize="0"/>
+          <p:nvPr/>
+        </p:nvPicPr>
+        <p:blipFill>
+          <a:blip r:embed="rId5">
+            <a:alphaModFix/>
+          </a:blip>
+          <a:stretch>
+            <a:fillRect/>
+          </a:stretch>
+        </p:blipFill>
+        <p:spPr>
+          <a:xfrm>
+            <a:off x="447725" y="2971123"/>
+            <a:ext cx="8839202" cy="1541194"/>
+          </a:xfrm>
+          <a:prstGeom prst="rect">
+            <a:avLst/>
+          </a:prstGeom>
+          <a:noFill/>
+          <a:ln>
+            <a:noFill/>
+          </a:ln>
+        </p:spPr>
+      </p:pic>
+    </p:spTree>
+  </p:cSld>
+  <p:clrMapOvr>
+    <a:masterClrMapping/>
+  </p:clrMapOvr>
+</p:sld>
+</file>
+
+<file path=ppt/slides/slide18.xml><?xml version="1.0" encoding="utf-8"?>
+<p:sld xmlns:a="http://schemas.openxmlformats.org/drawingml/2006/main" xmlns:r="http://schemas.openxmlformats.org/officeDocument/2006/relationships" xmlns:mc="http://schemas.openxmlformats.org/markup-compatibility/2006" xmlns:mv="urn:schemas-microsoft-com:mac:vml" xmlns:p="http://schemas.openxmlformats.org/presentationml/2006/main" xmlns:c="http://schemas.openxmlformats.org/drawingml/2006/chart" xmlns:dgm="http://schemas.openxmlformats.org/drawingml/2006/diagram" xmlns:o="urn:schemas-microsoft-com:office:office" xmlns:v="urn:schemas-microsoft-com:vml" xmlns:pvml="urn:schemas-microsoft-com:office:powerpoint" xmlns:com="http://schemas.openxmlformats.org/drawingml/2006/compatibility" xmlns:p14="http://schemas.microsoft.com/office/powerpoint/2010/main" xmlns:p15="http://schemas.microsoft.com/office/powerpoint/2012/main" xmlns:ahyp="http://schemas.microsoft.com/office/drawing/2018/hyperlinkcolor">
+  <p:cSld>
+    <p:spTree>
+      <p:nvGrpSpPr>
+        <p:cNvPr id="234" name="Shape 234"/>
+        <p:cNvGrpSpPr/>
+        <p:nvPr/>
+      </p:nvGrpSpPr>
+      <p:grpSpPr>
+        <a:xfrm>
+          <a:off x="0" y="0"/>
+          <a:ext cx="0" cy="0"/>
+          <a:chOff x="0" y="0"/>
+          <a:chExt cx="0" cy="0"/>
+        </a:xfrm>
+      </p:grpSpPr>
       <p:sp>
         <p:nvSpPr>
-          <p:cNvPr id="228" name="Google Shape;228;g3a9b731e4a8_0_31"/>
+          <p:cNvPr id="235" name="Google Shape;235;g3a9b731e4a8_0_31"/>
+          <p:cNvSpPr txBox="1"/>
+          <p:nvPr/>
+        </p:nvSpPr>
+        <p:spPr>
+          <a:xfrm>
+            <a:off x="2057615" y="417515"/>
+            <a:ext cx="6567600" cy="400800"/>
+          </a:xfrm>
+          <a:prstGeom prst="rect">
+            <a:avLst/>
+          </a:prstGeom>
+          <a:noFill/>
+          <a:ln>
+            <a:noFill/>
+          </a:ln>
+        </p:spPr>
+        <p:txBody>
+          <a:bodyPr anchorCtr="0" anchor="t" bIns="45700" lIns="91425" spcFirstLastPara="1" rIns="91425" wrap="square" tIns="45700">
+            <a:spAutoFit/>
+          </a:bodyPr>
+          <a:lstStyle/>
+          <a:p>
+            <a:pPr indent="0" lvl="0" marL="0" marR="0" rtl="0" algn="l">
+              <a:spcBef>
+                <a:spcPts val="0"/>
+              </a:spcBef>
+              <a:spcAft>
+                <a:spcPts val="0"/>
+              </a:spcAft>
+              <a:buNone/>
+            </a:pPr>
+            <a:r>
+              <a:rPr b="1" lang="it-IT" sz="2004">
+                <a:solidFill>
+                  <a:srgbClr val="0F4761"/>
+                </a:solidFill>
+                <a:latin typeface="Arial"/>
+                <a:ea typeface="Arial"/>
+                <a:cs typeface="Arial"/>
+                <a:sym typeface="Arial"/>
+              </a:rPr>
+              <a:t>04 Dicembre 2025 – Segreti sui moduli Python</a:t>
+            </a:r>
+            <a:endParaRPr/>
+          </a:p>
+        </p:txBody>
+      </p:sp>
+      <p:pic>
+        <p:nvPicPr>
+          <p:cNvPr id="236" name="Google Shape;236;g3a9b731e4a8_0_31"/>
+          <p:cNvPicPr preferRelativeResize="0"/>
+          <p:nvPr/>
+        </p:nvPicPr>
+        <p:blipFill rotWithShape="1">
+          <a:blip r:embed="rId3">
+            <a:alphaModFix/>
+          </a:blip>
+          <a:srcRect b="0" l="0" r="0" t="0"/>
+          <a:stretch/>
+        </p:blipFill>
+        <p:spPr>
+          <a:xfrm>
+            <a:off x="735898" y="213298"/>
+            <a:ext cx="1268025" cy="809225"/>
+          </a:xfrm>
+          <a:prstGeom prst="rect">
+            <a:avLst/>
+          </a:prstGeom>
+          <a:noFill/>
+          <a:ln>
+            <a:noFill/>
+          </a:ln>
+        </p:spPr>
+      </p:pic>
+      <p:pic>
+        <p:nvPicPr>
+          <p:cNvPr id="237" name="Google Shape;237;g3a9b731e4a8_0_31"/>
+          <p:cNvPicPr preferRelativeResize="0"/>
+          <p:nvPr/>
+        </p:nvPicPr>
+        <p:blipFill>
+          <a:blip r:embed="rId4">
+            <a:alphaModFix/>
+          </a:blip>
+          <a:stretch>
+            <a:fillRect/>
+          </a:stretch>
+        </p:blipFill>
+        <p:spPr>
+          <a:xfrm>
+            <a:off x="447725" y="2950275"/>
+            <a:ext cx="8839200" cy="581526"/>
+          </a:xfrm>
+          <a:prstGeom prst="rect">
+            <a:avLst/>
+          </a:prstGeom>
+          <a:noFill/>
+          <a:ln>
+            <a:noFill/>
+          </a:ln>
+        </p:spPr>
+      </p:pic>
+      <p:sp>
+        <p:nvSpPr>
+          <p:cNvPr id="238" name="Google Shape;238;g3a9b731e4a8_0_31"/>
           <p:cNvSpPr txBox="1"/>
           <p:nvPr/>
         </p:nvSpPr>
@@ -17058,12 +17418,12 @@
 </p:sld>
 </file>
 
-<file path=ppt/slides/slide18.xml><?xml version="1.0" encoding="utf-8"?>
+<file path=ppt/slides/slide19.xml><?xml version="1.0" encoding="utf-8"?>
 <p:sld xmlns:a="http://schemas.openxmlformats.org/drawingml/2006/main" xmlns:r="http://schemas.openxmlformats.org/officeDocument/2006/relationships" xmlns:mc="http://schemas.openxmlformats.org/markup-compatibility/2006" xmlns:mv="urn:schemas-microsoft-com:mac:vml" xmlns:p="http://schemas.openxmlformats.org/presentationml/2006/main" xmlns:c="http://schemas.openxmlformats.org/drawingml/2006/chart" xmlns:dgm="http://schemas.openxmlformats.org/drawingml/2006/diagram" xmlns:o="urn:schemas-microsoft-com:office:office" xmlns:v="urn:schemas-microsoft-com:vml" xmlns:pvml="urn:schemas-microsoft-com:office:powerpoint" xmlns:com="http://schemas.openxmlformats.org/drawingml/2006/compatibility" xmlns:p14="http://schemas.microsoft.com/office/powerpoint/2010/main" xmlns:p15="http://schemas.microsoft.com/office/powerpoint/2012/main" xmlns:ahyp="http://schemas.microsoft.com/office/drawing/2018/hyperlinkcolor">
   <p:cSld>
     <p:spTree>
       <p:nvGrpSpPr>
-        <p:cNvPr id="233" name="Shape 233"/>
+        <p:cNvPr id="243" name="Shape 243"/>
         <p:cNvGrpSpPr/>
         <p:nvPr/>
       </p:nvGrpSpPr>
@@ -17077,7 +17437,7 @@
       </p:grpSpPr>
       <p:sp>
         <p:nvSpPr>
-          <p:cNvPr id="234" name="Google Shape;234;g3a9b731e4a8_0_40"/>
+          <p:cNvPr id="244" name="Google Shape;244;g3a9b731e4a8_0_40"/>
           <p:cNvSpPr txBox="1"/>
           <p:nvPr/>
         </p:nvSpPr>
@@ -17127,7 +17487,7 @@
       </p:sp>
       <p:pic>
         <p:nvPicPr>
-          <p:cNvPr id="235" name="Google Shape;235;g3a9b731e4a8_0_40"/>
+          <p:cNvPr id="245" name="Google Shape;245;g3a9b731e4a8_0_40"/>
           <p:cNvPicPr preferRelativeResize="0"/>
           <p:nvPr/>
         </p:nvPicPr>
@@ -17154,7 +17514,7 @@
       </p:pic>
       <p:pic>
         <p:nvPicPr>
-          <p:cNvPr id="236" name="Google Shape;236;g3a9b731e4a8_0_40"/>
+          <p:cNvPr id="246" name="Google Shape;246;g3a9b731e4a8_0_40"/>
           <p:cNvPicPr preferRelativeResize="0"/>
           <p:nvPr/>
         </p:nvPicPr>
@@ -17182,7 +17542,7 @@
       </p:pic>
       <p:sp>
         <p:nvSpPr>
-          <p:cNvPr id="237" name="Google Shape;237;g3a9b731e4a8_0_40"/>
+          <p:cNvPr id="247" name="Google Shape;247;g3a9b731e4a8_0_40"/>
           <p:cNvSpPr txBox="1"/>
           <p:nvPr/>
         </p:nvSpPr>
@@ -17246,12 +17606,12 @@
 </p:sld>
 </file>
 
-<file path=ppt/slides/slide19.xml><?xml version="1.0" encoding="utf-8"?>
+<file path=ppt/slides/slide2.xml><?xml version="1.0" encoding="utf-8"?>
 <p:sld xmlns:a="http://schemas.openxmlformats.org/drawingml/2006/main" xmlns:r="http://schemas.openxmlformats.org/officeDocument/2006/relationships" xmlns:mc="http://schemas.openxmlformats.org/markup-compatibility/2006" xmlns:mv="urn:schemas-microsoft-com:mac:vml" xmlns:p="http://schemas.openxmlformats.org/presentationml/2006/main" xmlns:c="http://schemas.openxmlformats.org/drawingml/2006/chart" xmlns:dgm="http://schemas.openxmlformats.org/drawingml/2006/diagram" xmlns:o="urn:schemas-microsoft-com:office:office" xmlns:v="urn:schemas-microsoft-com:vml" xmlns:pvml="urn:schemas-microsoft-com:office:powerpoint" xmlns:com="http://schemas.openxmlformats.org/drawingml/2006/compatibility" xmlns:p14="http://schemas.microsoft.com/office/powerpoint/2010/main" xmlns:p15="http://schemas.microsoft.com/office/powerpoint/2012/main" xmlns:ahyp="http://schemas.microsoft.com/office/drawing/2018/hyperlinkcolor">
   <p:cSld>
     <p:spTree>
       <p:nvGrpSpPr>
-        <p:cNvPr id="242" name="Shape 242"/>
+        <p:cNvPr id="96" name="Shape 96"/>
         <p:cNvGrpSpPr/>
         <p:nvPr/>
       </p:nvGrpSpPr>
@@ -17265,7 +17625,448 @@
       </p:grpSpPr>
       <p:sp>
         <p:nvSpPr>
-          <p:cNvPr id="243" name="Google Shape;243;g38660da28e9_0_0"/>
+          <p:cNvPr id="97" name="Google Shape;97;p1"/>
+          <p:cNvSpPr txBox="1"/>
+          <p:nvPr/>
+        </p:nvSpPr>
+        <p:spPr>
+          <a:xfrm>
+            <a:off x="1252497" y="772991"/>
+            <a:ext cx="7192200" cy="387900"/>
+          </a:xfrm>
+          <a:prstGeom prst="rect">
+            <a:avLst/>
+          </a:prstGeom>
+          <a:noFill/>
+          <a:ln>
+            <a:noFill/>
+          </a:ln>
+        </p:spPr>
+        <p:txBody>
+          <a:bodyPr anchorCtr="0" anchor="t" bIns="0" lIns="0" spcFirstLastPara="1" rIns="0" wrap="square" tIns="0">
+            <a:spAutoFit/>
+          </a:bodyPr>
+          <a:lstStyle/>
+          <a:p>
+            <a:pPr indent="0" lvl="0" marL="0" marR="0" rtl="0" algn="l">
+              <a:lnSpc>
+                <a:spcPct val="78750"/>
+              </a:lnSpc>
+              <a:spcBef>
+                <a:spcPts val="0"/>
+              </a:spcBef>
+              <a:spcAft>
+                <a:spcPts val="0"/>
+              </a:spcAft>
+              <a:buNone/>
+            </a:pPr>
+            <a:r>
+              <a:rPr b="1" i="0" lang="it-IT" sz="3200" u="none" cap="none" strike="noStrike">
+                <a:solidFill>
+                  <a:schemeClr val="dk1"/>
+                </a:solidFill>
+                <a:latin typeface="Calibri"/>
+                <a:ea typeface="Calibri"/>
+                <a:cs typeface="Calibri"/>
+                <a:sym typeface="Calibri"/>
+              </a:rPr>
+              <a:t>        </a:t>
+            </a:r>
+            <a:r>
+              <a:rPr b="1" i="0" lang="it-IT" sz="3200" u="none" cap="none" strike="noStrike">
+                <a:solidFill>
+                  <a:srgbClr val="0F4761"/>
+                </a:solidFill>
+                <a:latin typeface="Arial"/>
+                <a:ea typeface="Arial"/>
+                <a:cs typeface="Arial"/>
+                <a:sym typeface="Arial"/>
+              </a:rPr>
+              <a:t>Segreti sui moduli Python</a:t>
+            </a:r>
+            <a:endParaRPr b="1" i="0" sz="3200" u="none" cap="none" strike="noStrike">
+              <a:solidFill>
+                <a:srgbClr val="0F4761"/>
+              </a:solidFill>
+              <a:latin typeface="Arial"/>
+              <a:ea typeface="Arial"/>
+              <a:cs typeface="Arial"/>
+              <a:sym typeface="Arial"/>
+            </a:endParaRPr>
+          </a:p>
+        </p:txBody>
+      </p:sp>
+      <p:pic>
+        <p:nvPicPr>
+          <p:cNvPr id="98" name="Google Shape;98;p1"/>
+          <p:cNvPicPr preferRelativeResize="0"/>
+          <p:nvPr/>
+        </p:nvPicPr>
+        <p:blipFill rotWithShape="1">
+          <a:blip r:embed="rId3">
+            <a:alphaModFix/>
+          </a:blip>
+          <a:srcRect b="0" l="0" r="0" t="0"/>
+          <a:stretch/>
+        </p:blipFill>
+        <p:spPr>
+          <a:xfrm>
+            <a:off x="551323" y="114848"/>
+            <a:ext cx="1268025" cy="809225"/>
+          </a:xfrm>
+          <a:prstGeom prst="rect">
+            <a:avLst/>
+          </a:prstGeom>
+          <a:noFill/>
+          <a:ln>
+            <a:noFill/>
+          </a:ln>
+        </p:spPr>
+      </p:pic>
+      <p:sp>
+        <p:nvSpPr>
+          <p:cNvPr id="99" name="Google Shape;99;p1"/>
+          <p:cNvSpPr txBox="1"/>
+          <p:nvPr/>
+        </p:nvSpPr>
+        <p:spPr>
+          <a:xfrm>
+            <a:off x="1680890" y="277000"/>
+            <a:ext cx="6567600" cy="400800"/>
+          </a:xfrm>
+          <a:prstGeom prst="rect">
+            <a:avLst/>
+          </a:prstGeom>
+          <a:noFill/>
+          <a:ln>
+            <a:noFill/>
+          </a:ln>
+        </p:spPr>
+        <p:txBody>
+          <a:bodyPr anchorCtr="0" anchor="t" bIns="45700" lIns="91425" spcFirstLastPara="1" rIns="91425" wrap="square" tIns="45700">
+            <a:spAutoFit/>
+          </a:bodyPr>
+          <a:lstStyle/>
+          <a:p>
+            <a:pPr indent="0" lvl="0" marL="0" marR="0" rtl="0" algn="l">
+              <a:spcBef>
+                <a:spcPts val="0"/>
+              </a:spcBef>
+              <a:spcAft>
+                <a:spcPts val="0"/>
+              </a:spcAft>
+              <a:buNone/>
+            </a:pPr>
+            <a:r>
+              <a:rPr b="1" i="0" lang="it-IT" sz="2004" u="none" cap="none" strike="noStrike">
+                <a:solidFill>
+                  <a:srgbClr val="0F4761"/>
+                </a:solidFill>
+                <a:latin typeface="Arial"/>
+                <a:ea typeface="Arial"/>
+                <a:cs typeface="Arial"/>
+                <a:sym typeface="Arial"/>
+              </a:rPr>
+              <a:t>04 Dicembre 2025 – Segreti sui moduli Python</a:t>
+            </a:r>
+            <a:endParaRPr/>
+          </a:p>
+        </p:txBody>
+      </p:sp>
+      <p:sp>
+        <p:nvSpPr>
+          <p:cNvPr id="100" name="Google Shape;100;p1"/>
+          <p:cNvSpPr txBox="1"/>
+          <p:nvPr/>
+        </p:nvSpPr>
+        <p:spPr>
+          <a:xfrm>
+            <a:off x="551326" y="1256099"/>
+            <a:ext cx="8147700" cy="3694200"/>
+          </a:xfrm>
+          <a:prstGeom prst="rect">
+            <a:avLst/>
+          </a:prstGeom>
+          <a:noFill/>
+          <a:ln>
+            <a:noFill/>
+          </a:ln>
+        </p:spPr>
+        <p:txBody>
+          <a:bodyPr anchorCtr="0" anchor="t" bIns="45700" lIns="91425" spcFirstLastPara="1" rIns="91425" wrap="square" tIns="45700">
+            <a:spAutoFit/>
+          </a:bodyPr>
+          <a:lstStyle/>
+          <a:p>
+            <a:pPr indent="-273050" lvl="0" marL="285750" marR="0" rtl="0" algn="l">
+              <a:spcBef>
+                <a:spcPts val="0"/>
+              </a:spcBef>
+              <a:spcAft>
+                <a:spcPts val="0"/>
+              </a:spcAft>
+              <a:buClr>
+                <a:schemeClr val="dk1"/>
+              </a:buClr>
+              <a:buSzPts val="2600"/>
+              <a:buFont typeface="Noto Sans Symbols"/>
+              <a:buChar char="⮚"/>
+            </a:pPr>
+            <a:r>
+              <a:rPr lang="it-IT" sz="2600">
+                <a:solidFill>
+                  <a:schemeClr val="dk1"/>
+                </a:solidFill>
+                <a:latin typeface="Calibri"/>
+                <a:ea typeface="Calibri"/>
+                <a:cs typeface="Calibri"/>
+                <a:sym typeface="Calibri"/>
+              </a:rPr>
+              <a:t>Cos’è un modulo standalone in Python</a:t>
+            </a:r>
+            <a:endParaRPr sz="1200"/>
+          </a:p>
+          <a:p>
+            <a:pPr indent="-273050" lvl="0" marL="285750" marR="0" rtl="0" algn="l">
+              <a:spcBef>
+                <a:spcPts val="0"/>
+              </a:spcBef>
+              <a:spcAft>
+                <a:spcPts val="0"/>
+              </a:spcAft>
+              <a:buClr>
+                <a:schemeClr val="dk1"/>
+              </a:buClr>
+              <a:buSzPts val="2600"/>
+              <a:buFont typeface="Noto Sans Symbols"/>
+              <a:buChar char="⮚"/>
+            </a:pPr>
+            <a:r>
+              <a:rPr lang="it-IT" sz="2600">
+                <a:solidFill>
+                  <a:schemeClr val="dk1"/>
+                </a:solidFill>
+                <a:latin typeface="Calibri"/>
+                <a:ea typeface="Calibri"/>
+                <a:cs typeface="Calibri"/>
+                <a:sym typeface="Calibri"/>
+              </a:rPr>
+              <a:t>Possibilità di creare più ambienti associati a più versioni di Python sulla workstation</a:t>
+            </a:r>
+            <a:endParaRPr sz="1200"/>
+          </a:p>
+          <a:p>
+            <a:pPr indent="-273050" lvl="0" marL="285750" marR="0" rtl="0" algn="l">
+              <a:spcBef>
+                <a:spcPts val="0"/>
+              </a:spcBef>
+              <a:spcAft>
+                <a:spcPts val="0"/>
+              </a:spcAft>
+              <a:buClr>
+                <a:schemeClr val="dk1"/>
+              </a:buClr>
+              <a:buSzPts val="2600"/>
+              <a:buFont typeface="Noto Sans Symbols"/>
+              <a:buChar char="⮚"/>
+            </a:pPr>
+            <a:r>
+              <a:rPr lang="it-IT" sz="2600">
+                <a:solidFill>
+                  <a:schemeClr val="dk1"/>
+                </a:solidFill>
+                <a:latin typeface="Calibri"/>
+                <a:ea typeface="Calibri"/>
+                <a:cs typeface="Calibri"/>
+                <a:sym typeface="Calibri"/>
+              </a:rPr>
+              <a:t>I possibili utilizzi di python –m in diversi scenari:</a:t>
+            </a:r>
+            <a:endParaRPr sz="1200"/>
+          </a:p>
+          <a:p>
+            <a:pPr indent="-273050" lvl="1" marL="742950" marR="0" rtl="0" algn="l">
+              <a:spcBef>
+                <a:spcPts val="0"/>
+              </a:spcBef>
+              <a:spcAft>
+                <a:spcPts val="0"/>
+              </a:spcAft>
+              <a:buClr>
+                <a:schemeClr val="dk1"/>
+              </a:buClr>
+              <a:buSzPts val="2600"/>
+              <a:buFont typeface="Noto Sans Symbols"/>
+              <a:buChar char="⮚"/>
+            </a:pPr>
+            <a:r>
+              <a:rPr b="0" i="0" lang="it-IT" sz="2600" u="none" cap="none" strike="noStrike">
+                <a:solidFill>
+                  <a:schemeClr val="dk1"/>
+                </a:solidFill>
+                <a:latin typeface="Calibri"/>
+                <a:ea typeface="Calibri"/>
+                <a:cs typeface="Calibri"/>
+                <a:sym typeface="Calibri"/>
+              </a:rPr>
+              <a:t>Contesto web</a:t>
+            </a:r>
+            <a:endParaRPr sz="1200"/>
+          </a:p>
+          <a:p>
+            <a:pPr indent="-273050" lvl="1" marL="742950" marR="0" rtl="0" algn="l">
+              <a:spcBef>
+                <a:spcPts val="0"/>
+              </a:spcBef>
+              <a:spcAft>
+                <a:spcPts val="0"/>
+              </a:spcAft>
+              <a:buClr>
+                <a:schemeClr val="dk1"/>
+              </a:buClr>
+              <a:buSzPts val="2600"/>
+              <a:buFont typeface="Noto Sans Symbols"/>
+              <a:buChar char="⮚"/>
+            </a:pPr>
+            <a:r>
+              <a:rPr b="0" i="0" lang="it-IT" sz="2600" u="none" cap="none" strike="noStrike">
+                <a:solidFill>
+                  <a:schemeClr val="dk1"/>
+                </a:solidFill>
+                <a:latin typeface="Calibri"/>
+                <a:ea typeface="Calibri"/>
+                <a:cs typeface="Calibri"/>
+                <a:sym typeface="Calibri"/>
+              </a:rPr>
+              <a:t>Avviare il debug interattivo di uno script</a:t>
+            </a:r>
+            <a:endParaRPr sz="1200"/>
+          </a:p>
+          <a:p>
+            <a:pPr indent="-273050" lvl="1" marL="742950" marR="0" rtl="0" algn="l">
+              <a:spcBef>
+                <a:spcPts val="0"/>
+              </a:spcBef>
+              <a:spcAft>
+                <a:spcPts val="0"/>
+              </a:spcAft>
+              <a:buClr>
+                <a:schemeClr val="dk1"/>
+              </a:buClr>
+              <a:buSzPts val="2600"/>
+              <a:buFont typeface="Noto Sans Symbols"/>
+              <a:buChar char="⮚"/>
+            </a:pPr>
+            <a:r>
+              <a:rPr b="0" i="0" lang="it-IT" sz="2600" u="none" cap="none" strike="noStrike">
+                <a:solidFill>
+                  <a:schemeClr val="dk1"/>
+                </a:solidFill>
+                <a:latin typeface="Calibri"/>
+                <a:ea typeface="Calibri"/>
+                <a:cs typeface="Calibri"/>
+                <a:sym typeface="Calibri"/>
+              </a:rPr>
+              <a:t>Misurare il tempo di esecuzione di uno script</a:t>
+            </a:r>
+            <a:endParaRPr sz="1200"/>
+          </a:p>
+          <a:p>
+            <a:pPr indent="-273050" lvl="1" marL="742950" marR="0" rtl="0" algn="l">
+              <a:spcBef>
+                <a:spcPts val="0"/>
+              </a:spcBef>
+              <a:spcAft>
+                <a:spcPts val="0"/>
+              </a:spcAft>
+              <a:buClr>
+                <a:schemeClr val="dk1"/>
+              </a:buClr>
+              <a:buSzPts val="2600"/>
+              <a:buFont typeface="Noto Sans Symbols"/>
+              <a:buChar char="⮚"/>
+            </a:pPr>
+            <a:r>
+              <a:rPr b="0" i="0" lang="it-IT" sz="2600" u="none" cap="none" strike="noStrike">
+                <a:solidFill>
+                  <a:schemeClr val="dk1"/>
+                </a:solidFill>
+                <a:latin typeface="Calibri"/>
+                <a:ea typeface="Calibri"/>
+                <a:cs typeface="Calibri"/>
+                <a:sym typeface="Calibri"/>
+              </a:rPr>
+              <a:t>Discovery automatico degli unit test in python</a:t>
+            </a:r>
+            <a:endParaRPr b="0" i="0" sz="2600" u="none" cap="none" strike="noStrike">
+              <a:solidFill>
+                <a:schemeClr val="dk1"/>
+              </a:solidFill>
+              <a:latin typeface="Calibri"/>
+              <a:ea typeface="Calibri"/>
+              <a:cs typeface="Calibri"/>
+              <a:sym typeface="Calibri"/>
+            </a:endParaRPr>
+          </a:p>
+          <a:p>
+            <a:pPr indent="-273050" lvl="1" marL="742950" marR="0" rtl="0" algn="l">
+              <a:spcBef>
+                <a:spcPts val="0"/>
+              </a:spcBef>
+              <a:spcAft>
+                <a:spcPts val="0"/>
+              </a:spcAft>
+              <a:buClr>
+                <a:schemeClr val="dk1"/>
+              </a:buClr>
+              <a:buSzPts val="2600"/>
+              <a:buFont typeface="Noto Sans Symbols"/>
+              <a:buChar char="⮚"/>
+            </a:pPr>
+            <a:r>
+              <a:rPr b="0" i="0" lang="it-IT" sz="2600" u="none" cap="none" strike="noStrike">
+                <a:solidFill>
+                  <a:schemeClr val="dk1"/>
+                </a:solidFill>
+                <a:latin typeface="Calibri"/>
+                <a:ea typeface="Calibri"/>
+                <a:cs typeface="Calibri"/>
+                <a:sym typeface="Calibri"/>
+              </a:rPr>
+              <a:t>Mostrare nel terminale i percorsi attivi dei pacchetti</a:t>
+            </a:r>
+            <a:endParaRPr sz="1200"/>
+          </a:p>
+        </p:txBody>
+      </p:sp>
+    </p:spTree>
+  </p:cSld>
+  <p:clrMapOvr>
+    <a:masterClrMapping/>
+  </p:clrMapOvr>
+</p:sld>
+</file>
+
+<file path=ppt/slides/slide20.xml><?xml version="1.0" encoding="utf-8"?>
+<p:sld xmlns:a="http://schemas.openxmlformats.org/drawingml/2006/main" xmlns:r="http://schemas.openxmlformats.org/officeDocument/2006/relationships" xmlns:mc="http://schemas.openxmlformats.org/markup-compatibility/2006" xmlns:mv="urn:schemas-microsoft-com:mac:vml" xmlns:p="http://schemas.openxmlformats.org/presentationml/2006/main" xmlns:c="http://schemas.openxmlformats.org/drawingml/2006/chart" xmlns:dgm="http://schemas.openxmlformats.org/drawingml/2006/diagram" xmlns:o="urn:schemas-microsoft-com:office:office" xmlns:v="urn:schemas-microsoft-com:vml" xmlns:pvml="urn:schemas-microsoft-com:office:powerpoint" xmlns:com="http://schemas.openxmlformats.org/drawingml/2006/compatibility" xmlns:p14="http://schemas.microsoft.com/office/powerpoint/2010/main" xmlns:p15="http://schemas.microsoft.com/office/powerpoint/2012/main" xmlns:ahyp="http://schemas.microsoft.com/office/drawing/2018/hyperlinkcolor">
+  <p:cSld>
+    <p:spTree>
+      <p:nvGrpSpPr>
+        <p:cNvPr id="252" name="Shape 252"/>
+        <p:cNvGrpSpPr/>
+        <p:nvPr/>
+      </p:nvGrpSpPr>
+      <p:grpSpPr>
+        <a:xfrm>
+          <a:off x="0" y="0"/>
+          <a:ext cx="0" cy="0"/>
+          <a:chOff x="0" y="0"/>
+          <a:chExt cx="0" cy="0"/>
+        </a:xfrm>
+      </p:grpSpPr>
+      <p:sp>
+        <p:nvSpPr>
+          <p:cNvPr id="253" name="Google Shape;253;g38660da28e9_0_0"/>
           <p:cNvSpPr txBox="1"/>
           <p:nvPr/>
         </p:nvSpPr>
@@ -17315,7 +18116,7 @@
       </p:sp>
       <p:pic>
         <p:nvPicPr>
-          <p:cNvPr id="244" name="Google Shape;244;g38660da28e9_0_0"/>
+          <p:cNvPr id="254" name="Google Shape;254;g38660da28e9_0_0"/>
           <p:cNvPicPr preferRelativeResize="0"/>
           <p:nvPr/>
         </p:nvPicPr>
@@ -17342,7 +18143,7 @@
       </p:pic>
       <p:sp>
         <p:nvSpPr>
-          <p:cNvPr id="245" name="Google Shape;245;g38660da28e9_0_0"/>
+          <p:cNvPr id="255" name="Google Shape;255;g38660da28e9_0_0"/>
           <p:cNvSpPr txBox="1"/>
           <p:nvPr/>
         </p:nvSpPr>
@@ -17495,7 +18296,7 @@
       </p:sp>
       <p:sp>
         <p:nvSpPr>
-          <p:cNvPr id="246" name="Google Shape;246;g38660da28e9_0_0"/>
+          <p:cNvPr id="256" name="Google Shape;256;g38660da28e9_0_0"/>
           <p:cNvSpPr txBox="1"/>
           <p:nvPr/>
         </p:nvSpPr>
@@ -17704,12 +18505,12 @@
 </p:sld>
 </file>
 
-<file path=ppt/slides/slide2.xml><?xml version="1.0" encoding="utf-8"?>
+<file path=ppt/slides/slide21.xml><?xml version="1.0" encoding="utf-8"?>
 <p:sld xmlns:a="http://schemas.openxmlformats.org/drawingml/2006/main" xmlns:r="http://schemas.openxmlformats.org/officeDocument/2006/relationships" xmlns:mc="http://schemas.openxmlformats.org/markup-compatibility/2006" xmlns:mv="urn:schemas-microsoft-com:mac:vml" xmlns:p="http://schemas.openxmlformats.org/presentationml/2006/main" xmlns:c="http://schemas.openxmlformats.org/drawingml/2006/chart" xmlns:dgm="http://schemas.openxmlformats.org/drawingml/2006/diagram" xmlns:o="urn:schemas-microsoft-com:office:office" xmlns:v="urn:schemas-microsoft-com:vml" xmlns:pvml="urn:schemas-microsoft-com:office:powerpoint" xmlns:com="http://schemas.openxmlformats.org/drawingml/2006/compatibility" xmlns:p14="http://schemas.microsoft.com/office/powerpoint/2010/main" xmlns:p15="http://schemas.microsoft.com/office/powerpoint/2012/main" xmlns:ahyp="http://schemas.microsoft.com/office/drawing/2018/hyperlinkcolor">
   <p:cSld>
     <p:spTree>
       <p:nvGrpSpPr>
-        <p:cNvPr id="96" name="Shape 96"/>
+        <p:cNvPr id="261" name="Shape 261"/>
         <p:cNvGrpSpPr/>
         <p:nvPr/>
       </p:nvGrpSpPr>
@@ -17723,448 +18524,7 @@
       </p:grpSpPr>
       <p:sp>
         <p:nvSpPr>
-          <p:cNvPr id="97" name="Google Shape;97;p1"/>
-          <p:cNvSpPr txBox="1"/>
-          <p:nvPr/>
-        </p:nvSpPr>
-        <p:spPr>
-          <a:xfrm>
-            <a:off x="1252497" y="772991"/>
-            <a:ext cx="7192200" cy="387900"/>
-          </a:xfrm>
-          <a:prstGeom prst="rect">
-            <a:avLst/>
-          </a:prstGeom>
-          <a:noFill/>
-          <a:ln>
-            <a:noFill/>
-          </a:ln>
-        </p:spPr>
-        <p:txBody>
-          <a:bodyPr anchorCtr="0" anchor="t" bIns="0" lIns="0" spcFirstLastPara="1" rIns="0" wrap="square" tIns="0">
-            <a:spAutoFit/>
-          </a:bodyPr>
-          <a:lstStyle/>
-          <a:p>
-            <a:pPr indent="0" lvl="0" marL="0" marR="0" rtl="0" algn="l">
-              <a:lnSpc>
-                <a:spcPct val="78750"/>
-              </a:lnSpc>
-              <a:spcBef>
-                <a:spcPts val="0"/>
-              </a:spcBef>
-              <a:spcAft>
-                <a:spcPts val="0"/>
-              </a:spcAft>
-              <a:buNone/>
-            </a:pPr>
-            <a:r>
-              <a:rPr b="1" i="0" lang="it-IT" sz="3200" u="none" cap="none" strike="noStrike">
-                <a:solidFill>
-                  <a:schemeClr val="dk1"/>
-                </a:solidFill>
-                <a:latin typeface="Calibri"/>
-                <a:ea typeface="Calibri"/>
-                <a:cs typeface="Calibri"/>
-                <a:sym typeface="Calibri"/>
-              </a:rPr>
-              <a:t>        </a:t>
-            </a:r>
-            <a:r>
-              <a:rPr b="1" i="0" lang="it-IT" sz="3200" u="none" cap="none" strike="noStrike">
-                <a:solidFill>
-                  <a:srgbClr val="0F4761"/>
-                </a:solidFill>
-                <a:latin typeface="Arial"/>
-                <a:ea typeface="Arial"/>
-                <a:cs typeface="Arial"/>
-                <a:sym typeface="Arial"/>
-              </a:rPr>
-              <a:t>Segreti sui moduli Python</a:t>
-            </a:r>
-            <a:endParaRPr b="1" i="0" sz="3200" u="none" cap="none" strike="noStrike">
-              <a:solidFill>
-                <a:srgbClr val="0F4761"/>
-              </a:solidFill>
-              <a:latin typeface="Arial"/>
-              <a:ea typeface="Arial"/>
-              <a:cs typeface="Arial"/>
-              <a:sym typeface="Arial"/>
-            </a:endParaRPr>
-          </a:p>
-        </p:txBody>
-      </p:sp>
-      <p:pic>
-        <p:nvPicPr>
-          <p:cNvPr id="98" name="Google Shape;98;p1"/>
-          <p:cNvPicPr preferRelativeResize="0"/>
-          <p:nvPr/>
-        </p:nvPicPr>
-        <p:blipFill rotWithShape="1">
-          <a:blip r:embed="rId3">
-            <a:alphaModFix/>
-          </a:blip>
-          <a:srcRect b="0" l="0" r="0" t="0"/>
-          <a:stretch/>
-        </p:blipFill>
-        <p:spPr>
-          <a:xfrm>
-            <a:off x="551323" y="114848"/>
-            <a:ext cx="1268025" cy="809225"/>
-          </a:xfrm>
-          <a:prstGeom prst="rect">
-            <a:avLst/>
-          </a:prstGeom>
-          <a:noFill/>
-          <a:ln>
-            <a:noFill/>
-          </a:ln>
-        </p:spPr>
-      </p:pic>
-      <p:sp>
-        <p:nvSpPr>
-          <p:cNvPr id="99" name="Google Shape;99;p1"/>
-          <p:cNvSpPr txBox="1"/>
-          <p:nvPr/>
-        </p:nvSpPr>
-        <p:spPr>
-          <a:xfrm>
-            <a:off x="1680890" y="277000"/>
-            <a:ext cx="6567600" cy="400800"/>
-          </a:xfrm>
-          <a:prstGeom prst="rect">
-            <a:avLst/>
-          </a:prstGeom>
-          <a:noFill/>
-          <a:ln>
-            <a:noFill/>
-          </a:ln>
-        </p:spPr>
-        <p:txBody>
-          <a:bodyPr anchorCtr="0" anchor="t" bIns="45700" lIns="91425" spcFirstLastPara="1" rIns="91425" wrap="square" tIns="45700">
-            <a:spAutoFit/>
-          </a:bodyPr>
-          <a:lstStyle/>
-          <a:p>
-            <a:pPr indent="0" lvl="0" marL="0" marR="0" rtl="0" algn="l">
-              <a:spcBef>
-                <a:spcPts val="0"/>
-              </a:spcBef>
-              <a:spcAft>
-                <a:spcPts val="0"/>
-              </a:spcAft>
-              <a:buNone/>
-            </a:pPr>
-            <a:r>
-              <a:rPr b="1" i="0" lang="it-IT" sz="2004" u="none" cap="none" strike="noStrike">
-                <a:solidFill>
-                  <a:srgbClr val="0F4761"/>
-                </a:solidFill>
-                <a:latin typeface="Arial"/>
-                <a:ea typeface="Arial"/>
-                <a:cs typeface="Arial"/>
-                <a:sym typeface="Arial"/>
-              </a:rPr>
-              <a:t>04 Dicembre 2025 – Segreti sui moduli Python</a:t>
-            </a:r>
-            <a:endParaRPr/>
-          </a:p>
-        </p:txBody>
-      </p:sp>
-      <p:sp>
-        <p:nvSpPr>
-          <p:cNvPr id="100" name="Google Shape;100;p1"/>
-          <p:cNvSpPr txBox="1"/>
-          <p:nvPr/>
-        </p:nvSpPr>
-        <p:spPr>
-          <a:xfrm>
-            <a:off x="551326" y="1256099"/>
-            <a:ext cx="8147700" cy="3694200"/>
-          </a:xfrm>
-          <a:prstGeom prst="rect">
-            <a:avLst/>
-          </a:prstGeom>
-          <a:noFill/>
-          <a:ln>
-            <a:noFill/>
-          </a:ln>
-        </p:spPr>
-        <p:txBody>
-          <a:bodyPr anchorCtr="0" anchor="t" bIns="45700" lIns="91425" spcFirstLastPara="1" rIns="91425" wrap="square" tIns="45700">
-            <a:spAutoFit/>
-          </a:bodyPr>
-          <a:lstStyle/>
-          <a:p>
-            <a:pPr indent="-273050" lvl="0" marL="285750" marR="0" rtl="0" algn="l">
-              <a:spcBef>
-                <a:spcPts val="0"/>
-              </a:spcBef>
-              <a:spcAft>
-                <a:spcPts val="0"/>
-              </a:spcAft>
-              <a:buClr>
-                <a:schemeClr val="dk1"/>
-              </a:buClr>
-              <a:buSzPts val="2600"/>
-              <a:buFont typeface="Noto Sans Symbols"/>
-              <a:buChar char="⮚"/>
-            </a:pPr>
-            <a:r>
-              <a:rPr lang="it-IT" sz="2600">
-                <a:solidFill>
-                  <a:schemeClr val="dk1"/>
-                </a:solidFill>
-                <a:latin typeface="Calibri"/>
-                <a:ea typeface="Calibri"/>
-                <a:cs typeface="Calibri"/>
-                <a:sym typeface="Calibri"/>
-              </a:rPr>
-              <a:t>Cos’è un modulo standalone in Python</a:t>
-            </a:r>
-            <a:endParaRPr sz="1200"/>
-          </a:p>
-          <a:p>
-            <a:pPr indent="-273050" lvl="0" marL="285750" marR="0" rtl="0" algn="l">
-              <a:spcBef>
-                <a:spcPts val="0"/>
-              </a:spcBef>
-              <a:spcAft>
-                <a:spcPts val="0"/>
-              </a:spcAft>
-              <a:buClr>
-                <a:schemeClr val="dk1"/>
-              </a:buClr>
-              <a:buSzPts val="2600"/>
-              <a:buFont typeface="Noto Sans Symbols"/>
-              <a:buChar char="⮚"/>
-            </a:pPr>
-            <a:r>
-              <a:rPr lang="it-IT" sz="2600">
-                <a:solidFill>
-                  <a:schemeClr val="dk1"/>
-                </a:solidFill>
-                <a:latin typeface="Calibri"/>
-                <a:ea typeface="Calibri"/>
-                <a:cs typeface="Calibri"/>
-                <a:sym typeface="Calibri"/>
-              </a:rPr>
-              <a:t>Possibilità di creare più ambienti associati a più versioni di Python sulla workstation</a:t>
-            </a:r>
-            <a:endParaRPr sz="1200"/>
-          </a:p>
-          <a:p>
-            <a:pPr indent="-273050" lvl="0" marL="285750" marR="0" rtl="0" algn="l">
-              <a:spcBef>
-                <a:spcPts val="0"/>
-              </a:spcBef>
-              <a:spcAft>
-                <a:spcPts val="0"/>
-              </a:spcAft>
-              <a:buClr>
-                <a:schemeClr val="dk1"/>
-              </a:buClr>
-              <a:buSzPts val="2600"/>
-              <a:buFont typeface="Noto Sans Symbols"/>
-              <a:buChar char="⮚"/>
-            </a:pPr>
-            <a:r>
-              <a:rPr lang="it-IT" sz="2600">
-                <a:solidFill>
-                  <a:schemeClr val="dk1"/>
-                </a:solidFill>
-                <a:latin typeface="Calibri"/>
-                <a:ea typeface="Calibri"/>
-                <a:cs typeface="Calibri"/>
-                <a:sym typeface="Calibri"/>
-              </a:rPr>
-              <a:t>I possibili utilizzi di python –m in diversi scenari:</a:t>
-            </a:r>
-            <a:endParaRPr sz="1200"/>
-          </a:p>
-          <a:p>
-            <a:pPr indent="-273050" lvl="1" marL="742950" marR="0" rtl="0" algn="l">
-              <a:spcBef>
-                <a:spcPts val="0"/>
-              </a:spcBef>
-              <a:spcAft>
-                <a:spcPts val="0"/>
-              </a:spcAft>
-              <a:buClr>
-                <a:schemeClr val="dk1"/>
-              </a:buClr>
-              <a:buSzPts val="2600"/>
-              <a:buFont typeface="Noto Sans Symbols"/>
-              <a:buChar char="⮚"/>
-            </a:pPr>
-            <a:r>
-              <a:rPr b="0" i="0" lang="it-IT" sz="2600" u="none" cap="none" strike="noStrike">
-                <a:solidFill>
-                  <a:schemeClr val="dk1"/>
-                </a:solidFill>
-                <a:latin typeface="Calibri"/>
-                <a:ea typeface="Calibri"/>
-                <a:cs typeface="Calibri"/>
-                <a:sym typeface="Calibri"/>
-              </a:rPr>
-              <a:t>Contesto web</a:t>
-            </a:r>
-            <a:endParaRPr sz="1200"/>
-          </a:p>
-          <a:p>
-            <a:pPr indent="-273050" lvl="1" marL="742950" marR="0" rtl="0" algn="l">
-              <a:spcBef>
-                <a:spcPts val="0"/>
-              </a:spcBef>
-              <a:spcAft>
-                <a:spcPts val="0"/>
-              </a:spcAft>
-              <a:buClr>
-                <a:schemeClr val="dk1"/>
-              </a:buClr>
-              <a:buSzPts val="2600"/>
-              <a:buFont typeface="Noto Sans Symbols"/>
-              <a:buChar char="⮚"/>
-            </a:pPr>
-            <a:r>
-              <a:rPr b="0" i="0" lang="it-IT" sz="2600" u="none" cap="none" strike="noStrike">
-                <a:solidFill>
-                  <a:schemeClr val="dk1"/>
-                </a:solidFill>
-                <a:latin typeface="Calibri"/>
-                <a:ea typeface="Calibri"/>
-                <a:cs typeface="Calibri"/>
-                <a:sym typeface="Calibri"/>
-              </a:rPr>
-              <a:t>Avviare il debug interattivo di uno script</a:t>
-            </a:r>
-            <a:endParaRPr sz="1200"/>
-          </a:p>
-          <a:p>
-            <a:pPr indent="-273050" lvl="1" marL="742950" marR="0" rtl="0" algn="l">
-              <a:spcBef>
-                <a:spcPts val="0"/>
-              </a:spcBef>
-              <a:spcAft>
-                <a:spcPts val="0"/>
-              </a:spcAft>
-              <a:buClr>
-                <a:schemeClr val="dk1"/>
-              </a:buClr>
-              <a:buSzPts val="2600"/>
-              <a:buFont typeface="Noto Sans Symbols"/>
-              <a:buChar char="⮚"/>
-            </a:pPr>
-            <a:r>
-              <a:rPr b="0" i="0" lang="it-IT" sz="2600" u="none" cap="none" strike="noStrike">
-                <a:solidFill>
-                  <a:schemeClr val="dk1"/>
-                </a:solidFill>
-                <a:latin typeface="Calibri"/>
-                <a:ea typeface="Calibri"/>
-                <a:cs typeface="Calibri"/>
-                <a:sym typeface="Calibri"/>
-              </a:rPr>
-              <a:t>Misurare il tempo di esecuzione di uno script</a:t>
-            </a:r>
-            <a:endParaRPr sz="1200"/>
-          </a:p>
-          <a:p>
-            <a:pPr indent="-273050" lvl="1" marL="742950" marR="0" rtl="0" algn="l">
-              <a:spcBef>
-                <a:spcPts val="0"/>
-              </a:spcBef>
-              <a:spcAft>
-                <a:spcPts val="0"/>
-              </a:spcAft>
-              <a:buClr>
-                <a:schemeClr val="dk1"/>
-              </a:buClr>
-              <a:buSzPts val="2600"/>
-              <a:buFont typeface="Noto Sans Symbols"/>
-              <a:buChar char="⮚"/>
-            </a:pPr>
-            <a:r>
-              <a:rPr b="0" i="0" lang="it-IT" sz="2600" u="none" cap="none" strike="noStrike">
-                <a:solidFill>
-                  <a:schemeClr val="dk1"/>
-                </a:solidFill>
-                <a:latin typeface="Calibri"/>
-                <a:ea typeface="Calibri"/>
-                <a:cs typeface="Calibri"/>
-                <a:sym typeface="Calibri"/>
-              </a:rPr>
-              <a:t>Discovery automatico degli unit test in python</a:t>
-            </a:r>
-            <a:endParaRPr b="0" i="0" sz="2600" u="none" cap="none" strike="noStrike">
-              <a:solidFill>
-                <a:schemeClr val="dk1"/>
-              </a:solidFill>
-              <a:latin typeface="Calibri"/>
-              <a:ea typeface="Calibri"/>
-              <a:cs typeface="Calibri"/>
-              <a:sym typeface="Calibri"/>
-            </a:endParaRPr>
-          </a:p>
-          <a:p>
-            <a:pPr indent="-273050" lvl="1" marL="742950" marR="0" rtl="0" algn="l">
-              <a:spcBef>
-                <a:spcPts val="0"/>
-              </a:spcBef>
-              <a:spcAft>
-                <a:spcPts val="0"/>
-              </a:spcAft>
-              <a:buClr>
-                <a:schemeClr val="dk1"/>
-              </a:buClr>
-              <a:buSzPts val="2600"/>
-              <a:buFont typeface="Noto Sans Symbols"/>
-              <a:buChar char="⮚"/>
-            </a:pPr>
-            <a:r>
-              <a:rPr b="0" i="0" lang="it-IT" sz="2600" u="none" cap="none" strike="noStrike">
-                <a:solidFill>
-                  <a:schemeClr val="dk1"/>
-                </a:solidFill>
-                <a:latin typeface="Calibri"/>
-                <a:ea typeface="Calibri"/>
-                <a:cs typeface="Calibri"/>
-                <a:sym typeface="Calibri"/>
-              </a:rPr>
-              <a:t>Mostrare nel terminale i percorsi attivi dei pacchetti</a:t>
-            </a:r>
-            <a:endParaRPr sz="1200"/>
-          </a:p>
-        </p:txBody>
-      </p:sp>
-    </p:spTree>
-  </p:cSld>
-  <p:clrMapOvr>
-    <a:masterClrMapping/>
-  </p:clrMapOvr>
-</p:sld>
-</file>
-
-<file path=ppt/slides/slide20.xml><?xml version="1.0" encoding="utf-8"?>
-<p:sld xmlns:a="http://schemas.openxmlformats.org/drawingml/2006/main" xmlns:r="http://schemas.openxmlformats.org/officeDocument/2006/relationships" xmlns:mc="http://schemas.openxmlformats.org/markup-compatibility/2006" xmlns:mv="urn:schemas-microsoft-com:mac:vml" xmlns:p="http://schemas.openxmlformats.org/presentationml/2006/main" xmlns:c="http://schemas.openxmlformats.org/drawingml/2006/chart" xmlns:dgm="http://schemas.openxmlformats.org/drawingml/2006/diagram" xmlns:o="urn:schemas-microsoft-com:office:office" xmlns:v="urn:schemas-microsoft-com:vml" xmlns:pvml="urn:schemas-microsoft-com:office:powerpoint" xmlns:com="http://schemas.openxmlformats.org/drawingml/2006/compatibility" xmlns:p14="http://schemas.microsoft.com/office/powerpoint/2010/main" xmlns:p15="http://schemas.microsoft.com/office/powerpoint/2012/main" xmlns:ahyp="http://schemas.microsoft.com/office/drawing/2018/hyperlinkcolor">
-  <p:cSld>
-    <p:spTree>
-      <p:nvGrpSpPr>
-        <p:cNvPr id="251" name="Shape 251"/>
-        <p:cNvGrpSpPr/>
-        <p:nvPr/>
-      </p:nvGrpSpPr>
-      <p:grpSpPr>
-        <a:xfrm>
-          <a:off x="0" y="0"/>
-          <a:ext cx="0" cy="0"/>
-          <a:chOff x="0" y="0"/>
-          <a:chExt cx="0" cy="0"/>
-        </a:xfrm>
-      </p:grpSpPr>
-      <p:sp>
-        <p:nvSpPr>
-          <p:cNvPr id="252" name="Google Shape;252;g39a291deda2_1_0"/>
+          <p:cNvPr id="262" name="Google Shape;262;g39a291deda2_1_0"/>
           <p:cNvSpPr txBox="1"/>
           <p:nvPr/>
         </p:nvSpPr>
@@ -18214,7 +18574,7 @@
       </p:sp>
       <p:pic>
         <p:nvPicPr>
-          <p:cNvPr id="253" name="Google Shape;253;g39a291deda2_1_0"/>
+          <p:cNvPr id="263" name="Google Shape;263;g39a291deda2_1_0"/>
           <p:cNvPicPr preferRelativeResize="0"/>
           <p:nvPr/>
         </p:nvPicPr>
@@ -18241,7 +18601,7 @@
       </p:pic>
       <p:sp>
         <p:nvSpPr>
-          <p:cNvPr id="254" name="Google Shape;254;g39a291deda2_1_0"/>
+          <p:cNvPr id="264" name="Google Shape;264;g39a291deda2_1_0"/>
           <p:cNvSpPr txBox="1"/>
           <p:nvPr/>
         </p:nvSpPr>
@@ -18299,7 +18659,7 @@
       </p:sp>
       <p:sp>
         <p:nvSpPr>
-          <p:cNvPr id="255" name="Google Shape;255;g39a291deda2_1_0"/>
+          <p:cNvPr id="265" name="Google Shape;265;g39a291deda2_1_0"/>
           <p:cNvSpPr txBox="1"/>
           <p:nvPr/>
         </p:nvSpPr>
@@ -18426,12 +18786,12 @@
 </p:sld>
 </file>
 
-<file path=ppt/slides/slide21.xml><?xml version="1.0" encoding="utf-8"?>
+<file path=ppt/slides/slide22.xml><?xml version="1.0" encoding="utf-8"?>
 <p:sld xmlns:a="http://schemas.openxmlformats.org/drawingml/2006/main" xmlns:r="http://schemas.openxmlformats.org/officeDocument/2006/relationships" xmlns:mc="http://schemas.openxmlformats.org/markup-compatibility/2006" xmlns:mv="urn:schemas-microsoft-com:mac:vml" xmlns:p="http://schemas.openxmlformats.org/presentationml/2006/main" xmlns:c="http://schemas.openxmlformats.org/drawingml/2006/chart" xmlns:dgm="http://schemas.openxmlformats.org/drawingml/2006/diagram" xmlns:o="urn:schemas-microsoft-com:office:office" xmlns:v="urn:schemas-microsoft-com:vml" xmlns:pvml="urn:schemas-microsoft-com:office:powerpoint" xmlns:com="http://schemas.openxmlformats.org/drawingml/2006/compatibility" xmlns:p14="http://schemas.microsoft.com/office/powerpoint/2010/main" xmlns:p15="http://schemas.microsoft.com/office/powerpoint/2012/main" xmlns:ahyp="http://schemas.microsoft.com/office/drawing/2018/hyperlinkcolor">
   <p:cSld>
     <p:spTree>
       <p:nvGrpSpPr>
-        <p:cNvPr id="260" name="Shape 260"/>
+        <p:cNvPr id="270" name="Shape 270"/>
         <p:cNvGrpSpPr/>
         <p:nvPr/>
       </p:nvGrpSpPr>
@@ -18445,7 +18805,7 @@
       </p:grpSpPr>
       <p:sp>
         <p:nvSpPr>
-          <p:cNvPr id="261" name="Google Shape;261;g39a291deda2_1_14"/>
+          <p:cNvPr id="271" name="Google Shape;271;g39a291deda2_1_14"/>
           <p:cNvSpPr txBox="1"/>
           <p:nvPr/>
         </p:nvSpPr>
@@ -18495,7 +18855,7 @@
       </p:sp>
       <p:pic>
         <p:nvPicPr>
-          <p:cNvPr id="262" name="Google Shape;262;g39a291deda2_1_14"/>
+          <p:cNvPr id="272" name="Google Shape;272;g39a291deda2_1_14"/>
           <p:cNvPicPr preferRelativeResize="0"/>
           <p:nvPr/>
         </p:nvPicPr>
@@ -18522,7 +18882,7 @@
       </p:pic>
       <p:sp>
         <p:nvSpPr>
-          <p:cNvPr id="263" name="Google Shape;263;g39a291deda2_1_14"/>
+          <p:cNvPr id="273" name="Google Shape;273;g39a291deda2_1_14"/>
           <p:cNvSpPr txBox="1"/>
           <p:nvPr/>
         </p:nvSpPr>
@@ -18580,7 +18940,7 @@
       </p:sp>
       <p:sp>
         <p:nvSpPr>
-          <p:cNvPr id="264" name="Google Shape;264;g39a291deda2_1_14"/>
+          <p:cNvPr id="274" name="Google Shape;274;g39a291deda2_1_14"/>
           <p:cNvSpPr txBox="1"/>
           <p:nvPr/>
         </p:nvSpPr>
@@ -18727,12 +19087,12 @@
 </p:sld>
 </file>
 
-<file path=ppt/slides/slide22.xml><?xml version="1.0" encoding="utf-8"?>
+<file path=ppt/slides/slide23.xml><?xml version="1.0" encoding="utf-8"?>
 <p:sld xmlns:a="http://schemas.openxmlformats.org/drawingml/2006/main" xmlns:r="http://schemas.openxmlformats.org/officeDocument/2006/relationships" xmlns:mc="http://schemas.openxmlformats.org/markup-compatibility/2006" xmlns:mv="urn:schemas-microsoft-com:mac:vml" xmlns:p="http://schemas.openxmlformats.org/presentationml/2006/main" xmlns:c="http://schemas.openxmlformats.org/drawingml/2006/chart" xmlns:dgm="http://schemas.openxmlformats.org/drawingml/2006/diagram" xmlns:o="urn:schemas-microsoft-com:office:office" xmlns:v="urn:schemas-microsoft-com:vml" xmlns:pvml="urn:schemas-microsoft-com:office:powerpoint" xmlns:com="http://schemas.openxmlformats.org/drawingml/2006/compatibility" xmlns:p14="http://schemas.microsoft.com/office/powerpoint/2010/main" xmlns:p15="http://schemas.microsoft.com/office/powerpoint/2012/main" xmlns:ahyp="http://schemas.microsoft.com/office/drawing/2018/hyperlinkcolor">
   <p:cSld>
     <p:spTree>
       <p:nvGrpSpPr>
-        <p:cNvPr id="269" name="Shape 269"/>
+        <p:cNvPr id="279" name="Shape 279"/>
         <p:cNvGrpSpPr/>
         <p:nvPr/>
       </p:nvGrpSpPr>
@@ -18746,7 +19106,7 @@
       </p:grpSpPr>
       <p:sp>
         <p:nvSpPr>
-          <p:cNvPr id="270" name="Google Shape;270;g39a291deda2_1_23"/>
+          <p:cNvPr id="280" name="Google Shape;280;g39a291deda2_1_23"/>
           <p:cNvSpPr txBox="1"/>
           <p:nvPr/>
         </p:nvSpPr>
@@ -18796,7 +19156,7 @@
       </p:sp>
       <p:pic>
         <p:nvPicPr>
-          <p:cNvPr id="271" name="Google Shape;271;g39a291deda2_1_23"/>
+          <p:cNvPr id="281" name="Google Shape;281;g39a291deda2_1_23"/>
           <p:cNvPicPr preferRelativeResize="0"/>
           <p:nvPr/>
         </p:nvPicPr>
@@ -18823,7 +19183,7 @@
       </p:pic>
       <p:sp>
         <p:nvSpPr>
-          <p:cNvPr id="272" name="Google Shape;272;g39a291deda2_1_23"/>
+          <p:cNvPr id="282" name="Google Shape;282;g39a291deda2_1_23"/>
           <p:cNvSpPr txBox="1"/>
           <p:nvPr/>
         </p:nvSpPr>
@@ -18881,7 +19241,7 @@
       </p:sp>
       <p:sp>
         <p:nvSpPr>
-          <p:cNvPr id="273" name="Google Shape;273;g39a291deda2_1_23"/>
+          <p:cNvPr id="283" name="Google Shape;283;g39a291deda2_1_23"/>
           <p:cNvSpPr txBox="1"/>
           <p:nvPr/>
         </p:nvSpPr>
@@ -18970,7 +19330,7 @@
       </p:sp>
       <p:sp>
         <p:nvSpPr>
-          <p:cNvPr id="274" name="Google Shape;274;g39a291deda2_1_23"/>
+          <p:cNvPr id="284" name="Google Shape;284;g39a291deda2_1_23"/>
           <p:cNvSpPr txBox="1"/>
           <p:nvPr/>
         </p:nvSpPr>
@@ -19016,7 +19376,7 @@
       </p:sp>
       <p:sp>
         <p:nvSpPr>
-          <p:cNvPr id="275" name="Google Shape;275;g39a291deda2_1_23"/>
+          <p:cNvPr id="285" name="Google Shape;285;g39a291deda2_1_23"/>
           <p:cNvSpPr txBox="1"/>
           <p:nvPr/>
         </p:nvSpPr>
@@ -19064,323 +19424,6 @@
           </a:p>
         </p:txBody>
       </p:sp>
-    </p:spTree>
-  </p:cSld>
-  <p:clrMapOvr>
-    <a:masterClrMapping/>
-  </p:clrMapOvr>
-</p:sld>
-</file>
-
-<file path=ppt/slides/slide23.xml><?xml version="1.0" encoding="utf-8"?>
-<p:sld xmlns:a="http://schemas.openxmlformats.org/drawingml/2006/main" xmlns:r="http://schemas.openxmlformats.org/officeDocument/2006/relationships" xmlns:mc="http://schemas.openxmlformats.org/markup-compatibility/2006" xmlns:mv="urn:schemas-microsoft-com:mac:vml" xmlns:p="http://schemas.openxmlformats.org/presentationml/2006/main" xmlns:c="http://schemas.openxmlformats.org/drawingml/2006/chart" xmlns:dgm="http://schemas.openxmlformats.org/drawingml/2006/diagram" xmlns:o="urn:schemas-microsoft-com:office:office" xmlns:v="urn:schemas-microsoft-com:vml" xmlns:pvml="urn:schemas-microsoft-com:office:powerpoint" xmlns:com="http://schemas.openxmlformats.org/drawingml/2006/compatibility" xmlns:p14="http://schemas.microsoft.com/office/powerpoint/2010/main" xmlns:p15="http://schemas.microsoft.com/office/powerpoint/2012/main" xmlns:ahyp="http://schemas.microsoft.com/office/drawing/2018/hyperlinkcolor">
-  <p:cSld>
-    <p:spTree>
-      <p:nvGrpSpPr>
-        <p:cNvPr id="280" name="Shape 280"/>
-        <p:cNvGrpSpPr/>
-        <p:nvPr/>
-      </p:nvGrpSpPr>
-      <p:grpSpPr>
-        <a:xfrm>
-          <a:off x="0" y="0"/>
-          <a:ext cx="0" cy="0"/>
-          <a:chOff x="0" y="0"/>
-          <a:chExt cx="0" cy="0"/>
-        </a:xfrm>
-      </p:grpSpPr>
-      <p:sp>
-        <p:nvSpPr>
-          <p:cNvPr id="281" name="Google Shape;281;g39a291deda2_1_39"/>
-          <p:cNvSpPr txBox="1"/>
-          <p:nvPr/>
-        </p:nvSpPr>
-        <p:spPr>
-          <a:xfrm>
-            <a:off x="1873040" y="319065"/>
-            <a:ext cx="6567600" cy="400800"/>
-          </a:xfrm>
-          <a:prstGeom prst="rect">
-            <a:avLst/>
-          </a:prstGeom>
-          <a:noFill/>
-          <a:ln>
-            <a:noFill/>
-          </a:ln>
-        </p:spPr>
-        <p:txBody>
-          <a:bodyPr anchorCtr="0" anchor="t" bIns="45700" lIns="91425" spcFirstLastPara="1" rIns="91425" wrap="square" tIns="45700">
-            <a:spAutoFit/>
-          </a:bodyPr>
-          <a:lstStyle/>
-          <a:p>
-            <a:pPr indent="0" lvl="0" marL="0" marR="0" rtl="0" algn="l">
-              <a:spcBef>
-                <a:spcPts val="0"/>
-              </a:spcBef>
-              <a:spcAft>
-                <a:spcPts val="0"/>
-              </a:spcAft>
-              <a:buNone/>
-            </a:pPr>
-            <a:r>
-              <a:rPr b="1" lang="it-IT" sz="2004">
-                <a:solidFill>
-                  <a:srgbClr val="0F4761"/>
-                </a:solidFill>
-                <a:latin typeface="Arial"/>
-                <a:ea typeface="Arial"/>
-                <a:cs typeface="Arial"/>
-                <a:sym typeface="Arial"/>
-              </a:rPr>
-              <a:t>04 Dicembre 2025 – Segreti sui moduli Python</a:t>
-            </a:r>
-            <a:endParaRPr/>
-          </a:p>
-        </p:txBody>
-      </p:sp>
-      <p:pic>
-        <p:nvPicPr>
-          <p:cNvPr id="282" name="Google Shape;282;g39a291deda2_1_39"/>
-          <p:cNvPicPr preferRelativeResize="0"/>
-          <p:nvPr/>
-        </p:nvPicPr>
-        <p:blipFill rotWithShape="1">
-          <a:blip r:embed="rId3">
-            <a:alphaModFix/>
-          </a:blip>
-          <a:srcRect b="0" l="0" r="0" t="0"/>
-          <a:stretch/>
-        </p:blipFill>
-        <p:spPr>
-          <a:xfrm>
-            <a:off x="551323" y="114848"/>
-            <a:ext cx="1268025" cy="809225"/>
-          </a:xfrm>
-          <a:prstGeom prst="rect">
-            <a:avLst/>
-          </a:prstGeom>
-          <a:noFill/>
-          <a:ln>
-            <a:noFill/>
-          </a:ln>
-        </p:spPr>
-      </p:pic>
-      <p:pic>
-        <p:nvPicPr>
-          <p:cNvPr id="283" name="Google Shape;283;g39a291deda2_1_39"/>
-          <p:cNvPicPr preferRelativeResize="0"/>
-          <p:nvPr/>
-        </p:nvPicPr>
-        <p:blipFill>
-          <a:blip r:embed="rId4">
-            <a:alphaModFix/>
-          </a:blip>
-          <a:stretch>
-            <a:fillRect/>
-          </a:stretch>
-        </p:blipFill>
-        <p:spPr>
-          <a:xfrm>
-            <a:off x="452902" y="1125952"/>
-            <a:ext cx="3131949" cy="2110700"/>
-          </a:xfrm>
-          <a:prstGeom prst="rect">
-            <a:avLst/>
-          </a:prstGeom>
-          <a:noFill/>
-          <a:ln>
-            <a:noFill/>
-          </a:ln>
-        </p:spPr>
-      </p:pic>
-      <p:sp>
-        <p:nvSpPr>
-          <p:cNvPr id="284" name="Google Shape;284;g39a291deda2_1_39"/>
-          <p:cNvSpPr txBox="1"/>
-          <p:nvPr/>
-        </p:nvSpPr>
-        <p:spPr>
-          <a:xfrm>
-            <a:off x="3925300" y="1119300"/>
-            <a:ext cx="5406000" cy="2124000"/>
-          </a:xfrm>
-          <a:prstGeom prst="rect">
-            <a:avLst/>
-          </a:prstGeom>
-          <a:noFill/>
-          <a:ln>
-            <a:noFill/>
-          </a:ln>
-        </p:spPr>
-        <p:txBody>
-          <a:bodyPr anchorCtr="0" anchor="t" bIns="91425" lIns="91425" spcFirstLastPara="1" rIns="91425" wrap="square" tIns="91425">
-            <a:spAutoFit/>
-          </a:bodyPr>
-          <a:lstStyle/>
-          <a:p>
-            <a:pPr indent="0" lvl="0" marL="0" rtl="0" algn="l">
-              <a:spcBef>
-                <a:spcPts val="0"/>
-              </a:spcBef>
-              <a:spcAft>
-                <a:spcPts val="0"/>
-              </a:spcAft>
-              <a:buNone/>
-            </a:pPr>
-            <a:r>
-              <a:rPr lang="it-IT"/>
-              <a:t>Alcuni comandi che permetterebbero di effettuare un debug interattivo:</a:t>
-            </a:r>
-            <a:endParaRPr sz="1800"/>
-          </a:p>
-          <a:p>
-            <a:pPr indent="0" lvl="0" marL="0" rtl="0" algn="l">
-              <a:spcBef>
-                <a:spcPts val="0"/>
-              </a:spcBef>
-              <a:spcAft>
-                <a:spcPts val="0"/>
-              </a:spcAft>
-              <a:buNone/>
-            </a:pPr>
-            <a:r>
-              <a:t/>
-            </a:r>
-            <a:endParaRPr/>
-          </a:p>
-          <a:p>
-            <a:pPr indent="-317500" lvl="0" marL="457200" rtl="0" algn="l">
-              <a:spcBef>
-                <a:spcPts val="0"/>
-              </a:spcBef>
-              <a:spcAft>
-                <a:spcPts val="0"/>
-              </a:spcAft>
-              <a:buSzPts val="1400"/>
-              <a:buChar char="●"/>
-            </a:pPr>
-            <a:r>
-              <a:rPr lang="it-IT"/>
-              <a:t>n (next)</a:t>
-            </a:r>
-            <a:endParaRPr/>
-          </a:p>
-          <a:p>
-            <a:pPr indent="-317500" lvl="0" marL="457200" rtl="0" algn="l">
-              <a:spcBef>
-                <a:spcPts val="0"/>
-              </a:spcBef>
-              <a:spcAft>
-                <a:spcPts val="0"/>
-              </a:spcAft>
-              <a:buSzPts val="1400"/>
-              <a:buChar char="●"/>
-            </a:pPr>
-            <a:r>
-              <a:rPr lang="it-IT"/>
-              <a:t>s (step)</a:t>
-            </a:r>
-            <a:endParaRPr/>
-          </a:p>
-          <a:p>
-            <a:pPr indent="-317500" lvl="0" marL="457200" rtl="0" algn="l">
-              <a:spcBef>
-                <a:spcPts val="0"/>
-              </a:spcBef>
-              <a:spcAft>
-                <a:spcPts val="0"/>
-              </a:spcAft>
-              <a:buSzPts val="1400"/>
-              <a:buChar char="●"/>
-            </a:pPr>
-            <a:r>
-              <a:rPr lang="it-IT"/>
-              <a:t>c (continue)</a:t>
-            </a:r>
-            <a:endParaRPr/>
-          </a:p>
-          <a:p>
-            <a:pPr indent="-317500" lvl="0" marL="457200" rtl="0" algn="l">
-              <a:spcBef>
-                <a:spcPts val="0"/>
-              </a:spcBef>
-              <a:spcAft>
-                <a:spcPts val="0"/>
-              </a:spcAft>
-              <a:buSzPts val="1400"/>
-              <a:buChar char="●"/>
-            </a:pPr>
-            <a:r>
-              <a:rPr lang="it-IT"/>
-              <a:t>l (list)</a:t>
-            </a:r>
-            <a:endParaRPr/>
-          </a:p>
-          <a:p>
-            <a:pPr indent="-317500" lvl="0" marL="457200" rtl="0" algn="l">
-              <a:spcBef>
-                <a:spcPts val="0"/>
-              </a:spcBef>
-              <a:spcAft>
-                <a:spcPts val="0"/>
-              </a:spcAft>
-              <a:buSzPts val="1400"/>
-              <a:buChar char="●"/>
-            </a:pPr>
-            <a:r>
-              <a:rPr lang="it-IT"/>
-              <a:t>p variabile</a:t>
-            </a:r>
-            <a:endParaRPr/>
-          </a:p>
-          <a:p>
-            <a:pPr indent="-317500" lvl="0" marL="457200" rtl="0" algn="l">
-              <a:spcBef>
-                <a:spcPts val="0"/>
-              </a:spcBef>
-              <a:spcAft>
-                <a:spcPts val="0"/>
-              </a:spcAft>
-              <a:buSzPts val="1400"/>
-              <a:buChar char="●"/>
-            </a:pPr>
-            <a:r>
-              <a:rPr lang="it-IT"/>
-              <a:t>q (quit)</a:t>
-            </a:r>
-            <a:endParaRPr/>
-          </a:p>
-        </p:txBody>
-      </p:sp>
-      <p:pic>
-        <p:nvPicPr>
-          <p:cNvPr id="285" name="Google Shape;285;g39a291deda2_1_39"/>
-          <p:cNvPicPr preferRelativeResize="0"/>
-          <p:nvPr/>
-        </p:nvPicPr>
-        <p:blipFill>
-          <a:blip r:embed="rId5">
-            <a:alphaModFix/>
-          </a:blip>
-          <a:stretch>
-            <a:fillRect/>
-          </a:stretch>
-        </p:blipFill>
-        <p:spPr>
-          <a:xfrm>
-            <a:off x="551325" y="3752550"/>
-            <a:ext cx="8839198" cy="1133388"/>
-          </a:xfrm>
-          <a:prstGeom prst="rect">
-            <a:avLst/>
-          </a:prstGeom>
-          <a:noFill/>
-          <a:ln>
-            <a:noFill/>
-          </a:ln>
-        </p:spPr>
-      </p:pic>
     </p:spTree>
   </p:cSld>
   <p:clrMapOvr>
@@ -19408,7 +19451,7 @@
       </p:grpSpPr>
       <p:sp>
         <p:nvSpPr>
-          <p:cNvPr id="291" name="Google Shape;291;g39a291deda2_1_50"/>
+          <p:cNvPr id="291" name="Google Shape;291;g39a291deda2_1_39"/>
           <p:cNvSpPr txBox="1"/>
           <p:nvPr/>
         </p:nvSpPr>
@@ -19458,7 +19501,7 @@
       </p:sp>
       <p:pic>
         <p:nvPicPr>
-          <p:cNvPr id="292" name="Google Shape;292;g39a291deda2_1_50"/>
+          <p:cNvPr id="292" name="Google Shape;292;g39a291deda2_1_39"/>
           <p:cNvPicPr preferRelativeResize="0"/>
           <p:nvPr/>
         </p:nvPicPr>
@@ -19485,7 +19528,7 @@
       </p:pic>
       <p:pic>
         <p:nvPicPr>
-          <p:cNvPr id="293" name="Google Shape;293;g39a291deda2_1_50"/>
+          <p:cNvPr id="293" name="Google Shape;293;g39a291deda2_1_39"/>
           <p:cNvPicPr preferRelativeResize="0"/>
           <p:nvPr/>
         </p:nvPicPr>
@@ -19499,8 +19542,8 @@
         </p:blipFill>
         <p:spPr>
           <a:xfrm>
-            <a:off x="1469025" y="885850"/>
-            <a:ext cx="6471800" cy="3371800"/>
+            <a:off x="452902" y="1125952"/>
+            <a:ext cx="3131949" cy="2110700"/>
           </a:xfrm>
           <a:prstGeom prst="rect">
             <a:avLst/>
@@ -19513,7 +19556,324 @@
       </p:pic>
       <p:sp>
         <p:nvSpPr>
-          <p:cNvPr id="294" name="Google Shape;294;g39a291deda2_1_50"/>
+          <p:cNvPr id="294" name="Google Shape;294;g39a291deda2_1_39"/>
+          <p:cNvSpPr txBox="1"/>
+          <p:nvPr/>
+        </p:nvSpPr>
+        <p:spPr>
+          <a:xfrm>
+            <a:off x="3925300" y="1119300"/>
+            <a:ext cx="5406000" cy="2124000"/>
+          </a:xfrm>
+          <a:prstGeom prst="rect">
+            <a:avLst/>
+          </a:prstGeom>
+          <a:noFill/>
+          <a:ln>
+            <a:noFill/>
+          </a:ln>
+        </p:spPr>
+        <p:txBody>
+          <a:bodyPr anchorCtr="0" anchor="t" bIns="91425" lIns="91425" spcFirstLastPara="1" rIns="91425" wrap="square" tIns="91425">
+            <a:spAutoFit/>
+          </a:bodyPr>
+          <a:lstStyle/>
+          <a:p>
+            <a:pPr indent="0" lvl="0" marL="0" rtl="0" algn="l">
+              <a:spcBef>
+                <a:spcPts val="0"/>
+              </a:spcBef>
+              <a:spcAft>
+                <a:spcPts val="0"/>
+              </a:spcAft>
+              <a:buNone/>
+            </a:pPr>
+            <a:r>
+              <a:rPr lang="it-IT"/>
+              <a:t>Alcuni comandi che permetterebbero di effettuare un debug interattivo:</a:t>
+            </a:r>
+            <a:endParaRPr sz="1800"/>
+          </a:p>
+          <a:p>
+            <a:pPr indent="0" lvl="0" marL="0" rtl="0" algn="l">
+              <a:spcBef>
+                <a:spcPts val="0"/>
+              </a:spcBef>
+              <a:spcAft>
+                <a:spcPts val="0"/>
+              </a:spcAft>
+              <a:buNone/>
+            </a:pPr>
+            <a:r>
+              <a:t/>
+            </a:r>
+            <a:endParaRPr/>
+          </a:p>
+          <a:p>
+            <a:pPr indent="-317500" lvl="0" marL="457200" rtl="0" algn="l">
+              <a:spcBef>
+                <a:spcPts val="0"/>
+              </a:spcBef>
+              <a:spcAft>
+                <a:spcPts val="0"/>
+              </a:spcAft>
+              <a:buSzPts val="1400"/>
+              <a:buChar char="●"/>
+            </a:pPr>
+            <a:r>
+              <a:rPr lang="it-IT"/>
+              <a:t>n (next)</a:t>
+            </a:r>
+            <a:endParaRPr/>
+          </a:p>
+          <a:p>
+            <a:pPr indent="-317500" lvl="0" marL="457200" rtl="0" algn="l">
+              <a:spcBef>
+                <a:spcPts val="0"/>
+              </a:spcBef>
+              <a:spcAft>
+                <a:spcPts val="0"/>
+              </a:spcAft>
+              <a:buSzPts val="1400"/>
+              <a:buChar char="●"/>
+            </a:pPr>
+            <a:r>
+              <a:rPr lang="it-IT"/>
+              <a:t>s (step)</a:t>
+            </a:r>
+            <a:endParaRPr/>
+          </a:p>
+          <a:p>
+            <a:pPr indent="-317500" lvl="0" marL="457200" rtl="0" algn="l">
+              <a:spcBef>
+                <a:spcPts val="0"/>
+              </a:spcBef>
+              <a:spcAft>
+                <a:spcPts val="0"/>
+              </a:spcAft>
+              <a:buSzPts val="1400"/>
+              <a:buChar char="●"/>
+            </a:pPr>
+            <a:r>
+              <a:rPr lang="it-IT"/>
+              <a:t>c (continue)</a:t>
+            </a:r>
+            <a:endParaRPr/>
+          </a:p>
+          <a:p>
+            <a:pPr indent="-317500" lvl="0" marL="457200" rtl="0" algn="l">
+              <a:spcBef>
+                <a:spcPts val="0"/>
+              </a:spcBef>
+              <a:spcAft>
+                <a:spcPts val="0"/>
+              </a:spcAft>
+              <a:buSzPts val="1400"/>
+              <a:buChar char="●"/>
+            </a:pPr>
+            <a:r>
+              <a:rPr lang="it-IT"/>
+              <a:t>l (list)</a:t>
+            </a:r>
+            <a:endParaRPr/>
+          </a:p>
+          <a:p>
+            <a:pPr indent="-317500" lvl="0" marL="457200" rtl="0" algn="l">
+              <a:spcBef>
+                <a:spcPts val="0"/>
+              </a:spcBef>
+              <a:spcAft>
+                <a:spcPts val="0"/>
+              </a:spcAft>
+              <a:buSzPts val="1400"/>
+              <a:buChar char="●"/>
+            </a:pPr>
+            <a:r>
+              <a:rPr lang="it-IT"/>
+              <a:t>p variabile</a:t>
+            </a:r>
+            <a:endParaRPr/>
+          </a:p>
+          <a:p>
+            <a:pPr indent="-317500" lvl="0" marL="457200" rtl="0" algn="l">
+              <a:spcBef>
+                <a:spcPts val="0"/>
+              </a:spcBef>
+              <a:spcAft>
+                <a:spcPts val="0"/>
+              </a:spcAft>
+              <a:buSzPts val="1400"/>
+              <a:buChar char="●"/>
+            </a:pPr>
+            <a:r>
+              <a:rPr lang="it-IT"/>
+              <a:t>q (quit)</a:t>
+            </a:r>
+            <a:endParaRPr/>
+          </a:p>
+        </p:txBody>
+      </p:sp>
+      <p:pic>
+        <p:nvPicPr>
+          <p:cNvPr id="295" name="Google Shape;295;g39a291deda2_1_39"/>
+          <p:cNvPicPr preferRelativeResize="0"/>
+          <p:nvPr/>
+        </p:nvPicPr>
+        <p:blipFill>
+          <a:blip r:embed="rId5">
+            <a:alphaModFix/>
+          </a:blip>
+          <a:stretch>
+            <a:fillRect/>
+          </a:stretch>
+        </p:blipFill>
+        <p:spPr>
+          <a:xfrm>
+            <a:off x="551325" y="3752550"/>
+            <a:ext cx="8839198" cy="1133388"/>
+          </a:xfrm>
+          <a:prstGeom prst="rect">
+            <a:avLst/>
+          </a:prstGeom>
+          <a:noFill/>
+          <a:ln>
+            <a:noFill/>
+          </a:ln>
+        </p:spPr>
+      </p:pic>
+    </p:spTree>
+  </p:cSld>
+  <p:clrMapOvr>
+    <a:masterClrMapping/>
+  </p:clrMapOvr>
+</p:sld>
+</file>
+
+<file path=ppt/slides/slide25.xml><?xml version="1.0" encoding="utf-8"?>
+<p:sld xmlns:a="http://schemas.openxmlformats.org/drawingml/2006/main" xmlns:r="http://schemas.openxmlformats.org/officeDocument/2006/relationships" xmlns:mc="http://schemas.openxmlformats.org/markup-compatibility/2006" xmlns:mv="urn:schemas-microsoft-com:mac:vml" xmlns:p="http://schemas.openxmlformats.org/presentationml/2006/main" xmlns:c="http://schemas.openxmlformats.org/drawingml/2006/chart" xmlns:dgm="http://schemas.openxmlformats.org/drawingml/2006/diagram" xmlns:o="urn:schemas-microsoft-com:office:office" xmlns:v="urn:schemas-microsoft-com:vml" xmlns:pvml="urn:schemas-microsoft-com:office:powerpoint" xmlns:com="http://schemas.openxmlformats.org/drawingml/2006/compatibility" xmlns:p14="http://schemas.microsoft.com/office/powerpoint/2010/main" xmlns:p15="http://schemas.microsoft.com/office/powerpoint/2012/main" xmlns:ahyp="http://schemas.microsoft.com/office/drawing/2018/hyperlinkcolor">
+  <p:cSld>
+    <p:spTree>
+      <p:nvGrpSpPr>
+        <p:cNvPr id="300" name="Shape 300"/>
+        <p:cNvGrpSpPr/>
+        <p:nvPr/>
+      </p:nvGrpSpPr>
+      <p:grpSpPr>
+        <a:xfrm>
+          <a:off x="0" y="0"/>
+          <a:ext cx="0" cy="0"/>
+          <a:chOff x="0" y="0"/>
+          <a:chExt cx="0" cy="0"/>
+        </a:xfrm>
+      </p:grpSpPr>
+      <p:sp>
+        <p:nvSpPr>
+          <p:cNvPr id="301" name="Google Shape;301;g39a291deda2_1_50"/>
+          <p:cNvSpPr txBox="1"/>
+          <p:nvPr/>
+        </p:nvSpPr>
+        <p:spPr>
+          <a:xfrm>
+            <a:off x="1873040" y="319065"/>
+            <a:ext cx="6567600" cy="400800"/>
+          </a:xfrm>
+          <a:prstGeom prst="rect">
+            <a:avLst/>
+          </a:prstGeom>
+          <a:noFill/>
+          <a:ln>
+            <a:noFill/>
+          </a:ln>
+        </p:spPr>
+        <p:txBody>
+          <a:bodyPr anchorCtr="0" anchor="t" bIns="45700" lIns="91425" spcFirstLastPara="1" rIns="91425" wrap="square" tIns="45700">
+            <a:spAutoFit/>
+          </a:bodyPr>
+          <a:lstStyle/>
+          <a:p>
+            <a:pPr indent="0" lvl="0" marL="0" marR="0" rtl="0" algn="l">
+              <a:spcBef>
+                <a:spcPts val="0"/>
+              </a:spcBef>
+              <a:spcAft>
+                <a:spcPts val="0"/>
+              </a:spcAft>
+              <a:buNone/>
+            </a:pPr>
+            <a:r>
+              <a:rPr b="1" lang="it-IT" sz="2004">
+                <a:solidFill>
+                  <a:srgbClr val="0F4761"/>
+                </a:solidFill>
+                <a:latin typeface="Arial"/>
+                <a:ea typeface="Arial"/>
+                <a:cs typeface="Arial"/>
+                <a:sym typeface="Arial"/>
+              </a:rPr>
+              <a:t>04 Dicembre 2025 – Segreti sui moduli Python</a:t>
+            </a:r>
+            <a:endParaRPr/>
+          </a:p>
+        </p:txBody>
+      </p:sp>
+      <p:pic>
+        <p:nvPicPr>
+          <p:cNvPr id="302" name="Google Shape;302;g39a291deda2_1_50"/>
+          <p:cNvPicPr preferRelativeResize="0"/>
+          <p:nvPr/>
+        </p:nvPicPr>
+        <p:blipFill rotWithShape="1">
+          <a:blip r:embed="rId3">
+            <a:alphaModFix/>
+          </a:blip>
+          <a:srcRect b="0" l="0" r="0" t="0"/>
+          <a:stretch/>
+        </p:blipFill>
+        <p:spPr>
+          <a:xfrm>
+            <a:off x="551323" y="114848"/>
+            <a:ext cx="1268025" cy="809225"/>
+          </a:xfrm>
+          <a:prstGeom prst="rect">
+            <a:avLst/>
+          </a:prstGeom>
+          <a:noFill/>
+          <a:ln>
+            <a:noFill/>
+          </a:ln>
+        </p:spPr>
+      </p:pic>
+      <p:pic>
+        <p:nvPicPr>
+          <p:cNvPr id="303" name="Google Shape;303;g39a291deda2_1_50"/>
+          <p:cNvPicPr preferRelativeResize="0"/>
+          <p:nvPr/>
+        </p:nvPicPr>
+        <p:blipFill>
+          <a:blip r:embed="rId4">
+            <a:alphaModFix/>
+          </a:blip>
+          <a:stretch>
+            <a:fillRect/>
+          </a:stretch>
+        </p:blipFill>
+        <p:spPr>
+          <a:xfrm>
+            <a:off x="1469025" y="885850"/>
+            <a:ext cx="6471800" cy="3371800"/>
+          </a:xfrm>
+          <a:prstGeom prst="rect">
+            <a:avLst/>
+          </a:prstGeom>
+          <a:noFill/>
+          <a:ln>
+            <a:noFill/>
+          </a:ln>
+        </p:spPr>
+      </p:pic>
+      <p:sp>
+        <p:nvSpPr>
+          <p:cNvPr id="304" name="Google Shape;304;g39a291deda2_1_50"/>
           <p:cNvSpPr txBox="1"/>
           <p:nvPr/>
         </p:nvSpPr>
@@ -19561,12 +19921,12 @@
 </p:sld>
 </file>
 
-<file path=ppt/slides/slide25.xml><?xml version="1.0" encoding="utf-8"?>
+<file path=ppt/slides/slide26.xml><?xml version="1.0" encoding="utf-8"?>
 <p:sld xmlns:a="http://schemas.openxmlformats.org/drawingml/2006/main" xmlns:r="http://schemas.openxmlformats.org/officeDocument/2006/relationships" xmlns:mc="http://schemas.openxmlformats.org/markup-compatibility/2006" xmlns:mv="urn:schemas-microsoft-com:mac:vml" xmlns:p="http://schemas.openxmlformats.org/presentationml/2006/main" xmlns:c="http://schemas.openxmlformats.org/drawingml/2006/chart" xmlns:dgm="http://schemas.openxmlformats.org/drawingml/2006/diagram" xmlns:o="urn:schemas-microsoft-com:office:office" xmlns:v="urn:schemas-microsoft-com:vml" xmlns:pvml="urn:schemas-microsoft-com:office:powerpoint" xmlns:com="http://schemas.openxmlformats.org/drawingml/2006/compatibility" xmlns:p14="http://schemas.microsoft.com/office/powerpoint/2010/main" xmlns:p15="http://schemas.microsoft.com/office/powerpoint/2012/main" xmlns:ahyp="http://schemas.microsoft.com/office/drawing/2018/hyperlinkcolor">
   <p:cSld>
     <p:spTree>
       <p:nvGrpSpPr>
-        <p:cNvPr id="299" name="Shape 299"/>
+        <p:cNvPr id="309" name="Shape 309"/>
         <p:cNvGrpSpPr/>
         <p:nvPr/>
       </p:nvGrpSpPr>
@@ -19580,7 +19940,7 @@
       </p:grpSpPr>
       <p:pic>
         <p:nvPicPr>
-          <p:cNvPr id="300" name="Google Shape;300;g3aa6201ac61_0_0"/>
+          <p:cNvPr id="310" name="Google Shape;310;g3aa6201ac61_0_0"/>
           <p:cNvPicPr preferRelativeResize="0"/>
           <p:nvPr/>
         </p:nvPicPr>
@@ -19608,7 +19968,7 @@
       </p:pic>
       <p:sp>
         <p:nvSpPr>
-          <p:cNvPr id="301" name="Google Shape;301;g3aa6201ac61_0_0"/>
+          <p:cNvPr id="311" name="Google Shape;311;g3aa6201ac61_0_0"/>
           <p:cNvSpPr txBox="1"/>
           <p:nvPr/>
         </p:nvSpPr>
@@ -19657,7 +20017,7 @@
       </p:sp>
       <p:sp>
         <p:nvSpPr>
-          <p:cNvPr id="302" name="Google Shape;302;g3aa6201ac61_0_0"/>
+          <p:cNvPr id="312" name="Google Shape;312;g3aa6201ac61_0_0"/>
           <p:cNvSpPr txBox="1"/>
           <p:nvPr/>
         </p:nvSpPr>
@@ -19984,7 +20344,7 @@
       </p:sp>
       <p:pic>
         <p:nvPicPr>
-          <p:cNvPr id="303" name="Google Shape;303;g3aa6201ac61_0_0"/>
+          <p:cNvPr id="313" name="Google Shape;313;g3aa6201ac61_0_0"/>
           <p:cNvPicPr preferRelativeResize="0"/>
           <p:nvPr/>
         </p:nvPicPr>
@@ -20018,12 +20378,12 @@
 </p:sld>
 </file>
 
-<file path=ppt/slides/slide26.xml><?xml version="1.0" encoding="utf-8"?>
+<file path=ppt/slides/slide27.xml><?xml version="1.0" encoding="utf-8"?>
 <p:sld xmlns:a="http://schemas.openxmlformats.org/drawingml/2006/main" xmlns:r="http://schemas.openxmlformats.org/officeDocument/2006/relationships" xmlns:mc="http://schemas.openxmlformats.org/markup-compatibility/2006" xmlns:mv="urn:schemas-microsoft-com:mac:vml" xmlns:p="http://schemas.openxmlformats.org/presentationml/2006/main" xmlns:c="http://schemas.openxmlformats.org/drawingml/2006/chart" xmlns:dgm="http://schemas.openxmlformats.org/drawingml/2006/diagram" xmlns:o="urn:schemas-microsoft-com:office:office" xmlns:v="urn:schemas-microsoft-com:vml" xmlns:pvml="urn:schemas-microsoft-com:office:powerpoint" xmlns:com="http://schemas.openxmlformats.org/drawingml/2006/compatibility" xmlns:p14="http://schemas.microsoft.com/office/powerpoint/2010/main" xmlns:p15="http://schemas.microsoft.com/office/powerpoint/2012/main" xmlns:ahyp="http://schemas.microsoft.com/office/drawing/2018/hyperlinkcolor">
   <p:cSld>
     <p:spTree>
       <p:nvGrpSpPr>
-        <p:cNvPr id="308" name="Shape 308"/>
+        <p:cNvPr id="318" name="Shape 318"/>
         <p:cNvGrpSpPr/>
         <p:nvPr/>
       </p:nvGrpSpPr>
@@ -20037,7 +20397,7 @@
       </p:grpSpPr>
       <p:pic>
         <p:nvPicPr>
-          <p:cNvPr id="309" name="Google Shape;309;g3aa6201ac61_0_6"/>
+          <p:cNvPr id="319" name="Google Shape;319;g3aa6201ac61_0_6"/>
           <p:cNvPicPr preferRelativeResize="0"/>
           <p:nvPr/>
         </p:nvPicPr>
@@ -20065,7 +20425,7 @@
       </p:pic>
       <p:pic>
         <p:nvPicPr>
-          <p:cNvPr id="310" name="Google Shape;310;g3aa6201ac61_0_6"/>
+          <p:cNvPr id="320" name="Google Shape;320;g3aa6201ac61_0_6"/>
           <p:cNvPicPr preferRelativeResize="0"/>
           <p:nvPr/>
         </p:nvPicPr>
@@ -20093,7 +20453,7 @@
       </p:pic>
       <p:sp>
         <p:nvSpPr>
-          <p:cNvPr id="311" name="Google Shape;311;g3aa6201ac61_0_6"/>
+          <p:cNvPr id="321" name="Google Shape;321;g3aa6201ac61_0_6"/>
           <p:cNvSpPr txBox="1"/>
           <p:nvPr/>
         </p:nvSpPr>
@@ -20157,12 +20517,12 @@
 </p:sld>
 </file>
 
-<file path=ppt/slides/slide27.xml><?xml version="1.0" encoding="utf-8"?>
+<file path=ppt/slides/slide28.xml><?xml version="1.0" encoding="utf-8"?>
 <p:sld xmlns:a="http://schemas.openxmlformats.org/drawingml/2006/main" xmlns:r="http://schemas.openxmlformats.org/officeDocument/2006/relationships" xmlns:mc="http://schemas.openxmlformats.org/markup-compatibility/2006" xmlns:mv="urn:schemas-microsoft-com:mac:vml" xmlns:p="http://schemas.openxmlformats.org/presentationml/2006/main" xmlns:c="http://schemas.openxmlformats.org/drawingml/2006/chart" xmlns:dgm="http://schemas.openxmlformats.org/drawingml/2006/diagram" xmlns:o="urn:schemas-microsoft-com:office:office" xmlns:v="urn:schemas-microsoft-com:vml" xmlns:pvml="urn:schemas-microsoft-com:office:powerpoint" xmlns:com="http://schemas.openxmlformats.org/drawingml/2006/compatibility" xmlns:p14="http://schemas.microsoft.com/office/powerpoint/2010/main" xmlns:p15="http://schemas.microsoft.com/office/powerpoint/2012/main" xmlns:ahyp="http://schemas.microsoft.com/office/drawing/2018/hyperlinkcolor">
   <p:cSld>
     <p:spTree>
       <p:nvGrpSpPr>
-        <p:cNvPr id="316" name="Shape 316"/>
+        <p:cNvPr id="326" name="Shape 326"/>
         <p:cNvGrpSpPr/>
         <p:nvPr/>
       </p:nvGrpSpPr>
@@ -20176,7 +20536,7 @@
       </p:grpSpPr>
       <p:pic>
         <p:nvPicPr>
-          <p:cNvPr id="317" name="Google Shape;317;g3ac9e9082d3_0_11"/>
+          <p:cNvPr id="327" name="Google Shape;327;g3ac9e9082d3_0_11"/>
           <p:cNvPicPr preferRelativeResize="0"/>
           <p:nvPr/>
         </p:nvPicPr>
@@ -20204,7 +20564,7 @@
       </p:pic>
       <p:sp>
         <p:nvSpPr>
-          <p:cNvPr id="318" name="Google Shape;318;g3ac9e9082d3_0_11"/>
+          <p:cNvPr id="328" name="Google Shape;328;g3ac9e9082d3_0_11"/>
           <p:cNvSpPr txBox="1"/>
           <p:nvPr/>
         </p:nvSpPr>
@@ -20262,7 +20622,7 @@
       </p:sp>
       <p:sp>
         <p:nvSpPr>
-          <p:cNvPr id="319" name="Google Shape;319;g3ac9e9082d3_0_11"/>
+          <p:cNvPr id="329" name="Google Shape;329;g3ac9e9082d3_0_11"/>
           <p:cNvSpPr txBox="1"/>
           <p:nvPr/>
         </p:nvSpPr>
@@ -20336,7 +20696,7 @@
       </p:sp>
       <p:sp>
         <p:nvSpPr>
-          <p:cNvPr id="320" name="Google Shape;320;g3ac9e9082d3_0_11"/>
+          <p:cNvPr id="330" name="Google Shape;330;g3ac9e9082d3_0_11"/>
           <p:cNvSpPr txBox="1"/>
           <p:nvPr/>
         </p:nvSpPr>
@@ -20400,12 +20760,12 @@
 </p:sld>
 </file>
 
-<file path=ppt/slides/slide28.xml><?xml version="1.0" encoding="utf-8"?>
+<file path=ppt/slides/slide29.xml><?xml version="1.0" encoding="utf-8"?>
 <p:sld xmlns:a="http://schemas.openxmlformats.org/drawingml/2006/main" xmlns:r="http://schemas.openxmlformats.org/officeDocument/2006/relationships" xmlns:mc="http://schemas.openxmlformats.org/markup-compatibility/2006" xmlns:mv="urn:schemas-microsoft-com:mac:vml" xmlns:p="http://schemas.openxmlformats.org/presentationml/2006/main" xmlns:c="http://schemas.openxmlformats.org/drawingml/2006/chart" xmlns:dgm="http://schemas.openxmlformats.org/drawingml/2006/diagram" xmlns:o="urn:schemas-microsoft-com:office:office" xmlns:v="urn:schemas-microsoft-com:vml" xmlns:pvml="urn:schemas-microsoft-com:office:powerpoint" xmlns:com="http://schemas.openxmlformats.org/drawingml/2006/compatibility" xmlns:p14="http://schemas.microsoft.com/office/powerpoint/2010/main" xmlns:p15="http://schemas.microsoft.com/office/powerpoint/2012/main" xmlns:ahyp="http://schemas.microsoft.com/office/drawing/2018/hyperlinkcolor">
   <p:cSld>
     <p:spTree>
       <p:nvGrpSpPr>
-        <p:cNvPr id="325" name="Shape 325"/>
+        <p:cNvPr id="335" name="Shape 335"/>
         <p:cNvGrpSpPr/>
         <p:nvPr/>
       </p:nvGrpSpPr>
@@ -20419,7 +20779,7 @@
       </p:grpSpPr>
       <p:pic>
         <p:nvPicPr>
-          <p:cNvPr id="326" name="Google Shape;326;g3ac9e796f79_0_0"/>
+          <p:cNvPr id="336" name="Google Shape;336;g3ac9e796f79_0_0"/>
           <p:cNvPicPr preferRelativeResize="0"/>
           <p:nvPr/>
         </p:nvPicPr>
@@ -20447,7 +20807,7 @@
       </p:pic>
       <p:sp>
         <p:nvSpPr>
-          <p:cNvPr id="327" name="Google Shape;327;g3ac9e796f79_0_0"/>
+          <p:cNvPr id="337" name="Google Shape;337;g3ac9e796f79_0_0"/>
           <p:cNvSpPr txBox="1"/>
           <p:nvPr/>
         </p:nvSpPr>
@@ -20735,115 +21095,6 @@
           </a:p>
         </p:txBody>
       </p:sp>
-    </p:spTree>
-  </p:cSld>
-  <p:clrMapOvr>
-    <a:masterClrMapping/>
-  </p:clrMapOvr>
-</p:sld>
-</file>
-
-<file path=ppt/slides/slide29.xml><?xml version="1.0" encoding="utf-8"?>
-<p:sld xmlns:a="http://schemas.openxmlformats.org/drawingml/2006/main" xmlns:r="http://schemas.openxmlformats.org/officeDocument/2006/relationships" xmlns:mc="http://schemas.openxmlformats.org/markup-compatibility/2006" xmlns:mv="urn:schemas-microsoft-com:mac:vml" xmlns:p="http://schemas.openxmlformats.org/presentationml/2006/main" xmlns:c="http://schemas.openxmlformats.org/drawingml/2006/chart" xmlns:dgm="http://schemas.openxmlformats.org/drawingml/2006/diagram" xmlns:o="urn:schemas-microsoft-com:office:office" xmlns:v="urn:schemas-microsoft-com:vml" xmlns:pvml="urn:schemas-microsoft-com:office:powerpoint" xmlns:com="http://schemas.openxmlformats.org/drawingml/2006/compatibility" xmlns:p14="http://schemas.microsoft.com/office/powerpoint/2010/main" xmlns:p15="http://schemas.microsoft.com/office/powerpoint/2012/main" xmlns:ahyp="http://schemas.microsoft.com/office/drawing/2018/hyperlinkcolor">
-  <p:cSld>
-    <p:spTree>
-      <p:nvGrpSpPr>
-        <p:cNvPr id="332" name="Shape 332"/>
-        <p:cNvGrpSpPr/>
-        <p:nvPr/>
-      </p:nvGrpSpPr>
-      <p:grpSpPr>
-        <a:xfrm>
-          <a:off x="0" y="0"/>
-          <a:ext cx="0" cy="0"/>
-          <a:chOff x="0" y="0"/>
-          <a:chExt cx="0" cy="0"/>
-        </a:xfrm>
-      </p:grpSpPr>
-      <p:pic>
-        <p:nvPicPr>
-          <p:cNvPr id="333" name="Google Shape;333;g3aa6201ac61_0_12"/>
-          <p:cNvPicPr preferRelativeResize="0"/>
-          <p:nvPr/>
-        </p:nvPicPr>
-        <p:blipFill>
-          <a:blip r:embed="rId3">
-            <a:alphaModFix/>
-          </a:blip>
-          <a:stretch>
-            <a:fillRect/>
-          </a:stretch>
-        </p:blipFill>
-        <p:spPr>
-          <a:xfrm>
-            <a:off x="435400" y="164700"/>
-            <a:ext cx="8839201" cy="907810"/>
-          </a:xfrm>
-          <a:prstGeom prst="rect">
-            <a:avLst/>
-          </a:prstGeom>
-          <a:noFill/>
-          <a:ln>
-            <a:noFill/>
-          </a:ln>
-        </p:spPr>
-      </p:pic>
-      <p:pic>
-        <p:nvPicPr>
-          <p:cNvPr id="334" name="Google Shape;334;g3aa6201ac61_0_12"/>
-          <p:cNvPicPr preferRelativeResize="0"/>
-          <p:nvPr/>
-        </p:nvPicPr>
-        <p:blipFill>
-          <a:blip r:embed="rId4">
-            <a:alphaModFix/>
-          </a:blip>
-          <a:stretch>
-            <a:fillRect/>
-          </a:stretch>
-        </p:blipFill>
-        <p:spPr>
-          <a:xfrm>
-            <a:off x="130600" y="3936312"/>
-            <a:ext cx="9143999" cy="685977"/>
-          </a:xfrm>
-          <a:prstGeom prst="rect">
-            <a:avLst/>
-          </a:prstGeom>
-          <a:noFill/>
-          <a:ln>
-            <a:noFill/>
-          </a:ln>
-        </p:spPr>
-      </p:pic>
-      <p:pic>
-        <p:nvPicPr>
-          <p:cNvPr id="335" name="Google Shape;335;g3aa6201ac61_0_12"/>
-          <p:cNvPicPr preferRelativeResize="0"/>
-          <p:nvPr/>
-        </p:nvPicPr>
-        <p:blipFill>
-          <a:blip r:embed="rId5">
-            <a:alphaModFix/>
-          </a:blip>
-          <a:stretch>
-            <a:fillRect/>
-          </a:stretch>
-        </p:blipFill>
-        <p:spPr>
-          <a:xfrm>
-            <a:off x="2773375" y="954185"/>
-            <a:ext cx="3750579" cy="2718978"/>
-          </a:xfrm>
-          <a:prstGeom prst="rect">
-            <a:avLst/>
-          </a:prstGeom>
-          <a:noFill/>
-          <a:ln>
-            <a:noFill/>
-          </a:ln>
-        </p:spPr>
-      </p:pic>
     </p:spTree>
   </p:cSld>
   <p:clrMapOvr>
@@ -21111,7 +21362,7 @@
   <p:cSld>
     <p:spTree>
       <p:nvGrpSpPr>
-        <p:cNvPr id="340" name="Shape 340"/>
+        <p:cNvPr id="342" name="Shape 342"/>
         <p:cNvGrpSpPr/>
         <p:nvPr/>
       </p:nvGrpSpPr>
@@ -21125,7 +21376,7 @@
       </p:grpSpPr>
       <p:pic>
         <p:nvPicPr>
-          <p:cNvPr id="341" name="Google Shape;341;g3ac9e796f79_0_6"/>
+          <p:cNvPr id="343" name="Google Shape;343;g3aa6201ac61_0_12"/>
           <p:cNvPicPr preferRelativeResize="0"/>
           <p:nvPr/>
         </p:nvPicPr>
@@ -21151,9 +21402,118 @@
           </a:ln>
         </p:spPr>
       </p:pic>
+      <p:pic>
+        <p:nvPicPr>
+          <p:cNvPr id="344" name="Google Shape;344;g3aa6201ac61_0_12"/>
+          <p:cNvPicPr preferRelativeResize="0"/>
+          <p:nvPr/>
+        </p:nvPicPr>
+        <p:blipFill>
+          <a:blip r:embed="rId4">
+            <a:alphaModFix/>
+          </a:blip>
+          <a:stretch>
+            <a:fillRect/>
+          </a:stretch>
+        </p:blipFill>
+        <p:spPr>
+          <a:xfrm>
+            <a:off x="130600" y="3936312"/>
+            <a:ext cx="9143999" cy="685977"/>
+          </a:xfrm>
+          <a:prstGeom prst="rect">
+            <a:avLst/>
+          </a:prstGeom>
+          <a:noFill/>
+          <a:ln>
+            <a:noFill/>
+          </a:ln>
+        </p:spPr>
+      </p:pic>
+      <p:pic>
+        <p:nvPicPr>
+          <p:cNvPr id="345" name="Google Shape;345;g3aa6201ac61_0_12"/>
+          <p:cNvPicPr preferRelativeResize="0"/>
+          <p:nvPr/>
+        </p:nvPicPr>
+        <p:blipFill>
+          <a:blip r:embed="rId5">
+            <a:alphaModFix/>
+          </a:blip>
+          <a:stretch>
+            <a:fillRect/>
+          </a:stretch>
+        </p:blipFill>
+        <p:spPr>
+          <a:xfrm>
+            <a:off x="2773375" y="954185"/>
+            <a:ext cx="3750579" cy="2718978"/>
+          </a:xfrm>
+          <a:prstGeom prst="rect">
+            <a:avLst/>
+          </a:prstGeom>
+          <a:noFill/>
+          <a:ln>
+            <a:noFill/>
+          </a:ln>
+        </p:spPr>
+      </p:pic>
+    </p:spTree>
+  </p:cSld>
+  <p:clrMapOvr>
+    <a:masterClrMapping/>
+  </p:clrMapOvr>
+</p:sld>
+</file>
+
+<file path=ppt/slides/slide31.xml><?xml version="1.0" encoding="utf-8"?>
+<p:sld xmlns:a="http://schemas.openxmlformats.org/drawingml/2006/main" xmlns:r="http://schemas.openxmlformats.org/officeDocument/2006/relationships" xmlns:mc="http://schemas.openxmlformats.org/markup-compatibility/2006" xmlns:mv="urn:schemas-microsoft-com:mac:vml" xmlns:p="http://schemas.openxmlformats.org/presentationml/2006/main" xmlns:c="http://schemas.openxmlformats.org/drawingml/2006/chart" xmlns:dgm="http://schemas.openxmlformats.org/drawingml/2006/diagram" xmlns:o="urn:schemas-microsoft-com:office:office" xmlns:v="urn:schemas-microsoft-com:vml" xmlns:pvml="urn:schemas-microsoft-com:office:powerpoint" xmlns:com="http://schemas.openxmlformats.org/drawingml/2006/compatibility" xmlns:p14="http://schemas.microsoft.com/office/powerpoint/2010/main" xmlns:p15="http://schemas.microsoft.com/office/powerpoint/2012/main" xmlns:ahyp="http://schemas.microsoft.com/office/drawing/2018/hyperlinkcolor">
+  <p:cSld>
+    <p:spTree>
+      <p:nvGrpSpPr>
+        <p:cNvPr id="350" name="Shape 350"/>
+        <p:cNvGrpSpPr/>
+        <p:nvPr/>
+      </p:nvGrpSpPr>
+      <p:grpSpPr>
+        <a:xfrm>
+          <a:off x="0" y="0"/>
+          <a:ext cx="0" cy="0"/>
+          <a:chOff x="0" y="0"/>
+          <a:chExt cx="0" cy="0"/>
+        </a:xfrm>
+      </p:grpSpPr>
+      <p:pic>
+        <p:nvPicPr>
+          <p:cNvPr id="351" name="Google Shape;351;g3ac9e796f79_0_6"/>
+          <p:cNvPicPr preferRelativeResize="0"/>
+          <p:nvPr/>
+        </p:nvPicPr>
+        <p:blipFill>
+          <a:blip r:embed="rId3">
+            <a:alphaModFix/>
+          </a:blip>
+          <a:stretch>
+            <a:fillRect/>
+          </a:stretch>
+        </p:blipFill>
+        <p:spPr>
+          <a:xfrm>
+            <a:off x="435400" y="164700"/>
+            <a:ext cx="8839201" cy="907810"/>
+          </a:xfrm>
+          <a:prstGeom prst="rect">
+            <a:avLst/>
+          </a:prstGeom>
+          <a:noFill/>
+          <a:ln>
+            <a:noFill/>
+          </a:ln>
+        </p:spPr>
+      </p:pic>
       <p:sp>
         <p:nvSpPr>
-          <p:cNvPr id="342" name="Google Shape;342;g3ac9e796f79_0_6"/>
+          <p:cNvPr id="352" name="Google Shape;352;g3ac9e796f79_0_6"/>
           <p:cNvSpPr txBox="1"/>
           <p:nvPr/>
         </p:nvSpPr>
@@ -21257,7 +21617,7 @@
       </p:sp>
       <p:pic>
         <p:nvPicPr>
-          <p:cNvPr id="343" name="Google Shape;343;g3ac9e796f79_0_6"/>
+          <p:cNvPr id="353" name="Google Shape;353;g3ac9e796f79_0_6"/>
           <p:cNvPicPr preferRelativeResize="0"/>
           <p:nvPr/>
         </p:nvPicPr>
@@ -21285,7 +21645,7 @@
       </p:pic>
       <p:sp>
         <p:nvSpPr>
-          <p:cNvPr id="344" name="Google Shape;344;g3ac9e796f79_0_6"/>
+          <p:cNvPr id="354" name="Google Shape;354;g3ac9e796f79_0_6"/>
           <p:cNvSpPr txBox="1"/>
           <p:nvPr/>
         </p:nvSpPr>
@@ -21361,12 +21721,12 @@
 </p:sld>
 </file>
 
-<file path=ppt/slides/slide31.xml><?xml version="1.0" encoding="utf-8"?>
+<file path=ppt/slides/slide32.xml><?xml version="1.0" encoding="utf-8"?>
 <p:sld xmlns:a="http://schemas.openxmlformats.org/drawingml/2006/main" xmlns:r="http://schemas.openxmlformats.org/officeDocument/2006/relationships" xmlns:mc="http://schemas.openxmlformats.org/markup-compatibility/2006" xmlns:mv="urn:schemas-microsoft-com:mac:vml" xmlns:p="http://schemas.openxmlformats.org/presentationml/2006/main" xmlns:c="http://schemas.openxmlformats.org/drawingml/2006/chart" xmlns:dgm="http://schemas.openxmlformats.org/drawingml/2006/diagram" xmlns:o="urn:schemas-microsoft-com:office:office" xmlns:v="urn:schemas-microsoft-com:vml" xmlns:pvml="urn:schemas-microsoft-com:office:powerpoint" xmlns:com="http://schemas.openxmlformats.org/drawingml/2006/compatibility" xmlns:p14="http://schemas.microsoft.com/office/powerpoint/2010/main" xmlns:p15="http://schemas.microsoft.com/office/powerpoint/2012/main" xmlns:ahyp="http://schemas.microsoft.com/office/drawing/2018/hyperlinkcolor">
   <p:cSld>
     <p:spTree>
       <p:nvGrpSpPr>
-        <p:cNvPr id="349" name="Shape 349"/>
+        <p:cNvPr id="359" name="Shape 359"/>
         <p:cNvGrpSpPr/>
         <p:nvPr/>
       </p:nvGrpSpPr>
@@ -21380,7 +21740,7 @@
       </p:grpSpPr>
       <p:pic>
         <p:nvPicPr>
-          <p:cNvPr id="350" name="Google Shape;350;g3aa6201ac61_0_19"/>
+          <p:cNvPr id="360" name="Google Shape;360;g3aa6201ac61_0_19"/>
           <p:cNvPicPr preferRelativeResize="0"/>
           <p:nvPr/>
         </p:nvPicPr>
@@ -21408,7 +21768,7 @@
       </p:pic>
       <p:pic>
         <p:nvPicPr>
-          <p:cNvPr id="351" name="Google Shape;351;g3aa6201ac61_0_19"/>
+          <p:cNvPr id="361" name="Google Shape;361;g3aa6201ac61_0_19"/>
           <p:cNvPicPr preferRelativeResize="0"/>
           <p:nvPr/>
         </p:nvPicPr>
@@ -21436,7 +21796,7 @@
       </p:pic>
       <p:pic>
         <p:nvPicPr>
-          <p:cNvPr id="352" name="Google Shape;352;g3aa6201ac61_0_19"/>
+          <p:cNvPr id="362" name="Google Shape;362;g3aa6201ac61_0_19"/>
           <p:cNvPicPr preferRelativeResize="0"/>
           <p:nvPr/>
         </p:nvPicPr>
@@ -21470,12 +21830,12 @@
 </p:sld>
 </file>
 
-<file path=ppt/slides/slide32.xml><?xml version="1.0" encoding="utf-8"?>
+<file path=ppt/slides/slide33.xml><?xml version="1.0" encoding="utf-8"?>
 <p:sld xmlns:a="http://schemas.openxmlformats.org/drawingml/2006/main" xmlns:r="http://schemas.openxmlformats.org/officeDocument/2006/relationships" xmlns:mc="http://schemas.openxmlformats.org/markup-compatibility/2006" xmlns:mv="urn:schemas-microsoft-com:mac:vml" xmlns:p="http://schemas.openxmlformats.org/presentationml/2006/main" xmlns:c="http://schemas.openxmlformats.org/drawingml/2006/chart" xmlns:dgm="http://schemas.openxmlformats.org/drawingml/2006/diagram" xmlns:o="urn:schemas-microsoft-com:office:office" xmlns:v="urn:schemas-microsoft-com:vml" xmlns:pvml="urn:schemas-microsoft-com:office:powerpoint" xmlns:com="http://schemas.openxmlformats.org/drawingml/2006/compatibility" xmlns:p14="http://schemas.microsoft.com/office/powerpoint/2010/main" xmlns:p15="http://schemas.microsoft.com/office/powerpoint/2012/main" xmlns:ahyp="http://schemas.microsoft.com/office/drawing/2018/hyperlinkcolor">
   <p:cSld>
     <p:spTree>
       <p:nvGrpSpPr>
-        <p:cNvPr id="357" name="Shape 357"/>
+        <p:cNvPr id="367" name="Shape 367"/>
         <p:cNvGrpSpPr/>
         <p:nvPr/>
       </p:nvGrpSpPr>
@@ -21489,7 +21849,7 @@
       </p:grpSpPr>
       <p:pic>
         <p:nvPicPr>
-          <p:cNvPr id="358" name="Google Shape;358;g3aa6201ac61_0_26"/>
+          <p:cNvPr id="368" name="Google Shape;368;g3aa6201ac61_0_26"/>
           <p:cNvPicPr preferRelativeResize="0"/>
           <p:nvPr/>
         </p:nvPicPr>
@@ -21517,7 +21877,7 @@
       </p:pic>
       <p:pic>
         <p:nvPicPr>
-          <p:cNvPr id="359" name="Google Shape;359;g3aa6201ac61_0_26"/>
+          <p:cNvPr id="369" name="Google Shape;369;g3aa6201ac61_0_26"/>
           <p:cNvPicPr preferRelativeResize="0"/>
           <p:nvPr/>
         </p:nvPicPr>
@@ -21545,7 +21905,7 @@
       </p:pic>
       <p:pic>
         <p:nvPicPr>
-          <p:cNvPr id="360" name="Google Shape;360;g3aa6201ac61_0_26"/>
+          <p:cNvPr id="370" name="Google Shape;370;g3aa6201ac61_0_26"/>
           <p:cNvPicPr preferRelativeResize="0"/>
           <p:nvPr/>
         </p:nvPicPr>
@@ -21573,7 +21933,7 @@
       </p:pic>
       <p:sp>
         <p:nvSpPr>
-          <p:cNvPr id="361" name="Google Shape;361;g3aa6201ac61_0_26"/>
+          <p:cNvPr id="371" name="Google Shape;371;g3aa6201ac61_0_26"/>
           <p:cNvSpPr txBox="1"/>
           <p:nvPr/>
         </p:nvSpPr>
@@ -21652,12 +22012,12 @@
 </p:sld>
 </file>
 
-<file path=ppt/slides/slide33.xml><?xml version="1.0" encoding="utf-8"?>
+<file path=ppt/slides/slide34.xml><?xml version="1.0" encoding="utf-8"?>
 <p:sld xmlns:a="http://schemas.openxmlformats.org/drawingml/2006/main" xmlns:r="http://schemas.openxmlformats.org/officeDocument/2006/relationships" xmlns:mc="http://schemas.openxmlformats.org/markup-compatibility/2006" xmlns:mv="urn:schemas-microsoft-com:mac:vml" xmlns:p="http://schemas.openxmlformats.org/presentationml/2006/main" xmlns:c="http://schemas.openxmlformats.org/drawingml/2006/chart" xmlns:dgm="http://schemas.openxmlformats.org/drawingml/2006/diagram" xmlns:o="urn:schemas-microsoft-com:office:office" xmlns:v="urn:schemas-microsoft-com:vml" xmlns:pvml="urn:schemas-microsoft-com:office:powerpoint" xmlns:com="http://schemas.openxmlformats.org/drawingml/2006/compatibility" xmlns:p14="http://schemas.microsoft.com/office/powerpoint/2010/main" xmlns:p15="http://schemas.microsoft.com/office/powerpoint/2012/main" xmlns:ahyp="http://schemas.microsoft.com/office/drawing/2018/hyperlinkcolor">
   <p:cSld>
     <p:spTree>
       <p:nvGrpSpPr>
-        <p:cNvPr id="365" name="Shape 365"/>
+        <p:cNvPr id="375" name="Shape 375"/>
         <p:cNvGrpSpPr/>
         <p:nvPr/>
       </p:nvGrpSpPr>
@@ -21671,7 +22031,7 @@
       </p:grpSpPr>
       <p:pic>
         <p:nvPicPr>
-          <p:cNvPr id="366" name="Google Shape;366;p15"/>
+          <p:cNvPr id="376" name="Google Shape;376;p15"/>
           <p:cNvPicPr preferRelativeResize="0"/>
           <p:nvPr/>
         </p:nvPicPr>
@@ -21698,7 +22058,7 @@
       </p:pic>
       <p:sp>
         <p:nvSpPr>
-          <p:cNvPr id="367" name="Google Shape;367;p15"/>
+          <p:cNvPr id="377" name="Google Shape;377;p15"/>
           <p:cNvSpPr txBox="1"/>
           <p:nvPr/>
         </p:nvSpPr>
@@ -21748,7 +22108,7 @@
       </p:sp>
       <p:pic>
         <p:nvPicPr>
-          <p:cNvPr id="368" name="Google Shape;368;p15"/>
+          <p:cNvPr id="378" name="Google Shape;378;p15"/>
           <p:cNvPicPr preferRelativeResize="0"/>
           <p:nvPr/>
         </p:nvPicPr>

</xml_diff>

<commit_message>
Aggiornamento final release slide talk
</commit_message>
<xml_diff>
--- a/SEGRETI_MODULI_PYTHON_FINALSLIDE.pptx
+++ b/SEGRETI_MODULI_PYTHON_FINALSLIDE.pptx
@@ -17150,7 +17150,7 @@
         </p:blipFill>
         <p:spPr>
           <a:xfrm>
-            <a:off x="354025" y="1649361"/>
+            <a:off x="152400" y="1649386"/>
             <a:ext cx="8839204" cy="750987"/>
           </a:xfrm>
           <a:prstGeom prst="rect">
@@ -17178,7 +17178,7 @@
         </p:blipFill>
         <p:spPr>
           <a:xfrm>
-            <a:off x="447725" y="2971123"/>
+            <a:off x="152400" y="2983423"/>
             <a:ext cx="8839202" cy="1541194"/>
           </a:xfrm>
           <a:prstGeom prst="rect">
@@ -18946,7 +18946,7 @@
         </p:nvSpPr>
         <p:spPr>
           <a:xfrm>
-            <a:off x="385550" y="1803275"/>
+            <a:off x="112200" y="1852500"/>
             <a:ext cx="9031800" cy="2893800"/>
           </a:xfrm>
           <a:prstGeom prst="rect">

</xml_diff>

<commit_message>
Aggiunte slides per containerizzare service in python
</commit_message>
<xml_diff>
--- a/SEGRETI_MODULI_PYTHON_FINALSLIDE.pptx
+++ b/SEGRETI_MODULI_PYTHON_FINALSLIDE.pptx
@@ -42,6 +42,9 @@
     <p:sldId id="287" r:id="rId37"/>
     <p:sldId id="288" r:id="rId38"/>
     <p:sldId id="289" r:id="rId39"/>
+    <p:sldId id="290" r:id="rId40"/>
+    <p:sldId id="291" r:id="rId41"/>
+    <p:sldId id="292" r:id="rId42"/>
   </p:sldIdLst>
   <p:sldSz cy="5143500" cx="9144000"/>
   <p:notesSz cx="6858000" cy="9144000"/>
@@ -290,7 +293,7 @@
       </p15:sldGuideLst>
     </p:ext>
     <p:ext uri="GoogleSlidesCustomDataVersion2">
-      <go:slidesCustomData xmlns:go="http://customooxmlschemas.google.com/" r:id="rId40" roundtripDataSignature="AMtx7mgQucvfgzgh8zg7dLE8ACzTvMHwSw=="/>
+      <go:slidesCustomData xmlns:go="http://customooxmlschemas.google.com/" r:id="rId43" roundtripDataSignature="AMtx7missyE4P3d5OCKLX6GxCoigcDWefQ=="/>
     </p:ext>
   </p:extLst>
 </p:presentation>
@@ -1612,7 +1615,7 @@
   <p:cSld>
     <p:spTree>
       <p:nvGrpSpPr>
-        <p:cNvPr id="160" name="Shape 160"/>
+        <p:cNvPr id="161" name="Shape 161"/>
         <p:cNvGrpSpPr/>
         <p:nvPr/>
       </p:nvGrpSpPr>
@@ -1626,7 +1629,7 @@
       </p:grpSpPr>
       <p:sp>
         <p:nvSpPr>
-          <p:cNvPr id="161" name="Google Shape;161;p8:notes"/>
+          <p:cNvPr id="162" name="Google Shape;162;p8:notes"/>
           <p:cNvSpPr txBox="1"/>
           <p:nvPr>
             <p:ph idx="1" type="body"/>
@@ -1665,7 +1668,7 @@
       </p:sp>
       <p:sp>
         <p:nvSpPr>
-          <p:cNvPr id="162" name="Google Shape;162;p8:notes"/>
+          <p:cNvPr id="163" name="Google Shape;163;p8:notes"/>
           <p:cNvSpPr/>
           <p:nvPr>
             <p:ph idx="2" type="sldImg"/>
@@ -1711,7 +1714,7 @@
   <p:cSld>
     <p:spTree>
       <p:nvGrpSpPr>
-        <p:cNvPr id="169" name="Shape 169"/>
+        <p:cNvPr id="170" name="Shape 170"/>
         <p:cNvGrpSpPr/>
         <p:nvPr/>
       </p:nvGrpSpPr>
@@ -1725,7 +1728,7 @@
       </p:grpSpPr>
       <p:sp>
         <p:nvSpPr>
-          <p:cNvPr id="170" name="Google Shape;170;p9:notes"/>
+          <p:cNvPr id="171" name="Google Shape;171;p9:notes"/>
           <p:cNvSpPr txBox="1"/>
           <p:nvPr>
             <p:ph idx="1" type="body"/>
@@ -1764,7 +1767,7 @@
       </p:sp>
       <p:sp>
         <p:nvSpPr>
-          <p:cNvPr id="171" name="Google Shape;171;p9:notes"/>
+          <p:cNvPr id="172" name="Google Shape;172;p9:notes"/>
           <p:cNvSpPr/>
           <p:nvPr>
             <p:ph idx="2" type="sldImg"/>
@@ -1810,7 +1813,7 @@
   <p:cSld>
     <p:spTree>
       <p:nvGrpSpPr>
-        <p:cNvPr id="178" name="Shape 178"/>
+        <p:cNvPr id="179" name="Shape 179"/>
         <p:cNvGrpSpPr/>
         <p:nvPr/>
       </p:nvGrpSpPr>
@@ -1824,7 +1827,7 @@
       </p:grpSpPr>
       <p:sp>
         <p:nvSpPr>
-          <p:cNvPr id="179" name="Google Shape;179;p10:notes"/>
+          <p:cNvPr id="180" name="Google Shape;180;p10:notes"/>
           <p:cNvSpPr txBox="1"/>
           <p:nvPr>
             <p:ph idx="1" type="body"/>
@@ -1863,7 +1866,7 @@
       </p:sp>
       <p:sp>
         <p:nvSpPr>
-          <p:cNvPr id="180" name="Google Shape;180;p10:notes"/>
+          <p:cNvPr id="181" name="Google Shape;181;p10:notes"/>
           <p:cNvSpPr/>
           <p:nvPr>
             <p:ph idx="2" type="sldImg"/>
@@ -1909,7 +1912,7 @@
   <p:cSld>
     <p:spTree>
       <p:nvGrpSpPr>
-        <p:cNvPr id="186" name="Shape 186"/>
+        <p:cNvPr id="187" name="Shape 187"/>
         <p:cNvGrpSpPr/>
         <p:nvPr/>
       </p:nvGrpSpPr>
@@ -1923,7 +1926,7 @@
       </p:grpSpPr>
       <p:sp>
         <p:nvSpPr>
-          <p:cNvPr id="187" name="Google Shape;187;p11:notes"/>
+          <p:cNvPr id="188" name="Google Shape;188;p11:notes"/>
           <p:cNvSpPr txBox="1"/>
           <p:nvPr>
             <p:ph idx="1" type="body"/>
@@ -1962,7 +1965,7 @@
       </p:sp>
       <p:sp>
         <p:nvSpPr>
-          <p:cNvPr id="188" name="Google Shape;188;p11:notes"/>
+          <p:cNvPr id="189" name="Google Shape;189;p11:notes"/>
           <p:cNvSpPr/>
           <p:nvPr>
             <p:ph idx="2" type="sldImg"/>
@@ -2008,7 +2011,7 @@
   <p:cSld>
     <p:spTree>
       <p:nvGrpSpPr>
-        <p:cNvPr id="195" name="Shape 195"/>
+        <p:cNvPr id="196" name="Shape 196"/>
         <p:cNvGrpSpPr/>
         <p:nvPr/>
       </p:nvGrpSpPr>
@@ -2022,7 +2025,7 @@
       </p:grpSpPr>
       <p:sp>
         <p:nvSpPr>
-          <p:cNvPr id="196" name="Google Shape;196;p12:notes"/>
+          <p:cNvPr id="197" name="Google Shape;197;p12:notes"/>
           <p:cNvSpPr/>
           <p:nvPr>
             <p:ph idx="2" type="sldImg"/>
@@ -2067,7 +2070,7 @@
       </p:sp>
       <p:sp>
         <p:nvSpPr>
-          <p:cNvPr id="197" name="Google Shape;197;p12:notes"/>
+          <p:cNvPr id="198" name="Google Shape;198;p12:notes"/>
           <p:cNvSpPr txBox="1"/>
           <p:nvPr>
             <p:ph idx="1" type="body"/>
@@ -2110,7 +2113,7 @@
       </p:sp>
       <p:sp>
         <p:nvSpPr>
-          <p:cNvPr id="198" name="Google Shape;198;p12:notes"/>
+          <p:cNvPr id="199" name="Google Shape;199;p12:notes"/>
           <p:cNvSpPr txBox="1"/>
           <p:nvPr>
             <p:ph idx="12" type="sldNum"/>
@@ -2165,7 +2168,7 @@
   <p:cSld>
     <p:spTree>
       <p:nvGrpSpPr>
-        <p:cNvPr id="204" name="Shape 204"/>
+        <p:cNvPr id="205" name="Shape 205"/>
         <p:cNvGrpSpPr/>
         <p:nvPr/>
       </p:nvGrpSpPr>
@@ -2179,7 +2182,7 @@
       </p:grpSpPr>
       <p:sp>
         <p:nvSpPr>
-          <p:cNvPr id="205" name="Google Shape;205;p13:notes"/>
+          <p:cNvPr id="206" name="Google Shape;206;p13:notes"/>
           <p:cNvSpPr txBox="1"/>
           <p:nvPr>
             <p:ph idx="1" type="body"/>
@@ -2218,7 +2221,7 @@
       </p:sp>
       <p:sp>
         <p:nvSpPr>
-          <p:cNvPr id="206" name="Google Shape;206;p13:notes"/>
+          <p:cNvPr id="207" name="Google Shape;207;p13:notes"/>
           <p:cNvSpPr/>
           <p:nvPr>
             <p:ph idx="2" type="sldImg"/>
@@ -2264,7 +2267,7 @@
   <p:cSld>
     <p:spTree>
       <p:nvGrpSpPr>
-        <p:cNvPr id="212" name="Shape 212"/>
+        <p:cNvPr id="213" name="Shape 213"/>
         <p:cNvGrpSpPr/>
         <p:nvPr/>
       </p:nvGrpSpPr>
@@ -2278,7 +2281,7 @@
       </p:grpSpPr>
       <p:sp>
         <p:nvSpPr>
-          <p:cNvPr id="213" name="Google Shape;213;p14:notes"/>
+          <p:cNvPr id="214" name="Google Shape;214;p14:notes"/>
           <p:cNvSpPr txBox="1"/>
           <p:nvPr>
             <p:ph idx="1" type="body"/>
@@ -2317,7 +2320,7 @@
       </p:sp>
       <p:sp>
         <p:nvSpPr>
-          <p:cNvPr id="214" name="Google Shape;214;p14:notes"/>
+          <p:cNvPr id="215" name="Google Shape;215;p14:notes"/>
           <p:cNvSpPr/>
           <p:nvPr>
             <p:ph idx="2" type="sldImg"/>
@@ -2363,7 +2366,7 @@
   <p:cSld>
     <p:spTree>
       <p:nvGrpSpPr>
-        <p:cNvPr id="220" name="Shape 220"/>
+        <p:cNvPr id="221" name="Shape 221"/>
         <p:cNvGrpSpPr/>
         <p:nvPr/>
       </p:nvGrpSpPr>
@@ -2377,7 +2380,7 @@
       </p:grpSpPr>
       <p:sp>
         <p:nvSpPr>
-          <p:cNvPr id="221" name="Google Shape;221;g3ad6459f57e_0_0:notes"/>
+          <p:cNvPr id="222" name="Google Shape;222;g3ad6459f57e_0_0:notes"/>
           <p:cNvSpPr/>
           <p:nvPr>
             <p:ph idx="2" type="sldImg"/>
@@ -2412,7 +2415,7 @@
       </p:sp>
       <p:sp>
         <p:nvSpPr>
-          <p:cNvPr id="222" name="Google Shape;222;g3ad6459f57e_0_0:notes"/>
+          <p:cNvPr id="223" name="Google Shape;223;g3ad6459f57e_0_0:notes"/>
           <p:cNvSpPr txBox="1"/>
           <p:nvPr>
             <p:ph idx="1" type="body"/>
@@ -2451,7 +2454,7 @@
       </p:sp>
       <p:sp>
         <p:nvSpPr>
-          <p:cNvPr id="223" name="Google Shape;223;g3ad6459f57e_0_0:notes"/>
+          <p:cNvPr id="224" name="Google Shape;224;g3ad6459f57e_0_0:notes"/>
           <p:cNvSpPr txBox="1"/>
           <p:nvPr>
             <p:ph idx="12" type="sldNum"/>
@@ -2506,7 +2509,7 @@
   <p:cSld>
     <p:spTree>
       <p:nvGrpSpPr>
-        <p:cNvPr id="230" name="Shape 230"/>
+        <p:cNvPr id="231" name="Shape 231"/>
         <p:cNvGrpSpPr/>
         <p:nvPr/>
       </p:nvGrpSpPr>
@@ -2520,7 +2523,7 @@
       </p:grpSpPr>
       <p:sp>
         <p:nvSpPr>
-          <p:cNvPr id="231" name="Google Shape;231;g3a9b731e4a8_0_31:notes"/>
+          <p:cNvPr id="232" name="Google Shape;232;g3a9b731e4a8_0_31:notes"/>
           <p:cNvSpPr/>
           <p:nvPr>
             <p:ph idx="2" type="sldImg"/>
@@ -2555,7 +2558,7 @@
       </p:sp>
       <p:sp>
         <p:nvSpPr>
-          <p:cNvPr id="232" name="Google Shape;232;g3a9b731e4a8_0_31:notes"/>
+          <p:cNvPr id="233" name="Google Shape;233;g3a9b731e4a8_0_31:notes"/>
           <p:cNvSpPr txBox="1"/>
           <p:nvPr>
             <p:ph idx="1" type="body"/>
@@ -2594,7 +2597,7 @@
       </p:sp>
       <p:sp>
         <p:nvSpPr>
-          <p:cNvPr id="233" name="Google Shape;233;g3a9b731e4a8_0_31:notes"/>
+          <p:cNvPr id="234" name="Google Shape;234;g3a9b731e4a8_0_31:notes"/>
           <p:cNvSpPr txBox="1"/>
           <p:nvPr>
             <p:ph idx="12" type="sldNum"/>
@@ -2649,7 +2652,7 @@
   <p:cSld>
     <p:spTree>
       <p:nvGrpSpPr>
-        <p:cNvPr id="239" name="Shape 239"/>
+        <p:cNvPr id="240" name="Shape 240"/>
         <p:cNvGrpSpPr/>
         <p:nvPr/>
       </p:nvGrpSpPr>
@@ -2663,7 +2666,7 @@
       </p:grpSpPr>
       <p:sp>
         <p:nvSpPr>
-          <p:cNvPr id="240" name="Google Shape;240;g3a9b731e4a8_0_40:notes"/>
+          <p:cNvPr id="241" name="Google Shape;241;g3a9b731e4a8_0_40:notes"/>
           <p:cNvSpPr/>
           <p:nvPr>
             <p:ph idx="2" type="sldImg"/>
@@ -2698,7 +2701,7 @@
       </p:sp>
       <p:sp>
         <p:nvSpPr>
-          <p:cNvPr id="241" name="Google Shape;241;g3a9b731e4a8_0_40:notes"/>
+          <p:cNvPr id="242" name="Google Shape;242;g3a9b731e4a8_0_40:notes"/>
           <p:cNvSpPr txBox="1"/>
           <p:nvPr>
             <p:ph idx="1" type="body"/>
@@ -2737,7 +2740,7 @@
       </p:sp>
       <p:sp>
         <p:nvSpPr>
-          <p:cNvPr id="242" name="Google Shape;242;g3a9b731e4a8_0_40:notes"/>
+          <p:cNvPr id="243" name="Google Shape;243;g3a9b731e4a8_0_40:notes"/>
           <p:cNvSpPr txBox="1"/>
           <p:nvPr>
             <p:ph idx="12" type="sldNum"/>
@@ -2792,7 +2795,7 @@
   <p:cSld>
     <p:spTree>
       <p:nvGrpSpPr>
-        <p:cNvPr id="93" name="Shape 93"/>
+        <p:cNvPr id="94" name="Shape 94"/>
         <p:cNvGrpSpPr/>
         <p:nvPr/>
       </p:nvGrpSpPr>
@@ -2806,7 +2809,7 @@
       </p:grpSpPr>
       <p:sp>
         <p:nvSpPr>
-          <p:cNvPr id="94" name="Google Shape;94;p1:notes"/>
+          <p:cNvPr id="95" name="Google Shape;95;p1:notes"/>
           <p:cNvSpPr txBox="1"/>
           <p:nvPr>
             <p:ph idx="1" type="body"/>
@@ -2845,7 +2848,7 @@
       </p:sp>
       <p:sp>
         <p:nvSpPr>
-          <p:cNvPr id="95" name="Google Shape;95;p1:notes"/>
+          <p:cNvPr id="96" name="Google Shape;96;p1:notes"/>
           <p:cNvSpPr/>
           <p:nvPr>
             <p:ph idx="2" type="sldImg"/>
@@ -2891,7 +2894,7 @@
   <p:cSld>
     <p:spTree>
       <p:nvGrpSpPr>
-        <p:cNvPr id="248" name="Shape 248"/>
+        <p:cNvPr id="249" name="Shape 249"/>
         <p:cNvGrpSpPr/>
         <p:nvPr/>
       </p:nvGrpSpPr>
@@ -2905,7 +2908,7 @@
       </p:grpSpPr>
       <p:sp>
         <p:nvSpPr>
-          <p:cNvPr id="249" name="Google Shape;249;g38660da28e9_0_0:notes"/>
+          <p:cNvPr id="250" name="Google Shape;250;g38660da28e9_0_0:notes"/>
           <p:cNvSpPr/>
           <p:nvPr>
             <p:ph idx="2" type="sldImg"/>
@@ -2940,7 +2943,7 @@
       </p:sp>
       <p:sp>
         <p:nvSpPr>
-          <p:cNvPr id="250" name="Google Shape;250;g38660da28e9_0_0:notes"/>
+          <p:cNvPr id="251" name="Google Shape;251;g38660da28e9_0_0:notes"/>
           <p:cNvSpPr txBox="1"/>
           <p:nvPr>
             <p:ph idx="1" type="body"/>
@@ -2979,7 +2982,7 @@
       </p:sp>
       <p:sp>
         <p:nvSpPr>
-          <p:cNvPr id="251" name="Google Shape;251;g38660da28e9_0_0:notes"/>
+          <p:cNvPr id="252" name="Google Shape;252;g38660da28e9_0_0:notes"/>
           <p:cNvSpPr txBox="1"/>
           <p:nvPr>
             <p:ph idx="12" type="sldNum"/>
@@ -3034,7 +3037,7 @@
   <p:cSld>
     <p:spTree>
       <p:nvGrpSpPr>
-        <p:cNvPr id="257" name="Shape 257"/>
+        <p:cNvPr id="258" name="Shape 258"/>
         <p:cNvGrpSpPr/>
         <p:nvPr/>
       </p:nvGrpSpPr>
@@ -3048,7 +3051,7 @@
       </p:grpSpPr>
       <p:sp>
         <p:nvSpPr>
-          <p:cNvPr id="258" name="Google Shape;258;g39a291deda2_1_0:notes"/>
+          <p:cNvPr id="259" name="Google Shape;259;g39a291deda2_1_0:notes"/>
           <p:cNvSpPr/>
           <p:nvPr>
             <p:ph idx="2" type="sldImg"/>
@@ -3083,7 +3086,7 @@
       </p:sp>
       <p:sp>
         <p:nvSpPr>
-          <p:cNvPr id="259" name="Google Shape;259;g39a291deda2_1_0:notes"/>
+          <p:cNvPr id="260" name="Google Shape;260;g39a291deda2_1_0:notes"/>
           <p:cNvSpPr txBox="1"/>
           <p:nvPr>
             <p:ph idx="1" type="body"/>
@@ -3122,7 +3125,7 @@
       </p:sp>
       <p:sp>
         <p:nvSpPr>
-          <p:cNvPr id="260" name="Google Shape;260;g39a291deda2_1_0:notes"/>
+          <p:cNvPr id="261" name="Google Shape;261;g39a291deda2_1_0:notes"/>
           <p:cNvSpPr txBox="1"/>
           <p:nvPr>
             <p:ph idx="12" type="sldNum"/>
@@ -3177,7 +3180,7 @@
   <p:cSld>
     <p:spTree>
       <p:nvGrpSpPr>
-        <p:cNvPr id="266" name="Shape 266"/>
+        <p:cNvPr id="267" name="Shape 267"/>
         <p:cNvGrpSpPr/>
         <p:nvPr/>
       </p:nvGrpSpPr>
@@ -3191,7 +3194,7 @@
       </p:grpSpPr>
       <p:sp>
         <p:nvSpPr>
-          <p:cNvPr id="267" name="Google Shape;267;g39a291deda2_1_14:notes"/>
+          <p:cNvPr id="268" name="Google Shape;268;g39a291deda2_1_14:notes"/>
           <p:cNvSpPr/>
           <p:nvPr>
             <p:ph idx="2" type="sldImg"/>
@@ -3226,7 +3229,7 @@
       </p:sp>
       <p:sp>
         <p:nvSpPr>
-          <p:cNvPr id="268" name="Google Shape;268;g39a291deda2_1_14:notes"/>
+          <p:cNvPr id="269" name="Google Shape;269;g39a291deda2_1_14:notes"/>
           <p:cNvSpPr txBox="1"/>
           <p:nvPr>
             <p:ph idx="1" type="body"/>
@@ -3265,7 +3268,7 @@
       </p:sp>
       <p:sp>
         <p:nvSpPr>
-          <p:cNvPr id="269" name="Google Shape;269;g39a291deda2_1_14:notes"/>
+          <p:cNvPr id="270" name="Google Shape;270;g39a291deda2_1_14:notes"/>
           <p:cNvSpPr txBox="1"/>
           <p:nvPr>
             <p:ph idx="12" type="sldNum"/>
@@ -3320,7 +3323,7 @@
   <p:cSld>
     <p:spTree>
       <p:nvGrpSpPr>
-        <p:cNvPr id="275" name="Shape 275"/>
+        <p:cNvPr id="276" name="Shape 276"/>
         <p:cNvGrpSpPr/>
         <p:nvPr/>
       </p:nvGrpSpPr>
@@ -3334,7 +3337,7 @@
       </p:grpSpPr>
       <p:sp>
         <p:nvSpPr>
-          <p:cNvPr id="276" name="Google Shape;276;g39a291deda2_1_23:notes"/>
+          <p:cNvPr id="277" name="Google Shape;277;g39a291deda2_1_23:notes"/>
           <p:cNvSpPr/>
           <p:nvPr>
             <p:ph idx="2" type="sldImg"/>
@@ -3369,7 +3372,7 @@
       </p:sp>
       <p:sp>
         <p:nvSpPr>
-          <p:cNvPr id="277" name="Google Shape;277;g39a291deda2_1_23:notes"/>
+          <p:cNvPr id="278" name="Google Shape;278;g39a291deda2_1_23:notes"/>
           <p:cNvSpPr txBox="1"/>
           <p:nvPr>
             <p:ph idx="1" type="body"/>
@@ -3408,7 +3411,7 @@
       </p:sp>
       <p:sp>
         <p:nvSpPr>
-          <p:cNvPr id="278" name="Google Shape;278;g39a291deda2_1_23:notes"/>
+          <p:cNvPr id="279" name="Google Shape;279;g39a291deda2_1_23:notes"/>
           <p:cNvSpPr txBox="1"/>
           <p:nvPr>
             <p:ph idx="12" type="sldNum"/>
@@ -3463,7 +3466,7 @@
   <p:cSld>
     <p:spTree>
       <p:nvGrpSpPr>
-        <p:cNvPr id="286" name="Shape 286"/>
+        <p:cNvPr id="287" name="Shape 287"/>
         <p:cNvGrpSpPr/>
         <p:nvPr/>
       </p:nvGrpSpPr>
@@ -3477,7 +3480,7 @@
       </p:grpSpPr>
       <p:sp>
         <p:nvSpPr>
-          <p:cNvPr id="287" name="Google Shape;287;g39a291deda2_1_39:notes"/>
+          <p:cNvPr id="288" name="Google Shape;288;g39a291deda2_1_39:notes"/>
           <p:cNvSpPr/>
           <p:nvPr>
             <p:ph idx="2" type="sldImg"/>
@@ -3512,7 +3515,7 @@
       </p:sp>
       <p:sp>
         <p:nvSpPr>
-          <p:cNvPr id="288" name="Google Shape;288;g39a291deda2_1_39:notes"/>
+          <p:cNvPr id="289" name="Google Shape;289;g39a291deda2_1_39:notes"/>
           <p:cNvSpPr txBox="1"/>
           <p:nvPr>
             <p:ph idx="1" type="body"/>
@@ -3551,7 +3554,7 @@
       </p:sp>
       <p:sp>
         <p:nvSpPr>
-          <p:cNvPr id="289" name="Google Shape;289;g39a291deda2_1_39:notes"/>
+          <p:cNvPr id="290" name="Google Shape;290;g39a291deda2_1_39:notes"/>
           <p:cNvSpPr txBox="1"/>
           <p:nvPr>
             <p:ph idx="12" type="sldNum"/>
@@ -3606,7 +3609,7 @@
   <p:cSld>
     <p:spTree>
       <p:nvGrpSpPr>
-        <p:cNvPr id="296" name="Shape 296"/>
+        <p:cNvPr id="297" name="Shape 297"/>
         <p:cNvGrpSpPr/>
         <p:nvPr/>
       </p:nvGrpSpPr>
@@ -3620,7 +3623,7 @@
       </p:grpSpPr>
       <p:sp>
         <p:nvSpPr>
-          <p:cNvPr id="297" name="Google Shape;297;g39a291deda2_1_50:notes"/>
+          <p:cNvPr id="298" name="Google Shape;298;g39a291deda2_1_50:notes"/>
           <p:cNvSpPr/>
           <p:nvPr>
             <p:ph idx="2" type="sldImg"/>
@@ -3655,7 +3658,7 @@
       </p:sp>
       <p:sp>
         <p:nvSpPr>
-          <p:cNvPr id="298" name="Google Shape;298;g39a291deda2_1_50:notes"/>
+          <p:cNvPr id="299" name="Google Shape;299;g39a291deda2_1_50:notes"/>
           <p:cNvSpPr txBox="1"/>
           <p:nvPr>
             <p:ph idx="1" type="body"/>
@@ -3694,7 +3697,7 @@
       </p:sp>
       <p:sp>
         <p:nvSpPr>
-          <p:cNvPr id="299" name="Google Shape;299;g39a291deda2_1_50:notes"/>
+          <p:cNvPr id="300" name="Google Shape;300;g39a291deda2_1_50:notes"/>
           <p:cNvSpPr txBox="1"/>
           <p:nvPr>
             <p:ph idx="12" type="sldNum"/>
@@ -3749,7 +3752,7 @@
   <p:cSld>
     <p:spTree>
       <p:nvGrpSpPr>
-        <p:cNvPr id="305" name="Shape 305"/>
+        <p:cNvPr id="306" name="Shape 306"/>
         <p:cNvGrpSpPr/>
         <p:nvPr/>
       </p:nvGrpSpPr>
@@ -3763,7 +3766,7 @@
       </p:grpSpPr>
       <p:sp>
         <p:nvSpPr>
-          <p:cNvPr id="306" name="Google Shape;306;g3aa6201ac61_0_0:notes"/>
+          <p:cNvPr id="307" name="Google Shape;307;g3aa6201ac61_0_0:notes"/>
           <p:cNvSpPr/>
           <p:nvPr>
             <p:ph idx="2" type="sldImg"/>
@@ -3798,7 +3801,7 @@
       </p:sp>
       <p:sp>
         <p:nvSpPr>
-          <p:cNvPr id="307" name="Google Shape;307;g3aa6201ac61_0_0:notes"/>
+          <p:cNvPr id="308" name="Google Shape;308;g3aa6201ac61_0_0:notes"/>
           <p:cNvSpPr txBox="1"/>
           <p:nvPr>
             <p:ph idx="1" type="body"/>
@@ -3837,7 +3840,7 @@
       </p:sp>
       <p:sp>
         <p:nvSpPr>
-          <p:cNvPr id="308" name="Google Shape;308;g3aa6201ac61_0_0:notes"/>
+          <p:cNvPr id="309" name="Google Shape;309;g3aa6201ac61_0_0:notes"/>
           <p:cNvSpPr txBox="1"/>
           <p:nvPr>
             <p:ph idx="12" type="sldNum"/>
@@ -3892,7 +3895,7 @@
   <p:cSld>
     <p:spTree>
       <p:nvGrpSpPr>
-        <p:cNvPr id="314" name="Shape 314"/>
+        <p:cNvPr id="315" name="Shape 315"/>
         <p:cNvGrpSpPr/>
         <p:nvPr/>
       </p:nvGrpSpPr>
@@ -3906,7 +3909,7 @@
       </p:grpSpPr>
       <p:sp>
         <p:nvSpPr>
-          <p:cNvPr id="315" name="Google Shape;315;g3aa6201ac61_0_6:notes"/>
+          <p:cNvPr id="316" name="Google Shape;316;g3aa6201ac61_0_6:notes"/>
           <p:cNvSpPr/>
           <p:nvPr>
             <p:ph idx="2" type="sldImg"/>
@@ -3941,7 +3944,7 @@
       </p:sp>
       <p:sp>
         <p:nvSpPr>
-          <p:cNvPr id="316" name="Google Shape;316;g3aa6201ac61_0_6:notes"/>
+          <p:cNvPr id="317" name="Google Shape;317;g3aa6201ac61_0_6:notes"/>
           <p:cNvSpPr txBox="1"/>
           <p:nvPr>
             <p:ph idx="1" type="body"/>
@@ -3980,7 +3983,7 @@
       </p:sp>
       <p:sp>
         <p:nvSpPr>
-          <p:cNvPr id="317" name="Google Shape;317;g3aa6201ac61_0_6:notes"/>
+          <p:cNvPr id="318" name="Google Shape;318;g3aa6201ac61_0_6:notes"/>
           <p:cNvSpPr txBox="1"/>
           <p:nvPr>
             <p:ph idx="12" type="sldNum"/>
@@ -4035,7 +4038,7 @@
   <p:cSld>
     <p:spTree>
       <p:nvGrpSpPr>
-        <p:cNvPr id="322" name="Shape 322"/>
+        <p:cNvPr id="323" name="Shape 323"/>
         <p:cNvGrpSpPr/>
         <p:nvPr/>
       </p:nvGrpSpPr>
@@ -4049,7 +4052,7 @@
       </p:grpSpPr>
       <p:sp>
         <p:nvSpPr>
-          <p:cNvPr id="323" name="Google Shape;323;g3ac9e9082d3_0_11:notes"/>
+          <p:cNvPr id="324" name="Google Shape;324;g3ac9e9082d3_0_11:notes"/>
           <p:cNvSpPr/>
           <p:nvPr>
             <p:ph idx="2" type="sldImg"/>
@@ -4084,7 +4087,7 @@
       </p:sp>
       <p:sp>
         <p:nvSpPr>
-          <p:cNvPr id="324" name="Google Shape;324;g3ac9e9082d3_0_11:notes"/>
+          <p:cNvPr id="325" name="Google Shape;325;g3ac9e9082d3_0_11:notes"/>
           <p:cNvSpPr txBox="1"/>
           <p:nvPr>
             <p:ph idx="1" type="body"/>
@@ -4123,7 +4126,7 @@
       </p:sp>
       <p:sp>
         <p:nvSpPr>
-          <p:cNvPr id="325" name="Google Shape;325;g3ac9e9082d3_0_11:notes"/>
+          <p:cNvPr id="326" name="Google Shape;326;g3ac9e9082d3_0_11:notes"/>
           <p:cNvSpPr txBox="1"/>
           <p:nvPr>
             <p:ph idx="12" type="sldNum"/>
@@ -4178,7 +4181,7 @@
   <p:cSld>
     <p:spTree>
       <p:nvGrpSpPr>
-        <p:cNvPr id="331" name="Shape 331"/>
+        <p:cNvPr id="332" name="Shape 332"/>
         <p:cNvGrpSpPr/>
         <p:nvPr/>
       </p:nvGrpSpPr>
@@ -4192,7 +4195,7 @@
       </p:grpSpPr>
       <p:sp>
         <p:nvSpPr>
-          <p:cNvPr id="332" name="Google Shape;332;g3ac9e796f79_0_0:notes"/>
+          <p:cNvPr id="333" name="Google Shape;333;g3ac9e796f79_0_0:notes"/>
           <p:cNvSpPr/>
           <p:nvPr>
             <p:ph idx="2" type="sldImg"/>
@@ -4227,7 +4230,7 @@
       </p:sp>
       <p:sp>
         <p:nvSpPr>
-          <p:cNvPr id="333" name="Google Shape;333;g3ac9e796f79_0_0:notes"/>
+          <p:cNvPr id="334" name="Google Shape;334;g3ac9e796f79_0_0:notes"/>
           <p:cNvSpPr txBox="1"/>
           <p:nvPr>
             <p:ph idx="1" type="body"/>
@@ -4266,7 +4269,7 @@
       </p:sp>
       <p:sp>
         <p:nvSpPr>
-          <p:cNvPr id="334" name="Google Shape;334;g3ac9e796f79_0_0:notes"/>
+          <p:cNvPr id="335" name="Google Shape;335;g3ac9e796f79_0_0:notes"/>
           <p:cNvSpPr txBox="1"/>
           <p:nvPr>
             <p:ph idx="12" type="sldNum"/>
@@ -4321,7 +4324,7 @@
   <p:cSld>
     <p:spTree>
       <p:nvGrpSpPr>
-        <p:cNvPr id="101" name="Shape 101"/>
+        <p:cNvPr id="102" name="Shape 102"/>
         <p:cNvGrpSpPr/>
         <p:nvPr/>
       </p:nvGrpSpPr>
@@ -4335,7 +4338,7 @@
       </p:grpSpPr>
       <p:sp>
         <p:nvSpPr>
-          <p:cNvPr id="102" name="Google Shape;102;p2:notes"/>
+          <p:cNvPr id="103" name="Google Shape;103;p2:notes"/>
           <p:cNvSpPr txBox="1"/>
           <p:nvPr>
             <p:ph idx="1" type="body"/>
@@ -4374,7 +4377,7 @@
       </p:sp>
       <p:sp>
         <p:nvSpPr>
-          <p:cNvPr id="103" name="Google Shape;103;p2:notes"/>
+          <p:cNvPr id="104" name="Google Shape;104;p2:notes"/>
           <p:cNvSpPr/>
           <p:nvPr>
             <p:ph idx="2" type="sldImg"/>
@@ -4420,7 +4423,7 @@
   <p:cSld>
     <p:spTree>
       <p:nvGrpSpPr>
-        <p:cNvPr id="338" name="Shape 338"/>
+        <p:cNvPr id="339" name="Shape 339"/>
         <p:cNvGrpSpPr/>
         <p:nvPr/>
       </p:nvGrpSpPr>
@@ -4434,7 +4437,7 @@
       </p:grpSpPr>
       <p:sp>
         <p:nvSpPr>
-          <p:cNvPr id="339" name="Google Shape;339;g3aa6201ac61_0_12:notes"/>
+          <p:cNvPr id="340" name="Google Shape;340;g3ad6459f57e_1_3:notes"/>
           <p:cNvSpPr/>
           <p:nvPr>
             <p:ph idx="2" type="sldImg"/>
@@ -4469,7 +4472,7 @@
       </p:sp>
       <p:sp>
         <p:nvSpPr>
-          <p:cNvPr id="340" name="Google Shape;340;g3aa6201ac61_0_12:notes"/>
+          <p:cNvPr id="341" name="Google Shape;341;g3ad6459f57e_1_3:notes"/>
           <p:cNvSpPr txBox="1"/>
           <p:nvPr>
             <p:ph idx="1" type="body"/>
@@ -4508,7 +4511,7 @@
       </p:sp>
       <p:sp>
         <p:nvSpPr>
-          <p:cNvPr id="341" name="Google Shape;341;g3aa6201ac61_0_12:notes"/>
+          <p:cNvPr id="342" name="Google Shape;342;g3ad6459f57e_1_3:notes"/>
           <p:cNvSpPr txBox="1"/>
           <p:nvPr>
             <p:ph idx="12" type="sldNum"/>
@@ -4577,7 +4580,7 @@
       </p:grpSpPr>
       <p:sp>
         <p:nvSpPr>
-          <p:cNvPr id="347" name="Google Shape;347;g3ac9e796f79_0_6:notes"/>
+          <p:cNvPr id="347" name="Google Shape;347;g3aa6201ac61_0_12:notes"/>
           <p:cNvSpPr/>
           <p:nvPr>
             <p:ph idx="2" type="sldImg"/>
@@ -4612,7 +4615,7 @@
       </p:sp>
       <p:sp>
         <p:nvSpPr>
-          <p:cNvPr id="348" name="Google Shape;348;g3ac9e796f79_0_6:notes"/>
+          <p:cNvPr id="348" name="Google Shape;348;g3aa6201ac61_0_12:notes"/>
           <p:cNvSpPr txBox="1"/>
           <p:nvPr>
             <p:ph idx="1" type="body"/>
@@ -4651,7 +4654,7 @@
       </p:sp>
       <p:sp>
         <p:nvSpPr>
-          <p:cNvPr id="349" name="Google Shape;349;g3ac9e796f79_0_6:notes"/>
+          <p:cNvPr id="349" name="Google Shape;349;g3aa6201ac61_0_12:notes"/>
           <p:cNvSpPr txBox="1"/>
           <p:nvPr>
             <p:ph idx="12" type="sldNum"/>
@@ -4706,7 +4709,7 @@
   <p:cSld>
     <p:spTree>
       <p:nvGrpSpPr>
-        <p:cNvPr id="355" name="Shape 355"/>
+        <p:cNvPr id="354" name="Shape 354"/>
         <p:cNvGrpSpPr/>
         <p:nvPr/>
       </p:nvGrpSpPr>
@@ -4720,7 +4723,7 @@
       </p:grpSpPr>
       <p:sp>
         <p:nvSpPr>
-          <p:cNvPr id="356" name="Google Shape;356;g3aa6201ac61_0_19:notes"/>
+          <p:cNvPr id="355" name="Google Shape;355;g3ac9e796f79_0_6:notes"/>
           <p:cNvSpPr/>
           <p:nvPr>
             <p:ph idx="2" type="sldImg"/>
@@ -4755,7 +4758,7 @@
       </p:sp>
       <p:sp>
         <p:nvSpPr>
-          <p:cNvPr id="357" name="Google Shape;357;g3aa6201ac61_0_19:notes"/>
+          <p:cNvPr id="356" name="Google Shape;356;g3ac9e796f79_0_6:notes"/>
           <p:cNvSpPr txBox="1"/>
           <p:nvPr>
             <p:ph idx="1" type="body"/>
@@ -4794,7 +4797,7 @@
       </p:sp>
       <p:sp>
         <p:nvSpPr>
-          <p:cNvPr id="358" name="Google Shape;358;g3aa6201ac61_0_19:notes"/>
+          <p:cNvPr id="357" name="Google Shape;357;g3ac9e796f79_0_6:notes"/>
           <p:cNvSpPr txBox="1"/>
           <p:nvPr>
             <p:ph idx="12" type="sldNum"/>
@@ -4863,7 +4866,7 @@
       </p:grpSpPr>
       <p:sp>
         <p:nvSpPr>
-          <p:cNvPr id="364" name="Google Shape;364;g3aa6201ac61_0_26:notes"/>
+          <p:cNvPr id="364" name="Google Shape;364;g3ad6459f57e_1_9:notes"/>
           <p:cNvSpPr/>
           <p:nvPr>
             <p:ph idx="2" type="sldImg"/>
@@ -4898,7 +4901,7 @@
       </p:sp>
       <p:sp>
         <p:nvSpPr>
-          <p:cNvPr id="365" name="Google Shape;365;g3aa6201ac61_0_26:notes"/>
+          <p:cNvPr id="365" name="Google Shape;365;g3ad6459f57e_1_9:notes"/>
           <p:cNvSpPr txBox="1"/>
           <p:nvPr>
             <p:ph idx="1" type="body"/>
@@ -4937,7 +4940,7 @@
       </p:sp>
       <p:sp>
         <p:nvSpPr>
-          <p:cNvPr id="366" name="Google Shape;366;g3aa6201ac61_0_26:notes"/>
+          <p:cNvPr id="366" name="Google Shape;366;g3ad6459f57e_1_9:notes"/>
           <p:cNvSpPr txBox="1"/>
           <p:nvPr>
             <p:ph idx="12" type="sldNum"/>
@@ -4992,7 +4995,7 @@
   <p:cSld>
     <p:spTree>
       <p:nvGrpSpPr>
-        <p:cNvPr id="372" name="Shape 372"/>
+        <p:cNvPr id="370" name="Shape 370"/>
         <p:cNvGrpSpPr/>
         <p:nvPr/>
       </p:nvGrpSpPr>
@@ -5006,46 +5009,7 @@
       </p:grpSpPr>
       <p:sp>
         <p:nvSpPr>
-          <p:cNvPr id="373" name="Google Shape;373;p15:notes"/>
-          <p:cNvSpPr txBox="1"/>
-          <p:nvPr>
-            <p:ph idx="1" type="body"/>
-          </p:nvPr>
-        </p:nvSpPr>
-        <p:spPr>
-          <a:xfrm>
-            <a:off x="685800" y="4400550"/>
-            <a:ext cx="5486400" cy="3600450"/>
-          </a:xfrm>
-          <a:prstGeom prst="rect">
-            <a:avLst/>
-          </a:prstGeom>
-        </p:spPr>
-        <p:txBody>
-          <a:bodyPr anchorCtr="0" anchor="t" bIns="45700" lIns="91425" spcFirstLastPara="1" rIns="91425" wrap="square" tIns="45700">
-            <a:noAutofit/>
-          </a:bodyPr>
-          <a:lstStyle/>
-          <a:p>
-            <a:pPr indent="0" lvl="0" marL="0" rtl="0" algn="l">
-              <a:spcBef>
-                <a:spcPts val="0"/>
-              </a:spcBef>
-              <a:spcAft>
-                <a:spcPts val="0"/>
-              </a:spcAft>
-              <a:buNone/>
-            </a:pPr>
-            <a:r>
-              <a:t/>
-            </a:r>
-            <a:endParaRPr/>
-          </a:p>
-        </p:txBody>
-      </p:sp>
-      <p:sp>
-        <p:nvSpPr>
-          <p:cNvPr id="374" name="Google Shape;374;p15:notes"/>
+          <p:cNvPr id="371" name="Google Shape;371;g3ad6459f57e_1_15:notes"/>
           <p:cNvSpPr/>
           <p:nvPr>
             <p:ph idx="2" type="sldImg"/>
@@ -5078,6 +5042,89 @@
           </a:custGeom>
         </p:spPr>
       </p:sp>
+      <p:sp>
+        <p:nvSpPr>
+          <p:cNvPr id="372" name="Google Shape;372;g3ad6459f57e_1_15:notes"/>
+          <p:cNvSpPr txBox="1"/>
+          <p:nvPr>
+            <p:ph idx="1" type="body"/>
+          </p:nvPr>
+        </p:nvSpPr>
+        <p:spPr>
+          <a:xfrm>
+            <a:off x="685800" y="4400550"/>
+            <a:ext cx="5486400" cy="3600600"/>
+          </a:xfrm>
+          <a:prstGeom prst="rect">
+            <a:avLst/>
+          </a:prstGeom>
+        </p:spPr>
+        <p:txBody>
+          <a:bodyPr anchorCtr="0" anchor="t" bIns="45700" lIns="91425" spcFirstLastPara="1" rIns="91425" wrap="square" tIns="45700">
+            <a:noAutofit/>
+          </a:bodyPr>
+          <a:lstStyle/>
+          <a:p>
+            <a:pPr indent="0" lvl="0" marL="0" rtl="0" algn="l">
+              <a:spcBef>
+                <a:spcPts val="0"/>
+              </a:spcBef>
+              <a:spcAft>
+                <a:spcPts val="0"/>
+              </a:spcAft>
+              <a:buNone/>
+            </a:pPr>
+            <a:r>
+              <a:t/>
+            </a:r>
+            <a:endParaRPr/>
+          </a:p>
+        </p:txBody>
+      </p:sp>
+      <p:sp>
+        <p:nvSpPr>
+          <p:cNvPr id="373" name="Google Shape;373;g3ad6459f57e_1_15:notes"/>
+          <p:cNvSpPr txBox="1"/>
+          <p:nvPr>
+            <p:ph idx="12" type="sldNum"/>
+          </p:nvPr>
+        </p:nvSpPr>
+        <p:spPr>
+          <a:xfrm>
+            <a:off x="3884613" y="8685213"/>
+            <a:ext cx="2971800" cy="458700"/>
+          </a:xfrm>
+          <a:prstGeom prst="rect">
+            <a:avLst/>
+          </a:prstGeom>
+        </p:spPr>
+        <p:txBody>
+          <a:bodyPr anchorCtr="0" anchor="b" bIns="45700" lIns="91425" spcFirstLastPara="1" rIns="91425" wrap="square" tIns="45700">
+            <a:noAutofit/>
+          </a:bodyPr>
+          <a:lstStyle/>
+          <a:p>
+            <a:pPr indent="0" lvl="0" marL="0" rtl="0" algn="r">
+              <a:spcBef>
+                <a:spcPts val="0"/>
+              </a:spcBef>
+              <a:spcAft>
+                <a:spcPts val="0"/>
+              </a:spcAft>
+              <a:buClr>
+                <a:srgbClr val="000000"/>
+              </a:buClr>
+              <a:buFont typeface="Arial"/>
+              <a:buNone/>
+            </a:pPr>
+            <a:fld id="{00000000-1234-1234-1234-123412341234}" type="slidenum">
+              <a:rPr lang="it-IT"/>
+              <a:t>‹#›</a:t>
+            </a:fld>
+            <a:endParaRPr/>
+          </a:p>
+        </p:txBody>
+      </p:sp>
     </p:spTree>
   </p:cSld>
   <p:clrMapOvr>
@@ -5086,12 +5133,12 @@
 </p:notes>
 </file>
 
-<file path=ppt/notesSlides/notesSlide4.xml><?xml version="1.0" encoding="utf-8"?>
+<file path=ppt/notesSlides/notesSlide35.xml><?xml version="1.0" encoding="utf-8"?>
 <p:notes xmlns:a="http://schemas.openxmlformats.org/drawingml/2006/main" xmlns:r="http://schemas.openxmlformats.org/officeDocument/2006/relationships" xmlns:mc="http://schemas.openxmlformats.org/markup-compatibility/2006" xmlns:mv="urn:schemas-microsoft-com:mac:vml" xmlns:p="http://schemas.openxmlformats.org/presentationml/2006/main" xmlns:c="http://schemas.openxmlformats.org/drawingml/2006/chart" xmlns:dgm="http://schemas.openxmlformats.org/drawingml/2006/diagram" xmlns:o="urn:schemas-microsoft-com:office:office" xmlns:v="urn:schemas-microsoft-com:vml" xmlns:pvml="urn:schemas-microsoft-com:office:powerpoint" xmlns:com="http://schemas.openxmlformats.org/drawingml/2006/compatibility" xmlns:p14="http://schemas.microsoft.com/office/powerpoint/2010/main" xmlns:p15="http://schemas.microsoft.com/office/powerpoint/2012/main" xmlns:ahyp="http://schemas.microsoft.com/office/drawing/2018/hyperlinkcolor" showMasterPhAnim="0" showMasterSp="0">
   <p:cSld>
     <p:spTree>
       <p:nvGrpSpPr>
-        <p:cNvPr id="110" name="Shape 110"/>
+        <p:cNvPr id="378" name="Shape 378"/>
         <p:cNvGrpSpPr/>
         <p:nvPr/>
       </p:nvGrpSpPr>
@@ -5105,46 +5152,7 @@
       </p:grpSpPr>
       <p:sp>
         <p:nvSpPr>
-          <p:cNvPr id="111" name="Google Shape;111;p3:notes"/>
-          <p:cNvSpPr txBox="1"/>
-          <p:nvPr>
-            <p:ph idx="1" type="body"/>
-          </p:nvPr>
-        </p:nvSpPr>
-        <p:spPr>
-          <a:xfrm>
-            <a:off x="685800" y="4400550"/>
-            <a:ext cx="5486400" cy="3600450"/>
-          </a:xfrm>
-          <a:prstGeom prst="rect">
-            <a:avLst/>
-          </a:prstGeom>
-        </p:spPr>
-        <p:txBody>
-          <a:bodyPr anchorCtr="0" anchor="t" bIns="45700" lIns="91425" spcFirstLastPara="1" rIns="91425" wrap="square" tIns="45700">
-            <a:noAutofit/>
-          </a:bodyPr>
-          <a:lstStyle/>
-          <a:p>
-            <a:pPr indent="0" lvl="0" marL="0" rtl="0" algn="l">
-              <a:spcBef>
-                <a:spcPts val="0"/>
-              </a:spcBef>
-              <a:spcAft>
-                <a:spcPts val="0"/>
-              </a:spcAft>
-              <a:buNone/>
-            </a:pPr>
-            <a:r>
-              <a:t/>
-            </a:r>
-            <a:endParaRPr/>
-          </a:p>
-        </p:txBody>
-      </p:sp>
-      <p:sp>
-        <p:nvSpPr>
-          <p:cNvPr id="112" name="Google Shape;112;p3:notes"/>
+          <p:cNvPr id="379" name="Google Shape;379;g3ad6459f57e_1_22:notes"/>
           <p:cNvSpPr/>
           <p:nvPr>
             <p:ph idx="2" type="sldImg"/>
@@ -5177,6 +5185,89 @@
           </a:custGeom>
         </p:spPr>
       </p:sp>
+      <p:sp>
+        <p:nvSpPr>
+          <p:cNvPr id="380" name="Google Shape;380;g3ad6459f57e_1_22:notes"/>
+          <p:cNvSpPr txBox="1"/>
+          <p:nvPr>
+            <p:ph idx="1" type="body"/>
+          </p:nvPr>
+        </p:nvSpPr>
+        <p:spPr>
+          <a:xfrm>
+            <a:off x="685800" y="4400550"/>
+            <a:ext cx="5486400" cy="3600600"/>
+          </a:xfrm>
+          <a:prstGeom prst="rect">
+            <a:avLst/>
+          </a:prstGeom>
+        </p:spPr>
+        <p:txBody>
+          <a:bodyPr anchorCtr="0" anchor="t" bIns="45700" lIns="91425" spcFirstLastPara="1" rIns="91425" wrap="square" tIns="45700">
+            <a:noAutofit/>
+          </a:bodyPr>
+          <a:lstStyle/>
+          <a:p>
+            <a:pPr indent="0" lvl="0" marL="0" rtl="0" algn="l">
+              <a:spcBef>
+                <a:spcPts val="0"/>
+              </a:spcBef>
+              <a:spcAft>
+                <a:spcPts val="0"/>
+              </a:spcAft>
+              <a:buNone/>
+            </a:pPr>
+            <a:r>
+              <a:t/>
+            </a:r>
+            <a:endParaRPr/>
+          </a:p>
+        </p:txBody>
+      </p:sp>
+      <p:sp>
+        <p:nvSpPr>
+          <p:cNvPr id="381" name="Google Shape;381;g3ad6459f57e_1_22:notes"/>
+          <p:cNvSpPr txBox="1"/>
+          <p:nvPr>
+            <p:ph idx="12" type="sldNum"/>
+          </p:nvPr>
+        </p:nvSpPr>
+        <p:spPr>
+          <a:xfrm>
+            <a:off x="3884613" y="8685213"/>
+            <a:ext cx="2971800" cy="458700"/>
+          </a:xfrm>
+          <a:prstGeom prst="rect">
+            <a:avLst/>
+          </a:prstGeom>
+        </p:spPr>
+        <p:txBody>
+          <a:bodyPr anchorCtr="0" anchor="b" bIns="45700" lIns="91425" spcFirstLastPara="1" rIns="91425" wrap="square" tIns="45700">
+            <a:noAutofit/>
+          </a:bodyPr>
+          <a:lstStyle/>
+          <a:p>
+            <a:pPr indent="0" lvl="0" marL="0" rtl="0" algn="r">
+              <a:spcBef>
+                <a:spcPts val="0"/>
+              </a:spcBef>
+              <a:spcAft>
+                <a:spcPts val="0"/>
+              </a:spcAft>
+              <a:buClr>
+                <a:srgbClr val="000000"/>
+              </a:buClr>
+              <a:buFont typeface="Arial"/>
+              <a:buNone/>
+            </a:pPr>
+            <a:fld id="{00000000-1234-1234-1234-123412341234}" type="slidenum">
+              <a:rPr lang="it-IT"/>
+              <a:t>‹#›</a:t>
+            </a:fld>
+            <a:endParaRPr/>
+          </a:p>
+        </p:txBody>
+      </p:sp>
     </p:spTree>
   </p:cSld>
   <p:clrMapOvr>
@@ -5185,12 +5276,12 @@
 </p:notes>
 </file>
 
-<file path=ppt/notesSlides/notesSlide5.xml><?xml version="1.0" encoding="utf-8"?>
+<file path=ppt/notesSlides/notesSlide36.xml><?xml version="1.0" encoding="utf-8"?>
 <p:notes xmlns:a="http://schemas.openxmlformats.org/drawingml/2006/main" xmlns:r="http://schemas.openxmlformats.org/officeDocument/2006/relationships" xmlns:mc="http://schemas.openxmlformats.org/markup-compatibility/2006" xmlns:mv="urn:schemas-microsoft-com:mac:vml" xmlns:p="http://schemas.openxmlformats.org/presentationml/2006/main" xmlns:c="http://schemas.openxmlformats.org/drawingml/2006/chart" xmlns:dgm="http://schemas.openxmlformats.org/drawingml/2006/diagram" xmlns:o="urn:schemas-microsoft-com:office:office" xmlns:v="urn:schemas-microsoft-com:vml" xmlns:pvml="urn:schemas-microsoft-com:office:powerpoint" xmlns:com="http://schemas.openxmlformats.org/drawingml/2006/compatibility" xmlns:p14="http://schemas.microsoft.com/office/powerpoint/2010/main" xmlns:p15="http://schemas.microsoft.com/office/powerpoint/2012/main" xmlns:ahyp="http://schemas.microsoft.com/office/drawing/2018/hyperlinkcolor" showMasterPhAnim="0" showMasterSp="0">
   <p:cSld>
     <p:spTree>
       <p:nvGrpSpPr>
-        <p:cNvPr id="117" name="Shape 117"/>
+        <p:cNvPr id="387" name="Shape 387"/>
         <p:cNvGrpSpPr/>
         <p:nvPr/>
       </p:nvGrpSpPr>
@@ -5204,46 +5295,7 @@
       </p:grpSpPr>
       <p:sp>
         <p:nvSpPr>
-          <p:cNvPr id="118" name="Google Shape;118;p4:notes"/>
-          <p:cNvSpPr txBox="1"/>
-          <p:nvPr>
-            <p:ph idx="1" type="body"/>
-          </p:nvPr>
-        </p:nvSpPr>
-        <p:spPr>
-          <a:xfrm>
-            <a:off x="685800" y="4400550"/>
-            <a:ext cx="5486400" cy="3600450"/>
-          </a:xfrm>
-          <a:prstGeom prst="rect">
-            <a:avLst/>
-          </a:prstGeom>
-        </p:spPr>
-        <p:txBody>
-          <a:bodyPr anchorCtr="0" anchor="t" bIns="45700" lIns="91425" spcFirstLastPara="1" rIns="91425" wrap="square" tIns="45700">
-            <a:noAutofit/>
-          </a:bodyPr>
-          <a:lstStyle/>
-          <a:p>
-            <a:pPr indent="0" lvl="0" marL="0" rtl="0" algn="l">
-              <a:spcBef>
-                <a:spcPts val="0"/>
-              </a:spcBef>
-              <a:spcAft>
-                <a:spcPts val="0"/>
-              </a:spcAft>
-              <a:buNone/>
-            </a:pPr>
-            <a:r>
-              <a:t/>
-            </a:r>
-            <a:endParaRPr/>
-          </a:p>
-        </p:txBody>
-      </p:sp>
-      <p:sp>
-        <p:nvSpPr>
-          <p:cNvPr id="119" name="Google Shape;119;p4:notes"/>
+          <p:cNvPr id="388" name="Google Shape;388;g3aa6201ac61_0_26:notes"/>
           <p:cNvSpPr/>
           <p:nvPr>
             <p:ph idx="2" type="sldImg"/>
@@ -5276,6 +5328,89 @@
           </a:custGeom>
         </p:spPr>
       </p:sp>
+      <p:sp>
+        <p:nvSpPr>
+          <p:cNvPr id="389" name="Google Shape;389;g3aa6201ac61_0_26:notes"/>
+          <p:cNvSpPr txBox="1"/>
+          <p:nvPr>
+            <p:ph idx="1" type="body"/>
+          </p:nvPr>
+        </p:nvSpPr>
+        <p:spPr>
+          <a:xfrm>
+            <a:off x="685800" y="4400550"/>
+            <a:ext cx="5486400" cy="3600600"/>
+          </a:xfrm>
+          <a:prstGeom prst="rect">
+            <a:avLst/>
+          </a:prstGeom>
+        </p:spPr>
+        <p:txBody>
+          <a:bodyPr anchorCtr="0" anchor="t" bIns="45700" lIns="91425" spcFirstLastPara="1" rIns="91425" wrap="square" tIns="45700">
+            <a:noAutofit/>
+          </a:bodyPr>
+          <a:lstStyle/>
+          <a:p>
+            <a:pPr indent="0" lvl="0" marL="0" rtl="0" algn="l">
+              <a:spcBef>
+                <a:spcPts val="0"/>
+              </a:spcBef>
+              <a:spcAft>
+                <a:spcPts val="0"/>
+              </a:spcAft>
+              <a:buNone/>
+            </a:pPr>
+            <a:r>
+              <a:t/>
+            </a:r>
+            <a:endParaRPr/>
+          </a:p>
+        </p:txBody>
+      </p:sp>
+      <p:sp>
+        <p:nvSpPr>
+          <p:cNvPr id="390" name="Google Shape;390;g3aa6201ac61_0_26:notes"/>
+          <p:cNvSpPr txBox="1"/>
+          <p:nvPr>
+            <p:ph idx="12" type="sldNum"/>
+          </p:nvPr>
+        </p:nvSpPr>
+        <p:spPr>
+          <a:xfrm>
+            <a:off x="3884613" y="8685213"/>
+            <a:ext cx="2971800" cy="458700"/>
+          </a:xfrm>
+          <a:prstGeom prst="rect">
+            <a:avLst/>
+          </a:prstGeom>
+        </p:spPr>
+        <p:txBody>
+          <a:bodyPr anchorCtr="0" anchor="b" bIns="45700" lIns="91425" spcFirstLastPara="1" rIns="91425" wrap="square" tIns="45700">
+            <a:noAutofit/>
+          </a:bodyPr>
+          <a:lstStyle/>
+          <a:p>
+            <a:pPr indent="0" lvl="0" marL="0" rtl="0" algn="r">
+              <a:spcBef>
+                <a:spcPts val="0"/>
+              </a:spcBef>
+              <a:spcAft>
+                <a:spcPts val="0"/>
+              </a:spcAft>
+              <a:buClr>
+                <a:srgbClr val="000000"/>
+              </a:buClr>
+              <a:buFont typeface="Arial"/>
+              <a:buNone/>
+            </a:pPr>
+            <a:fld id="{00000000-1234-1234-1234-123412341234}" type="slidenum">
+              <a:rPr lang="it-IT"/>
+              <a:t>‹#›</a:t>
+            </a:fld>
+            <a:endParaRPr/>
+          </a:p>
+        </p:txBody>
+      </p:sp>
     </p:spTree>
   </p:cSld>
   <p:clrMapOvr>
@@ -5284,12 +5419,12 @@
 </p:notes>
 </file>
 
-<file path=ppt/notesSlides/notesSlide6.xml><?xml version="1.0" encoding="utf-8"?>
+<file path=ppt/notesSlides/notesSlide37.xml><?xml version="1.0" encoding="utf-8"?>
 <p:notes xmlns:a="http://schemas.openxmlformats.org/drawingml/2006/main" xmlns:r="http://schemas.openxmlformats.org/officeDocument/2006/relationships" xmlns:mc="http://schemas.openxmlformats.org/markup-compatibility/2006" xmlns:mv="urn:schemas-microsoft-com:mac:vml" xmlns:p="http://schemas.openxmlformats.org/presentationml/2006/main" xmlns:c="http://schemas.openxmlformats.org/drawingml/2006/chart" xmlns:dgm="http://schemas.openxmlformats.org/drawingml/2006/diagram" xmlns:o="urn:schemas-microsoft-com:office:office" xmlns:v="urn:schemas-microsoft-com:vml" xmlns:pvml="urn:schemas-microsoft-com:office:powerpoint" xmlns:com="http://schemas.openxmlformats.org/drawingml/2006/compatibility" xmlns:p14="http://schemas.microsoft.com/office/powerpoint/2010/main" xmlns:p15="http://schemas.microsoft.com/office/powerpoint/2012/main" xmlns:ahyp="http://schemas.microsoft.com/office/drawing/2018/hyperlinkcolor" showMasterPhAnim="0" showMasterSp="0">
   <p:cSld>
     <p:spTree>
       <p:nvGrpSpPr>
-        <p:cNvPr id="125" name="Shape 125"/>
+        <p:cNvPr id="396" name="Shape 396"/>
         <p:cNvGrpSpPr/>
         <p:nvPr/>
       </p:nvGrpSpPr>
@@ -5303,7 +5438,7 @@
       </p:grpSpPr>
       <p:sp>
         <p:nvSpPr>
-          <p:cNvPr id="126" name="Google Shape;126;p5:notes"/>
+          <p:cNvPr id="397" name="Google Shape;397;p15:notes"/>
           <p:cNvSpPr txBox="1"/>
           <p:nvPr>
             <p:ph idx="1" type="body"/>
@@ -5342,7 +5477,7 @@
       </p:sp>
       <p:sp>
         <p:nvSpPr>
-          <p:cNvPr id="127" name="Google Shape;127;p5:notes"/>
+          <p:cNvPr id="398" name="Google Shape;398;p15:notes"/>
           <p:cNvSpPr/>
           <p:nvPr>
             <p:ph idx="2" type="sldImg"/>
@@ -5383,12 +5518,12 @@
 </p:notes>
 </file>
 
-<file path=ppt/notesSlides/notesSlide7.xml><?xml version="1.0" encoding="utf-8"?>
+<file path=ppt/notesSlides/notesSlide4.xml><?xml version="1.0" encoding="utf-8"?>
 <p:notes xmlns:a="http://schemas.openxmlformats.org/drawingml/2006/main" xmlns:r="http://schemas.openxmlformats.org/officeDocument/2006/relationships" xmlns:mc="http://schemas.openxmlformats.org/markup-compatibility/2006" xmlns:mv="urn:schemas-microsoft-com:mac:vml" xmlns:p="http://schemas.openxmlformats.org/presentationml/2006/main" xmlns:c="http://schemas.openxmlformats.org/drawingml/2006/chart" xmlns:dgm="http://schemas.openxmlformats.org/drawingml/2006/diagram" xmlns:o="urn:schemas-microsoft-com:office:office" xmlns:v="urn:schemas-microsoft-com:vml" xmlns:pvml="urn:schemas-microsoft-com:office:powerpoint" xmlns:com="http://schemas.openxmlformats.org/drawingml/2006/compatibility" xmlns:p14="http://schemas.microsoft.com/office/powerpoint/2010/main" xmlns:p15="http://schemas.microsoft.com/office/powerpoint/2012/main" xmlns:ahyp="http://schemas.microsoft.com/office/drawing/2018/hyperlinkcolor" showMasterPhAnim="0" showMasterSp="0">
   <p:cSld>
     <p:spTree>
       <p:nvGrpSpPr>
-        <p:cNvPr id="133" name="Shape 133"/>
+        <p:cNvPr id="111" name="Shape 111"/>
         <p:cNvGrpSpPr/>
         <p:nvPr/>
       </p:nvGrpSpPr>
@@ -5402,7 +5537,7 @@
       </p:grpSpPr>
       <p:sp>
         <p:nvSpPr>
-          <p:cNvPr id="134" name="Google Shape;134;p6:notes"/>
+          <p:cNvPr id="112" name="Google Shape;112;p3:notes"/>
           <p:cNvSpPr txBox="1"/>
           <p:nvPr>
             <p:ph idx="1" type="body"/>
@@ -5441,7 +5576,7 @@
       </p:sp>
       <p:sp>
         <p:nvSpPr>
-          <p:cNvPr id="135" name="Google Shape;135;p6:notes"/>
+          <p:cNvPr id="113" name="Google Shape;113;p3:notes"/>
           <p:cNvSpPr/>
           <p:nvPr>
             <p:ph idx="2" type="sldImg"/>
@@ -5482,12 +5617,12 @@
 </p:notes>
 </file>
 
-<file path=ppt/notesSlides/notesSlide8.xml><?xml version="1.0" encoding="utf-8"?>
+<file path=ppt/notesSlides/notesSlide5.xml><?xml version="1.0" encoding="utf-8"?>
 <p:notes xmlns:a="http://schemas.openxmlformats.org/drawingml/2006/main" xmlns:r="http://schemas.openxmlformats.org/officeDocument/2006/relationships" xmlns:mc="http://schemas.openxmlformats.org/markup-compatibility/2006" xmlns:mv="urn:schemas-microsoft-com:mac:vml" xmlns:p="http://schemas.openxmlformats.org/presentationml/2006/main" xmlns:c="http://schemas.openxmlformats.org/drawingml/2006/chart" xmlns:dgm="http://schemas.openxmlformats.org/drawingml/2006/diagram" xmlns:o="urn:schemas-microsoft-com:office:office" xmlns:v="urn:schemas-microsoft-com:vml" xmlns:pvml="urn:schemas-microsoft-com:office:powerpoint" xmlns:com="http://schemas.openxmlformats.org/drawingml/2006/compatibility" xmlns:p14="http://schemas.microsoft.com/office/powerpoint/2010/main" xmlns:p15="http://schemas.microsoft.com/office/powerpoint/2012/main" xmlns:ahyp="http://schemas.microsoft.com/office/drawing/2018/hyperlinkcolor" showMasterPhAnim="0" showMasterSp="0">
   <p:cSld>
     <p:spTree>
       <p:nvGrpSpPr>
-        <p:cNvPr id="142" name="Shape 142"/>
+        <p:cNvPr id="118" name="Shape 118"/>
         <p:cNvGrpSpPr/>
         <p:nvPr/>
       </p:nvGrpSpPr>
@@ -5501,7 +5636,7 @@
       </p:grpSpPr>
       <p:sp>
         <p:nvSpPr>
-          <p:cNvPr id="143" name="Google Shape;143;p7:notes"/>
+          <p:cNvPr id="119" name="Google Shape;119;p4:notes"/>
           <p:cNvSpPr txBox="1"/>
           <p:nvPr>
             <p:ph idx="1" type="body"/>
@@ -5540,7 +5675,7 @@
       </p:sp>
       <p:sp>
         <p:nvSpPr>
-          <p:cNvPr id="144" name="Google Shape;144;p7:notes"/>
+          <p:cNvPr id="120" name="Google Shape;120;p4:notes"/>
           <p:cNvSpPr/>
           <p:nvPr>
             <p:ph idx="2" type="sldImg"/>
@@ -5581,12 +5716,12 @@
 </p:notes>
 </file>
 
-<file path=ppt/notesSlides/notesSlide9.xml><?xml version="1.0" encoding="utf-8"?>
+<file path=ppt/notesSlides/notesSlide6.xml><?xml version="1.0" encoding="utf-8"?>
 <p:notes xmlns:a="http://schemas.openxmlformats.org/drawingml/2006/main" xmlns:r="http://schemas.openxmlformats.org/officeDocument/2006/relationships" xmlns:mc="http://schemas.openxmlformats.org/markup-compatibility/2006" xmlns:mv="urn:schemas-microsoft-com:mac:vml" xmlns:p="http://schemas.openxmlformats.org/presentationml/2006/main" xmlns:c="http://schemas.openxmlformats.org/drawingml/2006/chart" xmlns:dgm="http://schemas.openxmlformats.org/drawingml/2006/diagram" xmlns:o="urn:schemas-microsoft-com:office:office" xmlns:v="urn:schemas-microsoft-com:vml" xmlns:pvml="urn:schemas-microsoft-com:office:powerpoint" xmlns:com="http://schemas.openxmlformats.org/drawingml/2006/compatibility" xmlns:p14="http://schemas.microsoft.com/office/powerpoint/2010/main" xmlns:p15="http://schemas.microsoft.com/office/powerpoint/2012/main" xmlns:ahyp="http://schemas.microsoft.com/office/drawing/2018/hyperlinkcolor" showMasterPhAnim="0" showMasterSp="0">
   <p:cSld>
     <p:spTree>
       <p:nvGrpSpPr>
-        <p:cNvPr id="150" name="Shape 150"/>
+        <p:cNvPr id="126" name="Shape 126"/>
         <p:cNvGrpSpPr/>
         <p:nvPr/>
       </p:nvGrpSpPr>
@@ -5600,7 +5735,46 @@
       </p:grpSpPr>
       <p:sp>
         <p:nvSpPr>
-          <p:cNvPr id="151" name="Google Shape;151;g39a291deda2_0_29:notes"/>
+          <p:cNvPr id="127" name="Google Shape;127;p5:notes"/>
+          <p:cNvSpPr txBox="1"/>
+          <p:nvPr>
+            <p:ph idx="1" type="body"/>
+          </p:nvPr>
+        </p:nvSpPr>
+        <p:spPr>
+          <a:xfrm>
+            <a:off x="685800" y="4400550"/>
+            <a:ext cx="5486400" cy="3600450"/>
+          </a:xfrm>
+          <a:prstGeom prst="rect">
+            <a:avLst/>
+          </a:prstGeom>
+        </p:spPr>
+        <p:txBody>
+          <a:bodyPr anchorCtr="0" anchor="t" bIns="45700" lIns="91425" spcFirstLastPara="1" rIns="91425" wrap="square" tIns="45700">
+            <a:noAutofit/>
+          </a:bodyPr>
+          <a:lstStyle/>
+          <a:p>
+            <a:pPr indent="0" lvl="0" marL="0" rtl="0" algn="l">
+              <a:spcBef>
+                <a:spcPts val="0"/>
+              </a:spcBef>
+              <a:spcAft>
+                <a:spcPts val="0"/>
+              </a:spcAft>
+              <a:buNone/>
+            </a:pPr>
+            <a:r>
+              <a:t/>
+            </a:r>
+            <a:endParaRPr/>
+          </a:p>
+        </p:txBody>
+      </p:sp>
+      <p:sp>
+        <p:nvSpPr>
+          <p:cNvPr id="128" name="Google Shape;128;p5:notes"/>
           <p:cNvSpPr/>
           <p:nvPr>
             <p:ph idx="2" type="sldImg"/>
@@ -5633,9 +5807,34 @@
           </a:custGeom>
         </p:spPr>
       </p:sp>
+    </p:spTree>
+  </p:cSld>
+  <p:clrMapOvr>
+    <a:masterClrMapping/>
+  </p:clrMapOvr>
+</p:notes>
+</file>
+
+<file path=ppt/notesSlides/notesSlide7.xml><?xml version="1.0" encoding="utf-8"?>
+<p:notes xmlns:a="http://schemas.openxmlformats.org/drawingml/2006/main" xmlns:r="http://schemas.openxmlformats.org/officeDocument/2006/relationships" xmlns:mc="http://schemas.openxmlformats.org/markup-compatibility/2006" xmlns:mv="urn:schemas-microsoft-com:mac:vml" xmlns:p="http://schemas.openxmlformats.org/presentationml/2006/main" xmlns:c="http://schemas.openxmlformats.org/drawingml/2006/chart" xmlns:dgm="http://schemas.openxmlformats.org/drawingml/2006/diagram" xmlns:o="urn:schemas-microsoft-com:office:office" xmlns:v="urn:schemas-microsoft-com:vml" xmlns:pvml="urn:schemas-microsoft-com:office:powerpoint" xmlns:com="http://schemas.openxmlformats.org/drawingml/2006/compatibility" xmlns:p14="http://schemas.microsoft.com/office/powerpoint/2010/main" xmlns:p15="http://schemas.microsoft.com/office/powerpoint/2012/main" xmlns:ahyp="http://schemas.microsoft.com/office/drawing/2018/hyperlinkcolor" showMasterPhAnim="0" showMasterSp="0">
+  <p:cSld>
+    <p:spTree>
+      <p:nvGrpSpPr>
+        <p:cNvPr id="134" name="Shape 134"/>
+        <p:cNvGrpSpPr/>
+        <p:nvPr/>
+      </p:nvGrpSpPr>
+      <p:grpSpPr>
+        <a:xfrm>
+          <a:off x="0" y="0"/>
+          <a:ext cx="0" cy="0"/>
+          <a:chOff x="0" y="0"/>
+          <a:chExt cx="0" cy="0"/>
+        </a:xfrm>
+      </p:grpSpPr>
       <p:sp>
         <p:nvSpPr>
-          <p:cNvPr id="152" name="Google Shape;152;g39a291deda2_0_29:notes"/>
+          <p:cNvPr id="135" name="Google Shape;135;p6:notes"/>
           <p:cNvSpPr txBox="1"/>
           <p:nvPr>
             <p:ph idx="1" type="body"/>
@@ -5644,7 +5843,7 @@
         <p:spPr>
           <a:xfrm>
             <a:off x="685800" y="4400550"/>
-            <a:ext cx="5486400" cy="3600600"/>
+            <a:ext cx="5486400" cy="3600450"/>
           </a:xfrm>
           <a:prstGeom prst="rect">
             <a:avLst/>
@@ -5674,7 +5873,240 @@
       </p:sp>
       <p:sp>
         <p:nvSpPr>
+          <p:cNvPr id="136" name="Google Shape;136;p6:notes"/>
+          <p:cNvSpPr/>
+          <p:nvPr>
+            <p:ph idx="2" type="sldImg"/>
+          </p:nvPr>
+        </p:nvSpPr>
+        <p:spPr>
+          <a:xfrm>
+            <a:off x="685260" y="1143000"/>
+            <a:ext cx="5487600" cy="3086100"/>
+          </a:xfrm>
+          <a:custGeom>
+            <a:rect b="b" l="l" r="r" t="t"/>
+            <a:pathLst>
+              <a:path extrusionOk="0" h="120000" w="120000">
+                <a:moveTo>
+                  <a:pt x="0" y="0"/>
+                </a:moveTo>
+                <a:lnTo>
+                  <a:pt x="120000" y="0"/>
+                </a:lnTo>
+                <a:lnTo>
+                  <a:pt x="120000" y="120000"/>
+                </a:lnTo>
+                <a:lnTo>
+                  <a:pt x="0" y="120000"/>
+                </a:lnTo>
+                <a:close/>
+              </a:path>
+            </a:pathLst>
+          </a:custGeom>
+        </p:spPr>
+      </p:sp>
+    </p:spTree>
+  </p:cSld>
+  <p:clrMapOvr>
+    <a:masterClrMapping/>
+  </p:clrMapOvr>
+</p:notes>
+</file>
+
+<file path=ppt/notesSlides/notesSlide8.xml><?xml version="1.0" encoding="utf-8"?>
+<p:notes xmlns:a="http://schemas.openxmlformats.org/drawingml/2006/main" xmlns:r="http://schemas.openxmlformats.org/officeDocument/2006/relationships" xmlns:mc="http://schemas.openxmlformats.org/markup-compatibility/2006" xmlns:mv="urn:schemas-microsoft-com:mac:vml" xmlns:p="http://schemas.openxmlformats.org/presentationml/2006/main" xmlns:c="http://schemas.openxmlformats.org/drawingml/2006/chart" xmlns:dgm="http://schemas.openxmlformats.org/drawingml/2006/diagram" xmlns:o="urn:schemas-microsoft-com:office:office" xmlns:v="urn:schemas-microsoft-com:vml" xmlns:pvml="urn:schemas-microsoft-com:office:powerpoint" xmlns:com="http://schemas.openxmlformats.org/drawingml/2006/compatibility" xmlns:p14="http://schemas.microsoft.com/office/powerpoint/2010/main" xmlns:p15="http://schemas.microsoft.com/office/powerpoint/2012/main" xmlns:ahyp="http://schemas.microsoft.com/office/drawing/2018/hyperlinkcolor" showMasterPhAnim="0" showMasterSp="0">
+  <p:cSld>
+    <p:spTree>
+      <p:nvGrpSpPr>
+        <p:cNvPr id="143" name="Shape 143"/>
+        <p:cNvGrpSpPr/>
+        <p:nvPr/>
+      </p:nvGrpSpPr>
+      <p:grpSpPr>
+        <a:xfrm>
+          <a:off x="0" y="0"/>
+          <a:ext cx="0" cy="0"/>
+          <a:chOff x="0" y="0"/>
+          <a:chExt cx="0" cy="0"/>
+        </a:xfrm>
+      </p:grpSpPr>
+      <p:sp>
+        <p:nvSpPr>
+          <p:cNvPr id="144" name="Google Shape;144;p7:notes"/>
+          <p:cNvSpPr txBox="1"/>
+          <p:nvPr>
+            <p:ph idx="1" type="body"/>
+          </p:nvPr>
+        </p:nvSpPr>
+        <p:spPr>
+          <a:xfrm>
+            <a:off x="685800" y="4400550"/>
+            <a:ext cx="5486400" cy="3600450"/>
+          </a:xfrm>
+          <a:prstGeom prst="rect">
+            <a:avLst/>
+          </a:prstGeom>
+        </p:spPr>
+        <p:txBody>
+          <a:bodyPr anchorCtr="0" anchor="t" bIns="45700" lIns="91425" spcFirstLastPara="1" rIns="91425" wrap="square" tIns="45700">
+            <a:noAutofit/>
+          </a:bodyPr>
+          <a:lstStyle/>
+          <a:p>
+            <a:pPr indent="0" lvl="0" marL="0" rtl="0" algn="l">
+              <a:spcBef>
+                <a:spcPts val="0"/>
+              </a:spcBef>
+              <a:spcAft>
+                <a:spcPts val="0"/>
+              </a:spcAft>
+              <a:buNone/>
+            </a:pPr>
+            <a:r>
+              <a:t/>
+            </a:r>
+            <a:endParaRPr/>
+          </a:p>
+        </p:txBody>
+      </p:sp>
+      <p:sp>
+        <p:nvSpPr>
+          <p:cNvPr id="145" name="Google Shape;145;p7:notes"/>
+          <p:cNvSpPr/>
+          <p:nvPr>
+            <p:ph idx="2" type="sldImg"/>
+          </p:nvPr>
+        </p:nvSpPr>
+        <p:spPr>
+          <a:xfrm>
+            <a:off x="685260" y="1143000"/>
+            <a:ext cx="5487600" cy="3086100"/>
+          </a:xfrm>
+          <a:custGeom>
+            <a:rect b="b" l="l" r="r" t="t"/>
+            <a:pathLst>
+              <a:path extrusionOk="0" h="120000" w="120000">
+                <a:moveTo>
+                  <a:pt x="0" y="0"/>
+                </a:moveTo>
+                <a:lnTo>
+                  <a:pt x="120000" y="0"/>
+                </a:lnTo>
+                <a:lnTo>
+                  <a:pt x="120000" y="120000"/>
+                </a:lnTo>
+                <a:lnTo>
+                  <a:pt x="0" y="120000"/>
+                </a:lnTo>
+                <a:close/>
+              </a:path>
+            </a:pathLst>
+          </a:custGeom>
+        </p:spPr>
+      </p:sp>
+    </p:spTree>
+  </p:cSld>
+  <p:clrMapOvr>
+    <a:masterClrMapping/>
+  </p:clrMapOvr>
+</p:notes>
+</file>
+
+<file path=ppt/notesSlides/notesSlide9.xml><?xml version="1.0" encoding="utf-8"?>
+<p:notes xmlns:a="http://schemas.openxmlformats.org/drawingml/2006/main" xmlns:r="http://schemas.openxmlformats.org/officeDocument/2006/relationships" xmlns:mc="http://schemas.openxmlformats.org/markup-compatibility/2006" xmlns:mv="urn:schemas-microsoft-com:mac:vml" xmlns:p="http://schemas.openxmlformats.org/presentationml/2006/main" xmlns:c="http://schemas.openxmlformats.org/drawingml/2006/chart" xmlns:dgm="http://schemas.openxmlformats.org/drawingml/2006/diagram" xmlns:o="urn:schemas-microsoft-com:office:office" xmlns:v="urn:schemas-microsoft-com:vml" xmlns:pvml="urn:schemas-microsoft-com:office:powerpoint" xmlns:com="http://schemas.openxmlformats.org/drawingml/2006/compatibility" xmlns:p14="http://schemas.microsoft.com/office/powerpoint/2010/main" xmlns:p15="http://schemas.microsoft.com/office/powerpoint/2012/main" xmlns:ahyp="http://schemas.microsoft.com/office/drawing/2018/hyperlinkcolor" showMasterPhAnim="0" showMasterSp="0">
+  <p:cSld>
+    <p:spTree>
+      <p:nvGrpSpPr>
+        <p:cNvPr id="151" name="Shape 151"/>
+        <p:cNvGrpSpPr/>
+        <p:nvPr/>
+      </p:nvGrpSpPr>
+      <p:grpSpPr>
+        <a:xfrm>
+          <a:off x="0" y="0"/>
+          <a:ext cx="0" cy="0"/>
+          <a:chOff x="0" y="0"/>
+          <a:chExt cx="0" cy="0"/>
+        </a:xfrm>
+      </p:grpSpPr>
+      <p:sp>
+        <p:nvSpPr>
+          <p:cNvPr id="152" name="Google Shape;152;g39a291deda2_0_29:notes"/>
+          <p:cNvSpPr/>
+          <p:nvPr>
+            <p:ph idx="2" type="sldImg"/>
+          </p:nvPr>
+        </p:nvSpPr>
+        <p:spPr>
+          <a:xfrm>
+            <a:off x="685260" y="1143000"/>
+            <a:ext cx="5487600" cy="3086100"/>
+          </a:xfrm>
+          <a:custGeom>
+            <a:rect b="b" l="l" r="r" t="t"/>
+            <a:pathLst>
+              <a:path extrusionOk="0" h="120000" w="120000">
+                <a:moveTo>
+                  <a:pt x="0" y="0"/>
+                </a:moveTo>
+                <a:lnTo>
+                  <a:pt x="120000" y="0"/>
+                </a:lnTo>
+                <a:lnTo>
+                  <a:pt x="120000" y="120000"/>
+                </a:lnTo>
+                <a:lnTo>
+                  <a:pt x="0" y="120000"/>
+                </a:lnTo>
+                <a:close/>
+              </a:path>
+            </a:pathLst>
+          </a:custGeom>
+        </p:spPr>
+      </p:sp>
+      <p:sp>
+        <p:nvSpPr>
           <p:cNvPr id="153" name="Google Shape;153;g39a291deda2_0_29:notes"/>
+          <p:cNvSpPr txBox="1"/>
+          <p:nvPr>
+            <p:ph idx="1" type="body"/>
+          </p:nvPr>
+        </p:nvSpPr>
+        <p:spPr>
+          <a:xfrm>
+            <a:off x="685800" y="4400550"/>
+            <a:ext cx="5486400" cy="3600600"/>
+          </a:xfrm>
+          <a:prstGeom prst="rect">
+            <a:avLst/>
+          </a:prstGeom>
+        </p:spPr>
+        <p:txBody>
+          <a:bodyPr anchorCtr="0" anchor="t" bIns="45700" lIns="91425" spcFirstLastPara="1" rIns="91425" wrap="square" tIns="45700">
+            <a:noAutofit/>
+          </a:bodyPr>
+          <a:lstStyle/>
+          <a:p>
+            <a:pPr indent="0" lvl="0" marL="0" rtl="0" algn="l">
+              <a:spcBef>
+                <a:spcPts val="0"/>
+              </a:spcBef>
+              <a:spcAft>
+                <a:spcPts val="0"/>
+              </a:spcAft>
+              <a:buNone/>
+            </a:pPr>
+            <a:r>
+              <a:t/>
+            </a:r>
+            <a:endParaRPr/>
+          </a:p>
+        </p:txBody>
+      </p:sp>
+      <p:sp>
+        <p:nvSpPr>
+          <p:cNvPr id="154" name="Google Shape;154;g39a291deda2_0_29:notes"/>
           <p:cNvSpPr txBox="1"/>
           <p:nvPr>
             <p:ph idx="12" type="sldNum"/>
@@ -15352,7 +15784,7 @@
         </p:blipFill>
         <p:spPr>
           <a:xfrm>
-            <a:off x="3360677" y="434825"/>
+            <a:off x="3348377" y="114900"/>
             <a:ext cx="2568903" cy="1639425"/>
           </a:xfrm>
           <a:prstGeom prst="rect">
@@ -15372,7 +15804,7 @@
         </p:nvSpPr>
         <p:spPr>
           <a:xfrm>
-            <a:off x="260825" y="3340975"/>
+            <a:off x="260825" y="2898000"/>
             <a:ext cx="9513600" cy="461700"/>
           </a:xfrm>
           <a:prstGeom prst="rect">
@@ -15403,14 +15835,10 @@
                 <a:solidFill>
                   <a:srgbClr val="0F4761"/>
                 </a:solidFill>
-                <a:latin typeface="Arial"/>
-                <a:ea typeface="Arial"/>
-                <a:cs typeface="Arial"/>
-                <a:sym typeface="Arial"/>
               </a:rPr>
               <a:t>04 Dicembre 2025 – Segreti sui moduli Python</a:t>
             </a:r>
-            <a:endParaRPr sz="2400"/>
+            <a:endParaRPr b="1" sz="2400"/>
           </a:p>
         </p:txBody>
       </p:sp>
@@ -15422,7 +15850,7 @@
         </p:nvSpPr>
         <p:spPr>
           <a:xfrm>
-            <a:off x="1473725" y="2245913"/>
+            <a:off x="1473725" y="1913663"/>
             <a:ext cx="7087800" cy="923400"/>
           </a:xfrm>
           <a:prstGeom prst="rect">
@@ -15480,7 +15908,7 @@
         </p:nvSpPr>
         <p:spPr>
           <a:xfrm>
-            <a:off x="1714525" y="4165150"/>
+            <a:off x="1714525" y="3420625"/>
             <a:ext cx="6283800" cy="677100"/>
           </a:xfrm>
           <a:prstGeom prst="rect">
@@ -15507,7 +15935,7 @@
               <a:buNone/>
             </a:pPr>
             <a:r>
-              <a:rPr lang="it-IT" sz="3200">
+              <a:rPr b="1" lang="it-IT" sz="3200">
                 <a:solidFill>
                   <a:schemeClr val="dk1"/>
                 </a:solidFill>
@@ -15518,7 +15946,7 @@
               </a:rPr>
               <a:t>francescospalluzzi@gmail.com</a:t>
             </a:r>
-            <a:endParaRPr sz="3200">
+            <a:endParaRPr b="1" sz="3200">
               <a:solidFill>
                 <a:schemeClr val="dk1"/>
               </a:solidFill>
@@ -15527,6 +15955,48 @@
               <a:cs typeface="Calibri"/>
               <a:sym typeface="Calibri"/>
             </a:endParaRPr>
+          </a:p>
+        </p:txBody>
+      </p:sp>
+      <p:sp>
+        <p:nvSpPr>
+          <p:cNvPr id="93" name="Google Shape;93;g39a291deda2_0_0"/>
+          <p:cNvSpPr txBox="1"/>
+          <p:nvPr/>
+        </p:nvSpPr>
+        <p:spPr>
+          <a:xfrm>
+            <a:off x="1765025" y="4269825"/>
+            <a:ext cx="6796500" cy="461700"/>
+          </a:xfrm>
+          <a:prstGeom prst="rect">
+            <a:avLst/>
+          </a:prstGeom>
+          <a:noFill/>
+          <a:ln>
+            <a:noFill/>
+          </a:ln>
+        </p:spPr>
+        <p:txBody>
+          <a:bodyPr anchorCtr="0" anchor="t" bIns="91425" lIns="91425" spcFirstLastPara="1" rIns="91425" wrap="square" tIns="91425">
+            <a:spAutoFit/>
+          </a:bodyPr>
+          <a:lstStyle/>
+          <a:p>
+            <a:pPr indent="0" lvl="0" marL="0" rtl="0" algn="ctr">
+              <a:spcBef>
+                <a:spcPts val="0"/>
+              </a:spcBef>
+              <a:spcAft>
+                <a:spcPts val="0"/>
+              </a:spcAft>
+              <a:buNone/>
+            </a:pPr>
+            <a:r>
+              <a:rPr b="1" lang="it-IT" sz="1800"/>
+              <a:t>https://github.com/jobFrancoNet/segretiModulePython.git</a:t>
+            </a:r>
+            <a:endParaRPr b="1" sz="1800"/>
           </a:p>
         </p:txBody>
       </p:sp>
@@ -15543,7 +16013,7 @@
   <p:cSld>
     <p:spTree>
       <p:nvGrpSpPr>
-        <p:cNvPr id="163" name="Shape 163"/>
+        <p:cNvPr id="164" name="Shape 164"/>
         <p:cNvGrpSpPr/>
         <p:nvPr/>
       </p:nvGrpSpPr>
@@ -15557,7 +16027,7 @@
       </p:grpSpPr>
       <p:sp>
         <p:nvSpPr>
-          <p:cNvPr id="164" name="Google Shape;164;p8"/>
+          <p:cNvPr id="165" name="Google Shape;165;p8"/>
           <p:cNvSpPr txBox="1"/>
           <p:nvPr/>
         </p:nvSpPr>
@@ -15607,7 +16077,7 @@
       </p:sp>
       <p:pic>
         <p:nvPicPr>
-          <p:cNvPr id="165" name="Google Shape;165;p8"/>
+          <p:cNvPr id="166" name="Google Shape;166;p8"/>
           <p:cNvPicPr preferRelativeResize="0"/>
           <p:nvPr/>
         </p:nvPicPr>
@@ -15634,7 +16104,7 @@
       </p:pic>
       <p:pic>
         <p:nvPicPr>
-          <p:cNvPr id="166" name="Google Shape;166;p8"/>
+          <p:cNvPr id="167" name="Google Shape;167;p8"/>
           <p:cNvPicPr preferRelativeResize="0"/>
           <p:nvPr/>
         </p:nvPicPr>
@@ -15662,7 +16132,7 @@
       </p:pic>
       <p:sp>
         <p:nvSpPr>
-          <p:cNvPr id="167" name="Google Shape;167;p8"/>
+          <p:cNvPr id="168" name="Google Shape;168;p8"/>
           <p:cNvSpPr txBox="1"/>
           <p:nvPr/>
         </p:nvSpPr>
@@ -15720,7 +16190,7 @@
       </p:sp>
       <p:pic>
         <p:nvPicPr>
-          <p:cNvPr id="168" name="Google Shape;168;p8"/>
+          <p:cNvPr id="169" name="Google Shape;169;p8"/>
           <p:cNvPicPr preferRelativeResize="0"/>
           <p:nvPr/>
         </p:nvPicPr>
@@ -15759,7 +16229,7 @@
   <p:cSld>
     <p:spTree>
       <p:nvGrpSpPr>
-        <p:cNvPr id="172" name="Shape 172"/>
+        <p:cNvPr id="173" name="Shape 173"/>
         <p:cNvGrpSpPr/>
         <p:nvPr/>
       </p:nvGrpSpPr>
@@ -15773,7 +16243,7 @@
       </p:grpSpPr>
       <p:sp>
         <p:nvSpPr>
-          <p:cNvPr id="173" name="Google Shape;173;p9"/>
+          <p:cNvPr id="174" name="Google Shape;174;p9"/>
           <p:cNvSpPr txBox="1"/>
           <p:nvPr/>
         </p:nvSpPr>
@@ -15823,7 +16293,7 @@
       </p:sp>
       <p:pic>
         <p:nvPicPr>
-          <p:cNvPr id="174" name="Google Shape;174;p9"/>
+          <p:cNvPr id="175" name="Google Shape;175;p9"/>
           <p:cNvPicPr preferRelativeResize="0"/>
           <p:nvPr/>
         </p:nvPicPr>
@@ -15850,7 +16320,7 @@
       </p:pic>
       <p:pic>
         <p:nvPicPr>
-          <p:cNvPr id="175" name="Google Shape;175;p9"/>
+          <p:cNvPr id="176" name="Google Shape;176;p9"/>
           <p:cNvPicPr preferRelativeResize="0"/>
           <p:nvPr/>
         </p:nvPicPr>
@@ -15878,7 +16348,7 @@
       </p:pic>
       <p:pic>
         <p:nvPicPr>
-          <p:cNvPr id="176" name="Google Shape;176;p9"/>
+          <p:cNvPr id="177" name="Google Shape;177;p9"/>
           <p:cNvPicPr preferRelativeResize="0"/>
           <p:nvPr/>
         </p:nvPicPr>
@@ -15906,7 +16376,7 @@
       </p:pic>
       <p:pic>
         <p:nvPicPr>
-          <p:cNvPr id="177" name="Google Shape;177;p9"/>
+          <p:cNvPr id="178" name="Google Shape;178;p9"/>
           <p:cNvPicPr preferRelativeResize="0"/>
           <p:nvPr/>
         </p:nvPicPr>
@@ -15945,7 +16415,7 @@
   <p:cSld>
     <p:spTree>
       <p:nvGrpSpPr>
-        <p:cNvPr id="181" name="Shape 181"/>
+        <p:cNvPr id="182" name="Shape 182"/>
         <p:cNvGrpSpPr/>
         <p:nvPr/>
       </p:nvGrpSpPr>
@@ -15959,7 +16429,7 @@
       </p:grpSpPr>
       <p:sp>
         <p:nvSpPr>
-          <p:cNvPr id="182" name="Google Shape;182;p10"/>
+          <p:cNvPr id="183" name="Google Shape;183;p10"/>
           <p:cNvSpPr txBox="1"/>
           <p:nvPr/>
         </p:nvSpPr>
@@ -16009,7 +16479,7 @@
       </p:sp>
       <p:pic>
         <p:nvPicPr>
-          <p:cNvPr id="183" name="Google Shape;183;p10"/>
+          <p:cNvPr id="184" name="Google Shape;184;p10"/>
           <p:cNvPicPr preferRelativeResize="0"/>
           <p:nvPr/>
         </p:nvPicPr>
@@ -16036,7 +16506,7 @@
       </p:pic>
       <p:pic>
         <p:nvPicPr>
-          <p:cNvPr id="184" name="Google Shape;184;p10"/>
+          <p:cNvPr id="185" name="Google Shape;185;p10"/>
           <p:cNvPicPr preferRelativeResize="0"/>
           <p:nvPr/>
         </p:nvPicPr>
@@ -16064,7 +16534,7 @@
       </p:pic>
       <p:pic>
         <p:nvPicPr>
-          <p:cNvPr id="185" name="Google Shape;185;p10"/>
+          <p:cNvPr id="186" name="Google Shape;186;p10"/>
           <p:cNvPicPr preferRelativeResize="0"/>
           <p:nvPr/>
         </p:nvPicPr>
@@ -16103,7 +16573,7 @@
   <p:cSld>
     <p:spTree>
       <p:nvGrpSpPr>
-        <p:cNvPr id="189" name="Shape 189"/>
+        <p:cNvPr id="190" name="Shape 190"/>
         <p:cNvGrpSpPr/>
         <p:nvPr/>
       </p:nvGrpSpPr>
@@ -16117,7 +16587,7 @@
       </p:grpSpPr>
       <p:sp>
         <p:nvSpPr>
-          <p:cNvPr id="190" name="Google Shape;190;p11"/>
+          <p:cNvPr id="191" name="Google Shape;191;p11"/>
           <p:cNvSpPr txBox="1"/>
           <p:nvPr/>
         </p:nvSpPr>
@@ -16167,7 +16637,7 @@
       </p:sp>
       <p:pic>
         <p:nvPicPr>
-          <p:cNvPr id="191" name="Google Shape;191;p11"/>
+          <p:cNvPr id="192" name="Google Shape;192;p11"/>
           <p:cNvPicPr preferRelativeResize="0"/>
           <p:nvPr/>
         </p:nvPicPr>
@@ -16194,7 +16664,7 @@
       </p:pic>
       <p:pic>
         <p:nvPicPr>
-          <p:cNvPr id="192" name="Google Shape;192;p11"/>
+          <p:cNvPr id="193" name="Google Shape;193;p11"/>
           <p:cNvPicPr preferRelativeResize="0"/>
           <p:nvPr/>
         </p:nvPicPr>
@@ -16222,7 +16692,7 @@
       </p:pic>
       <p:pic>
         <p:nvPicPr>
-          <p:cNvPr id="193" name="Google Shape;193;p11"/>
+          <p:cNvPr id="194" name="Google Shape;194;p11"/>
           <p:cNvPicPr preferRelativeResize="0"/>
           <p:nvPr/>
         </p:nvPicPr>
@@ -16250,7 +16720,7 @@
       </p:pic>
       <p:sp>
         <p:nvSpPr>
-          <p:cNvPr id="194" name="Google Shape;194;p11"/>
+          <p:cNvPr id="195" name="Google Shape;195;p11"/>
           <p:cNvSpPr txBox="1"/>
           <p:nvPr/>
         </p:nvSpPr>
@@ -16319,7 +16789,7 @@
   <p:cSld>
     <p:spTree>
       <p:nvGrpSpPr>
-        <p:cNvPr id="199" name="Shape 199"/>
+        <p:cNvPr id="200" name="Shape 200"/>
         <p:cNvGrpSpPr/>
         <p:nvPr/>
       </p:nvGrpSpPr>
@@ -16333,7 +16803,7 @@
       </p:grpSpPr>
       <p:sp>
         <p:nvSpPr>
-          <p:cNvPr id="200" name="Google Shape;200;p12"/>
+          <p:cNvPr id="201" name="Google Shape;201;p12"/>
           <p:cNvSpPr txBox="1"/>
           <p:nvPr/>
         </p:nvSpPr>
@@ -16383,7 +16853,7 @@
       </p:sp>
       <p:pic>
         <p:nvPicPr>
-          <p:cNvPr id="201" name="Google Shape;201;p12"/>
+          <p:cNvPr id="202" name="Google Shape;202;p12"/>
           <p:cNvPicPr preferRelativeResize="0"/>
           <p:nvPr/>
         </p:nvPicPr>
@@ -16410,7 +16880,7 @@
       </p:pic>
       <p:pic>
         <p:nvPicPr>
-          <p:cNvPr id="202" name="Google Shape;202;p12"/>
+          <p:cNvPr id="203" name="Google Shape;203;p12"/>
           <p:cNvPicPr preferRelativeResize="0"/>
           <p:nvPr/>
         </p:nvPicPr>
@@ -16438,7 +16908,7 @@
       </p:pic>
       <p:sp>
         <p:nvSpPr>
-          <p:cNvPr id="203" name="Google Shape;203;p12"/>
+          <p:cNvPr id="204" name="Google Shape;204;p12"/>
           <p:cNvSpPr txBox="1"/>
           <p:nvPr/>
         </p:nvSpPr>
@@ -16491,7 +16961,7 @@
   <p:cSld>
     <p:spTree>
       <p:nvGrpSpPr>
-        <p:cNvPr id="207" name="Shape 207"/>
+        <p:cNvPr id="208" name="Shape 208"/>
         <p:cNvGrpSpPr/>
         <p:nvPr/>
       </p:nvGrpSpPr>
@@ -16505,7 +16975,7 @@
       </p:grpSpPr>
       <p:sp>
         <p:nvSpPr>
-          <p:cNvPr id="208" name="Google Shape;208;p13"/>
+          <p:cNvPr id="209" name="Google Shape;209;p13"/>
           <p:cNvSpPr txBox="1"/>
           <p:nvPr/>
         </p:nvSpPr>
@@ -16555,7 +17025,7 @@
       </p:sp>
       <p:pic>
         <p:nvPicPr>
-          <p:cNvPr id="209" name="Google Shape;209;p13"/>
+          <p:cNvPr id="210" name="Google Shape;210;p13"/>
           <p:cNvPicPr preferRelativeResize="0"/>
           <p:nvPr/>
         </p:nvPicPr>
@@ -16582,7 +17052,7 @@
       </p:pic>
       <p:pic>
         <p:nvPicPr>
-          <p:cNvPr id="210" name="Google Shape;210;p13"/>
+          <p:cNvPr id="211" name="Google Shape;211;p13"/>
           <p:cNvPicPr preferRelativeResize="0"/>
           <p:nvPr/>
         </p:nvPicPr>
@@ -16610,7 +17080,7 @@
       </p:pic>
       <p:sp>
         <p:nvSpPr>
-          <p:cNvPr id="211" name="Google Shape;211;p13"/>
+          <p:cNvPr id="212" name="Google Shape;212;p13"/>
           <p:cNvSpPr txBox="1"/>
           <p:nvPr/>
         </p:nvSpPr>
@@ -16743,7 +17213,7 @@
   <p:cSld>
     <p:spTree>
       <p:nvGrpSpPr>
-        <p:cNvPr id="215" name="Shape 215"/>
+        <p:cNvPr id="216" name="Shape 216"/>
         <p:cNvGrpSpPr/>
         <p:nvPr/>
       </p:nvGrpSpPr>
@@ -16757,7 +17227,7 @@
       </p:grpSpPr>
       <p:sp>
         <p:nvSpPr>
-          <p:cNvPr id="216" name="Google Shape;216;p14"/>
+          <p:cNvPr id="217" name="Google Shape;217;p14"/>
           <p:cNvSpPr txBox="1"/>
           <p:nvPr/>
         </p:nvSpPr>
@@ -16807,7 +17277,7 @@
       </p:sp>
       <p:pic>
         <p:nvPicPr>
-          <p:cNvPr id="217" name="Google Shape;217;p14"/>
+          <p:cNvPr id="218" name="Google Shape;218;p14"/>
           <p:cNvPicPr preferRelativeResize="0"/>
           <p:nvPr/>
         </p:nvPicPr>
@@ -16834,7 +17304,7 @@
       </p:pic>
       <p:pic>
         <p:nvPicPr>
-          <p:cNvPr id="218" name="Google Shape;218;p14"/>
+          <p:cNvPr id="219" name="Google Shape;219;p14"/>
           <p:cNvPicPr preferRelativeResize="0"/>
           <p:nvPr/>
         </p:nvPicPr>
@@ -16862,7 +17332,7 @@
       </p:pic>
       <p:sp>
         <p:nvSpPr>
-          <p:cNvPr id="219" name="Google Shape;219;p14"/>
+          <p:cNvPr id="220" name="Google Shape;220;p14"/>
           <p:cNvSpPr txBox="1"/>
           <p:nvPr/>
         </p:nvSpPr>
@@ -16987,7 +17457,7 @@
   <p:cSld>
     <p:spTree>
       <p:nvGrpSpPr>
-        <p:cNvPr id="224" name="Shape 224"/>
+        <p:cNvPr id="225" name="Shape 225"/>
         <p:cNvGrpSpPr/>
         <p:nvPr/>
       </p:nvGrpSpPr>
@@ -17001,7 +17471,7 @@
       </p:grpSpPr>
       <p:sp>
         <p:nvSpPr>
-          <p:cNvPr id="225" name="Google Shape;225;g3ad6459f57e_0_0"/>
+          <p:cNvPr id="226" name="Google Shape;226;g3ad6459f57e_0_0"/>
           <p:cNvSpPr txBox="1"/>
           <p:nvPr/>
         </p:nvSpPr>
@@ -17051,7 +17521,7 @@
       </p:sp>
       <p:pic>
         <p:nvPicPr>
-          <p:cNvPr id="226" name="Google Shape;226;g3ad6459f57e_0_0"/>
+          <p:cNvPr id="227" name="Google Shape;227;g3ad6459f57e_0_0"/>
           <p:cNvPicPr preferRelativeResize="0"/>
           <p:nvPr/>
         </p:nvPicPr>
@@ -17078,7 +17548,7 @@
       </p:pic>
       <p:sp>
         <p:nvSpPr>
-          <p:cNvPr id="227" name="Google Shape;227;g3ad6459f57e_0_0"/>
+          <p:cNvPr id="228" name="Google Shape;228;g3ad6459f57e_0_0"/>
           <p:cNvSpPr txBox="1"/>
           <p:nvPr/>
         </p:nvSpPr>
@@ -17136,7 +17606,7 @@
       </p:sp>
       <p:pic>
         <p:nvPicPr>
-          <p:cNvPr id="228" name="Google Shape;228;g3ad6459f57e_0_0"/>
+          <p:cNvPr id="229" name="Google Shape;229;g3ad6459f57e_0_0"/>
           <p:cNvPicPr preferRelativeResize="0"/>
           <p:nvPr/>
         </p:nvPicPr>
@@ -17164,7 +17634,7 @@
       </p:pic>
       <p:pic>
         <p:nvPicPr>
-          <p:cNvPr id="229" name="Google Shape;229;g3ad6459f57e_0_0"/>
+          <p:cNvPr id="230" name="Google Shape;230;g3ad6459f57e_0_0"/>
           <p:cNvPicPr preferRelativeResize="0"/>
           <p:nvPr/>
         </p:nvPicPr>
@@ -17203,7 +17673,7 @@
   <p:cSld>
     <p:spTree>
       <p:nvGrpSpPr>
-        <p:cNvPr id="234" name="Shape 234"/>
+        <p:cNvPr id="235" name="Shape 235"/>
         <p:cNvGrpSpPr/>
         <p:nvPr/>
       </p:nvGrpSpPr>
@@ -17217,7 +17687,7 @@
       </p:grpSpPr>
       <p:sp>
         <p:nvSpPr>
-          <p:cNvPr id="235" name="Google Shape;235;g3a9b731e4a8_0_31"/>
+          <p:cNvPr id="236" name="Google Shape;236;g3a9b731e4a8_0_31"/>
           <p:cNvSpPr txBox="1"/>
           <p:nvPr/>
         </p:nvSpPr>
@@ -17267,7 +17737,7 @@
       </p:sp>
       <p:pic>
         <p:nvPicPr>
-          <p:cNvPr id="236" name="Google Shape;236;g3a9b731e4a8_0_31"/>
+          <p:cNvPr id="237" name="Google Shape;237;g3a9b731e4a8_0_31"/>
           <p:cNvPicPr preferRelativeResize="0"/>
           <p:nvPr/>
         </p:nvPicPr>
@@ -17294,7 +17764,7 @@
       </p:pic>
       <p:pic>
         <p:nvPicPr>
-          <p:cNvPr id="237" name="Google Shape;237;g3a9b731e4a8_0_31"/>
+          <p:cNvPr id="238" name="Google Shape;238;g3a9b731e4a8_0_31"/>
           <p:cNvPicPr preferRelativeResize="0"/>
           <p:nvPr/>
         </p:nvPicPr>
@@ -17322,7 +17792,7 @@
       </p:pic>
       <p:sp>
         <p:nvSpPr>
-          <p:cNvPr id="238" name="Google Shape;238;g3a9b731e4a8_0_31"/>
+          <p:cNvPr id="239" name="Google Shape;239;g3a9b731e4a8_0_31"/>
           <p:cNvSpPr txBox="1"/>
           <p:nvPr/>
         </p:nvSpPr>
@@ -17423,7 +17893,7 @@
   <p:cSld>
     <p:spTree>
       <p:nvGrpSpPr>
-        <p:cNvPr id="243" name="Shape 243"/>
+        <p:cNvPr id="244" name="Shape 244"/>
         <p:cNvGrpSpPr/>
         <p:nvPr/>
       </p:nvGrpSpPr>
@@ -17437,7 +17907,7 @@
       </p:grpSpPr>
       <p:sp>
         <p:nvSpPr>
-          <p:cNvPr id="244" name="Google Shape;244;g3a9b731e4a8_0_40"/>
+          <p:cNvPr id="245" name="Google Shape;245;g3a9b731e4a8_0_40"/>
           <p:cNvSpPr txBox="1"/>
           <p:nvPr/>
         </p:nvSpPr>
@@ -17487,7 +17957,7 @@
       </p:sp>
       <p:pic>
         <p:nvPicPr>
-          <p:cNvPr id="245" name="Google Shape;245;g3a9b731e4a8_0_40"/>
+          <p:cNvPr id="246" name="Google Shape;246;g3a9b731e4a8_0_40"/>
           <p:cNvPicPr preferRelativeResize="0"/>
           <p:nvPr/>
         </p:nvPicPr>
@@ -17514,7 +17984,7 @@
       </p:pic>
       <p:pic>
         <p:nvPicPr>
-          <p:cNvPr id="246" name="Google Shape;246;g3a9b731e4a8_0_40"/>
+          <p:cNvPr id="247" name="Google Shape;247;g3a9b731e4a8_0_40"/>
           <p:cNvPicPr preferRelativeResize="0"/>
           <p:nvPr/>
         </p:nvPicPr>
@@ -17542,7 +18012,7 @@
       </p:pic>
       <p:sp>
         <p:nvSpPr>
-          <p:cNvPr id="247" name="Google Shape;247;g3a9b731e4a8_0_40"/>
+          <p:cNvPr id="248" name="Google Shape;248;g3a9b731e4a8_0_40"/>
           <p:cNvSpPr txBox="1"/>
           <p:nvPr/>
         </p:nvSpPr>
@@ -17611,7 +18081,7 @@
   <p:cSld>
     <p:spTree>
       <p:nvGrpSpPr>
-        <p:cNvPr id="96" name="Shape 96"/>
+        <p:cNvPr id="97" name="Shape 97"/>
         <p:cNvGrpSpPr/>
         <p:nvPr/>
       </p:nvGrpSpPr>
@@ -17625,7 +18095,7 @@
       </p:grpSpPr>
       <p:sp>
         <p:nvSpPr>
-          <p:cNvPr id="97" name="Google Shape;97;p1"/>
+          <p:cNvPr id="98" name="Google Shape;98;p1"/>
           <p:cNvSpPr txBox="1"/>
           <p:nvPr/>
         </p:nvSpPr>
@@ -17698,7 +18168,7 @@
       </p:sp>
       <p:pic>
         <p:nvPicPr>
-          <p:cNvPr id="98" name="Google Shape;98;p1"/>
+          <p:cNvPr id="99" name="Google Shape;99;p1"/>
           <p:cNvPicPr preferRelativeResize="0"/>
           <p:nvPr/>
         </p:nvPicPr>
@@ -17725,7 +18195,7 @@
       </p:pic>
       <p:sp>
         <p:nvSpPr>
-          <p:cNvPr id="99" name="Google Shape;99;p1"/>
+          <p:cNvPr id="100" name="Google Shape;100;p1"/>
           <p:cNvSpPr txBox="1"/>
           <p:nvPr/>
         </p:nvSpPr>
@@ -17775,7 +18245,7 @@
       </p:sp>
       <p:sp>
         <p:nvSpPr>
-          <p:cNvPr id="100" name="Google Shape;100;p1"/>
+          <p:cNvPr id="101" name="Google Shape;101;p1"/>
           <p:cNvSpPr txBox="1"/>
           <p:nvPr/>
         </p:nvSpPr>
@@ -18052,7 +18522,7 @@
   <p:cSld>
     <p:spTree>
       <p:nvGrpSpPr>
-        <p:cNvPr id="252" name="Shape 252"/>
+        <p:cNvPr id="253" name="Shape 253"/>
         <p:cNvGrpSpPr/>
         <p:nvPr/>
       </p:nvGrpSpPr>
@@ -18066,7 +18536,7 @@
       </p:grpSpPr>
       <p:sp>
         <p:nvSpPr>
-          <p:cNvPr id="253" name="Google Shape;253;g38660da28e9_0_0"/>
+          <p:cNvPr id="254" name="Google Shape;254;g38660da28e9_0_0"/>
           <p:cNvSpPr txBox="1"/>
           <p:nvPr/>
         </p:nvSpPr>
@@ -18116,7 +18586,7 @@
       </p:sp>
       <p:pic>
         <p:nvPicPr>
-          <p:cNvPr id="254" name="Google Shape;254;g38660da28e9_0_0"/>
+          <p:cNvPr id="255" name="Google Shape;255;g38660da28e9_0_0"/>
           <p:cNvPicPr preferRelativeResize="0"/>
           <p:nvPr/>
         </p:nvPicPr>
@@ -18143,7 +18613,7 @@
       </p:pic>
       <p:sp>
         <p:nvSpPr>
-          <p:cNvPr id="255" name="Google Shape;255;g38660da28e9_0_0"/>
+          <p:cNvPr id="256" name="Google Shape;256;g38660da28e9_0_0"/>
           <p:cNvSpPr txBox="1"/>
           <p:nvPr/>
         </p:nvSpPr>
@@ -18296,7 +18766,7 @@
       </p:sp>
       <p:sp>
         <p:nvSpPr>
-          <p:cNvPr id="256" name="Google Shape;256;g38660da28e9_0_0"/>
+          <p:cNvPr id="257" name="Google Shape;257;g38660da28e9_0_0"/>
           <p:cNvSpPr txBox="1"/>
           <p:nvPr/>
         </p:nvSpPr>
@@ -18510,7 +18980,7 @@
   <p:cSld>
     <p:spTree>
       <p:nvGrpSpPr>
-        <p:cNvPr id="261" name="Shape 261"/>
+        <p:cNvPr id="262" name="Shape 262"/>
         <p:cNvGrpSpPr/>
         <p:nvPr/>
       </p:nvGrpSpPr>
@@ -18524,7 +18994,7 @@
       </p:grpSpPr>
       <p:sp>
         <p:nvSpPr>
-          <p:cNvPr id="262" name="Google Shape;262;g39a291deda2_1_0"/>
+          <p:cNvPr id="263" name="Google Shape;263;g39a291deda2_1_0"/>
           <p:cNvSpPr txBox="1"/>
           <p:nvPr/>
         </p:nvSpPr>
@@ -18574,7 +19044,7 @@
       </p:sp>
       <p:pic>
         <p:nvPicPr>
-          <p:cNvPr id="263" name="Google Shape;263;g39a291deda2_1_0"/>
+          <p:cNvPr id="264" name="Google Shape;264;g39a291deda2_1_0"/>
           <p:cNvPicPr preferRelativeResize="0"/>
           <p:nvPr/>
         </p:nvPicPr>
@@ -18601,7 +19071,7 @@
       </p:pic>
       <p:sp>
         <p:nvSpPr>
-          <p:cNvPr id="264" name="Google Shape;264;g39a291deda2_1_0"/>
+          <p:cNvPr id="265" name="Google Shape;265;g39a291deda2_1_0"/>
           <p:cNvSpPr txBox="1"/>
           <p:nvPr/>
         </p:nvSpPr>
@@ -18659,7 +19129,7 @@
       </p:sp>
       <p:sp>
         <p:nvSpPr>
-          <p:cNvPr id="265" name="Google Shape;265;g39a291deda2_1_0"/>
+          <p:cNvPr id="266" name="Google Shape;266;g39a291deda2_1_0"/>
           <p:cNvSpPr txBox="1"/>
           <p:nvPr/>
         </p:nvSpPr>
@@ -18791,7 +19261,7 @@
   <p:cSld>
     <p:spTree>
       <p:nvGrpSpPr>
-        <p:cNvPr id="270" name="Shape 270"/>
+        <p:cNvPr id="271" name="Shape 271"/>
         <p:cNvGrpSpPr/>
         <p:nvPr/>
       </p:nvGrpSpPr>
@@ -18805,7 +19275,7 @@
       </p:grpSpPr>
       <p:sp>
         <p:nvSpPr>
-          <p:cNvPr id="271" name="Google Shape;271;g39a291deda2_1_14"/>
+          <p:cNvPr id="272" name="Google Shape;272;g39a291deda2_1_14"/>
           <p:cNvSpPr txBox="1"/>
           <p:nvPr/>
         </p:nvSpPr>
@@ -18855,7 +19325,7 @@
       </p:sp>
       <p:pic>
         <p:nvPicPr>
-          <p:cNvPr id="272" name="Google Shape;272;g39a291deda2_1_14"/>
+          <p:cNvPr id="273" name="Google Shape;273;g39a291deda2_1_14"/>
           <p:cNvPicPr preferRelativeResize="0"/>
           <p:nvPr/>
         </p:nvPicPr>
@@ -18882,7 +19352,7 @@
       </p:pic>
       <p:sp>
         <p:nvSpPr>
-          <p:cNvPr id="273" name="Google Shape;273;g39a291deda2_1_14"/>
+          <p:cNvPr id="274" name="Google Shape;274;g39a291deda2_1_14"/>
           <p:cNvSpPr txBox="1"/>
           <p:nvPr/>
         </p:nvSpPr>
@@ -18940,7 +19410,7 @@
       </p:sp>
       <p:sp>
         <p:nvSpPr>
-          <p:cNvPr id="274" name="Google Shape;274;g39a291deda2_1_14"/>
+          <p:cNvPr id="275" name="Google Shape;275;g39a291deda2_1_14"/>
           <p:cNvSpPr txBox="1"/>
           <p:nvPr/>
         </p:nvSpPr>
@@ -19092,7 +19562,7 @@
   <p:cSld>
     <p:spTree>
       <p:nvGrpSpPr>
-        <p:cNvPr id="279" name="Shape 279"/>
+        <p:cNvPr id="280" name="Shape 280"/>
         <p:cNvGrpSpPr/>
         <p:nvPr/>
       </p:nvGrpSpPr>
@@ -19106,7 +19576,7 @@
       </p:grpSpPr>
       <p:sp>
         <p:nvSpPr>
-          <p:cNvPr id="280" name="Google Shape;280;g39a291deda2_1_23"/>
+          <p:cNvPr id="281" name="Google Shape;281;g39a291deda2_1_23"/>
           <p:cNvSpPr txBox="1"/>
           <p:nvPr/>
         </p:nvSpPr>
@@ -19156,7 +19626,7 @@
       </p:sp>
       <p:pic>
         <p:nvPicPr>
-          <p:cNvPr id="281" name="Google Shape;281;g39a291deda2_1_23"/>
+          <p:cNvPr id="282" name="Google Shape;282;g39a291deda2_1_23"/>
           <p:cNvPicPr preferRelativeResize="0"/>
           <p:nvPr/>
         </p:nvPicPr>
@@ -19183,7 +19653,7 @@
       </p:pic>
       <p:sp>
         <p:nvSpPr>
-          <p:cNvPr id="282" name="Google Shape;282;g39a291deda2_1_23"/>
+          <p:cNvPr id="283" name="Google Shape;283;g39a291deda2_1_23"/>
           <p:cNvSpPr txBox="1"/>
           <p:nvPr/>
         </p:nvSpPr>
@@ -19241,7 +19711,7 @@
       </p:sp>
       <p:sp>
         <p:nvSpPr>
-          <p:cNvPr id="283" name="Google Shape;283;g39a291deda2_1_23"/>
+          <p:cNvPr id="284" name="Google Shape;284;g39a291deda2_1_23"/>
           <p:cNvSpPr txBox="1"/>
           <p:nvPr/>
         </p:nvSpPr>
@@ -19330,7 +19800,7 @@
       </p:sp>
       <p:sp>
         <p:nvSpPr>
-          <p:cNvPr id="284" name="Google Shape;284;g39a291deda2_1_23"/>
+          <p:cNvPr id="285" name="Google Shape;285;g39a291deda2_1_23"/>
           <p:cNvSpPr txBox="1"/>
           <p:nvPr/>
         </p:nvSpPr>
@@ -19376,7 +19846,7 @@
       </p:sp>
       <p:sp>
         <p:nvSpPr>
-          <p:cNvPr id="285" name="Google Shape;285;g39a291deda2_1_23"/>
+          <p:cNvPr id="286" name="Google Shape;286;g39a291deda2_1_23"/>
           <p:cNvSpPr txBox="1"/>
           <p:nvPr/>
         </p:nvSpPr>
@@ -19437,7 +19907,7 @@
   <p:cSld>
     <p:spTree>
       <p:nvGrpSpPr>
-        <p:cNvPr id="290" name="Shape 290"/>
+        <p:cNvPr id="291" name="Shape 291"/>
         <p:cNvGrpSpPr/>
         <p:nvPr/>
       </p:nvGrpSpPr>
@@ -19451,7 +19921,7 @@
       </p:grpSpPr>
       <p:sp>
         <p:nvSpPr>
-          <p:cNvPr id="291" name="Google Shape;291;g39a291deda2_1_39"/>
+          <p:cNvPr id="292" name="Google Shape;292;g39a291deda2_1_39"/>
           <p:cNvSpPr txBox="1"/>
           <p:nvPr/>
         </p:nvSpPr>
@@ -19501,7 +19971,7 @@
       </p:sp>
       <p:pic>
         <p:nvPicPr>
-          <p:cNvPr id="292" name="Google Shape;292;g39a291deda2_1_39"/>
+          <p:cNvPr id="293" name="Google Shape;293;g39a291deda2_1_39"/>
           <p:cNvPicPr preferRelativeResize="0"/>
           <p:nvPr/>
         </p:nvPicPr>
@@ -19528,7 +19998,7 @@
       </p:pic>
       <p:pic>
         <p:nvPicPr>
-          <p:cNvPr id="293" name="Google Shape;293;g39a291deda2_1_39"/>
+          <p:cNvPr id="294" name="Google Shape;294;g39a291deda2_1_39"/>
           <p:cNvPicPr preferRelativeResize="0"/>
           <p:nvPr/>
         </p:nvPicPr>
@@ -19556,7 +20026,7 @@
       </p:pic>
       <p:sp>
         <p:nvSpPr>
-          <p:cNvPr id="294" name="Google Shape;294;g39a291deda2_1_39"/>
+          <p:cNvPr id="295" name="Google Shape;295;g39a291deda2_1_39"/>
           <p:cNvSpPr txBox="1"/>
           <p:nvPr/>
         </p:nvSpPr>
@@ -19715,7 +20185,7 @@
       </p:sp>
       <p:pic>
         <p:nvPicPr>
-          <p:cNvPr id="295" name="Google Shape;295;g39a291deda2_1_39"/>
+          <p:cNvPr id="296" name="Google Shape;296;g39a291deda2_1_39"/>
           <p:cNvPicPr preferRelativeResize="0"/>
           <p:nvPr/>
         </p:nvPicPr>
@@ -19754,7 +20224,7 @@
   <p:cSld>
     <p:spTree>
       <p:nvGrpSpPr>
-        <p:cNvPr id="300" name="Shape 300"/>
+        <p:cNvPr id="301" name="Shape 301"/>
         <p:cNvGrpSpPr/>
         <p:nvPr/>
       </p:nvGrpSpPr>
@@ -19768,7 +20238,7 @@
       </p:grpSpPr>
       <p:sp>
         <p:nvSpPr>
-          <p:cNvPr id="301" name="Google Shape;301;g39a291deda2_1_50"/>
+          <p:cNvPr id="302" name="Google Shape;302;g39a291deda2_1_50"/>
           <p:cNvSpPr txBox="1"/>
           <p:nvPr/>
         </p:nvSpPr>
@@ -19818,7 +20288,7 @@
       </p:sp>
       <p:pic>
         <p:nvPicPr>
-          <p:cNvPr id="302" name="Google Shape;302;g39a291deda2_1_50"/>
+          <p:cNvPr id="303" name="Google Shape;303;g39a291deda2_1_50"/>
           <p:cNvPicPr preferRelativeResize="0"/>
           <p:nvPr/>
         </p:nvPicPr>
@@ -19845,7 +20315,7 @@
       </p:pic>
       <p:pic>
         <p:nvPicPr>
-          <p:cNvPr id="303" name="Google Shape;303;g39a291deda2_1_50"/>
+          <p:cNvPr id="304" name="Google Shape;304;g39a291deda2_1_50"/>
           <p:cNvPicPr preferRelativeResize="0"/>
           <p:nvPr/>
         </p:nvPicPr>
@@ -19873,7 +20343,7 @@
       </p:pic>
       <p:sp>
         <p:nvSpPr>
-          <p:cNvPr id="304" name="Google Shape;304;g39a291deda2_1_50"/>
+          <p:cNvPr id="305" name="Google Shape;305;g39a291deda2_1_50"/>
           <p:cNvSpPr txBox="1"/>
           <p:nvPr/>
         </p:nvSpPr>
@@ -19926,7 +20396,7 @@
   <p:cSld>
     <p:spTree>
       <p:nvGrpSpPr>
-        <p:cNvPr id="309" name="Shape 309"/>
+        <p:cNvPr id="310" name="Shape 310"/>
         <p:cNvGrpSpPr/>
         <p:nvPr/>
       </p:nvGrpSpPr>
@@ -19940,7 +20410,7 @@
       </p:grpSpPr>
       <p:pic>
         <p:nvPicPr>
-          <p:cNvPr id="310" name="Google Shape;310;g3aa6201ac61_0_0"/>
+          <p:cNvPr id="311" name="Google Shape;311;g3aa6201ac61_0_0"/>
           <p:cNvPicPr preferRelativeResize="0"/>
           <p:nvPr/>
         </p:nvPicPr>
@@ -19968,7 +20438,7 @@
       </p:pic>
       <p:sp>
         <p:nvSpPr>
-          <p:cNvPr id="311" name="Google Shape;311;g3aa6201ac61_0_0"/>
+          <p:cNvPr id="312" name="Google Shape;312;g3aa6201ac61_0_0"/>
           <p:cNvSpPr txBox="1"/>
           <p:nvPr/>
         </p:nvSpPr>
@@ -20017,7 +20487,7 @@
       </p:sp>
       <p:sp>
         <p:nvSpPr>
-          <p:cNvPr id="312" name="Google Shape;312;g3aa6201ac61_0_0"/>
+          <p:cNvPr id="313" name="Google Shape;313;g3aa6201ac61_0_0"/>
           <p:cNvSpPr txBox="1"/>
           <p:nvPr/>
         </p:nvSpPr>
@@ -20344,7 +20814,7 @@
       </p:sp>
       <p:pic>
         <p:nvPicPr>
-          <p:cNvPr id="313" name="Google Shape;313;g3aa6201ac61_0_0"/>
+          <p:cNvPr id="314" name="Google Shape;314;g3aa6201ac61_0_0"/>
           <p:cNvPicPr preferRelativeResize="0"/>
           <p:nvPr/>
         </p:nvPicPr>
@@ -20383,7 +20853,7 @@
   <p:cSld>
     <p:spTree>
       <p:nvGrpSpPr>
-        <p:cNvPr id="318" name="Shape 318"/>
+        <p:cNvPr id="319" name="Shape 319"/>
         <p:cNvGrpSpPr/>
         <p:nvPr/>
       </p:nvGrpSpPr>
@@ -20397,7 +20867,7 @@
       </p:grpSpPr>
       <p:pic>
         <p:nvPicPr>
-          <p:cNvPr id="319" name="Google Shape;319;g3aa6201ac61_0_6"/>
+          <p:cNvPr id="320" name="Google Shape;320;g3aa6201ac61_0_6"/>
           <p:cNvPicPr preferRelativeResize="0"/>
           <p:nvPr/>
         </p:nvPicPr>
@@ -20425,7 +20895,7 @@
       </p:pic>
       <p:pic>
         <p:nvPicPr>
-          <p:cNvPr id="320" name="Google Shape;320;g3aa6201ac61_0_6"/>
+          <p:cNvPr id="321" name="Google Shape;321;g3aa6201ac61_0_6"/>
           <p:cNvPicPr preferRelativeResize="0"/>
           <p:nvPr/>
         </p:nvPicPr>
@@ -20453,7 +20923,7 @@
       </p:pic>
       <p:sp>
         <p:nvSpPr>
-          <p:cNvPr id="321" name="Google Shape;321;g3aa6201ac61_0_6"/>
+          <p:cNvPr id="322" name="Google Shape;322;g3aa6201ac61_0_6"/>
           <p:cNvSpPr txBox="1"/>
           <p:nvPr/>
         </p:nvSpPr>
@@ -20522,7 +20992,7 @@
   <p:cSld>
     <p:spTree>
       <p:nvGrpSpPr>
-        <p:cNvPr id="326" name="Shape 326"/>
+        <p:cNvPr id="327" name="Shape 327"/>
         <p:cNvGrpSpPr/>
         <p:nvPr/>
       </p:nvGrpSpPr>
@@ -20536,7 +21006,7 @@
       </p:grpSpPr>
       <p:pic>
         <p:nvPicPr>
-          <p:cNvPr id="327" name="Google Shape;327;g3ac9e9082d3_0_11"/>
+          <p:cNvPr id="328" name="Google Shape;328;g3ac9e9082d3_0_11"/>
           <p:cNvPicPr preferRelativeResize="0"/>
           <p:nvPr/>
         </p:nvPicPr>
@@ -20564,7 +21034,7 @@
       </p:pic>
       <p:sp>
         <p:nvSpPr>
-          <p:cNvPr id="328" name="Google Shape;328;g3ac9e9082d3_0_11"/>
+          <p:cNvPr id="329" name="Google Shape;329;g3ac9e9082d3_0_11"/>
           <p:cNvSpPr txBox="1"/>
           <p:nvPr/>
         </p:nvSpPr>
@@ -20622,7 +21092,7 @@
       </p:sp>
       <p:sp>
         <p:nvSpPr>
-          <p:cNvPr id="329" name="Google Shape;329;g3ac9e9082d3_0_11"/>
+          <p:cNvPr id="330" name="Google Shape;330;g3ac9e9082d3_0_11"/>
           <p:cNvSpPr txBox="1"/>
           <p:nvPr/>
         </p:nvSpPr>
@@ -20696,7 +21166,7 @@
       </p:sp>
       <p:sp>
         <p:nvSpPr>
-          <p:cNvPr id="330" name="Google Shape;330;g3ac9e9082d3_0_11"/>
+          <p:cNvPr id="331" name="Google Shape;331;g3ac9e9082d3_0_11"/>
           <p:cNvSpPr txBox="1"/>
           <p:nvPr/>
         </p:nvSpPr>
@@ -20765,7 +21235,7 @@
   <p:cSld>
     <p:spTree>
       <p:nvGrpSpPr>
-        <p:cNvPr id="335" name="Shape 335"/>
+        <p:cNvPr id="336" name="Shape 336"/>
         <p:cNvGrpSpPr/>
         <p:nvPr/>
       </p:nvGrpSpPr>
@@ -20779,7 +21249,7 @@
       </p:grpSpPr>
       <p:pic>
         <p:nvPicPr>
-          <p:cNvPr id="336" name="Google Shape;336;g3ac9e796f79_0_0"/>
+          <p:cNvPr id="337" name="Google Shape;337;g3ac9e796f79_0_0"/>
           <p:cNvPicPr preferRelativeResize="0"/>
           <p:nvPr/>
         </p:nvPicPr>
@@ -20807,7 +21277,7 @@
       </p:pic>
       <p:sp>
         <p:nvSpPr>
-          <p:cNvPr id="337" name="Google Shape;337;g3ac9e796f79_0_0"/>
+          <p:cNvPr id="338" name="Google Shape;338;g3ac9e796f79_0_0"/>
           <p:cNvSpPr txBox="1"/>
           <p:nvPr/>
         </p:nvSpPr>
@@ -21108,7 +21578,7 @@
   <p:cSld>
     <p:spTree>
       <p:nvGrpSpPr>
-        <p:cNvPr id="104" name="Shape 104"/>
+        <p:cNvPr id="105" name="Shape 105"/>
         <p:cNvGrpSpPr/>
         <p:nvPr/>
       </p:nvGrpSpPr>
@@ -21122,7 +21592,7 @@
       </p:grpSpPr>
       <p:sp>
         <p:nvSpPr>
-          <p:cNvPr id="105" name="Google Shape;105;p2"/>
+          <p:cNvPr id="106" name="Google Shape;106;p2"/>
           <p:cNvSpPr txBox="1"/>
           <p:nvPr/>
         </p:nvSpPr>
@@ -21171,7 +21641,7 @@
       </p:sp>
       <p:sp>
         <p:nvSpPr>
-          <p:cNvPr id="106" name="Google Shape;106;p2"/>
+          <p:cNvPr id="107" name="Google Shape;107;p2"/>
           <p:cNvSpPr txBox="1"/>
           <p:nvPr/>
         </p:nvSpPr>
@@ -21221,7 +21691,7 @@
       </p:sp>
       <p:pic>
         <p:nvPicPr>
-          <p:cNvPr id="107" name="Google Shape;107;p2"/>
+          <p:cNvPr id="108" name="Google Shape;108;p2"/>
           <p:cNvPicPr preferRelativeResize="0"/>
           <p:nvPr/>
         </p:nvPicPr>
@@ -21248,7 +21718,7 @@
       </p:pic>
       <p:pic>
         <p:nvPicPr>
-          <p:cNvPr id="108" name="Google Shape;108;p2"/>
+          <p:cNvPr id="109" name="Google Shape;109;p2"/>
           <p:cNvPicPr preferRelativeResize="0"/>
           <p:nvPr/>
         </p:nvPicPr>
@@ -21276,7 +21746,7 @@
       </p:pic>
       <p:sp>
         <p:nvSpPr>
-          <p:cNvPr id="109" name="Google Shape;109;p2"/>
+          <p:cNvPr id="110" name="Google Shape;110;p2"/>
           <p:cNvSpPr txBox="1"/>
           <p:nvPr/>
         </p:nvSpPr>
@@ -21362,7 +21832,7 @@
   <p:cSld>
     <p:spTree>
       <p:nvGrpSpPr>
-        <p:cNvPr id="342" name="Shape 342"/>
+        <p:cNvPr id="343" name="Shape 343"/>
         <p:cNvGrpSpPr/>
         <p:nvPr/>
       </p:nvGrpSpPr>
@@ -21376,7 +21846,7 @@
       </p:grpSpPr>
       <p:pic>
         <p:nvPicPr>
-          <p:cNvPr id="343" name="Google Shape;343;g3aa6201ac61_0_12"/>
+          <p:cNvPr id="344" name="Google Shape;344;g3ad6459f57e_1_3"/>
           <p:cNvPicPr preferRelativeResize="0"/>
           <p:nvPr/>
         </p:nvPicPr>
@@ -21404,7 +21874,7 @@
       </p:pic>
       <p:pic>
         <p:nvPicPr>
-          <p:cNvPr id="344" name="Google Shape;344;g3aa6201ac61_0_12"/>
+          <p:cNvPr id="345" name="Google Shape;345;g3ad6459f57e_1_3"/>
           <p:cNvPicPr preferRelativeResize="0"/>
           <p:nvPr/>
         </p:nvPicPr>
@@ -21418,36 +21888,8 @@
         </p:blipFill>
         <p:spPr>
           <a:xfrm>
-            <a:off x="130600" y="3936312"/>
-            <a:ext cx="9143999" cy="685977"/>
-          </a:xfrm>
-          <a:prstGeom prst="rect">
-            <a:avLst/>
-          </a:prstGeom>
-          <a:noFill/>
-          <a:ln>
-            <a:noFill/>
-          </a:ln>
-        </p:spPr>
-      </p:pic>
-      <p:pic>
-        <p:nvPicPr>
-          <p:cNvPr id="345" name="Google Shape;345;g3aa6201ac61_0_12"/>
-          <p:cNvPicPr preferRelativeResize="0"/>
-          <p:nvPr/>
-        </p:nvPicPr>
-        <p:blipFill>
-          <a:blip r:embed="rId5">
-            <a:alphaModFix/>
-          </a:blip>
-          <a:stretch>
-            <a:fillRect/>
-          </a:stretch>
-        </p:blipFill>
-        <p:spPr>
-          <a:xfrm>
-            <a:off x="2773375" y="954185"/>
-            <a:ext cx="3750579" cy="2718978"/>
+            <a:off x="2158125" y="1163385"/>
+            <a:ext cx="5781675" cy="2943225"/>
           </a:xfrm>
           <a:prstGeom prst="rect">
             <a:avLst/>
@@ -21485,7 +21927,7 @@
       </p:grpSpPr>
       <p:pic>
         <p:nvPicPr>
-          <p:cNvPr id="351" name="Google Shape;351;g3ac9e796f79_0_6"/>
+          <p:cNvPr id="351" name="Google Shape;351;g3aa6201ac61_0_12"/>
           <p:cNvPicPr preferRelativeResize="0"/>
           <p:nvPr/>
         </p:nvPicPr>
@@ -21511,9 +21953,118 @@
           </a:ln>
         </p:spPr>
       </p:pic>
+      <p:pic>
+        <p:nvPicPr>
+          <p:cNvPr id="352" name="Google Shape;352;g3aa6201ac61_0_12"/>
+          <p:cNvPicPr preferRelativeResize="0"/>
+          <p:nvPr/>
+        </p:nvPicPr>
+        <p:blipFill>
+          <a:blip r:embed="rId4">
+            <a:alphaModFix/>
+          </a:blip>
+          <a:stretch>
+            <a:fillRect/>
+          </a:stretch>
+        </p:blipFill>
+        <p:spPr>
+          <a:xfrm>
+            <a:off x="130600" y="3936312"/>
+            <a:ext cx="9143999" cy="685977"/>
+          </a:xfrm>
+          <a:prstGeom prst="rect">
+            <a:avLst/>
+          </a:prstGeom>
+          <a:noFill/>
+          <a:ln>
+            <a:noFill/>
+          </a:ln>
+        </p:spPr>
+      </p:pic>
+      <p:pic>
+        <p:nvPicPr>
+          <p:cNvPr id="353" name="Google Shape;353;g3aa6201ac61_0_12"/>
+          <p:cNvPicPr preferRelativeResize="0"/>
+          <p:nvPr/>
+        </p:nvPicPr>
+        <p:blipFill>
+          <a:blip r:embed="rId5">
+            <a:alphaModFix/>
+          </a:blip>
+          <a:stretch>
+            <a:fillRect/>
+          </a:stretch>
+        </p:blipFill>
+        <p:spPr>
+          <a:xfrm>
+            <a:off x="2773375" y="954185"/>
+            <a:ext cx="3750579" cy="2718978"/>
+          </a:xfrm>
+          <a:prstGeom prst="rect">
+            <a:avLst/>
+          </a:prstGeom>
+          <a:noFill/>
+          <a:ln>
+            <a:noFill/>
+          </a:ln>
+        </p:spPr>
+      </p:pic>
+    </p:spTree>
+  </p:cSld>
+  <p:clrMapOvr>
+    <a:masterClrMapping/>
+  </p:clrMapOvr>
+</p:sld>
+</file>
+
+<file path=ppt/slides/slide32.xml><?xml version="1.0" encoding="utf-8"?>
+<p:sld xmlns:a="http://schemas.openxmlformats.org/drawingml/2006/main" xmlns:r="http://schemas.openxmlformats.org/officeDocument/2006/relationships" xmlns:mc="http://schemas.openxmlformats.org/markup-compatibility/2006" xmlns:mv="urn:schemas-microsoft-com:mac:vml" xmlns:p="http://schemas.openxmlformats.org/presentationml/2006/main" xmlns:c="http://schemas.openxmlformats.org/drawingml/2006/chart" xmlns:dgm="http://schemas.openxmlformats.org/drawingml/2006/diagram" xmlns:o="urn:schemas-microsoft-com:office:office" xmlns:v="urn:schemas-microsoft-com:vml" xmlns:pvml="urn:schemas-microsoft-com:office:powerpoint" xmlns:com="http://schemas.openxmlformats.org/drawingml/2006/compatibility" xmlns:p14="http://schemas.microsoft.com/office/powerpoint/2010/main" xmlns:p15="http://schemas.microsoft.com/office/powerpoint/2012/main" xmlns:ahyp="http://schemas.microsoft.com/office/drawing/2018/hyperlinkcolor">
+  <p:cSld>
+    <p:spTree>
+      <p:nvGrpSpPr>
+        <p:cNvPr id="358" name="Shape 358"/>
+        <p:cNvGrpSpPr/>
+        <p:nvPr/>
+      </p:nvGrpSpPr>
+      <p:grpSpPr>
+        <a:xfrm>
+          <a:off x="0" y="0"/>
+          <a:ext cx="0" cy="0"/>
+          <a:chOff x="0" y="0"/>
+          <a:chExt cx="0" cy="0"/>
+        </a:xfrm>
+      </p:grpSpPr>
+      <p:pic>
+        <p:nvPicPr>
+          <p:cNvPr id="359" name="Google Shape;359;g3ac9e796f79_0_6"/>
+          <p:cNvPicPr preferRelativeResize="0"/>
+          <p:nvPr/>
+        </p:nvPicPr>
+        <p:blipFill>
+          <a:blip r:embed="rId3">
+            <a:alphaModFix/>
+          </a:blip>
+          <a:stretch>
+            <a:fillRect/>
+          </a:stretch>
+        </p:blipFill>
+        <p:spPr>
+          <a:xfrm>
+            <a:off x="435400" y="164700"/>
+            <a:ext cx="8839201" cy="907810"/>
+          </a:xfrm>
+          <a:prstGeom prst="rect">
+            <a:avLst/>
+          </a:prstGeom>
+          <a:noFill/>
+          <a:ln>
+            <a:noFill/>
+          </a:ln>
+        </p:spPr>
+      </p:pic>
       <p:sp>
         <p:nvSpPr>
-          <p:cNvPr id="352" name="Google Shape;352;g3ac9e796f79_0_6"/>
+          <p:cNvPr id="360" name="Google Shape;360;g3ac9e796f79_0_6"/>
           <p:cNvSpPr txBox="1"/>
           <p:nvPr/>
         </p:nvSpPr>
@@ -21617,7 +22168,7 @@
       </p:sp>
       <p:pic>
         <p:nvPicPr>
-          <p:cNvPr id="353" name="Google Shape;353;g3ac9e796f79_0_6"/>
+          <p:cNvPr id="361" name="Google Shape;361;g3ac9e796f79_0_6"/>
           <p:cNvPicPr preferRelativeResize="0"/>
           <p:nvPr/>
         </p:nvPicPr>
@@ -21645,7 +22196,7 @@
       </p:pic>
       <p:sp>
         <p:nvSpPr>
-          <p:cNvPr id="354" name="Google Shape;354;g3ac9e796f79_0_6"/>
+          <p:cNvPr id="362" name="Google Shape;362;g3ac9e796f79_0_6"/>
           <p:cNvSpPr txBox="1"/>
           <p:nvPr/>
         </p:nvSpPr>
@@ -21721,115 +22272,6 @@
 </p:sld>
 </file>
 
-<file path=ppt/slides/slide32.xml><?xml version="1.0" encoding="utf-8"?>
-<p:sld xmlns:a="http://schemas.openxmlformats.org/drawingml/2006/main" xmlns:r="http://schemas.openxmlformats.org/officeDocument/2006/relationships" xmlns:mc="http://schemas.openxmlformats.org/markup-compatibility/2006" xmlns:mv="urn:schemas-microsoft-com:mac:vml" xmlns:p="http://schemas.openxmlformats.org/presentationml/2006/main" xmlns:c="http://schemas.openxmlformats.org/drawingml/2006/chart" xmlns:dgm="http://schemas.openxmlformats.org/drawingml/2006/diagram" xmlns:o="urn:schemas-microsoft-com:office:office" xmlns:v="urn:schemas-microsoft-com:vml" xmlns:pvml="urn:schemas-microsoft-com:office:powerpoint" xmlns:com="http://schemas.openxmlformats.org/drawingml/2006/compatibility" xmlns:p14="http://schemas.microsoft.com/office/powerpoint/2010/main" xmlns:p15="http://schemas.microsoft.com/office/powerpoint/2012/main" xmlns:ahyp="http://schemas.microsoft.com/office/drawing/2018/hyperlinkcolor">
-  <p:cSld>
-    <p:spTree>
-      <p:nvGrpSpPr>
-        <p:cNvPr id="359" name="Shape 359"/>
-        <p:cNvGrpSpPr/>
-        <p:nvPr/>
-      </p:nvGrpSpPr>
-      <p:grpSpPr>
-        <a:xfrm>
-          <a:off x="0" y="0"/>
-          <a:ext cx="0" cy="0"/>
-          <a:chOff x="0" y="0"/>
-          <a:chExt cx="0" cy="0"/>
-        </a:xfrm>
-      </p:grpSpPr>
-      <p:pic>
-        <p:nvPicPr>
-          <p:cNvPr id="360" name="Google Shape;360;g3aa6201ac61_0_19"/>
-          <p:cNvPicPr preferRelativeResize="0"/>
-          <p:nvPr/>
-        </p:nvPicPr>
-        <p:blipFill>
-          <a:blip r:embed="rId3">
-            <a:alphaModFix/>
-          </a:blip>
-          <a:stretch>
-            <a:fillRect/>
-          </a:stretch>
-        </p:blipFill>
-        <p:spPr>
-          <a:xfrm>
-            <a:off x="435400" y="164700"/>
-            <a:ext cx="8839201" cy="907810"/>
-          </a:xfrm>
-          <a:prstGeom prst="rect">
-            <a:avLst/>
-          </a:prstGeom>
-          <a:noFill/>
-          <a:ln>
-            <a:noFill/>
-          </a:ln>
-        </p:spPr>
-      </p:pic>
-      <p:pic>
-        <p:nvPicPr>
-          <p:cNvPr id="361" name="Google Shape;361;g3aa6201ac61_0_19"/>
-          <p:cNvPicPr preferRelativeResize="0"/>
-          <p:nvPr/>
-        </p:nvPicPr>
-        <p:blipFill>
-          <a:blip r:embed="rId4">
-            <a:alphaModFix/>
-          </a:blip>
-          <a:stretch>
-            <a:fillRect/>
-          </a:stretch>
-        </p:blipFill>
-        <p:spPr>
-          <a:xfrm>
-            <a:off x="1632925" y="949425"/>
-            <a:ext cx="6615549" cy="3052300"/>
-          </a:xfrm>
-          <a:prstGeom prst="rect">
-            <a:avLst/>
-          </a:prstGeom>
-          <a:noFill/>
-          <a:ln>
-            <a:noFill/>
-          </a:ln>
-        </p:spPr>
-      </p:pic>
-      <p:pic>
-        <p:nvPicPr>
-          <p:cNvPr id="362" name="Google Shape;362;g3aa6201ac61_0_19"/>
-          <p:cNvPicPr preferRelativeResize="0"/>
-          <p:nvPr/>
-        </p:nvPicPr>
-        <p:blipFill>
-          <a:blip r:embed="rId5">
-            <a:alphaModFix/>
-          </a:blip>
-          <a:stretch>
-            <a:fillRect/>
-          </a:stretch>
-        </p:blipFill>
-        <p:spPr>
-          <a:xfrm>
-            <a:off x="1328813" y="4393000"/>
-            <a:ext cx="7667625" cy="590550"/>
-          </a:xfrm>
-          <a:prstGeom prst="rect">
-            <a:avLst/>
-          </a:prstGeom>
-          <a:noFill/>
-          <a:ln>
-            <a:noFill/>
-          </a:ln>
-        </p:spPr>
-      </p:pic>
-    </p:spTree>
-  </p:cSld>
-  <p:clrMapOvr>
-    <a:masterClrMapping/>
-  </p:clrMapOvr>
-</p:sld>
-</file>
-
 <file path=ppt/slides/slide33.xml><?xml version="1.0" encoding="utf-8"?>
 <p:sld xmlns:a="http://schemas.openxmlformats.org/drawingml/2006/main" xmlns:r="http://schemas.openxmlformats.org/officeDocument/2006/relationships" xmlns:mc="http://schemas.openxmlformats.org/markup-compatibility/2006" xmlns:mv="urn:schemas-microsoft-com:mac:vml" xmlns:p="http://schemas.openxmlformats.org/presentationml/2006/main" xmlns:c="http://schemas.openxmlformats.org/drawingml/2006/chart" xmlns:dgm="http://schemas.openxmlformats.org/drawingml/2006/diagram" xmlns:o="urn:schemas-microsoft-com:office:office" xmlns:v="urn:schemas-microsoft-com:vml" xmlns:pvml="urn:schemas-microsoft-com:office:powerpoint" xmlns:com="http://schemas.openxmlformats.org/drawingml/2006/compatibility" xmlns:p14="http://schemas.microsoft.com/office/powerpoint/2010/main" xmlns:p15="http://schemas.microsoft.com/office/powerpoint/2012/main" xmlns:ahyp="http://schemas.microsoft.com/office/drawing/2018/hyperlinkcolor">
   <p:cSld>
@@ -21849,7 +22291,7 @@
       </p:grpSpPr>
       <p:pic>
         <p:nvPicPr>
-          <p:cNvPr id="368" name="Google Shape;368;g3aa6201ac61_0_26"/>
+          <p:cNvPr id="368" name="Google Shape;368;g3ad6459f57e_1_9"/>
           <p:cNvPicPr preferRelativeResize="0"/>
           <p:nvPr/>
         </p:nvPicPr>
@@ -21877,7 +22319,7 @@
       </p:pic>
       <p:pic>
         <p:nvPicPr>
-          <p:cNvPr id="369" name="Google Shape;369;g3aa6201ac61_0_26"/>
+          <p:cNvPr id="369" name="Google Shape;369;g3ad6459f57e_1_9"/>
           <p:cNvPicPr preferRelativeResize="0"/>
           <p:nvPr/>
         </p:nvPicPr>
@@ -21891,8 +22333,8 @@
         </p:blipFill>
         <p:spPr>
           <a:xfrm>
-            <a:off x="275450" y="1151077"/>
-            <a:ext cx="3494000" cy="3055950"/>
+            <a:off x="2108875" y="1072510"/>
+            <a:ext cx="5703397" cy="3766190"/>
           </a:xfrm>
           <a:prstGeom prst="rect">
             <a:avLst/>
@@ -21903,9 +22345,90 @@
           </a:ln>
         </p:spPr>
       </p:pic>
+    </p:spTree>
+  </p:cSld>
+  <p:clrMapOvr>
+    <a:masterClrMapping/>
+  </p:clrMapOvr>
+</p:sld>
+</file>
+
+<file path=ppt/slides/slide34.xml><?xml version="1.0" encoding="utf-8"?>
+<p:sld xmlns:a="http://schemas.openxmlformats.org/drawingml/2006/main" xmlns:r="http://schemas.openxmlformats.org/officeDocument/2006/relationships" xmlns:mc="http://schemas.openxmlformats.org/markup-compatibility/2006" xmlns:mv="urn:schemas-microsoft-com:mac:vml" xmlns:p="http://schemas.openxmlformats.org/presentationml/2006/main" xmlns:c="http://schemas.openxmlformats.org/drawingml/2006/chart" xmlns:dgm="http://schemas.openxmlformats.org/drawingml/2006/diagram" xmlns:o="urn:schemas-microsoft-com:office:office" xmlns:v="urn:schemas-microsoft-com:vml" xmlns:pvml="urn:schemas-microsoft-com:office:powerpoint" xmlns:com="http://schemas.openxmlformats.org/drawingml/2006/compatibility" xmlns:p14="http://schemas.microsoft.com/office/powerpoint/2010/main" xmlns:p15="http://schemas.microsoft.com/office/powerpoint/2012/main" xmlns:ahyp="http://schemas.microsoft.com/office/drawing/2018/hyperlinkcolor">
+  <p:cSld>
+    <p:spTree>
+      <p:nvGrpSpPr>
+        <p:cNvPr id="374" name="Shape 374"/>
+        <p:cNvGrpSpPr/>
+        <p:nvPr/>
+      </p:nvGrpSpPr>
+      <p:grpSpPr>
+        <a:xfrm>
+          <a:off x="0" y="0"/>
+          <a:ext cx="0" cy="0"/>
+          <a:chOff x="0" y="0"/>
+          <a:chExt cx="0" cy="0"/>
+        </a:xfrm>
+      </p:grpSpPr>
       <p:pic>
         <p:nvPicPr>
-          <p:cNvPr id="370" name="Google Shape;370;g3aa6201ac61_0_26"/>
+          <p:cNvPr id="375" name="Google Shape;375;g3ad6459f57e_1_15"/>
+          <p:cNvPicPr preferRelativeResize="0"/>
+          <p:nvPr/>
+        </p:nvPicPr>
+        <p:blipFill>
+          <a:blip r:embed="rId3">
+            <a:alphaModFix/>
+          </a:blip>
+          <a:stretch>
+            <a:fillRect/>
+          </a:stretch>
+        </p:blipFill>
+        <p:spPr>
+          <a:xfrm>
+            <a:off x="435400" y="164700"/>
+            <a:ext cx="8839201" cy="907810"/>
+          </a:xfrm>
+          <a:prstGeom prst="rect">
+            <a:avLst/>
+          </a:prstGeom>
+          <a:noFill/>
+          <a:ln>
+            <a:noFill/>
+          </a:ln>
+        </p:spPr>
+      </p:pic>
+      <p:pic>
+        <p:nvPicPr>
+          <p:cNvPr id="376" name="Google Shape;376;g3ad6459f57e_1_15"/>
+          <p:cNvPicPr preferRelativeResize="0"/>
+          <p:nvPr/>
+        </p:nvPicPr>
+        <p:blipFill>
+          <a:blip r:embed="rId4">
+            <a:alphaModFix/>
+          </a:blip>
+          <a:stretch>
+            <a:fillRect/>
+          </a:stretch>
+        </p:blipFill>
+        <p:spPr>
+          <a:xfrm>
+            <a:off x="496925" y="1175685"/>
+            <a:ext cx="8839199" cy="293442"/>
+          </a:xfrm>
+          <a:prstGeom prst="rect">
+            <a:avLst/>
+          </a:prstGeom>
+          <a:noFill/>
+          <a:ln>
+            <a:noFill/>
+          </a:ln>
+        </p:spPr>
+      </p:pic>
+      <p:pic>
+        <p:nvPicPr>
+          <p:cNvPr id="377" name="Google Shape;377;g3ad6459f57e_1_15"/>
           <p:cNvPicPr preferRelativeResize="0"/>
           <p:nvPr/>
         </p:nvPicPr>
@@ -21919,8 +22442,8 @@
         </p:blipFill>
         <p:spPr>
           <a:xfrm>
-            <a:off x="3971050" y="1371472"/>
-            <a:ext cx="5045151" cy="1836498"/>
+            <a:off x="536213" y="1649352"/>
+            <a:ext cx="8637565" cy="3369573"/>
           </a:xfrm>
           <a:prstGeom prst="rect">
             <a:avLst/>
@@ -21931,9 +22454,255 @@
           </a:ln>
         </p:spPr>
       </p:pic>
+    </p:spTree>
+  </p:cSld>
+  <p:clrMapOvr>
+    <a:masterClrMapping/>
+  </p:clrMapOvr>
+</p:sld>
+</file>
+
+<file path=ppt/slides/slide35.xml><?xml version="1.0" encoding="utf-8"?>
+<p:sld xmlns:a="http://schemas.openxmlformats.org/drawingml/2006/main" xmlns:r="http://schemas.openxmlformats.org/officeDocument/2006/relationships" xmlns:mc="http://schemas.openxmlformats.org/markup-compatibility/2006" xmlns:mv="urn:schemas-microsoft-com:mac:vml" xmlns:p="http://schemas.openxmlformats.org/presentationml/2006/main" xmlns:c="http://schemas.openxmlformats.org/drawingml/2006/chart" xmlns:dgm="http://schemas.openxmlformats.org/drawingml/2006/diagram" xmlns:o="urn:schemas-microsoft-com:office:office" xmlns:v="urn:schemas-microsoft-com:vml" xmlns:pvml="urn:schemas-microsoft-com:office:powerpoint" xmlns:com="http://schemas.openxmlformats.org/drawingml/2006/compatibility" xmlns:p14="http://schemas.microsoft.com/office/powerpoint/2010/main" xmlns:p15="http://schemas.microsoft.com/office/powerpoint/2012/main" xmlns:ahyp="http://schemas.microsoft.com/office/drawing/2018/hyperlinkcolor">
+  <p:cSld>
+    <p:spTree>
+      <p:nvGrpSpPr>
+        <p:cNvPr id="382" name="Shape 382"/>
+        <p:cNvGrpSpPr/>
+        <p:nvPr/>
+      </p:nvGrpSpPr>
+      <p:grpSpPr>
+        <a:xfrm>
+          <a:off x="0" y="0"/>
+          <a:ext cx="0" cy="0"/>
+          <a:chOff x="0" y="0"/>
+          <a:chExt cx="0" cy="0"/>
+        </a:xfrm>
+      </p:grpSpPr>
+      <p:pic>
+        <p:nvPicPr>
+          <p:cNvPr id="383" name="Google Shape;383;g3ad6459f57e_1_22"/>
+          <p:cNvPicPr preferRelativeResize="0"/>
+          <p:nvPr/>
+        </p:nvPicPr>
+        <p:blipFill>
+          <a:blip r:embed="rId3">
+            <a:alphaModFix/>
+          </a:blip>
+          <a:stretch>
+            <a:fillRect/>
+          </a:stretch>
+        </p:blipFill>
+        <p:spPr>
+          <a:xfrm>
+            <a:off x="435400" y="164700"/>
+            <a:ext cx="8839201" cy="907810"/>
+          </a:xfrm>
+          <a:prstGeom prst="rect">
+            <a:avLst/>
+          </a:prstGeom>
+          <a:noFill/>
+          <a:ln>
+            <a:noFill/>
+          </a:ln>
+        </p:spPr>
+      </p:pic>
+      <p:pic>
+        <p:nvPicPr>
+          <p:cNvPr id="384" name="Google Shape;384;g3ad6459f57e_1_22"/>
+          <p:cNvPicPr preferRelativeResize="0"/>
+          <p:nvPr/>
+        </p:nvPicPr>
+        <p:blipFill>
+          <a:blip r:embed="rId4">
+            <a:alphaModFix/>
+          </a:blip>
+          <a:stretch>
+            <a:fillRect/>
+          </a:stretch>
+        </p:blipFill>
+        <p:spPr>
+          <a:xfrm>
+            <a:off x="607675" y="1335685"/>
+            <a:ext cx="8839202" cy="394105"/>
+          </a:xfrm>
+          <a:prstGeom prst="rect">
+            <a:avLst/>
+          </a:prstGeom>
+          <a:noFill/>
+          <a:ln>
+            <a:noFill/>
+          </a:ln>
+        </p:spPr>
+      </p:pic>
+      <p:pic>
+        <p:nvPicPr>
+          <p:cNvPr id="385" name="Google Shape;385;g3ad6459f57e_1_22"/>
+          <p:cNvPicPr preferRelativeResize="0"/>
+          <p:nvPr/>
+        </p:nvPicPr>
+        <p:blipFill>
+          <a:blip r:embed="rId5">
+            <a:alphaModFix/>
+          </a:blip>
+          <a:stretch>
+            <a:fillRect/>
+          </a:stretch>
+        </p:blipFill>
+        <p:spPr>
+          <a:xfrm>
+            <a:off x="607675" y="1931414"/>
+            <a:ext cx="8839198" cy="990941"/>
+          </a:xfrm>
+          <a:prstGeom prst="rect">
+            <a:avLst/>
+          </a:prstGeom>
+          <a:noFill/>
+          <a:ln>
+            <a:noFill/>
+          </a:ln>
+        </p:spPr>
+      </p:pic>
+      <p:pic>
+        <p:nvPicPr>
+          <p:cNvPr id="386" name="Google Shape;386;g3ad6459f57e_1_22"/>
+          <p:cNvPicPr preferRelativeResize="0"/>
+          <p:nvPr/>
+        </p:nvPicPr>
+        <p:blipFill>
+          <a:blip r:embed="rId6">
+            <a:alphaModFix/>
+          </a:blip>
+          <a:stretch>
+            <a:fillRect/>
+          </a:stretch>
+        </p:blipFill>
+        <p:spPr>
+          <a:xfrm>
+            <a:off x="607675" y="3005681"/>
+            <a:ext cx="4870142" cy="1916344"/>
+          </a:xfrm>
+          <a:prstGeom prst="rect">
+            <a:avLst/>
+          </a:prstGeom>
+          <a:noFill/>
+          <a:ln>
+            <a:noFill/>
+          </a:ln>
+        </p:spPr>
+      </p:pic>
+    </p:spTree>
+  </p:cSld>
+  <p:clrMapOvr>
+    <a:masterClrMapping/>
+  </p:clrMapOvr>
+</p:sld>
+</file>
+
+<file path=ppt/slides/slide36.xml><?xml version="1.0" encoding="utf-8"?>
+<p:sld xmlns:a="http://schemas.openxmlformats.org/drawingml/2006/main" xmlns:r="http://schemas.openxmlformats.org/officeDocument/2006/relationships" xmlns:mc="http://schemas.openxmlformats.org/markup-compatibility/2006" xmlns:mv="urn:schemas-microsoft-com:mac:vml" xmlns:p="http://schemas.openxmlformats.org/presentationml/2006/main" xmlns:c="http://schemas.openxmlformats.org/drawingml/2006/chart" xmlns:dgm="http://schemas.openxmlformats.org/drawingml/2006/diagram" xmlns:o="urn:schemas-microsoft-com:office:office" xmlns:v="urn:schemas-microsoft-com:vml" xmlns:pvml="urn:schemas-microsoft-com:office:powerpoint" xmlns:com="http://schemas.openxmlformats.org/drawingml/2006/compatibility" xmlns:p14="http://schemas.microsoft.com/office/powerpoint/2010/main" xmlns:p15="http://schemas.microsoft.com/office/powerpoint/2012/main" xmlns:ahyp="http://schemas.microsoft.com/office/drawing/2018/hyperlinkcolor">
+  <p:cSld>
+    <p:spTree>
+      <p:nvGrpSpPr>
+        <p:cNvPr id="391" name="Shape 391"/>
+        <p:cNvGrpSpPr/>
+        <p:nvPr/>
+      </p:nvGrpSpPr>
+      <p:grpSpPr>
+        <a:xfrm>
+          <a:off x="0" y="0"/>
+          <a:ext cx="0" cy="0"/>
+          <a:chOff x="0" y="0"/>
+          <a:chExt cx="0" cy="0"/>
+        </a:xfrm>
+      </p:grpSpPr>
+      <p:pic>
+        <p:nvPicPr>
+          <p:cNvPr id="392" name="Google Shape;392;g3aa6201ac61_0_26"/>
+          <p:cNvPicPr preferRelativeResize="0"/>
+          <p:nvPr/>
+        </p:nvPicPr>
+        <p:blipFill>
+          <a:blip r:embed="rId3">
+            <a:alphaModFix/>
+          </a:blip>
+          <a:stretch>
+            <a:fillRect/>
+          </a:stretch>
+        </p:blipFill>
+        <p:spPr>
+          <a:xfrm>
+            <a:off x="435400" y="164700"/>
+            <a:ext cx="8839201" cy="907810"/>
+          </a:xfrm>
+          <a:prstGeom prst="rect">
+            <a:avLst/>
+          </a:prstGeom>
+          <a:noFill/>
+          <a:ln>
+            <a:noFill/>
+          </a:ln>
+        </p:spPr>
+      </p:pic>
+      <p:pic>
+        <p:nvPicPr>
+          <p:cNvPr id="393" name="Google Shape;393;g3aa6201ac61_0_26"/>
+          <p:cNvPicPr preferRelativeResize="0"/>
+          <p:nvPr/>
+        </p:nvPicPr>
+        <p:blipFill>
+          <a:blip r:embed="rId4">
+            <a:alphaModFix/>
+          </a:blip>
+          <a:stretch>
+            <a:fillRect/>
+          </a:stretch>
+        </p:blipFill>
+        <p:spPr>
+          <a:xfrm>
+            <a:off x="275450" y="1151077"/>
+            <a:ext cx="3494000" cy="3055950"/>
+          </a:xfrm>
+          <a:prstGeom prst="rect">
+            <a:avLst/>
+          </a:prstGeom>
+          <a:noFill/>
+          <a:ln>
+            <a:noFill/>
+          </a:ln>
+        </p:spPr>
+      </p:pic>
+      <p:pic>
+        <p:nvPicPr>
+          <p:cNvPr id="394" name="Google Shape;394;g3aa6201ac61_0_26"/>
+          <p:cNvPicPr preferRelativeResize="0"/>
+          <p:nvPr/>
+        </p:nvPicPr>
+        <p:blipFill>
+          <a:blip r:embed="rId5">
+            <a:alphaModFix/>
+          </a:blip>
+          <a:stretch>
+            <a:fillRect/>
+          </a:stretch>
+        </p:blipFill>
+        <p:spPr>
+          <a:xfrm>
+            <a:off x="3971050" y="1371472"/>
+            <a:ext cx="5045151" cy="1836498"/>
+          </a:xfrm>
+          <a:prstGeom prst="rect">
+            <a:avLst/>
+          </a:prstGeom>
+          <a:noFill/>
+          <a:ln>
+            <a:noFill/>
+          </a:ln>
+        </p:spPr>
+      </p:pic>
       <p:sp>
         <p:nvSpPr>
-          <p:cNvPr id="371" name="Google Shape;371;g3aa6201ac61_0_26"/>
+          <p:cNvPr id="395" name="Google Shape;395;g3aa6201ac61_0_26"/>
           <p:cNvSpPr txBox="1"/>
           <p:nvPr/>
         </p:nvSpPr>
@@ -22012,12 +22781,12 @@
 </p:sld>
 </file>
 
-<file path=ppt/slides/slide34.xml><?xml version="1.0" encoding="utf-8"?>
+<file path=ppt/slides/slide37.xml><?xml version="1.0" encoding="utf-8"?>
 <p:sld xmlns:a="http://schemas.openxmlformats.org/drawingml/2006/main" xmlns:r="http://schemas.openxmlformats.org/officeDocument/2006/relationships" xmlns:mc="http://schemas.openxmlformats.org/markup-compatibility/2006" xmlns:mv="urn:schemas-microsoft-com:mac:vml" xmlns:p="http://schemas.openxmlformats.org/presentationml/2006/main" xmlns:c="http://schemas.openxmlformats.org/drawingml/2006/chart" xmlns:dgm="http://schemas.openxmlformats.org/drawingml/2006/diagram" xmlns:o="urn:schemas-microsoft-com:office:office" xmlns:v="urn:schemas-microsoft-com:vml" xmlns:pvml="urn:schemas-microsoft-com:office:powerpoint" xmlns:com="http://schemas.openxmlformats.org/drawingml/2006/compatibility" xmlns:p14="http://schemas.microsoft.com/office/powerpoint/2010/main" xmlns:p15="http://schemas.microsoft.com/office/powerpoint/2012/main" xmlns:ahyp="http://schemas.microsoft.com/office/drawing/2018/hyperlinkcolor">
   <p:cSld>
     <p:spTree>
       <p:nvGrpSpPr>
-        <p:cNvPr id="375" name="Shape 375"/>
+        <p:cNvPr id="399" name="Shape 399"/>
         <p:cNvGrpSpPr/>
         <p:nvPr/>
       </p:nvGrpSpPr>
@@ -22031,7 +22800,7 @@
       </p:grpSpPr>
       <p:pic>
         <p:nvPicPr>
-          <p:cNvPr id="376" name="Google Shape;376;p15"/>
+          <p:cNvPr id="400" name="Google Shape;400;p15"/>
           <p:cNvPicPr preferRelativeResize="0"/>
           <p:nvPr/>
         </p:nvPicPr>
@@ -22058,7 +22827,7 @@
       </p:pic>
       <p:sp>
         <p:nvSpPr>
-          <p:cNvPr id="377" name="Google Shape;377;p15"/>
+          <p:cNvPr id="401" name="Google Shape;401;p15"/>
           <p:cNvSpPr txBox="1"/>
           <p:nvPr/>
         </p:nvSpPr>
@@ -22108,7 +22877,7 @@
       </p:sp>
       <p:pic>
         <p:nvPicPr>
-          <p:cNvPr id="378" name="Google Shape;378;p15"/>
+          <p:cNvPr id="402" name="Google Shape;402;p15"/>
           <p:cNvPicPr preferRelativeResize="0"/>
           <p:nvPr/>
         </p:nvPicPr>
@@ -22147,7 +22916,7 @@
   <p:cSld>
     <p:spTree>
       <p:nvGrpSpPr>
-        <p:cNvPr id="113" name="Shape 113"/>
+        <p:cNvPr id="114" name="Shape 114"/>
         <p:cNvGrpSpPr/>
         <p:nvPr/>
       </p:nvGrpSpPr>
@@ -22161,7 +22930,7 @@
       </p:grpSpPr>
       <p:pic>
         <p:nvPicPr>
-          <p:cNvPr id="114" name="Google Shape;114;p3"/>
+          <p:cNvPr id="115" name="Google Shape;115;p3"/>
           <p:cNvPicPr preferRelativeResize="0"/>
           <p:nvPr/>
         </p:nvPicPr>
@@ -22188,7 +22957,7 @@
       </p:pic>
       <p:sp>
         <p:nvSpPr>
-          <p:cNvPr id="115" name="Google Shape;115;p3"/>
+          <p:cNvPr id="116" name="Google Shape;116;p3"/>
           <p:cNvSpPr txBox="1"/>
           <p:nvPr/>
         </p:nvSpPr>
@@ -22238,7 +23007,7 @@
       </p:sp>
       <p:sp>
         <p:nvSpPr>
-          <p:cNvPr id="116" name="Google Shape;116;p3"/>
+          <p:cNvPr id="117" name="Google Shape;117;p3"/>
           <p:cNvSpPr txBox="1"/>
           <p:nvPr/>
         </p:nvSpPr>
@@ -22459,7 +23228,7 @@
   <p:cSld>
     <p:spTree>
       <p:nvGrpSpPr>
-        <p:cNvPr id="120" name="Shape 120"/>
+        <p:cNvPr id="121" name="Shape 121"/>
         <p:cNvGrpSpPr/>
         <p:nvPr/>
       </p:nvGrpSpPr>
@@ -22473,7 +23242,7 @@
       </p:grpSpPr>
       <p:sp>
         <p:nvSpPr>
-          <p:cNvPr id="121" name="Google Shape;121;p4"/>
+          <p:cNvPr id="122" name="Google Shape;122;p4"/>
           <p:cNvSpPr txBox="1"/>
           <p:nvPr/>
         </p:nvSpPr>
@@ -22523,7 +23292,7 @@
       </p:sp>
       <p:pic>
         <p:nvPicPr>
-          <p:cNvPr id="122" name="Google Shape;122;p4"/>
+          <p:cNvPr id="123" name="Google Shape;123;p4"/>
           <p:cNvPicPr preferRelativeResize="0"/>
           <p:nvPr/>
         </p:nvPicPr>
@@ -22550,7 +23319,7 @@
       </p:pic>
       <p:pic>
         <p:nvPicPr>
-          <p:cNvPr id="123" name="Google Shape;123;p4"/>
+          <p:cNvPr id="124" name="Google Shape;124;p4"/>
           <p:cNvPicPr preferRelativeResize="0"/>
           <p:nvPr/>
         </p:nvPicPr>
@@ -22578,7 +23347,7 @@
       </p:pic>
       <p:sp>
         <p:nvSpPr>
-          <p:cNvPr id="124" name="Google Shape;124;p4"/>
+          <p:cNvPr id="125" name="Google Shape;125;p4"/>
           <p:cNvSpPr txBox="1"/>
           <p:nvPr/>
         </p:nvSpPr>
@@ -22647,7 +23416,7 @@
   <p:cSld>
     <p:spTree>
       <p:nvGrpSpPr>
-        <p:cNvPr id="128" name="Shape 128"/>
+        <p:cNvPr id="129" name="Shape 129"/>
         <p:cNvGrpSpPr/>
         <p:nvPr/>
       </p:nvGrpSpPr>
@@ -22661,7 +23430,7 @@
       </p:grpSpPr>
       <p:sp>
         <p:nvSpPr>
-          <p:cNvPr id="129" name="Google Shape;129;p5"/>
+          <p:cNvPr id="130" name="Google Shape;130;p5"/>
           <p:cNvSpPr txBox="1"/>
           <p:nvPr/>
         </p:nvSpPr>
@@ -22711,7 +23480,7 @@
       </p:sp>
       <p:pic>
         <p:nvPicPr>
-          <p:cNvPr id="130" name="Google Shape;130;p5"/>
+          <p:cNvPr id="131" name="Google Shape;131;p5"/>
           <p:cNvPicPr preferRelativeResize="0"/>
           <p:nvPr/>
         </p:nvPicPr>
@@ -22738,7 +23507,7 @@
       </p:pic>
       <p:pic>
         <p:nvPicPr>
-          <p:cNvPr id="131" name="Google Shape;131;p5"/>
+          <p:cNvPr id="132" name="Google Shape;132;p5"/>
           <p:cNvPicPr preferRelativeResize="0"/>
           <p:nvPr/>
         </p:nvPicPr>
@@ -22766,7 +23535,7 @@
       </p:pic>
       <p:pic>
         <p:nvPicPr>
-          <p:cNvPr id="132" name="Google Shape;132;p5"/>
+          <p:cNvPr id="133" name="Google Shape;133;p5"/>
           <p:cNvPicPr preferRelativeResize="0"/>
           <p:nvPr/>
         </p:nvPicPr>
@@ -22805,7 +23574,7 @@
   <p:cSld>
     <p:spTree>
       <p:nvGrpSpPr>
-        <p:cNvPr id="136" name="Shape 136"/>
+        <p:cNvPr id="137" name="Shape 137"/>
         <p:cNvGrpSpPr/>
         <p:nvPr/>
       </p:nvGrpSpPr>
@@ -22819,7 +23588,7 @@
       </p:grpSpPr>
       <p:sp>
         <p:nvSpPr>
-          <p:cNvPr id="137" name="Google Shape;137;p6"/>
+          <p:cNvPr id="138" name="Google Shape;138;p6"/>
           <p:cNvSpPr txBox="1"/>
           <p:nvPr/>
         </p:nvSpPr>
@@ -22869,7 +23638,7 @@
       </p:sp>
       <p:pic>
         <p:nvPicPr>
-          <p:cNvPr id="138" name="Google Shape;138;p6"/>
+          <p:cNvPr id="139" name="Google Shape;139;p6"/>
           <p:cNvPicPr preferRelativeResize="0"/>
           <p:nvPr/>
         </p:nvPicPr>
@@ -22896,7 +23665,7 @@
       </p:pic>
       <p:pic>
         <p:nvPicPr>
-          <p:cNvPr id="139" name="Google Shape;139;p6"/>
+          <p:cNvPr id="140" name="Google Shape;140;p6"/>
           <p:cNvPicPr preferRelativeResize="0"/>
           <p:nvPr/>
         </p:nvPicPr>
@@ -22924,7 +23693,7 @@
       </p:pic>
       <p:pic>
         <p:nvPicPr>
-          <p:cNvPr id="140" name="Google Shape;140;p6"/>
+          <p:cNvPr id="141" name="Google Shape;141;p6"/>
           <p:cNvPicPr preferRelativeResize="0"/>
           <p:nvPr/>
         </p:nvPicPr>
@@ -22952,7 +23721,7 @@
       </p:pic>
       <p:pic>
         <p:nvPicPr>
-          <p:cNvPr id="141" name="Google Shape;141;p6"/>
+          <p:cNvPr id="142" name="Google Shape;142;p6"/>
           <p:cNvPicPr preferRelativeResize="0"/>
           <p:nvPr/>
         </p:nvPicPr>
@@ -22991,7 +23760,7 @@
   <p:cSld>
     <p:spTree>
       <p:nvGrpSpPr>
-        <p:cNvPr id="145" name="Shape 145"/>
+        <p:cNvPr id="146" name="Shape 146"/>
         <p:cNvGrpSpPr/>
         <p:nvPr/>
       </p:nvGrpSpPr>
@@ -23005,7 +23774,7 @@
       </p:grpSpPr>
       <p:sp>
         <p:nvSpPr>
-          <p:cNvPr id="146" name="Google Shape;146;p7"/>
+          <p:cNvPr id="147" name="Google Shape;147;p7"/>
           <p:cNvSpPr txBox="1"/>
           <p:nvPr/>
         </p:nvSpPr>
@@ -23055,7 +23824,7 @@
       </p:sp>
       <p:pic>
         <p:nvPicPr>
-          <p:cNvPr id="147" name="Google Shape;147;p7"/>
+          <p:cNvPr id="148" name="Google Shape;148;p7"/>
           <p:cNvPicPr preferRelativeResize="0"/>
           <p:nvPr/>
         </p:nvPicPr>
@@ -23082,7 +23851,7 @@
       </p:pic>
       <p:sp>
         <p:nvSpPr>
-          <p:cNvPr id="148" name="Google Shape;148;p7"/>
+          <p:cNvPr id="149" name="Google Shape;149;p7"/>
           <p:cNvSpPr txBox="1"/>
           <p:nvPr/>
         </p:nvSpPr>
@@ -23179,7 +23948,7 @@
       </p:sp>
       <p:sp>
         <p:nvSpPr>
-          <p:cNvPr id="149" name="Google Shape;149;p7"/>
+          <p:cNvPr id="150" name="Google Shape;150;p7"/>
           <p:cNvSpPr txBox="1"/>
           <p:nvPr/>
         </p:nvSpPr>
@@ -23248,7 +24017,7 @@
   <p:cSld>
     <p:spTree>
       <p:nvGrpSpPr>
-        <p:cNvPr id="154" name="Shape 154"/>
+        <p:cNvPr id="155" name="Shape 155"/>
         <p:cNvGrpSpPr/>
         <p:nvPr/>
       </p:nvGrpSpPr>
@@ -23262,7 +24031,7 @@
       </p:grpSpPr>
       <p:sp>
         <p:nvSpPr>
-          <p:cNvPr id="155" name="Google Shape;155;g39a291deda2_0_29"/>
+          <p:cNvPr id="156" name="Google Shape;156;g39a291deda2_0_29"/>
           <p:cNvSpPr txBox="1"/>
           <p:nvPr/>
         </p:nvSpPr>
@@ -23312,7 +24081,7 @@
       </p:sp>
       <p:pic>
         <p:nvPicPr>
-          <p:cNvPr id="156" name="Google Shape;156;g39a291deda2_0_29"/>
+          <p:cNvPr id="157" name="Google Shape;157;g39a291deda2_0_29"/>
           <p:cNvPicPr preferRelativeResize="0"/>
           <p:nvPr/>
         </p:nvPicPr>
@@ -23339,7 +24108,7 @@
       </p:pic>
       <p:sp>
         <p:nvSpPr>
-          <p:cNvPr id="157" name="Google Shape;157;g39a291deda2_0_29"/>
+          <p:cNvPr id="158" name="Google Shape;158;g39a291deda2_0_29"/>
           <p:cNvSpPr txBox="1"/>
           <p:nvPr/>
         </p:nvSpPr>
@@ -23397,7 +24166,7 @@
       </p:sp>
       <p:pic>
         <p:nvPicPr>
-          <p:cNvPr id="158" name="Google Shape;158;g39a291deda2_0_29"/>
+          <p:cNvPr id="159" name="Google Shape;159;g39a291deda2_0_29"/>
           <p:cNvPicPr preferRelativeResize="0"/>
           <p:nvPr/>
         </p:nvPicPr>
@@ -23425,7 +24194,7 @@
       </p:pic>
       <p:sp>
         <p:nvSpPr>
-          <p:cNvPr id="159" name="Google Shape;159;g39a291deda2_0_29"/>
+          <p:cNvPr id="160" name="Google Shape;160;g39a291deda2_0_29"/>
           <p:cNvSpPr txBox="1"/>
           <p:nvPr/>
         </p:nvSpPr>

</xml_diff>

<commit_message>
Aggiornamento final release slide qry code corretti
</commit_message>
<xml_diff>
--- a/SEGRETI_MODULI_PYTHON_FINALSLIDE.pptx
+++ b/SEGRETI_MODULI_PYTHON_FINALSLIDE.pptx
@@ -294,7 +294,7 @@
       </p15:sldGuideLst>
     </p:ext>
     <p:ext uri="GoogleSlidesCustomDataVersion2">
-      <go:slidesCustomData xmlns:go="http://customooxmlschemas.google.com/" r:id="rId44" roundtripDataSignature="AMtx7mg4jxvMnVkbDpGJSnE2xfucn5ylXg=="/>
+      <go:slidesCustomData xmlns:go="http://customooxmlschemas.google.com/" r:id="rId44" roundtripDataSignature="AMtx7miqlSzTomZ6+DCG+KZ7AZp9M0z1aQ=="/>
     </p:ext>
   </p:extLst>
 </p:presentation>
@@ -23145,7 +23145,7 @@
         </p:blipFill>
         <p:spPr>
           <a:xfrm>
-            <a:off x="920472" y="218883"/>
+            <a:off x="930122" y="8"/>
             <a:ext cx="1424500" cy="909075"/>
           </a:xfrm>
           <a:prstGeom prst="rect">
@@ -23165,7 +23165,7 @@
         </p:nvSpPr>
         <p:spPr>
           <a:xfrm>
-            <a:off x="2344965" y="552703"/>
+            <a:off x="2354615" y="333828"/>
             <a:ext cx="6567600" cy="400800"/>
           </a:xfrm>
           <a:prstGeom prst="rect">
@@ -23207,9 +23207,67 @@
           </a:p>
         </p:txBody>
       </p:sp>
+      <p:sp>
+        <p:nvSpPr>
+          <p:cNvPr id="411" name="Google Shape;411;p15"/>
+          <p:cNvSpPr txBox="1"/>
+          <p:nvPr/>
+        </p:nvSpPr>
+        <p:spPr>
+          <a:xfrm>
+            <a:off x="1431500" y="960750"/>
+            <a:ext cx="7087800" cy="877200"/>
+          </a:xfrm>
+          <a:prstGeom prst="rect">
+            <a:avLst/>
+          </a:prstGeom>
+          <a:noFill/>
+          <a:ln>
+            <a:noFill/>
+          </a:ln>
+        </p:spPr>
+        <p:txBody>
+          <a:bodyPr anchorCtr="0" anchor="t" bIns="91425" lIns="91425" spcFirstLastPara="1" rIns="91425" wrap="square" tIns="91425">
+            <a:spAutoFit/>
+          </a:bodyPr>
+          <a:lstStyle/>
+          <a:p>
+            <a:pPr indent="0" lvl="0" marL="0" rtl="0" algn="ctr">
+              <a:spcBef>
+                <a:spcPts val="0"/>
+              </a:spcBef>
+              <a:spcAft>
+                <a:spcPts val="0"/>
+              </a:spcAft>
+              <a:buNone/>
+            </a:pPr>
+            <a:r>
+              <a:rPr lang="it-IT" sz="4500">
+                <a:solidFill>
+                  <a:schemeClr val="dk1"/>
+                </a:solidFill>
+                <a:latin typeface="Calibri"/>
+                <a:ea typeface="Calibri"/>
+                <a:cs typeface="Calibri"/>
+                <a:sym typeface="Calibri"/>
+              </a:rPr>
+              <a:t>GRAZIE A PYTHON PESCARA</a:t>
+            </a:r>
+            <a:endParaRPr sz="4500">
+              <a:solidFill>
+                <a:schemeClr val="dk1"/>
+              </a:solidFill>
+              <a:latin typeface="Calibri"/>
+              <a:ea typeface="Calibri"/>
+              <a:cs typeface="Calibri"/>
+              <a:sym typeface="Calibri"/>
+            </a:endParaRPr>
+          </a:p>
+        </p:txBody>
+      </p:sp>
       <p:pic>
         <p:nvPicPr>
-          <p:cNvPr id="411" name="Google Shape;411;p15"/>
+          <p:cNvPr id="412" name="Google Shape;412;p15"/>
           <p:cNvPicPr preferRelativeResize="0"/>
           <p:nvPr/>
         </p:nvPicPr>
@@ -23223,8 +23281,8 @@
         </p:blipFill>
         <p:spPr>
           <a:xfrm>
-            <a:off x="829175" y="1354183"/>
-            <a:ext cx="8403741" cy="3710743"/>
+            <a:off x="1567500" y="1837950"/>
+            <a:ext cx="2507299" cy="2501300"/>
           </a:xfrm>
           <a:prstGeom prst="rect">
             <a:avLst/>
@@ -23235,6 +23293,150 @@
           </a:ln>
         </p:spPr>
       </p:pic>
+      <p:pic>
+        <p:nvPicPr>
+          <p:cNvPr id="413" name="Google Shape;413;p15"/>
+          <p:cNvPicPr preferRelativeResize="0"/>
+          <p:nvPr/>
+        </p:nvPicPr>
+        <p:blipFill>
+          <a:blip r:embed="rId5">
+            <a:alphaModFix/>
+          </a:blip>
+          <a:stretch>
+            <a:fillRect/>
+          </a:stretch>
+        </p:blipFill>
+        <p:spPr>
+          <a:xfrm>
+            <a:off x="5310999" y="1837950"/>
+            <a:ext cx="2200275" cy="2286000"/>
+          </a:xfrm>
+          <a:prstGeom prst="rect">
+            <a:avLst/>
+          </a:prstGeom>
+          <a:noFill/>
+          <a:ln>
+            <a:noFill/>
+          </a:ln>
+        </p:spPr>
+      </p:pic>
+      <p:sp>
+        <p:nvSpPr>
+          <p:cNvPr id="414" name="Google Shape;414;p15"/>
+          <p:cNvSpPr txBox="1"/>
+          <p:nvPr/>
+        </p:nvSpPr>
+        <p:spPr>
+          <a:xfrm>
+            <a:off x="1375300" y="4339250"/>
+            <a:ext cx="2891700" cy="677100"/>
+          </a:xfrm>
+          <a:prstGeom prst="rect">
+            <a:avLst/>
+          </a:prstGeom>
+          <a:noFill/>
+          <a:ln>
+            <a:noFill/>
+          </a:ln>
+        </p:spPr>
+        <p:txBody>
+          <a:bodyPr anchorCtr="0" anchor="t" bIns="91425" lIns="91425" spcFirstLastPara="1" rIns="91425" wrap="square" tIns="91425">
+            <a:spAutoFit/>
+          </a:bodyPr>
+          <a:lstStyle/>
+          <a:p>
+            <a:pPr indent="0" lvl="0" marL="0" rtl="0" algn="l">
+              <a:spcBef>
+                <a:spcPts val="0"/>
+              </a:spcBef>
+              <a:spcAft>
+                <a:spcPts val="0"/>
+              </a:spcAft>
+              <a:buNone/>
+            </a:pPr>
+            <a:r>
+              <a:rPr lang="it-IT" sz="3200">
+                <a:solidFill>
+                  <a:schemeClr val="dk1"/>
+                </a:solidFill>
+                <a:latin typeface="Calibri"/>
+                <a:ea typeface="Calibri"/>
+                <a:cs typeface="Calibri"/>
+                <a:sym typeface="Calibri"/>
+              </a:rPr>
+              <a:t>Linkedin profile</a:t>
+            </a:r>
+            <a:endParaRPr sz="3200">
+              <a:solidFill>
+                <a:schemeClr val="dk1"/>
+              </a:solidFill>
+              <a:latin typeface="Calibri"/>
+              <a:ea typeface="Calibri"/>
+              <a:cs typeface="Calibri"/>
+              <a:sym typeface="Calibri"/>
+            </a:endParaRPr>
+          </a:p>
+        </p:txBody>
+      </p:sp>
+      <p:sp>
+        <p:nvSpPr>
+          <p:cNvPr id="415" name="Google Shape;415;p15"/>
+          <p:cNvSpPr txBox="1"/>
+          <p:nvPr/>
+        </p:nvSpPr>
+        <p:spPr>
+          <a:xfrm>
+            <a:off x="5101825" y="4339250"/>
+            <a:ext cx="3666900" cy="677100"/>
+          </a:xfrm>
+          <a:prstGeom prst="rect">
+            <a:avLst/>
+          </a:prstGeom>
+          <a:noFill/>
+          <a:ln>
+            <a:noFill/>
+          </a:ln>
+        </p:spPr>
+        <p:txBody>
+          <a:bodyPr anchorCtr="0" anchor="t" bIns="91425" lIns="91425" spcFirstLastPara="1" rIns="91425" wrap="square" tIns="91425">
+            <a:spAutoFit/>
+          </a:bodyPr>
+          <a:lstStyle/>
+          <a:p>
+            <a:pPr indent="0" lvl="0" marL="0" rtl="0" algn="l">
+              <a:spcBef>
+                <a:spcPts val="0"/>
+              </a:spcBef>
+              <a:spcAft>
+                <a:spcPts val="0"/>
+              </a:spcAft>
+              <a:buNone/>
+            </a:pPr>
+            <a:r>
+              <a:rPr lang="it-IT" sz="3200">
+                <a:solidFill>
+                  <a:schemeClr val="dk1"/>
+                </a:solidFill>
+                <a:latin typeface="Calibri"/>
+                <a:ea typeface="Calibri"/>
+                <a:cs typeface="Calibri"/>
+                <a:sym typeface="Calibri"/>
+              </a:rPr>
+              <a:t>Github url repository</a:t>
+            </a:r>
+            <a:endParaRPr sz="3200">
+              <a:solidFill>
+                <a:schemeClr val="dk1"/>
+              </a:solidFill>
+              <a:latin typeface="Calibri"/>
+              <a:ea typeface="Calibri"/>
+              <a:cs typeface="Calibri"/>
+              <a:sym typeface="Calibri"/>
+            </a:endParaRPr>
+          </a:p>
+        </p:txBody>
+      </p:sp>
     </p:spTree>
   </p:cSld>
   <p:clrMapOvr>
@@ -24596,6 +24798,285 @@
 </file>
 
 <file path=ppt/theme/theme1.xml><?xml version="1.0" encoding="utf-8"?>
+<a:theme xmlns:a="http://schemas.openxmlformats.org/drawingml/2006/main" xmlns:r="http://schemas.openxmlformats.org/officeDocument/2006/relationships" name="Tema di Office">
+  <a:themeElements>
+    <a:clrScheme name="Office">
+      <a:dk1>
+        <a:srgbClr val="000000"/>
+      </a:dk1>
+      <a:lt1>
+        <a:srgbClr val="FFFFFF"/>
+      </a:lt1>
+      <a:dk2>
+        <a:srgbClr val="44546A"/>
+      </a:dk2>
+      <a:lt2>
+        <a:srgbClr val="E7E6E6"/>
+      </a:lt2>
+      <a:accent1>
+        <a:srgbClr val="4472C4"/>
+      </a:accent1>
+      <a:accent2>
+        <a:srgbClr val="ED7D31"/>
+      </a:accent2>
+      <a:accent3>
+        <a:srgbClr val="A5A5A5"/>
+      </a:accent3>
+      <a:accent4>
+        <a:srgbClr val="FFC000"/>
+      </a:accent4>
+      <a:accent5>
+        <a:srgbClr val="5B9BD5"/>
+      </a:accent5>
+      <a:accent6>
+        <a:srgbClr val="70AD47"/>
+      </a:accent6>
+      <a:hlink>
+        <a:srgbClr val="0563C1"/>
+      </a:hlink>
+      <a:folHlink>
+        <a:srgbClr val="954F72"/>
+      </a:folHlink>
+    </a:clrScheme>
+    <a:fontScheme name="Office">
+      <a:majorFont>
+        <a:latin typeface="Arial"/>
+        <a:ea typeface=""/>
+        <a:cs typeface=""/>
+        <a:font script="Jpan" typeface="ＭＳ Ｐゴシック"/>
+        <a:font script="Hang" typeface="맑은 고딕"/>
+        <a:font script="Hans" typeface="宋体"/>
+        <a:font script="Hant" typeface="新細明體"/>
+        <a:font script="Arab" typeface="Times New Roman"/>
+        <a:font script="Hebr" typeface="Times New Roman"/>
+        <a:font script="Thai" typeface="Angsana New"/>
+        <a:font script="Ethi" typeface="Nyala"/>
+        <a:font script="Beng" typeface="Vrinda"/>
+        <a:font script="Gujr" typeface="Shruti"/>
+        <a:font script="Khmr" typeface="MoolBoran"/>
+        <a:font script="Knda" typeface="Tunga"/>
+        <a:font script="Guru" typeface="Raavi"/>
+        <a:font script="Cans" typeface="Euphemia"/>
+        <a:font script="Cher" typeface="Plantagenet Cherokee"/>
+        <a:font script="Yiii" typeface="Microsoft Yi Baiti"/>
+        <a:font script="Tibt" typeface="Microsoft Himalaya"/>
+        <a:font script="Thaa" typeface="MV Boli"/>
+        <a:font script="Deva" typeface="Mangal"/>
+        <a:font script="Telu" typeface="Gautami"/>
+        <a:font script="Taml" typeface="Latha"/>
+        <a:font script="Syrc" typeface="Estrangelo Edessa"/>
+        <a:font script="Orya" typeface="Kalinga"/>
+        <a:font script="Mlym" typeface="Kartika"/>
+        <a:font script="Laoo" typeface="DokChampa"/>
+        <a:font script="Sinh" typeface="Iskoola Pota"/>
+        <a:font script="Mong" typeface="Mongolian Baiti"/>
+        <a:font script="Viet" typeface="Times New Roman"/>
+        <a:font script="Uigh" typeface="Microsoft Uighur"/>
+        <a:font script="Geor" typeface="Sylfaen"/>
+      </a:majorFont>
+      <a:minorFont>
+        <a:latin typeface="Arial"/>
+        <a:ea typeface=""/>
+        <a:cs typeface=""/>
+        <a:font script="Jpan" typeface="ＭＳ Ｐゴシック"/>
+        <a:font script="Hang" typeface="맑은 고딕"/>
+        <a:font script="Hans" typeface="宋体"/>
+        <a:font script="Hant" typeface="新細明體"/>
+        <a:font script="Arab" typeface="Arial"/>
+        <a:font script="Hebr" typeface="Arial"/>
+        <a:font script="Thai" typeface="Cordia New"/>
+        <a:font script="Ethi" typeface="Nyala"/>
+        <a:font script="Beng" typeface="Vrinda"/>
+        <a:font script="Gujr" typeface="Shruti"/>
+        <a:font script="Khmr" typeface="DaunPenh"/>
+        <a:font script="Knda" typeface="Tunga"/>
+        <a:font script="Guru" typeface="Raavi"/>
+        <a:font script="Cans" typeface="Euphemia"/>
+        <a:font script="Cher" typeface="Plantagenet Cherokee"/>
+        <a:font script="Yiii" typeface="Microsoft Yi Baiti"/>
+        <a:font script="Tibt" typeface="Microsoft Himalaya"/>
+        <a:font script="Thaa" typeface="MV Boli"/>
+        <a:font script="Deva" typeface="Mangal"/>
+        <a:font script="Telu" typeface="Gautami"/>
+        <a:font script="Taml" typeface="Latha"/>
+        <a:font script="Syrc" typeface="Estrangelo Edessa"/>
+        <a:font script="Orya" typeface="Kalinga"/>
+        <a:font script="Mlym" typeface="Kartika"/>
+        <a:font script="Laoo" typeface="DokChampa"/>
+        <a:font script="Sinh" typeface="Iskoola Pota"/>
+        <a:font script="Mong" typeface="Mongolian Baiti"/>
+        <a:font script="Viet" typeface="Arial"/>
+        <a:font script="Uigh" typeface="Microsoft Uighur"/>
+        <a:font script="Geor" typeface="Sylfaen"/>
+      </a:minorFont>
+    </a:fontScheme>
+    <a:fmtScheme name="Office">
+      <a:fillStyleLst>
+        <a:solidFill>
+          <a:schemeClr val="phClr"/>
+        </a:solidFill>
+        <a:gradFill rotWithShape="1">
+          <a:gsLst>
+            <a:gs pos="0">
+              <a:schemeClr val="phClr">
+                <a:tint val="50000"/>
+                <a:satMod val="300000"/>
+              </a:schemeClr>
+            </a:gs>
+            <a:gs pos="35000">
+              <a:schemeClr val="phClr">
+                <a:tint val="37000"/>
+                <a:satMod val="300000"/>
+              </a:schemeClr>
+            </a:gs>
+            <a:gs pos="100000">
+              <a:schemeClr val="phClr">
+                <a:tint val="15000"/>
+                <a:satMod val="350000"/>
+              </a:schemeClr>
+            </a:gs>
+          </a:gsLst>
+          <a:lin ang="16200000" scaled="1"/>
+        </a:gradFill>
+        <a:gradFill rotWithShape="1">
+          <a:gsLst>
+            <a:gs pos="0">
+              <a:schemeClr val="phClr">
+                <a:tint val="100000"/>
+                <a:shade val="100000"/>
+                <a:satMod val="130000"/>
+              </a:schemeClr>
+            </a:gs>
+            <a:gs pos="100000">
+              <a:schemeClr val="phClr">
+                <a:tint val="50000"/>
+                <a:shade val="100000"/>
+                <a:satMod val="350000"/>
+              </a:schemeClr>
+            </a:gs>
+          </a:gsLst>
+          <a:lin ang="16200000" scaled="0"/>
+        </a:gradFill>
+      </a:fillStyleLst>
+      <a:lnStyleLst>
+        <a:ln w="9525" cap="flat" cmpd="sng" algn="ctr">
+          <a:solidFill>
+            <a:schemeClr val="phClr">
+              <a:shade val="95000"/>
+              <a:satMod val="105000"/>
+            </a:schemeClr>
+          </a:solidFill>
+          <a:prstDash val="solid"/>
+        </a:ln>
+        <a:ln w="25400" cap="flat" cmpd="sng" algn="ctr">
+          <a:solidFill>
+            <a:schemeClr val="phClr"/>
+          </a:solidFill>
+          <a:prstDash val="solid"/>
+        </a:ln>
+        <a:ln w="38100" cap="flat" cmpd="sng" algn="ctr">
+          <a:solidFill>
+            <a:schemeClr val="phClr"/>
+          </a:solidFill>
+          <a:prstDash val="solid"/>
+        </a:ln>
+      </a:lnStyleLst>
+      <a:effectStyleLst>
+        <a:effectStyle>
+          <a:effectLst>
+            <a:outerShdw blurRad="40000" dist="20000" dir="5400000" rotWithShape="0">
+              <a:srgbClr val="000000">
+                <a:alpha val="38000"/>
+              </a:srgbClr>
+            </a:outerShdw>
+          </a:effectLst>
+        </a:effectStyle>
+        <a:effectStyle>
+          <a:effectLst>
+            <a:outerShdw blurRad="40000" dist="23000" dir="5400000" rotWithShape="0">
+              <a:srgbClr val="000000">
+                <a:alpha val="35000"/>
+              </a:srgbClr>
+            </a:outerShdw>
+          </a:effectLst>
+        </a:effectStyle>
+        <a:effectStyle>
+          <a:effectLst>
+            <a:outerShdw blurRad="40000" dist="23000" dir="5400000" rotWithShape="0">
+              <a:srgbClr val="000000">
+                <a:alpha val="35000"/>
+              </a:srgbClr>
+            </a:outerShdw>
+          </a:effectLst>
+          <a:scene3d>
+            <a:camera prst="orthographicFront">
+              <a:rot lat="0" lon="0" rev="0"/>
+            </a:camera>
+            <a:lightRig rig="threePt" dir="t">
+              <a:rot lat="0" lon="0" rev="1200000"/>
+            </a:lightRig>
+          </a:scene3d>
+          <a:sp3d>
+            <a:bevelT w="63500" h="25400"/>
+          </a:sp3d>
+        </a:effectStyle>
+      </a:effectStyleLst>
+      <a:bgFillStyleLst>
+        <a:solidFill>
+          <a:schemeClr val="phClr"/>
+        </a:solidFill>
+        <a:gradFill rotWithShape="1">
+          <a:gsLst>
+            <a:gs pos="0">
+              <a:schemeClr val="phClr">
+                <a:tint val="40000"/>
+                <a:satMod val="350000"/>
+              </a:schemeClr>
+            </a:gs>
+            <a:gs pos="40000">
+              <a:schemeClr val="phClr">
+                <a:tint val="45000"/>
+                <a:shade val="99000"/>
+                <a:satMod val="350000"/>
+              </a:schemeClr>
+            </a:gs>
+            <a:gs pos="100000">
+              <a:schemeClr val="phClr">
+                <a:shade val="20000"/>
+                <a:satMod val="255000"/>
+              </a:schemeClr>
+            </a:gs>
+          </a:gsLst>
+          <a:path path="circle">
+            <a:fillToRect l="50000" t="-80000" r="50000" b="180000"/>
+          </a:path>
+        </a:gradFill>
+        <a:gradFill rotWithShape="1">
+          <a:gsLst>
+            <a:gs pos="0">
+              <a:schemeClr val="phClr">
+                <a:tint val="80000"/>
+                <a:satMod val="300000"/>
+              </a:schemeClr>
+            </a:gs>
+            <a:gs pos="100000">
+              <a:schemeClr val="phClr">
+                <a:shade val="30000"/>
+                <a:satMod val="200000"/>
+              </a:schemeClr>
+            </a:gs>
+          </a:gsLst>
+          <a:path path="circle">
+            <a:fillToRect l="50000" t="50000" r="50000" b="50000"/>
+          </a:path>
+        </a:gradFill>
+      </a:bgFillStyleLst>
+    </a:fmtScheme>
+  </a:themeElements>
+</a:theme>
+</file>
+
+<file path=ppt/theme/theme2.xml><?xml version="1.0" encoding="utf-8"?>
 <a:theme xmlns:a="http://schemas.openxmlformats.org/drawingml/2006/main" xmlns:r="http://schemas.openxmlformats.org/officeDocument/2006/relationships" name="Office Theme">
   <a:themeElements>
     <a:clrScheme name="Office">
@@ -24872,283 +25353,4 @@
     </a:fmtScheme>
   </a:themeElements>
 </a:theme>
-</file>
-
-<file path=ppt/theme/theme2.xml><?xml version="1.0" encoding="utf-8"?>
-<a:theme xmlns:a="http://schemas.openxmlformats.org/drawingml/2006/main" xmlns:r="http://schemas.openxmlformats.org/officeDocument/2006/relationships" name="Tema di Office">
-  <a:themeElements>
-    <a:clrScheme name="Office">
-      <a:dk1>
-        <a:srgbClr val="000000"/>
-      </a:dk1>
-      <a:lt1>
-        <a:srgbClr val="FFFFFF"/>
-      </a:lt1>
-      <a:dk2>
-        <a:srgbClr val="44546A"/>
-      </a:dk2>
-      <a:lt2>
-        <a:srgbClr val="E7E6E6"/>
-      </a:lt2>
-      <a:accent1>
-        <a:srgbClr val="4472C4"/>
-      </a:accent1>
-      <a:accent2>
-        <a:srgbClr val="ED7D31"/>
-      </a:accent2>
-      <a:accent3>
-        <a:srgbClr val="A5A5A5"/>
-      </a:accent3>
-      <a:accent4>
-        <a:srgbClr val="FFC000"/>
-      </a:accent4>
-      <a:accent5>
-        <a:srgbClr val="5B9BD5"/>
-      </a:accent5>
-      <a:accent6>
-        <a:srgbClr val="70AD47"/>
-      </a:accent6>
-      <a:hlink>
-        <a:srgbClr val="0563C1"/>
-      </a:hlink>
-      <a:folHlink>
-        <a:srgbClr val="954F72"/>
-      </a:folHlink>
-    </a:clrScheme>
-    <a:fontScheme name="Office">
-      <a:majorFont>
-        <a:latin typeface="Arial"/>
-        <a:ea typeface=""/>
-        <a:cs typeface=""/>
-        <a:font script="Jpan" typeface="ＭＳ Ｐゴシック"/>
-        <a:font script="Hang" typeface="맑은 고딕"/>
-        <a:font script="Hans" typeface="宋体"/>
-        <a:font script="Hant" typeface="新細明體"/>
-        <a:font script="Arab" typeface="Times New Roman"/>
-        <a:font script="Hebr" typeface="Times New Roman"/>
-        <a:font script="Thai" typeface="Angsana New"/>
-        <a:font script="Ethi" typeface="Nyala"/>
-        <a:font script="Beng" typeface="Vrinda"/>
-        <a:font script="Gujr" typeface="Shruti"/>
-        <a:font script="Khmr" typeface="MoolBoran"/>
-        <a:font script="Knda" typeface="Tunga"/>
-        <a:font script="Guru" typeface="Raavi"/>
-        <a:font script="Cans" typeface="Euphemia"/>
-        <a:font script="Cher" typeface="Plantagenet Cherokee"/>
-        <a:font script="Yiii" typeface="Microsoft Yi Baiti"/>
-        <a:font script="Tibt" typeface="Microsoft Himalaya"/>
-        <a:font script="Thaa" typeface="MV Boli"/>
-        <a:font script="Deva" typeface="Mangal"/>
-        <a:font script="Telu" typeface="Gautami"/>
-        <a:font script="Taml" typeface="Latha"/>
-        <a:font script="Syrc" typeface="Estrangelo Edessa"/>
-        <a:font script="Orya" typeface="Kalinga"/>
-        <a:font script="Mlym" typeface="Kartika"/>
-        <a:font script="Laoo" typeface="DokChampa"/>
-        <a:font script="Sinh" typeface="Iskoola Pota"/>
-        <a:font script="Mong" typeface="Mongolian Baiti"/>
-        <a:font script="Viet" typeface="Times New Roman"/>
-        <a:font script="Uigh" typeface="Microsoft Uighur"/>
-        <a:font script="Geor" typeface="Sylfaen"/>
-      </a:majorFont>
-      <a:minorFont>
-        <a:latin typeface="Arial"/>
-        <a:ea typeface=""/>
-        <a:cs typeface=""/>
-        <a:font script="Jpan" typeface="ＭＳ Ｐゴシック"/>
-        <a:font script="Hang" typeface="맑은 고딕"/>
-        <a:font script="Hans" typeface="宋体"/>
-        <a:font script="Hant" typeface="新細明體"/>
-        <a:font script="Arab" typeface="Arial"/>
-        <a:font script="Hebr" typeface="Arial"/>
-        <a:font script="Thai" typeface="Cordia New"/>
-        <a:font script="Ethi" typeface="Nyala"/>
-        <a:font script="Beng" typeface="Vrinda"/>
-        <a:font script="Gujr" typeface="Shruti"/>
-        <a:font script="Khmr" typeface="DaunPenh"/>
-        <a:font script="Knda" typeface="Tunga"/>
-        <a:font script="Guru" typeface="Raavi"/>
-        <a:font script="Cans" typeface="Euphemia"/>
-        <a:font script="Cher" typeface="Plantagenet Cherokee"/>
-        <a:font script="Yiii" typeface="Microsoft Yi Baiti"/>
-        <a:font script="Tibt" typeface="Microsoft Himalaya"/>
-        <a:font script="Thaa" typeface="MV Boli"/>
-        <a:font script="Deva" typeface="Mangal"/>
-        <a:font script="Telu" typeface="Gautami"/>
-        <a:font script="Taml" typeface="Latha"/>
-        <a:font script="Syrc" typeface="Estrangelo Edessa"/>
-        <a:font script="Orya" typeface="Kalinga"/>
-        <a:font script="Mlym" typeface="Kartika"/>
-        <a:font script="Laoo" typeface="DokChampa"/>
-        <a:font script="Sinh" typeface="Iskoola Pota"/>
-        <a:font script="Mong" typeface="Mongolian Baiti"/>
-        <a:font script="Viet" typeface="Arial"/>
-        <a:font script="Uigh" typeface="Microsoft Uighur"/>
-        <a:font script="Geor" typeface="Sylfaen"/>
-      </a:minorFont>
-    </a:fontScheme>
-    <a:fmtScheme name="Office">
-      <a:fillStyleLst>
-        <a:solidFill>
-          <a:schemeClr val="phClr"/>
-        </a:solidFill>
-        <a:gradFill rotWithShape="1">
-          <a:gsLst>
-            <a:gs pos="0">
-              <a:schemeClr val="phClr">
-                <a:tint val="50000"/>
-                <a:satMod val="300000"/>
-              </a:schemeClr>
-            </a:gs>
-            <a:gs pos="35000">
-              <a:schemeClr val="phClr">
-                <a:tint val="37000"/>
-                <a:satMod val="300000"/>
-              </a:schemeClr>
-            </a:gs>
-            <a:gs pos="100000">
-              <a:schemeClr val="phClr">
-                <a:tint val="15000"/>
-                <a:satMod val="350000"/>
-              </a:schemeClr>
-            </a:gs>
-          </a:gsLst>
-          <a:lin ang="16200000" scaled="1"/>
-        </a:gradFill>
-        <a:gradFill rotWithShape="1">
-          <a:gsLst>
-            <a:gs pos="0">
-              <a:schemeClr val="phClr">
-                <a:tint val="100000"/>
-                <a:shade val="100000"/>
-                <a:satMod val="130000"/>
-              </a:schemeClr>
-            </a:gs>
-            <a:gs pos="100000">
-              <a:schemeClr val="phClr">
-                <a:tint val="50000"/>
-                <a:shade val="100000"/>
-                <a:satMod val="350000"/>
-              </a:schemeClr>
-            </a:gs>
-          </a:gsLst>
-          <a:lin ang="16200000" scaled="0"/>
-        </a:gradFill>
-      </a:fillStyleLst>
-      <a:lnStyleLst>
-        <a:ln w="9525" cap="flat" cmpd="sng" algn="ctr">
-          <a:solidFill>
-            <a:schemeClr val="phClr">
-              <a:shade val="95000"/>
-              <a:satMod val="105000"/>
-            </a:schemeClr>
-          </a:solidFill>
-          <a:prstDash val="solid"/>
-        </a:ln>
-        <a:ln w="25400" cap="flat" cmpd="sng" algn="ctr">
-          <a:solidFill>
-            <a:schemeClr val="phClr"/>
-          </a:solidFill>
-          <a:prstDash val="solid"/>
-        </a:ln>
-        <a:ln w="38100" cap="flat" cmpd="sng" algn="ctr">
-          <a:solidFill>
-            <a:schemeClr val="phClr"/>
-          </a:solidFill>
-          <a:prstDash val="solid"/>
-        </a:ln>
-      </a:lnStyleLst>
-      <a:effectStyleLst>
-        <a:effectStyle>
-          <a:effectLst>
-            <a:outerShdw blurRad="40000" dist="20000" dir="5400000" rotWithShape="0">
-              <a:srgbClr val="000000">
-                <a:alpha val="38000"/>
-              </a:srgbClr>
-            </a:outerShdw>
-          </a:effectLst>
-        </a:effectStyle>
-        <a:effectStyle>
-          <a:effectLst>
-            <a:outerShdw blurRad="40000" dist="23000" dir="5400000" rotWithShape="0">
-              <a:srgbClr val="000000">
-                <a:alpha val="35000"/>
-              </a:srgbClr>
-            </a:outerShdw>
-          </a:effectLst>
-        </a:effectStyle>
-        <a:effectStyle>
-          <a:effectLst>
-            <a:outerShdw blurRad="40000" dist="23000" dir="5400000" rotWithShape="0">
-              <a:srgbClr val="000000">
-                <a:alpha val="35000"/>
-              </a:srgbClr>
-            </a:outerShdw>
-          </a:effectLst>
-          <a:scene3d>
-            <a:camera prst="orthographicFront">
-              <a:rot lat="0" lon="0" rev="0"/>
-            </a:camera>
-            <a:lightRig rig="threePt" dir="t">
-              <a:rot lat="0" lon="0" rev="1200000"/>
-            </a:lightRig>
-          </a:scene3d>
-          <a:sp3d>
-            <a:bevelT w="63500" h="25400"/>
-          </a:sp3d>
-        </a:effectStyle>
-      </a:effectStyleLst>
-      <a:bgFillStyleLst>
-        <a:solidFill>
-          <a:schemeClr val="phClr"/>
-        </a:solidFill>
-        <a:gradFill rotWithShape="1">
-          <a:gsLst>
-            <a:gs pos="0">
-              <a:schemeClr val="phClr">
-                <a:tint val="40000"/>
-                <a:satMod val="350000"/>
-              </a:schemeClr>
-            </a:gs>
-            <a:gs pos="40000">
-              <a:schemeClr val="phClr">
-                <a:tint val="45000"/>
-                <a:shade val="99000"/>
-                <a:satMod val="350000"/>
-              </a:schemeClr>
-            </a:gs>
-            <a:gs pos="100000">
-              <a:schemeClr val="phClr">
-                <a:shade val="20000"/>
-                <a:satMod val="255000"/>
-              </a:schemeClr>
-            </a:gs>
-          </a:gsLst>
-          <a:path path="circle">
-            <a:fillToRect l="50000" t="-80000" r="50000" b="180000"/>
-          </a:path>
-        </a:gradFill>
-        <a:gradFill rotWithShape="1">
-          <a:gsLst>
-            <a:gs pos="0">
-              <a:schemeClr val="phClr">
-                <a:tint val="80000"/>
-                <a:satMod val="300000"/>
-              </a:schemeClr>
-            </a:gs>
-            <a:gs pos="100000">
-              <a:schemeClr val="phClr">
-                <a:shade val="30000"/>
-                <a:satMod val="200000"/>
-              </a:schemeClr>
-            </a:gs>
-          </a:gsLst>
-          <a:path path="circle">
-            <a:fillToRect l="50000" t="50000" r="50000" b="50000"/>
-          </a:path>
-        </a:gradFill>
-      </a:bgFillStyleLst>
-    </a:fmtScheme>
-  </a:themeElements>
-</a:theme>
 </file>
</xml_diff>